<commit_message>
Adjusting image, add definitions from 3/4 call
</commit_message>
<xml_diff>
--- a/US-PCS ballot images 2026.pptx
+++ b/US-PCS ballot images 2026.pptx
@@ -861,7 +861,7 @@
           <a:p>
             <a:fld id="{10B9A41D-2C14-4FD9-A8FE-469DBFAB3809}" type="datetimeFigureOut">
               <a:rPr lang="en-CA" smtClean="0"/>
-              <a:t>2026-02-25</a:t>
+              <a:t>2026-03-06</a:t>
             </a:fld>
             <a:endParaRPr lang="en-CA" dirty="0"/>
           </a:p>
@@ -1713,7 +1713,7 @@
           <a:p>
             <a:fld id="{0D2F0FE0-C0B2-431B-95AF-3256C55C95DF}" type="datetimeFigureOut">
               <a:rPr lang="en-US" smtClean="0"/>
-              <a:t>2/25/2026</a:t>
+              <a:t>3/6/2026</a:t>
             </a:fld>
             <a:endParaRPr lang="en-US"/>
           </a:p>
@@ -1911,7 +1911,7 @@
           <a:p>
             <a:fld id="{0D2F0FE0-C0B2-431B-95AF-3256C55C95DF}" type="datetimeFigureOut">
               <a:rPr lang="en-US" smtClean="0"/>
-              <a:t>2/25/2026</a:t>
+              <a:t>3/6/2026</a:t>
             </a:fld>
             <a:endParaRPr lang="en-US"/>
           </a:p>
@@ -2186,7 +2186,7 @@
           <a:p>
             <a:fld id="{0D2F0FE0-C0B2-431B-95AF-3256C55C95DF}" type="datetimeFigureOut">
               <a:rPr lang="en-US" smtClean="0"/>
-              <a:t>2/25/2026</a:t>
+              <a:t>3/6/2026</a:t>
             </a:fld>
             <a:endParaRPr lang="en-US"/>
           </a:p>
@@ -2451,7 +2451,7 @@
           <a:p>
             <a:fld id="{0D2F0FE0-C0B2-431B-95AF-3256C55C95DF}" type="datetimeFigureOut">
               <a:rPr lang="en-US" smtClean="0"/>
-              <a:t>2/25/2026</a:t>
+              <a:t>3/6/2026</a:t>
             </a:fld>
             <a:endParaRPr lang="en-US"/>
           </a:p>
@@ -2863,7 +2863,7 @@
           <a:p>
             <a:fld id="{0D2F0FE0-C0B2-431B-95AF-3256C55C95DF}" type="datetimeFigureOut">
               <a:rPr lang="en-US" smtClean="0"/>
-              <a:t>2/25/2026</a:t>
+              <a:t>3/6/2026</a:t>
             </a:fld>
             <a:endParaRPr lang="en-US"/>
           </a:p>
@@ -3004,7 +3004,7 @@
           <a:p>
             <a:fld id="{0D2F0FE0-C0B2-431B-95AF-3256C55C95DF}" type="datetimeFigureOut">
               <a:rPr lang="en-US" smtClean="0"/>
-              <a:t>2/25/2026</a:t>
+              <a:t>3/6/2026</a:t>
             </a:fld>
             <a:endParaRPr lang="en-US"/>
           </a:p>
@@ -3117,7 +3117,7 @@
           <a:p>
             <a:fld id="{0D2F0FE0-C0B2-431B-95AF-3256C55C95DF}" type="datetimeFigureOut">
               <a:rPr lang="en-US" smtClean="0"/>
-              <a:t>2/25/2026</a:t>
+              <a:t>3/6/2026</a:t>
             </a:fld>
             <a:endParaRPr lang="en-US"/>
           </a:p>
@@ -3428,7 +3428,7 @@
           <a:p>
             <a:fld id="{0D2F0FE0-C0B2-431B-95AF-3256C55C95DF}" type="datetimeFigureOut">
               <a:rPr lang="en-US" smtClean="0"/>
-              <a:t>2/25/2026</a:t>
+              <a:t>3/6/2026</a:t>
             </a:fld>
             <a:endParaRPr lang="en-US"/>
           </a:p>
@@ -3716,7 +3716,7 @@
           <a:p>
             <a:fld id="{0D2F0FE0-C0B2-431B-95AF-3256C55C95DF}" type="datetimeFigureOut">
               <a:rPr lang="en-US" smtClean="0"/>
-              <a:t>2/25/2026</a:t>
+              <a:t>3/6/2026</a:t>
             </a:fld>
             <a:endParaRPr lang="en-US"/>
           </a:p>
@@ -3914,7 +3914,7 @@
           <a:p>
             <a:fld id="{0D2F0FE0-C0B2-431B-95AF-3256C55C95DF}" type="datetimeFigureOut">
               <a:rPr lang="en-US" smtClean="0"/>
-              <a:t>2/25/2026</a:t>
+              <a:t>3/6/2026</a:t>
             </a:fld>
             <a:endParaRPr lang="en-US"/>
           </a:p>
@@ -4365,7 +4365,7 @@
           <a:p>
             <a:fld id="{0D2F0FE0-C0B2-431B-95AF-3256C55C95DF}" type="datetimeFigureOut">
               <a:rPr lang="en-US" smtClean="0"/>
-              <a:t>2/25/2026</a:t>
+              <a:t>3/6/2026</a:t>
             </a:fld>
             <a:endParaRPr lang="en-US"/>
           </a:p>
@@ -7947,7 +7947,7 @@
           <a:p>
             <a:fld id="{0D2F0FE0-C0B2-431B-95AF-3256C55C95DF}" type="datetimeFigureOut">
               <a:rPr lang="en-US" smtClean="0"/>
-              <a:t>2/25/2026</a:t>
+              <a:t>3/6/2026</a:t>
             </a:fld>
             <a:endParaRPr lang="en-US"/>
           </a:p>
@@ -15384,7 +15384,7 @@
         <p:spPr>
           <a:xfrm>
             <a:off x="872082" y="1570402"/>
-            <a:ext cx="1661417" cy="415498"/>
+            <a:ext cx="1657633" cy="415498"/>
           </a:xfrm>
           <a:prstGeom prst="rect">
             <a:avLst/>
@@ -15399,7 +15399,7 @@
           <a:p>
             <a:pPr defTabSz="685800"/>
             <a:r>
-              <a:rPr lang="en-US" sz="2100" i="1" dirty="0">
+              <a:rPr lang="en-US" sz="2100" i="1">
                 <a:solidFill>
                   <a:prstClr val="black">
                     <a:lumMod val="50000"/>
@@ -15408,7 +15408,19 @@
                 </a:solidFill>
                 <a:latin typeface="Aptos" panose="02110004020202020204"/>
               </a:rPr>
-              <a:t>Inherits from</a:t>
+              <a:t>Derives </a:t>
+            </a:r>
+            <a:r>
+              <a:rPr lang="en-US" sz="2100" i="1" dirty="0">
+                <a:solidFill>
+                  <a:prstClr val="black">
+                    <a:lumMod val="50000"/>
+                    <a:lumOff val="50000"/>
+                  </a:prstClr>
+                </a:solidFill>
+                <a:latin typeface="Aptos" panose="02110004020202020204"/>
+              </a:rPr>
+              <a:t>from</a:t>
             </a:r>
           </a:p>
         </p:txBody>
@@ -15754,7 +15766,7 @@
             <a:pPr algn="ctr"/>
             <a:r>
               <a:rPr lang="en-US" sz="1400" i="1" dirty="0"/>
-              <a:t>Variances between US Core and IPS Profiles to be documented in US-PCS</a:t>
+              <a:t>Variances from IPS clinical profiles to US Core documented in US-PCS</a:t>
             </a:r>
           </a:p>
         </p:txBody>

</xml_diff>

<commit_message>
Alternatives to front image
</commit_message>
<xml_diff>
--- a/US-PCS ballot images 2026.pptx
+++ b/US-PCS ballot images 2026.pptx
@@ -6,14 +6,17 @@
     <p:sldMasterId id="2147483670" r:id="rId2"/>
   </p:sldMasterIdLst>
   <p:notesMasterIdLst>
-    <p:notesMasterId r:id="rId8"/>
+    <p:notesMasterId r:id="rId11"/>
   </p:notesMasterIdLst>
   <p:sldIdLst>
     <p:sldId id="801" r:id="rId3"/>
-    <p:sldId id="258" r:id="rId4"/>
-    <p:sldId id="802" r:id="rId5"/>
-    <p:sldId id="803" r:id="rId6"/>
-    <p:sldId id="804" r:id="rId7"/>
+    <p:sldId id="806" r:id="rId4"/>
+    <p:sldId id="807" r:id="rId5"/>
+    <p:sldId id="805" r:id="rId6"/>
+    <p:sldId id="258" r:id="rId7"/>
+    <p:sldId id="802" r:id="rId8"/>
+    <p:sldId id="803" r:id="rId9"/>
+    <p:sldId id="804" r:id="rId10"/>
   </p:sldIdLst>
   <p:sldSz cx="9144000" cy="6858000" type="screen4x3"/>
   <p:notesSz cx="6858000" cy="9144000"/>
@@ -118,6 +121,9 @@
         <p14:section name="Untitled Section" id="{0D1D49B2-C01F-438C-A1BE-F96EC5A09F44}">
           <p14:sldIdLst>
             <p14:sldId id="801"/>
+            <p14:sldId id="806"/>
+            <p14:sldId id="807"/>
+            <p14:sldId id="805"/>
             <p14:sldId id="258"/>
             <p14:sldId id="802"/>
             <p14:sldId id="803"/>
@@ -861,7 +867,7 @@
           <a:p>
             <a:fld id="{10B9A41D-2C14-4FD9-A8FE-469DBFAB3809}" type="datetimeFigureOut">
               <a:rPr lang="en-CA" smtClean="0"/>
-              <a:t>2026-03-06</a:t>
+              <a:t>2026-03-19</a:t>
             </a:fld>
             <a:endParaRPr lang="en-CA" dirty="0"/>
           </a:p>
@@ -1713,7 +1719,7 @@
           <a:p>
             <a:fld id="{0D2F0FE0-C0B2-431B-95AF-3256C55C95DF}" type="datetimeFigureOut">
               <a:rPr lang="en-US" smtClean="0"/>
-              <a:t>3/6/2026</a:t>
+              <a:t>3/19/2026</a:t>
             </a:fld>
             <a:endParaRPr lang="en-US"/>
           </a:p>
@@ -1911,7 +1917,7 @@
           <a:p>
             <a:fld id="{0D2F0FE0-C0B2-431B-95AF-3256C55C95DF}" type="datetimeFigureOut">
               <a:rPr lang="en-US" smtClean="0"/>
-              <a:t>3/6/2026</a:t>
+              <a:t>3/19/2026</a:t>
             </a:fld>
             <a:endParaRPr lang="en-US"/>
           </a:p>
@@ -2186,7 +2192,7 @@
           <a:p>
             <a:fld id="{0D2F0FE0-C0B2-431B-95AF-3256C55C95DF}" type="datetimeFigureOut">
               <a:rPr lang="en-US" smtClean="0"/>
-              <a:t>3/6/2026</a:t>
+              <a:t>3/19/2026</a:t>
             </a:fld>
             <a:endParaRPr lang="en-US"/>
           </a:p>
@@ -2451,7 +2457,7 @@
           <a:p>
             <a:fld id="{0D2F0FE0-C0B2-431B-95AF-3256C55C95DF}" type="datetimeFigureOut">
               <a:rPr lang="en-US" smtClean="0"/>
-              <a:t>3/6/2026</a:t>
+              <a:t>3/19/2026</a:t>
             </a:fld>
             <a:endParaRPr lang="en-US"/>
           </a:p>
@@ -2863,7 +2869,7 @@
           <a:p>
             <a:fld id="{0D2F0FE0-C0B2-431B-95AF-3256C55C95DF}" type="datetimeFigureOut">
               <a:rPr lang="en-US" smtClean="0"/>
-              <a:t>3/6/2026</a:t>
+              <a:t>3/19/2026</a:t>
             </a:fld>
             <a:endParaRPr lang="en-US"/>
           </a:p>
@@ -3004,7 +3010,7 @@
           <a:p>
             <a:fld id="{0D2F0FE0-C0B2-431B-95AF-3256C55C95DF}" type="datetimeFigureOut">
               <a:rPr lang="en-US" smtClean="0"/>
-              <a:t>3/6/2026</a:t>
+              <a:t>3/19/2026</a:t>
             </a:fld>
             <a:endParaRPr lang="en-US"/>
           </a:p>
@@ -3117,7 +3123,7 @@
           <a:p>
             <a:fld id="{0D2F0FE0-C0B2-431B-95AF-3256C55C95DF}" type="datetimeFigureOut">
               <a:rPr lang="en-US" smtClean="0"/>
-              <a:t>3/6/2026</a:t>
+              <a:t>3/19/2026</a:t>
             </a:fld>
             <a:endParaRPr lang="en-US"/>
           </a:p>
@@ -3428,7 +3434,7 @@
           <a:p>
             <a:fld id="{0D2F0FE0-C0B2-431B-95AF-3256C55C95DF}" type="datetimeFigureOut">
               <a:rPr lang="en-US" smtClean="0"/>
-              <a:t>3/6/2026</a:t>
+              <a:t>3/19/2026</a:t>
             </a:fld>
             <a:endParaRPr lang="en-US"/>
           </a:p>
@@ -3716,7 +3722,7 @@
           <a:p>
             <a:fld id="{0D2F0FE0-C0B2-431B-95AF-3256C55C95DF}" type="datetimeFigureOut">
               <a:rPr lang="en-US" smtClean="0"/>
-              <a:t>3/6/2026</a:t>
+              <a:t>3/19/2026</a:t>
             </a:fld>
             <a:endParaRPr lang="en-US"/>
           </a:p>
@@ -3914,7 +3920,7 @@
           <a:p>
             <a:fld id="{0D2F0FE0-C0B2-431B-95AF-3256C55C95DF}" type="datetimeFigureOut">
               <a:rPr lang="en-US" smtClean="0"/>
-              <a:t>3/6/2026</a:t>
+              <a:t>3/19/2026</a:t>
             </a:fld>
             <a:endParaRPr lang="en-US"/>
           </a:p>
@@ -4365,7 +4371,7 @@
           <a:p>
             <a:fld id="{0D2F0FE0-C0B2-431B-95AF-3256C55C95DF}" type="datetimeFigureOut">
               <a:rPr lang="en-US" smtClean="0"/>
-              <a:t>3/6/2026</a:t>
+              <a:t>3/19/2026</a:t>
             </a:fld>
             <a:endParaRPr lang="en-US"/>
           </a:p>
@@ -7947,7 +7953,7 @@
           <a:p>
             <a:fld id="{0D2F0FE0-C0B2-431B-95AF-3256C55C95DF}" type="datetimeFigureOut">
               <a:rPr lang="en-US" smtClean="0"/>
-              <a:t>3/6/2026</a:t>
+              <a:t>3/19/2026</a:t>
             </a:fld>
             <a:endParaRPr lang="en-US"/>
           </a:p>
@@ -10046,6 +10052,4633 @@
       </p:grpSpPr>
       <p:sp>
         <p:nvSpPr>
+          <p:cNvPr id="2" name="Slide Number Placeholder 1">
+            <a:extLst>
+              <a:ext uri="{FF2B5EF4-FFF2-40B4-BE49-F238E27FC236}">
+                <a16:creationId xmlns:a16="http://schemas.microsoft.com/office/drawing/2014/main" id="{37554427-701E-FA52-56A1-9B2A5AAA4500}"/>
+              </a:ext>
+            </a:extLst>
+          </p:cNvPr>
+          <p:cNvSpPr>
+            <a:spLocks noGrp="1"/>
+          </p:cNvSpPr>
+          <p:nvPr>
+            <p:ph type="sldNum" sz="quarter" idx="4"/>
+          </p:nvPr>
+        </p:nvSpPr>
+        <p:spPr/>
+        <p:txBody>
+          <a:bodyPr/>
+          <a:lstStyle/>
+          <a:p>
+            <a:fld id="{5CC3E5C4-3E2B-40F1-9F2B-C46CEB0C88DF}" type="slidenum">
+              <a:rPr lang="en-CA" smtClean="0"/>
+              <a:pPr/>
+              <a:t>2</a:t>
+            </a:fld>
+            <a:endParaRPr lang="en-CA" dirty="0"/>
+          </a:p>
+        </p:txBody>
+      </p:sp>
+      <p:grpSp>
+        <p:nvGrpSpPr>
+          <p:cNvPr id="38" name="Group 37">
+            <a:extLst>
+              <a:ext uri="{FF2B5EF4-FFF2-40B4-BE49-F238E27FC236}">
+                <a16:creationId xmlns:a16="http://schemas.microsoft.com/office/drawing/2014/main" id="{8B63BF7D-8B95-FC49-F010-3CB23B3B656A}"/>
+              </a:ext>
+            </a:extLst>
+          </p:cNvPr>
+          <p:cNvGrpSpPr/>
+          <p:nvPr/>
+        </p:nvGrpSpPr>
+        <p:grpSpPr>
+          <a:xfrm>
+            <a:off x="2038464" y="1159868"/>
+            <a:ext cx="6439800" cy="5634215"/>
+            <a:chOff x="2038464" y="1159868"/>
+            <a:chExt cx="6439800" cy="5634215"/>
+          </a:xfrm>
+        </p:grpSpPr>
+        <p:pic>
+          <p:nvPicPr>
+            <p:cNvPr id="18" name="Picture 17">
+              <a:extLst>
+                <a:ext uri="{FF2B5EF4-FFF2-40B4-BE49-F238E27FC236}">
+                  <a16:creationId xmlns:a16="http://schemas.microsoft.com/office/drawing/2014/main" id="{99C1ACDB-8FD1-F8F0-064C-22F24A5CA3FE}"/>
+                </a:ext>
+              </a:extLst>
+            </p:cNvPr>
+            <p:cNvPicPr>
+              <a:picLocks noChangeAspect="1"/>
+            </p:cNvPicPr>
+            <p:nvPr/>
+          </p:nvPicPr>
+          <p:blipFill>
+            <a:blip r:embed="rId2"/>
+            <a:stretch>
+              <a:fillRect/>
+            </a:stretch>
+          </p:blipFill>
+          <p:spPr>
+            <a:xfrm>
+              <a:off x="2038464" y="5117449"/>
+              <a:ext cx="6439799" cy="1676634"/>
+            </a:xfrm>
+            <a:prstGeom prst="rect">
+              <a:avLst/>
+            </a:prstGeom>
+          </p:spPr>
+        </p:pic>
+        <p:sp>
+          <p:nvSpPr>
+            <p:cNvPr id="27" name="Rectangle 26">
+              <a:extLst>
+                <a:ext uri="{FF2B5EF4-FFF2-40B4-BE49-F238E27FC236}">
+                  <a16:creationId xmlns:a16="http://schemas.microsoft.com/office/drawing/2014/main" id="{F486077C-723E-F159-7EC3-37A83B6744CA}"/>
+                </a:ext>
+              </a:extLst>
+            </p:cNvPr>
+            <p:cNvSpPr/>
+            <p:nvPr/>
+          </p:nvSpPr>
+          <p:spPr bwMode="auto">
+            <a:xfrm rot="1533085">
+              <a:off x="2176983" y="5362567"/>
+              <a:ext cx="1095367" cy="144017"/>
+            </a:xfrm>
+            <a:prstGeom prst="rect">
+              <a:avLst/>
+            </a:prstGeom>
+            <a:gradFill flip="none" rotWithShape="1">
+              <a:gsLst>
+                <a:gs pos="32500">
+                  <a:srgbClr val="E1C387"/>
+                </a:gs>
+                <a:gs pos="0">
+                  <a:srgbClr val="F3E6CD"/>
+                </a:gs>
+                <a:gs pos="65000">
+                  <a:srgbClr val="AE832C"/>
+                </a:gs>
+                <a:gs pos="100000">
+                  <a:srgbClr val="F3E6CD"/>
+                </a:gs>
+              </a:gsLst>
+              <a:lin ang="0" scaled="1"/>
+              <a:tileRect/>
+            </a:gradFill>
+            <a:ln w="9525" cap="flat" cmpd="sng" algn="ctr">
+              <a:noFill/>
+              <a:prstDash val="solid"/>
+              <a:round/>
+              <a:headEnd type="none" w="med" len="med"/>
+              <a:tailEnd type="none" w="med" len="med"/>
+            </a:ln>
+            <a:effectLst/>
+          </p:spPr>
+          <p:txBody>
+            <a:bodyPr vert="horz" wrap="square" lIns="91440" tIns="45720" rIns="91440" bIns="45720" numCol="1" rtlCol="0" anchor="t" anchorCtr="0" compatLnSpc="1">
+              <a:prstTxWarp prst="textNoShape">
+                <a:avLst/>
+              </a:prstTxWarp>
+            </a:bodyPr>
+            <a:lstStyle/>
+            <a:p>
+              <a:pPr marL="0" marR="0" indent="0" algn="l" defTabSz="914400" rtl="0" eaLnBrk="0" fontAlgn="base" latinLnBrk="0" hangingPunct="0">
+                <a:lnSpc>
+                  <a:spcPct val="100000"/>
+                </a:lnSpc>
+                <a:spcBef>
+                  <a:spcPct val="0"/>
+                </a:spcBef>
+                <a:spcAft>
+                  <a:spcPct val="0"/>
+                </a:spcAft>
+                <a:buClrTx/>
+                <a:buSzTx/>
+                <a:buFontTx/>
+                <a:buNone/>
+                <a:tabLst/>
+              </a:pPr>
+              <a:endParaRPr kumimoji="0" lang="en-US" sz="1800" b="0" i="0" u="none" strike="noStrike" cap="none" normalizeH="0" baseline="0">
+                <a:ln>
+                  <a:noFill/>
+                </a:ln>
+                <a:solidFill>
+                  <a:schemeClr val="tx1"/>
+                </a:solidFill>
+                <a:effectLst/>
+                <a:latin typeface="Arial" charset="0"/>
+              </a:endParaRPr>
+            </a:p>
+          </p:txBody>
+        </p:sp>
+        <p:sp>
+          <p:nvSpPr>
+            <p:cNvPr id="19" name="Arrow: Pentagon 18">
+              <a:extLst>
+                <a:ext uri="{FF2B5EF4-FFF2-40B4-BE49-F238E27FC236}">
+                  <a16:creationId xmlns:a16="http://schemas.microsoft.com/office/drawing/2014/main" id="{ABE7EA1B-7863-A85F-8F1C-D6DF74D6000B}"/>
+                </a:ext>
+              </a:extLst>
+            </p:cNvPr>
+            <p:cNvSpPr/>
+            <p:nvPr/>
+          </p:nvSpPr>
+          <p:spPr bwMode="auto">
+            <a:xfrm>
+              <a:off x="3367278" y="4723786"/>
+              <a:ext cx="5110986" cy="577421"/>
+            </a:xfrm>
+            <a:prstGeom prst="homePlate">
+              <a:avLst/>
+            </a:prstGeom>
+            <a:solidFill>
+              <a:srgbClr val="FF0000"/>
+            </a:solidFill>
+            <a:ln w="9525" cap="flat" cmpd="sng" algn="ctr">
+              <a:noFill/>
+              <a:prstDash val="solid"/>
+              <a:round/>
+              <a:headEnd type="none" w="med" len="med"/>
+              <a:tailEnd type="none" w="med" len="med"/>
+            </a:ln>
+            <a:effectLst/>
+          </p:spPr>
+          <p:txBody>
+            <a:bodyPr vert="horz" wrap="square" lIns="91440" tIns="45720" rIns="91440" bIns="45720" numCol="1" rtlCol="0" anchor="ctr" anchorCtr="0" compatLnSpc="1">
+              <a:prstTxWarp prst="textNoShape">
+                <a:avLst/>
+              </a:prstTxWarp>
+            </a:bodyPr>
+            <a:lstStyle/>
+            <a:p>
+              <a:pPr marL="800100" indent="114300" eaLnBrk="0" fontAlgn="base" hangingPunct="0">
+                <a:spcBef>
+                  <a:spcPct val="0"/>
+                </a:spcBef>
+                <a:spcAft>
+                  <a:spcPct val="0"/>
+                </a:spcAft>
+                <a:tabLst>
+                  <a:tab pos="857250" algn="l"/>
+                </a:tabLst>
+              </a:pPr>
+              <a:endParaRPr lang="en-US" sz="2800" b="1" dirty="0">
+                <a:solidFill>
+                  <a:schemeClr val="bg1"/>
+                </a:solidFill>
+                <a:latin typeface="Aptos" panose="020B0004020202020204" pitchFamily="34" charset="0"/>
+              </a:endParaRPr>
+            </a:p>
+          </p:txBody>
+        </p:sp>
+        <p:sp>
+          <p:nvSpPr>
+            <p:cNvPr id="21" name="Arrow: Pentagon 20">
+              <a:extLst>
+                <a:ext uri="{FF2B5EF4-FFF2-40B4-BE49-F238E27FC236}">
+                  <a16:creationId xmlns:a16="http://schemas.microsoft.com/office/drawing/2014/main" id="{5B3517DF-DBA2-06E6-23AC-099B613B1191}"/>
+                </a:ext>
+              </a:extLst>
+            </p:cNvPr>
+            <p:cNvSpPr/>
+            <p:nvPr/>
+          </p:nvSpPr>
+          <p:spPr bwMode="auto">
+            <a:xfrm>
+              <a:off x="3462810" y="4149935"/>
+              <a:ext cx="5015454" cy="577421"/>
+            </a:xfrm>
+            <a:prstGeom prst="homePlate">
+              <a:avLst/>
+            </a:prstGeom>
+            <a:solidFill>
+              <a:srgbClr val="E86328"/>
+            </a:solidFill>
+            <a:ln w="9525" cap="flat" cmpd="sng" algn="ctr">
+              <a:noFill/>
+              <a:prstDash val="solid"/>
+              <a:round/>
+              <a:headEnd type="none" w="med" len="med"/>
+              <a:tailEnd type="none" w="med" len="med"/>
+            </a:ln>
+            <a:effectLst/>
+          </p:spPr>
+          <p:txBody>
+            <a:bodyPr vert="horz" wrap="square" lIns="91440" tIns="45720" rIns="91440" bIns="45720" numCol="1" rtlCol="0" anchor="ctr" anchorCtr="0" compatLnSpc="1">
+              <a:prstTxWarp prst="textNoShape">
+                <a:avLst/>
+              </a:prstTxWarp>
+            </a:bodyPr>
+            <a:lstStyle/>
+            <a:p>
+              <a:pPr indent="800100" eaLnBrk="0" fontAlgn="base" hangingPunct="0">
+                <a:spcBef>
+                  <a:spcPct val="0"/>
+                </a:spcBef>
+                <a:spcAft>
+                  <a:spcPct val="0"/>
+                </a:spcAft>
+              </a:pPr>
+              <a:endParaRPr lang="en-US" sz="2800" b="1" dirty="0">
+                <a:solidFill>
+                  <a:schemeClr val="bg1"/>
+                </a:solidFill>
+                <a:latin typeface="Aptos" panose="020B0004020202020204" pitchFamily="34" charset="0"/>
+              </a:endParaRPr>
+            </a:p>
+          </p:txBody>
+        </p:sp>
+        <p:sp>
+          <p:nvSpPr>
+            <p:cNvPr id="22" name="Arrow: Pentagon 21">
+              <a:extLst>
+                <a:ext uri="{FF2B5EF4-FFF2-40B4-BE49-F238E27FC236}">
+                  <a16:creationId xmlns:a16="http://schemas.microsoft.com/office/drawing/2014/main" id="{B988A241-5748-E42E-C3DD-BFB446C97C35}"/>
+                </a:ext>
+              </a:extLst>
+            </p:cNvPr>
+            <p:cNvSpPr/>
+            <p:nvPr/>
+          </p:nvSpPr>
+          <p:spPr bwMode="auto">
+            <a:xfrm>
+              <a:off x="3462810" y="3573293"/>
+              <a:ext cx="5015454" cy="577421"/>
+            </a:xfrm>
+            <a:prstGeom prst="homePlate">
+              <a:avLst/>
+            </a:prstGeom>
+            <a:solidFill>
+              <a:srgbClr val="F7D33E"/>
+            </a:solidFill>
+            <a:ln w="9525" cap="flat" cmpd="sng" algn="ctr">
+              <a:noFill/>
+              <a:prstDash val="solid"/>
+              <a:round/>
+              <a:headEnd type="none" w="med" len="med"/>
+              <a:tailEnd type="none" w="med" len="med"/>
+            </a:ln>
+            <a:effectLst/>
+          </p:spPr>
+          <p:txBody>
+            <a:bodyPr vert="horz" wrap="square" lIns="91440" tIns="45720" rIns="91440" bIns="45720" numCol="1" rtlCol="0" anchor="ctr" anchorCtr="0" compatLnSpc="1">
+              <a:prstTxWarp prst="textNoShape">
+                <a:avLst/>
+              </a:prstTxWarp>
+            </a:bodyPr>
+            <a:lstStyle/>
+            <a:p>
+              <a:pPr indent="857250" eaLnBrk="0" fontAlgn="base" hangingPunct="0">
+                <a:spcBef>
+                  <a:spcPct val="0"/>
+                </a:spcBef>
+                <a:spcAft>
+                  <a:spcPct val="0"/>
+                </a:spcAft>
+              </a:pPr>
+              <a:r>
+                <a:rPr lang="en-US" sz="2800" b="1" dirty="0">
+                  <a:solidFill>
+                    <a:srgbClr val="E86328"/>
+                  </a:solidFill>
+                  <a:latin typeface="Aptos" panose="020B0004020202020204" pitchFamily="34" charset="0"/>
+                </a:rPr>
+                <a:t>Results</a:t>
+              </a:r>
+            </a:p>
+          </p:txBody>
+        </p:sp>
+        <p:sp>
+          <p:nvSpPr>
+            <p:cNvPr id="23" name="Arrow: Pentagon 22">
+              <a:extLst>
+                <a:ext uri="{FF2B5EF4-FFF2-40B4-BE49-F238E27FC236}">
+                  <a16:creationId xmlns:a16="http://schemas.microsoft.com/office/drawing/2014/main" id="{D47DE90E-E879-7C15-FC17-5F156C9D967A}"/>
+                </a:ext>
+              </a:extLst>
+            </p:cNvPr>
+            <p:cNvSpPr/>
+            <p:nvPr/>
+          </p:nvSpPr>
+          <p:spPr bwMode="auto">
+            <a:xfrm>
+              <a:off x="3462809" y="2998077"/>
+              <a:ext cx="5015454" cy="577421"/>
+            </a:xfrm>
+            <a:prstGeom prst="homePlate">
+              <a:avLst/>
+            </a:prstGeom>
+            <a:solidFill>
+              <a:srgbClr val="CAD404"/>
+            </a:solidFill>
+            <a:ln w="9525" cap="flat" cmpd="sng" algn="ctr">
+              <a:noFill/>
+              <a:prstDash val="solid"/>
+              <a:round/>
+              <a:headEnd type="none" w="med" len="med"/>
+              <a:tailEnd type="none" w="med" len="med"/>
+            </a:ln>
+            <a:effectLst/>
+          </p:spPr>
+          <p:txBody>
+            <a:bodyPr vert="horz" wrap="square" lIns="91440" tIns="45720" rIns="91440" bIns="45720" numCol="1" rtlCol="0" anchor="ctr" anchorCtr="0" compatLnSpc="1">
+              <a:prstTxWarp prst="textNoShape">
+                <a:avLst/>
+              </a:prstTxWarp>
+            </a:bodyPr>
+            <a:lstStyle/>
+            <a:p>
+              <a:pPr indent="857250" eaLnBrk="0" fontAlgn="base" hangingPunct="0">
+                <a:spcBef>
+                  <a:spcPct val="0"/>
+                </a:spcBef>
+                <a:spcAft>
+                  <a:spcPct val="0"/>
+                </a:spcAft>
+              </a:pPr>
+              <a:r>
+                <a:rPr lang="en-US" sz="2800" b="1" dirty="0">
+                  <a:solidFill>
+                    <a:srgbClr val="54A831"/>
+                  </a:solidFill>
+                  <a:latin typeface="Aptos" panose="020B0004020202020204" pitchFamily="34" charset="0"/>
+                </a:rPr>
+                <a:t>Immunizations</a:t>
+              </a:r>
+            </a:p>
+          </p:txBody>
+        </p:sp>
+        <p:sp>
+          <p:nvSpPr>
+            <p:cNvPr id="24" name="Arrow: Pentagon 23">
+              <a:extLst>
+                <a:ext uri="{FF2B5EF4-FFF2-40B4-BE49-F238E27FC236}">
+                  <a16:creationId xmlns:a16="http://schemas.microsoft.com/office/drawing/2014/main" id="{2C55BE85-58AB-3B42-D9BD-2E11BEAF0D0F}"/>
+                </a:ext>
+              </a:extLst>
+            </p:cNvPr>
+            <p:cNvSpPr/>
+            <p:nvPr/>
+          </p:nvSpPr>
+          <p:spPr bwMode="auto">
+            <a:xfrm>
+              <a:off x="3635896" y="2419554"/>
+              <a:ext cx="4842368" cy="577421"/>
+            </a:xfrm>
+            <a:prstGeom prst="homePlate">
+              <a:avLst/>
+            </a:prstGeom>
+            <a:solidFill>
+              <a:srgbClr val="54A831"/>
+            </a:solidFill>
+            <a:ln w="9525" cap="flat" cmpd="sng" algn="ctr">
+              <a:noFill/>
+              <a:prstDash val="solid"/>
+              <a:round/>
+              <a:headEnd type="none" w="med" len="med"/>
+              <a:tailEnd type="none" w="med" len="med"/>
+            </a:ln>
+            <a:effectLst/>
+          </p:spPr>
+          <p:txBody>
+            <a:bodyPr vert="horz" wrap="square" lIns="91440" tIns="45720" rIns="91440" bIns="45720" numCol="1" rtlCol="0" anchor="ctr" anchorCtr="0" compatLnSpc="1">
+              <a:prstTxWarp prst="textNoShape">
+                <a:avLst/>
+              </a:prstTxWarp>
+            </a:bodyPr>
+            <a:lstStyle/>
+            <a:p>
+              <a:pPr indent="685800" eaLnBrk="0" fontAlgn="base" hangingPunct="0">
+                <a:spcBef>
+                  <a:spcPct val="0"/>
+                </a:spcBef>
+                <a:spcAft>
+                  <a:spcPct val="0"/>
+                </a:spcAft>
+              </a:pPr>
+              <a:endParaRPr lang="en-US" sz="2800" b="1" dirty="0">
+                <a:solidFill>
+                  <a:schemeClr val="bg1"/>
+                </a:solidFill>
+                <a:latin typeface="Aptos" panose="020B0004020202020204" pitchFamily="34" charset="0"/>
+              </a:endParaRPr>
+            </a:p>
+          </p:txBody>
+        </p:sp>
+        <p:sp>
+          <p:nvSpPr>
+            <p:cNvPr id="26" name="Arrow: Pentagon 25">
+              <a:extLst>
+                <a:ext uri="{FF2B5EF4-FFF2-40B4-BE49-F238E27FC236}">
+                  <a16:creationId xmlns:a16="http://schemas.microsoft.com/office/drawing/2014/main" id="{33C21BAD-CB12-70DD-E575-061C098AE2EF}"/>
+                </a:ext>
+              </a:extLst>
+            </p:cNvPr>
+            <p:cNvSpPr/>
+            <p:nvPr/>
+          </p:nvSpPr>
+          <p:spPr bwMode="auto">
+            <a:xfrm>
+              <a:off x="3851242" y="1273480"/>
+              <a:ext cx="4627021" cy="577421"/>
+            </a:xfrm>
+            <a:prstGeom prst="homePlate">
+              <a:avLst/>
+            </a:prstGeom>
+            <a:solidFill>
+              <a:srgbClr val="7030A0"/>
+            </a:solidFill>
+            <a:ln w="9525" cap="flat" cmpd="sng" algn="ctr">
+              <a:noFill/>
+              <a:prstDash val="solid"/>
+              <a:round/>
+              <a:headEnd type="none" w="med" len="med"/>
+              <a:tailEnd type="none" w="med" len="med"/>
+            </a:ln>
+            <a:effectLst/>
+          </p:spPr>
+          <p:txBody>
+            <a:bodyPr vert="horz" wrap="square" lIns="91440" tIns="45720" rIns="91440" bIns="45720" numCol="1" rtlCol="0" anchor="ctr" anchorCtr="0" compatLnSpc="1">
+              <a:prstTxWarp prst="textNoShape">
+                <a:avLst/>
+              </a:prstTxWarp>
+            </a:bodyPr>
+            <a:lstStyle/>
+            <a:p>
+              <a:pPr indent="457200" eaLnBrk="0" fontAlgn="base" hangingPunct="0">
+                <a:spcBef>
+                  <a:spcPct val="0"/>
+                </a:spcBef>
+                <a:spcAft>
+                  <a:spcPct val="0"/>
+                </a:spcAft>
+              </a:pPr>
+              <a:endParaRPr lang="en-US" sz="2800" b="1" dirty="0">
+                <a:solidFill>
+                  <a:schemeClr val="bg1"/>
+                </a:solidFill>
+                <a:latin typeface="Aptos" panose="020B0004020202020204" pitchFamily="34" charset="0"/>
+              </a:endParaRPr>
+            </a:p>
+          </p:txBody>
+        </p:sp>
+        <p:sp>
+          <p:nvSpPr>
+            <p:cNvPr id="32" name="TextBox 31">
+              <a:extLst>
+                <a:ext uri="{FF2B5EF4-FFF2-40B4-BE49-F238E27FC236}">
+                  <a16:creationId xmlns:a16="http://schemas.microsoft.com/office/drawing/2014/main" id="{19A7F87A-463B-B53E-118A-BBB71382FD44}"/>
+                </a:ext>
+              </a:extLst>
+            </p:cNvPr>
+            <p:cNvSpPr txBox="1"/>
+            <p:nvPr/>
+          </p:nvSpPr>
+          <p:spPr>
+            <a:xfrm>
+              <a:off x="4317285" y="1307344"/>
+              <a:ext cx="1754455" cy="523220"/>
+            </a:xfrm>
+            <a:prstGeom prst="rect">
+              <a:avLst/>
+            </a:prstGeom>
+            <a:noFill/>
+          </p:spPr>
+          <p:txBody>
+            <a:bodyPr wrap="none" rtlCol="0">
+              <a:spAutoFit/>
+            </a:bodyPr>
+            <a:lstStyle/>
+            <a:p>
+              <a:r>
+                <a:rPr lang="en-US" sz="2800" b="1" dirty="0">
+                  <a:solidFill>
+                    <a:schemeClr val="bg1"/>
+                  </a:solidFill>
+                  <a:latin typeface="Aptos" panose="020B0004020202020204" pitchFamily="34" charset="0"/>
+                </a:rPr>
+                <a:t>Problems</a:t>
+              </a:r>
+            </a:p>
+          </p:txBody>
+        </p:sp>
+        <p:sp>
+          <p:nvSpPr>
+            <p:cNvPr id="33" name="TextBox 32">
+              <a:extLst>
+                <a:ext uri="{FF2B5EF4-FFF2-40B4-BE49-F238E27FC236}">
+                  <a16:creationId xmlns:a16="http://schemas.microsoft.com/office/drawing/2014/main" id="{BB87A014-7BDF-3F0F-907C-FC53E64E6E96}"/>
+                </a:ext>
+              </a:extLst>
+            </p:cNvPr>
+            <p:cNvSpPr txBox="1"/>
+            <p:nvPr/>
+          </p:nvSpPr>
+          <p:spPr>
+            <a:xfrm>
+              <a:off x="4317285" y="2469371"/>
+              <a:ext cx="2274533" cy="523220"/>
+            </a:xfrm>
+            <a:prstGeom prst="rect">
+              <a:avLst/>
+            </a:prstGeom>
+            <a:noFill/>
+          </p:spPr>
+          <p:txBody>
+            <a:bodyPr wrap="none" rtlCol="0">
+              <a:spAutoFit/>
+            </a:bodyPr>
+            <a:lstStyle/>
+            <a:p>
+              <a:r>
+                <a:rPr lang="en-US" sz="2800" b="1" dirty="0">
+                  <a:solidFill>
+                    <a:schemeClr val="bg1"/>
+                  </a:solidFill>
+                  <a:latin typeface="Aptos" panose="020B0004020202020204" pitchFamily="34" charset="0"/>
+                </a:rPr>
+                <a:t>Medications</a:t>
+              </a:r>
+            </a:p>
+          </p:txBody>
+        </p:sp>
+        <p:sp>
+          <p:nvSpPr>
+            <p:cNvPr id="34" name="TextBox 33">
+              <a:extLst>
+                <a:ext uri="{FF2B5EF4-FFF2-40B4-BE49-F238E27FC236}">
+                  <a16:creationId xmlns:a16="http://schemas.microsoft.com/office/drawing/2014/main" id="{4B83632F-92AC-A135-87F7-B5E6CACD36B2}"/>
+                </a:ext>
+              </a:extLst>
+            </p:cNvPr>
+            <p:cNvSpPr txBox="1"/>
+            <p:nvPr/>
+          </p:nvSpPr>
+          <p:spPr>
+            <a:xfrm>
+              <a:off x="4317285" y="4196845"/>
+              <a:ext cx="2064604" cy="523220"/>
+            </a:xfrm>
+            <a:prstGeom prst="rect">
+              <a:avLst/>
+            </a:prstGeom>
+            <a:noFill/>
+          </p:spPr>
+          <p:txBody>
+            <a:bodyPr wrap="none" rtlCol="0">
+              <a:spAutoFit/>
+            </a:bodyPr>
+            <a:lstStyle/>
+            <a:p>
+              <a:r>
+                <a:rPr lang="en-US" sz="2800" b="1" dirty="0">
+                  <a:solidFill>
+                    <a:schemeClr val="bg1"/>
+                  </a:solidFill>
+                  <a:latin typeface="Aptos" panose="020B0004020202020204" pitchFamily="34" charset="0"/>
+                </a:rPr>
+                <a:t>Procedures</a:t>
+              </a:r>
+            </a:p>
+          </p:txBody>
+        </p:sp>
+        <p:sp>
+          <p:nvSpPr>
+            <p:cNvPr id="35" name="TextBox 34">
+              <a:extLst>
+                <a:ext uri="{FF2B5EF4-FFF2-40B4-BE49-F238E27FC236}">
+                  <a16:creationId xmlns:a16="http://schemas.microsoft.com/office/drawing/2014/main" id="{4F83CB2A-890A-668A-8B55-08F26CA0E982}"/>
+                </a:ext>
+              </a:extLst>
+            </p:cNvPr>
+            <p:cNvSpPr txBox="1"/>
+            <p:nvPr/>
+          </p:nvSpPr>
+          <p:spPr>
+            <a:xfrm>
+              <a:off x="4317285" y="4739086"/>
+              <a:ext cx="2133469" cy="523220"/>
+            </a:xfrm>
+            <a:prstGeom prst="rect">
+              <a:avLst/>
+            </a:prstGeom>
+            <a:noFill/>
+          </p:spPr>
+          <p:txBody>
+            <a:bodyPr wrap="none" rtlCol="0">
+              <a:spAutoFit/>
+            </a:bodyPr>
+            <a:lstStyle/>
+            <a:p>
+              <a:r>
+                <a:rPr lang="en-US" sz="2800" b="1" dirty="0">
+                  <a:solidFill>
+                    <a:schemeClr val="bg1"/>
+                  </a:solidFill>
+                  <a:latin typeface="Aptos" panose="020B0004020202020204" pitchFamily="34" charset="0"/>
+                </a:rPr>
+                <a:t>Encounters</a:t>
+              </a:r>
+            </a:p>
+          </p:txBody>
+        </p:sp>
+        <p:sp>
+          <p:nvSpPr>
+            <p:cNvPr id="37" name="Rectangle 36">
+              <a:extLst>
+                <a:ext uri="{FF2B5EF4-FFF2-40B4-BE49-F238E27FC236}">
+                  <a16:creationId xmlns:a16="http://schemas.microsoft.com/office/drawing/2014/main" id="{12F7958F-C8BE-2EDD-C277-EF681A5E8B47}"/>
+                </a:ext>
+              </a:extLst>
+            </p:cNvPr>
+            <p:cNvSpPr/>
+            <p:nvPr/>
+          </p:nvSpPr>
+          <p:spPr bwMode="auto">
+            <a:xfrm rot="1387559">
+              <a:off x="3723776" y="1336957"/>
+              <a:ext cx="459856" cy="573573"/>
+            </a:xfrm>
+            <a:prstGeom prst="rect">
+              <a:avLst/>
+            </a:prstGeom>
+            <a:solidFill>
+              <a:srgbClr val="7030A0"/>
+            </a:solidFill>
+            <a:ln w="9525" cap="flat" cmpd="sng" algn="ctr">
+              <a:noFill/>
+              <a:prstDash val="solid"/>
+              <a:round/>
+              <a:headEnd type="none" w="med" len="med"/>
+              <a:tailEnd type="none" w="med" len="med"/>
+            </a:ln>
+            <a:effectLst/>
+          </p:spPr>
+          <p:txBody>
+            <a:bodyPr vert="horz" wrap="square" lIns="91440" tIns="45720" rIns="91440" bIns="45720" numCol="1" rtlCol="0" anchor="ctr" anchorCtr="0" compatLnSpc="1">
+              <a:prstTxWarp prst="textNoShape">
+                <a:avLst/>
+              </a:prstTxWarp>
+            </a:bodyPr>
+            <a:lstStyle/>
+            <a:p>
+              <a:pPr eaLnBrk="0" fontAlgn="base" hangingPunct="0">
+                <a:spcBef>
+                  <a:spcPct val="0"/>
+                </a:spcBef>
+                <a:spcAft>
+                  <a:spcPct val="0"/>
+                </a:spcAft>
+              </a:pPr>
+              <a:endParaRPr lang="en-US" sz="3200">
+                <a:solidFill>
+                  <a:schemeClr val="bg1"/>
+                </a:solidFill>
+                <a:latin typeface="Aptos" panose="020B0004020202020204" pitchFamily="34" charset="0"/>
+              </a:endParaRPr>
+            </a:p>
+          </p:txBody>
+        </p:sp>
+        <p:sp>
+          <p:nvSpPr>
+            <p:cNvPr id="25" name="Arrow: Pentagon 24">
+              <a:extLst>
+                <a:ext uri="{FF2B5EF4-FFF2-40B4-BE49-F238E27FC236}">
+                  <a16:creationId xmlns:a16="http://schemas.microsoft.com/office/drawing/2014/main" id="{D33E52DB-2C2F-8ED6-5739-382D8780D7E5}"/>
+                </a:ext>
+              </a:extLst>
+            </p:cNvPr>
+            <p:cNvSpPr/>
+            <p:nvPr/>
+          </p:nvSpPr>
+          <p:spPr bwMode="auto">
+            <a:xfrm>
+              <a:off x="3686710" y="1846517"/>
+              <a:ext cx="4791553" cy="577421"/>
+            </a:xfrm>
+            <a:prstGeom prst="homePlate">
+              <a:avLst/>
+            </a:prstGeom>
+            <a:solidFill>
+              <a:srgbClr val="87C9FB"/>
+            </a:solidFill>
+            <a:ln w="9525" cap="flat" cmpd="sng" algn="ctr">
+              <a:noFill/>
+              <a:prstDash val="solid"/>
+              <a:round/>
+              <a:headEnd type="none" w="med" len="med"/>
+              <a:tailEnd type="none" w="med" len="med"/>
+            </a:ln>
+            <a:effectLst/>
+          </p:spPr>
+          <p:txBody>
+            <a:bodyPr vert="horz" wrap="square" lIns="91440" tIns="45720" rIns="91440" bIns="45720" numCol="1" rtlCol="0" anchor="ctr" anchorCtr="0" compatLnSpc="1">
+              <a:prstTxWarp prst="textNoShape">
+                <a:avLst/>
+              </a:prstTxWarp>
+            </a:bodyPr>
+            <a:lstStyle/>
+            <a:p>
+              <a:pPr indent="628650" eaLnBrk="0" fontAlgn="base" hangingPunct="0">
+                <a:spcBef>
+                  <a:spcPct val="0"/>
+                </a:spcBef>
+                <a:spcAft>
+                  <a:spcPct val="0"/>
+                </a:spcAft>
+              </a:pPr>
+              <a:r>
+                <a:rPr lang="en-US" sz="2800" b="1" dirty="0">
+                  <a:solidFill>
+                    <a:srgbClr val="7030A0"/>
+                  </a:solidFill>
+                  <a:latin typeface="Aptos" panose="020B0004020202020204" pitchFamily="34" charset="0"/>
+                </a:rPr>
+                <a:t>Allergies / Intolerances</a:t>
+              </a:r>
+            </a:p>
+          </p:txBody>
+        </p:sp>
+        <p:grpSp>
+          <p:nvGrpSpPr>
+            <p:cNvPr id="28" name="Group 27">
+              <a:extLst>
+                <a:ext uri="{FF2B5EF4-FFF2-40B4-BE49-F238E27FC236}">
+                  <a16:creationId xmlns:a16="http://schemas.microsoft.com/office/drawing/2014/main" id="{D716CC92-BD05-8DA2-6719-F018AF8504C6}"/>
+                </a:ext>
+              </a:extLst>
+            </p:cNvPr>
+            <p:cNvGrpSpPr/>
+            <p:nvPr/>
+          </p:nvGrpSpPr>
+          <p:grpSpPr>
+            <a:xfrm>
+              <a:off x="2997976" y="1159868"/>
+              <a:ext cx="422181" cy="4591612"/>
+              <a:chOff x="2997976" y="1159868"/>
+              <a:chExt cx="422181" cy="4591612"/>
+            </a:xfrm>
+          </p:grpSpPr>
+          <p:sp>
+            <p:nvSpPr>
+              <p:cNvPr id="7" name="Rectangle: Rounded Corners 6">
+                <a:extLst>
+                  <a:ext uri="{FF2B5EF4-FFF2-40B4-BE49-F238E27FC236}">
+                    <a16:creationId xmlns:a16="http://schemas.microsoft.com/office/drawing/2014/main" id="{782EA5FF-7F5C-D99C-B9B3-FD809BF86221}"/>
+                  </a:ext>
+                </a:extLst>
+              </p:cNvPr>
+              <p:cNvSpPr/>
+              <p:nvPr/>
+            </p:nvSpPr>
+            <p:spPr bwMode="auto">
+              <a:xfrm rot="17559388">
+                <a:off x="2809983" y="5141307"/>
+                <a:ext cx="1057843" cy="162504"/>
+              </a:xfrm>
+              <a:prstGeom prst="roundRect">
+                <a:avLst>
+                  <a:gd name="adj" fmla="val 50000"/>
+                </a:avLst>
+              </a:prstGeom>
+              <a:solidFill>
+                <a:srgbClr val="FF0000"/>
+              </a:solidFill>
+              <a:ln w="9525" cap="flat" cmpd="sng" algn="ctr">
+                <a:noFill/>
+                <a:prstDash val="solid"/>
+                <a:round/>
+                <a:headEnd type="none" w="med" len="med"/>
+                <a:tailEnd type="none" w="med" len="med"/>
+              </a:ln>
+              <a:effectLst/>
+            </p:spPr>
+            <p:txBody>
+              <a:bodyPr vert="horz" wrap="square" lIns="91440" tIns="45720" rIns="91440" bIns="45720" numCol="1" rtlCol="0" anchor="t" anchorCtr="0" compatLnSpc="1">
+                <a:prstTxWarp prst="textNoShape">
+                  <a:avLst/>
+                </a:prstTxWarp>
+              </a:bodyPr>
+              <a:lstStyle/>
+              <a:p>
+                <a:pPr marL="0" marR="0" indent="0" algn="l" defTabSz="914400" rtl="0" eaLnBrk="0" fontAlgn="base" latinLnBrk="0" hangingPunct="0">
+                  <a:lnSpc>
+                    <a:spcPct val="100000"/>
+                  </a:lnSpc>
+                  <a:spcBef>
+                    <a:spcPct val="0"/>
+                  </a:spcBef>
+                  <a:spcAft>
+                    <a:spcPct val="0"/>
+                  </a:spcAft>
+                  <a:buClrTx/>
+                  <a:buSzTx/>
+                  <a:buFontTx/>
+                  <a:buNone/>
+                  <a:tabLst/>
+                </a:pPr>
+                <a:endParaRPr kumimoji="0" lang="en-US" sz="1800" b="0" i="0" u="none" strike="noStrike" cap="none" normalizeH="0" baseline="0">
+                  <a:ln>
+                    <a:noFill/>
+                  </a:ln>
+                  <a:solidFill>
+                    <a:schemeClr val="tx1"/>
+                  </a:solidFill>
+                  <a:effectLst/>
+                  <a:latin typeface="Arial" charset="0"/>
+                </a:endParaRPr>
+              </a:p>
+            </p:txBody>
+          </p:sp>
+          <p:sp>
+            <p:nvSpPr>
+              <p:cNvPr id="8" name="Rectangle: Rounded Corners 7">
+                <a:extLst>
+                  <a:ext uri="{FF2B5EF4-FFF2-40B4-BE49-F238E27FC236}">
+                    <a16:creationId xmlns:a16="http://schemas.microsoft.com/office/drawing/2014/main" id="{F7946ED0-23B1-B36E-9C13-CC338B2F54FB}"/>
+                  </a:ext>
+                </a:extLst>
+              </p:cNvPr>
+              <p:cNvSpPr/>
+              <p:nvPr/>
+            </p:nvSpPr>
+            <p:spPr bwMode="auto">
+              <a:xfrm rot="17559388">
+                <a:off x="2531189" y="4890955"/>
+                <a:ext cx="1478280" cy="162504"/>
+              </a:xfrm>
+              <a:prstGeom prst="roundRect">
+                <a:avLst>
+                  <a:gd name="adj" fmla="val 50000"/>
+                </a:avLst>
+              </a:prstGeom>
+              <a:solidFill>
+                <a:srgbClr val="E86328"/>
+              </a:solidFill>
+              <a:ln w="9525" cap="flat" cmpd="sng" algn="ctr">
+                <a:noFill/>
+                <a:prstDash val="solid"/>
+                <a:round/>
+                <a:headEnd type="none" w="med" len="med"/>
+                <a:tailEnd type="none" w="med" len="med"/>
+              </a:ln>
+              <a:effectLst/>
+            </p:spPr>
+            <p:txBody>
+              <a:bodyPr vert="horz" wrap="square" lIns="91440" tIns="45720" rIns="91440" bIns="45720" numCol="1" rtlCol="0" anchor="ctr" anchorCtr="0" compatLnSpc="1">
+                <a:prstTxWarp prst="textNoShape">
+                  <a:avLst/>
+                </a:prstTxWarp>
+              </a:bodyPr>
+              <a:lstStyle/>
+              <a:p>
+                <a:pPr marL="0" marR="0" indent="0" algn="l" defTabSz="914400" rtl="0" eaLnBrk="0" fontAlgn="base" latinLnBrk="0" hangingPunct="0">
+                  <a:lnSpc>
+                    <a:spcPct val="100000"/>
+                  </a:lnSpc>
+                  <a:spcBef>
+                    <a:spcPct val="0"/>
+                  </a:spcBef>
+                  <a:spcAft>
+                    <a:spcPct val="0"/>
+                  </a:spcAft>
+                  <a:buClrTx/>
+                  <a:buSzTx/>
+                  <a:buFontTx/>
+                  <a:buNone/>
+                  <a:tabLst/>
+                </a:pPr>
+                <a:endParaRPr kumimoji="0" lang="en-US" sz="3200" b="0" i="0" u="none" strike="noStrike" cap="none" normalizeH="0" baseline="0">
+                  <a:ln>
+                    <a:noFill/>
+                  </a:ln>
+                  <a:solidFill>
+                    <a:schemeClr val="bg1"/>
+                  </a:solidFill>
+                  <a:effectLst/>
+                  <a:latin typeface="Aptos" panose="020B0004020202020204" pitchFamily="34" charset="0"/>
+                </a:endParaRPr>
+              </a:p>
+            </p:txBody>
+          </p:sp>
+          <p:sp>
+            <p:nvSpPr>
+              <p:cNvPr id="9" name="Rectangle: Rounded Corners 8">
+                <a:extLst>
+                  <a:ext uri="{FF2B5EF4-FFF2-40B4-BE49-F238E27FC236}">
+                    <a16:creationId xmlns:a16="http://schemas.microsoft.com/office/drawing/2014/main" id="{F416E9FF-91D3-A2FA-FA4D-7A11912BA804}"/>
+                  </a:ext>
+                </a:extLst>
+              </p:cNvPr>
+              <p:cNvSpPr/>
+              <p:nvPr/>
+            </p:nvSpPr>
+            <p:spPr bwMode="auto">
+              <a:xfrm rot="17559388">
+                <a:off x="2191074" y="4532279"/>
+                <a:ext cx="2111117" cy="162504"/>
+              </a:xfrm>
+              <a:prstGeom prst="roundRect">
+                <a:avLst>
+                  <a:gd name="adj" fmla="val 50000"/>
+                </a:avLst>
+              </a:prstGeom>
+              <a:solidFill>
+                <a:srgbClr val="F7D33E"/>
+              </a:solidFill>
+              <a:ln w="9525" cap="flat" cmpd="sng" algn="ctr">
+                <a:noFill/>
+                <a:prstDash val="solid"/>
+                <a:round/>
+                <a:headEnd type="none" w="med" len="med"/>
+                <a:tailEnd type="none" w="med" len="med"/>
+              </a:ln>
+              <a:effectLst/>
+            </p:spPr>
+            <p:txBody>
+              <a:bodyPr vert="horz" wrap="square" lIns="91440" tIns="45720" rIns="91440" bIns="45720" numCol="1" rtlCol="0" anchor="ctr" anchorCtr="0" compatLnSpc="1">
+                <a:prstTxWarp prst="textNoShape">
+                  <a:avLst/>
+                </a:prstTxWarp>
+              </a:bodyPr>
+              <a:lstStyle/>
+              <a:p>
+                <a:pPr marL="0" marR="0" indent="0" algn="l" defTabSz="914400" rtl="0" eaLnBrk="0" fontAlgn="base" latinLnBrk="0" hangingPunct="0">
+                  <a:lnSpc>
+                    <a:spcPct val="100000"/>
+                  </a:lnSpc>
+                  <a:spcBef>
+                    <a:spcPct val="0"/>
+                  </a:spcBef>
+                  <a:spcAft>
+                    <a:spcPct val="0"/>
+                  </a:spcAft>
+                  <a:buClrTx/>
+                  <a:buSzTx/>
+                  <a:buFontTx/>
+                  <a:buNone/>
+                  <a:tabLst/>
+                </a:pPr>
+                <a:endParaRPr kumimoji="0" lang="en-US" sz="3200" b="0" i="0" u="none" strike="noStrike" cap="none" normalizeH="0" baseline="0">
+                  <a:ln>
+                    <a:noFill/>
+                  </a:ln>
+                  <a:solidFill>
+                    <a:schemeClr val="bg1"/>
+                  </a:solidFill>
+                  <a:effectLst/>
+                  <a:latin typeface="Aptos" panose="020B0004020202020204" pitchFamily="34" charset="0"/>
+                </a:endParaRPr>
+              </a:p>
+            </p:txBody>
+          </p:sp>
+          <p:sp>
+            <p:nvSpPr>
+              <p:cNvPr id="10" name="Rectangle: Rounded Corners 9">
+                <a:extLst>
+                  <a:ext uri="{FF2B5EF4-FFF2-40B4-BE49-F238E27FC236}">
+                    <a16:creationId xmlns:a16="http://schemas.microsoft.com/office/drawing/2014/main" id="{1600D0F9-1B84-54FD-028B-DA8AFF6BB6B4}"/>
+                  </a:ext>
+                </a:extLst>
+              </p:cNvPr>
+              <p:cNvSpPr/>
+              <p:nvPr/>
+            </p:nvSpPr>
+            <p:spPr bwMode="auto">
+              <a:xfrm rot="17559388">
+                <a:off x="1868635" y="4208078"/>
+                <a:ext cx="2676120" cy="162504"/>
+              </a:xfrm>
+              <a:prstGeom prst="roundRect">
+                <a:avLst>
+                  <a:gd name="adj" fmla="val 50000"/>
+                </a:avLst>
+              </a:prstGeom>
+              <a:solidFill>
+                <a:srgbClr val="CAD404"/>
+              </a:solidFill>
+              <a:ln w="9525" cap="flat" cmpd="sng" algn="ctr">
+                <a:noFill/>
+                <a:prstDash val="solid"/>
+                <a:round/>
+                <a:headEnd type="none" w="med" len="med"/>
+                <a:tailEnd type="none" w="med" len="med"/>
+              </a:ln>
+              <a:effectLst/>
+            </p:spPr>
+            <p:txBody>
+              <a:bodyPr vert="horz" wrap="square" lIns="91440" tIns="45720" rIns="91440" bIns="45720" numCol="1" rtlCol="0" anchor="ctr" anchorCtr="0" compatLnSpc="1">
+                <a:prstTxWarp prst="textNoShape">
+                  <a:avLst/>
+                </a:prstTxWarp>
+              </a:bodyPr>
+              <a:lstStyle/>
+              <a:p>
+                <a:pPr marL="0" marR="0" indent="0" algn="l" defTabSz="914400" rtl="0" eaLnBrk="0" fontAlgn="base" latinLnBrk="0" hangingPunct="0">
+                  <a:lnSpc>
+                    <a:spcPct val="100000"/>
+                  </a:lnSpc>
+                  <a:spcBef>
+                    <a:spcPct val="0"/>
+                  </a:spcBef>
+                  <a:spcAft>
+                    <a:spcPct val="0"/>
+                  </a:spcAft>
+                  <a:buClrTx/>
+                  <a:buSzTx/>
+                  <a:buFontTx/>
+                  <a:buNone/>
+                  <a:tabLst/>
+                </a:pPr>
+                <a:endParaRPr kumimoji="0" lang="en-US" sz="3200" b="0" i="0" u="none" strike="noStrike" cap="none" normalizeH="0" baseline="0">
+                  <a:ln>
+                    <a:noFill/>
+                  </a:ln>
+                  <a:solidFill>
+                    <a:schemeClr val="bg1"/>
+                  </a:solidFill>
+                  <a:effectLst/>
+                  <a:latin typeface="Aptos" panose="020B0004020202020204" pitchFamily="34" charset="0"/>
+                </a:endParaRPr>
+              </a:p>
+            </p:txBody>
+          </p:sp>
+          <p:sp>
+            <p:nvSpPr>
+              <p:cNvPr id="11" name="Rectangle: Rounded Corners 10">
+                <a:extLst>
+                  <a:ext uri="{FF2B5EF4-FFF2-40B4-BE49-F238E27FC236}">
+                    <a16:creationId xmlns:a16="http://schemas.microsoft.com/office/drawing/2014/main" id="{D5252B57-C88C-842A-415B-30A73034551A}"/>
+                  </a:ext>
+                </a:extLst>
+              </p:cNvPr>
+              <p:cNvSpPr/>
+              <p:nvPr/>
+            </p:nvSpPr>
+            <p:spPr bwMode="auto">
+              <a:xfrm rot="17559388">
+                <a:off x="1550830" y="3891230"/>
+                <a:ext cx="3223466" cy="162504"/>
+              </a:xfrm>
+              <a:prstGeom prst="roundRect">
+                <a:avLst>
+                  <a:gd name="adj" fmla="val 50000"/>
+                </a:avLst>
+              </a:prstGeom>
+              <a:solidFill>
+                <a:srgbClr val="54A831"/>
+              </a:solidFill>
+              <a:ln w="9525" cap="flat" cmpd="sng" algn="ctr">
+                <a:noFill/>
+                <a:prstDash val="solid"/>
+                <a:round/>
+                <a:headEnd type="none" w="med" len="med"/>
+                <a:tailEnd type="none" w="med" len="med"/>
+              </a:ln>
+              <a:effectLst/>
+            </p:spPr>
+            <p:txBody>
+              <a:bodyPr vert="horz" wrap="square" lIns="91440" tIns="45720" rIns="91440" bIns="45720" numCol="1" rtlCol="0" anchor="ctr" anchorCtr="0" compatLnSpc="1">
+                <a:prstTxWarp prst="textNoShape">
+                  <a:avLst/>
+                </a:prstTxWarp>
+              </a:bodyPr>
+              <a:lstStyle/>
+              <a:p>
+                <a:pPr marL="0" marR="0" indent="0" algn="l" defTabSz="914400" rtl="0" eaLnBrk="0" fontAlgn="base" latinLnBrk="0" hangingPunct="0">
+                  <a:lnSpc>
+                    <a:spcPct val="100000"/>
+                  </a:lnSpc>
+                  <a:spcBef>
+                    <a:spcPct val="0"/>
+                  </a:spcBef>
+                  <a:spcAft>
+                    <a:spcPct val="0"/>
+                  </a:spcAft>
+                  <a:buClrTx/>
+                  <a:buSzTx/>
+                  <a:buFontTx/>
+                  <a:buNone/>
+                  <a:tabLst/>
+                </a:pPr>
+                <a:endParaRPr kumimoji="0" lang="en-US" sz="3200" b="0" i="0" u="none" strike="noStrike" cap="none" normalizeH="0" baseline="0">
+                  <a:ln>
+                    <a:noFill/>
+                  </a:ln>
+                  <a:solidFill>
+                    <a:schemeClr val="bg1"/>
+                  </a:solidFill>
+                  <a:effectLst/>
+                  <a:latin typeface="Aptos" panose="020B0004020202020204" pitchFamily="34" charset="0"/>
+                </a:endParaRPr>
+              </a:p>
+            </p:txBody>
+          </p:sp>
+          <p:sp>
+            <p:nvSpPr>
+              <p:cNvPr id="12" name="Rectangle: Rounded Corners 11">
+                <a:extLst>
+                  <a:ext uri="{FF2B5EF4-FFF2-40B4-BE49-F238E27FC236}">
+                    <a16:creationId xmlns:a16="http://schemas.microsoft.com/office/drawing/2014/main" id="{66193A0A-53CB-3B50-D1A3-0340FA3B1136}"/>
+                  </a:ext>
+                </a:extLst>
+              </p:cNvPr>
+              <p:cNvSpPr/>
+              <p:nvPr/>
+            </p:nvSpPr>
+            <p:spPr bwMode="auto">
+              <a:xfrm rot="17559388">
+                <a:off x="1210525" y="3547350"/>
+                <a:ext cx="3843158" cy="162504"/>
+              </a:xfrm>
+              <a:prstGeom prst="roundRect">
+                <a:avLst>
+                  <a:gd name="adj" fmla="val 50000"/>
+                </a:avLst>
+              </a:prstGeom>
+              <a:solidFill>
+                <a:srgbClr val="87C9FB"/>
+              </a:solidFill>
+              <a:ln w="9525" cap="flat" cmpd="sng" algn="ctr">
+                <a:noFill/>
+                <a:prstDash val="solid"/>
+                <a:round/>
+                <a:headEnd type="none" w="med" len="med"/>
+                <a:tailEnd type="none" w="med" len="med"/>
+              </a:ln>
+              <a:effectLst/>
+            </p:spPr>
+            <p:txBody>
+              <a:bodyPr vert="horz" wrap="square" lIns="91440" tIns="45720" rIns="91440" bIns="45720" numCol="1" rtlCol="0" anchor="ctr" anchorCtr="0" compatLnSpc="1">
+                <a:prstTxWarp prst="textNoShape">
+                  <a:avLst/>
+                </a:prstTxWarp>
+              </a:bodyPr>
+              <a:lstStyle/>
+              <a:p>
+                <a:pPr marL="0" marR="0" indent="0" algn="l" defTabSz="914400" rtl="0" eaLnBrk="0" fontAlgn="base" latinLnBrk="0" hangingPunct="0">
+                  <a:lnSpc>
+                    <a:spcPct val="100000"/>
+                  </a:lnSpc>
+                  <a:spcBef>
+                    <a:spcPct val="0"/>
+                  </a:spcBef>
+                  <a:spcAft>
+                    <a:spcPct val="0"/>
+                  </a:spcAft>
+                  <a:buClrTx/>
+                  <a:buSzTx/>
+                  <a:buFontTx/>
+                  <a:buNone/>
+                  <a:tabLst/>
+                </a:pPr>
+                <a:endParaRPr kumimoji="0" lang="en-US" sz="3200" b="0" i="0" u="none" strike="noStrike" cap="none" normalizeH="0" baseline="0">
+                  <a:ln>
+                    <a:noFill/>
+                  </a:ln>
+                  <a:solidFill>
+                    <a:schemeClr val="bg1"/>
+                  </a:solidFill>
+                  <a:effectLst/>
+                  <a:latin typeface="Aptos" panose="020B0004020202020204" pitchFamily="34" charset="0"/>
+                </a:endParaRPr>
+              </a:p>
+            </p:txBody>
+          </p:sp>
+          <p:sp>
+            <p:nvSpPr>
+              <p:cNvPr id="13" name="Rectangle: Rounded Corners 12">
+                <a:extLst>
+                  <a:ext uri="{FF2B5EF4-FFF2-40B4-BE49-F238E27FC236}">
+                    <a16:creationId xmlns:a16="http://schemas.microsoft.com/office/drawing/2014/main" id="{49BFA074-1FB6-4F27-A377-622D4E1A36CA}"/>
+                  </a:ext>
+                </a:extLst>
+              </p:cNvPr>
+              <p:cNvSpPr/>
+              <p:nvPr/>
+            </p:nvSpPr>
+            <p:spPr bwMode="auto">
+              <a:xfrm rot="17559388">
+                <a:off x="909418" y="3248426"/>
+                <a:ext cx="4339619" cy="162504"/>
+              </a:xfrm>
+              <a:prstGeom prst="roundRect">
+                <a:avLst>
+                  <a:gd name="adj" fmla="val 50000"/>
+                </a:avLst>
+              </a:prstGeom>
+              <a:solidFill>
+                <a:srgbClr val="7030A0"/>
+              </a:solidFill>
+              <a:ln w="9525" cap="flat" cmpd="sng" algn="ctr">
+                <a:noFill/>
+                <a:prstDash val="solid"/>
+                <a:round/>
+                <a:headEnd type="none" w="med" len="med"/>
+                <a:tailEnd type="none" w="med" len="med"/>
+              </a:ln>
+              <a:effectLst/>
+            </p:spPr>
+            <p:txBody>
+              <a:bodyPr vert="horz" wrap="square" lIns="91440" tIns="45720" rIns="91440" bIns="45720" numCol="1" rtlCol="0" anchor="ctr" anchorCtr="0" compatLnSpc="1">
+                <a:prstTxWarp prst="textNoShape">
+                  <a:avLst/>
+                </a:prstTxWarp>
+              </a:bodyPr>
+              <a:lstStyle/>
+              <a:p>
+                <a:pPr marL="0" marR="0" indent="0" algn="l" defTabSz="914400" rtl="0" eaLnBrk="0" fontAlgn="base" latinLnBrk="0" hangingPunct="0">
+                  <a:lnSpc>
+                    <a:spcPct val="100000"/>
+                  </a:lnSpc>
+                  <a:spcBef>
+                    <a:spcPct val="0"/>
+                  </a:spcBef>
+                  <a:spcAft>
+                    <a:spcPct val="0"/>
+                  </a:spcAft>
+                  <a:buClrTx/>
+                  <a:buSzTx/>
+                  <a:buFontTx/>
+                  <a:buNone/>
+                  <a:tabLst/>
+                </a:pPr>
+                <a:endParaRPr kumimoji="0" lang="en-US" sz="3200" b="0" i="0" u="none" strike="noStrike" cap="none" normalizeH="0" baseline="0">
+                  <a:ln>
+                    <a:noFill/>
+                  </a:ln>
+                  <a:solidFill>
+                    <a:schemeClr val="bg1"/>
+                  </a:solidFill>
+                  <a:effectLst/>
+                  <a:latin typeface="Aptos" panose="020B0004020202020204" pitchFamily="34" charset="0"/>
+                </a:endParaRPr>
+              </a:p>
+            </p:txBody>
+          </p:sp>
+        </p:grpSp>
+      </p:grpSp>
+    </p:spTree>
+    <p:extLst>
+      <p:ext uri="{BB962C8B-B14F-4D97-AF65-F5344CB8AC3E}">
+        <p14:creationId xmlns:p14="http://schemas.microsoft.com/office/powerpoint/2010/main" val="1537337488"/>
+      </p:ext>
+    </p:extLst>
+  </p:cSld>
+  <p:clrMapOvr>
+    <a:masterClrMapping/>
+  </p:clrMapOvr>
+</p:sld>
+</file>
+
+<file path=ppt/slides/slide3.xml><?xml version="1.0" encoding="utf-8"?>
+<p:sld xmlns:a="http://schemas.openxmlformats.org/drawingml/2006/main" xmlns:r="http://schemas.openxmlformats.org/officeDocument/2006/relationships" xmlns:p="http://schemas.openxmlformats.org/presentationml/2006/main">
+  <p:cSld>
+    <p:spTree>
+      <p:nvGrpSpPr>
+        <p:cNvPr id="1" name=""/>
+        <p:cNvGrpSpPr/>
+        <p:nvPr/>
+      </p:nvGrpSpPr>
+      <p:grpSpPr>
+        <a:xfrm>
+          <a:off x="0" y="0"/>
+          <a:ext cx="0" cy="0"/>
+          <a:chOff x="0" y="0"/>
+          <a:chExt cx="0" cy="0"/>
+        </a:xfrm>
+      </p:grpSpPr>
+      <p:pic>
+        <p:nvPicPr>
+          <p:cNvPr id="45" name="Picture 44">
+            <a:extLst>
+              <a:ext uri="{FF2B5EF4-FFF2-40B4-BE49-F238E27FC236}">
+                <a16:creationId xmlns:a16="http://schemas.microsoft.com/office/drawing/2014/main" id="{7DF1DB27-939A-CC5D-0302-A5C583118024}"/>
+              </a:ext>
+            </a:extLst>
+          </p:cNvPr>
+          <p:cNvPicPr>
+            <a:picLocks noChangeAspect="1"/>
+          </p:cNvPicPr>
+          <p:nvPr/>
+        </p:nvPicPr>
+        <p:blipFill>
+          <a:blip r:embed="rId2"/>
+          <a:stretch>
+            <a:fillRect/>
+          </a:stretch>
+        </p:blipFill>
+        <p:spPr>
+          <a:xfrm>
+            <a:off x="3970270" y="259705"/>
+            <a:ext cx="3470619" cy="2991233"/>
+          </a:xfrm>
+          <a:prstGeom prst="rect">
+            <a:avLst/>
+          </a:prstGeom>
+        </p:spPr>
+      </p:pic>
+      <p:sp>
+        <p:nvSpPr>
+          <p:cNvPr id="2" name="Slide Number Placeholder 1">
+            <a:extLst>
+              <a:ext uri="{FF2B5EF4-FFF2-40B4-BE49-F238E27FC236}">
+                <a16:creationId xmlns:a16="http://schemas.microsoft.com/office/drawing/2014/main" id="{DDE1E218-6DD4-FC45-6827-1F4ED02E9FFC}"/>
+              </a:ext>
+            </a:extLst>
+          </p:cNvPr>
+          <p:cNvSpPr>
+            <a:spLocks noGrp="1"/>
+          </p:cNvSpPr>
+          <p:nvPr>
+            <p:ph type="sldNum" sz="quarter" idx="4"/>
+          </p:nvPr>
+        </p:nvSpPr>
+        <p:spPr/>
+        <p:txBody>
+          <a:bodyPr/>
+          <a:lstStyle/>
+          <a:p>
+            <a:fld id="{5CC3E5C4-3E2B-40F1-9F2B-C46CEB0C88DF}" type="slidenum">
+              <a:rPr lang="en-CA" smtClean="0"/>
+              <a:pPr/>
+              <a:t>3</a:t>
+            </a:fld>
+            <a:endParaRPr lang="en-CA" dirty="0"/>
+          </a:p>
+        </p:txBody>
+      </p:sp>
+      <p:sp>
+        <p:nvSpPr>
+          <p:cNvPr id="4" name="Arrow: Right 3">
+            <a:extLst>
+              <a:ext uri="{FF2B5EF4-FFF2-40B4-BE49-F238E27FC236}">
+                <a16:creationId xmlns:a16="http://schemas.microsoft.com/office/drawing/2014/main" id="{EA9A628B-7967-0BC8-CD0C-19B116008529}"/>
+              </a:ext>
+            </a:extLst>
+          </p:cNvPr>
+          <p:cNvSpPr/>
+          <p:nvPr/>
+        </p:nvSpPr>
+        <p:spPr bwMode="auto">
+          <a:xfrm>
+            <a:off x="683568" y="1203653"/>
+            <a:ext cx="3050389" cy="1080120"/>
+          </a:xfrm>
+          <a:prstGeom prst="rightArrow">
+            <a:avLst/>
+          </a:prstGeom>
+          <a:solidFill>
+            <a:srgbClr val="00B0F0"/>
+          </a:solidFill>
+          <a:ln w="9525" cap="flat" cmpd="sng" algn="ctr">
+            <a:noFill/>
+            <a:prstDash val="solid"/>
+            <a:round/>
+            <a:headEnd type="none" w="med" len="med"/>
+            <a:tailEnd type="none" w="med" len="med"/>
+          </a:ln>
+          <a:effectLst/>
+        </p:spPr>
+        <p:txBody>
+          <a:bodyPr vert="horz" wrap="square" lIns="91440" tIns="45720" rIns="91440" bIns="45720" numCol="1" rtlCol="0" anchor="ctr" anchorCtr="0" compatLnSpc="1">
+            <a:prstTxWarp prst="textNoShape">
+              <a:avLst/>
+            </a:prstTxWarp>
+          </a:bodyPr>
+          <a:lstStyle/>
+          <a:p>
+            <a:pPr marL="0" marR="0" indent="0" algn="ctr" defTabSz="914400" rtl="0" eaLnBrk="0" fontAlgn="base" latinLnBrk="0" hangingPunct="0">
+              <a:lnSpc>
+                <a:spcPct val="100000"/>
+              </a:lnSpc>
+              <a:spcBef>
+                <a:spcPct val="0"/>
+              </a:spcBef>
+              <a:spcAft>
+                <a:spcPct val="0"/>
+              </a:spcAft>
+              <a:buClrTx/>
+              <a:buSzTx/>
+              <a:buFontTx/>
+              <a:buNone/>
+              <a:tabLst/>
+            </a:pPr>
+            <a:r>
+              <a:rPr kumimoji="0" lang="en-US" sz="2800" b="1" i="0" u="none" strike="noStrike" cap="none" normalizeH="0" baseline="0" dirty="0">
+                <a:ln>
+                  <a:noFill/>
+                </a:ln>
+                <a:solidFill>
+                  <a:schemeClr val="tx1"/>
+                </a:solidFill>
+                <a:effectLst/>
+                <a:latin typeface="Aptos" panose="020B0004020202020204" pitchFamily="34" charset="0"/>
+                <a:ea typeface="Calibri" panose="020F0502020204030204" pitchFamily="34" charset="0"/>
+                <a:cs typeface="Calibri" panose="020F0502020204030204" pitchFamily="34" charset="0"/>
+              </a:rPr>
+              <a:t>The US-PCS</a:t>
+            </a:r>
+          </a:p>
+        </p:txBody>
+      </p:sp>
+      <p:sp>
+        <p:nvSpPr>
+          <p:cNvPr id="5" name="Rectangle: Rounded Corners 4">
+            <a:extLst>
+              <a:ext uri="{FF2B5EF4-FFF2-40B4-BE49-F238E27FC236}">
+                <a16:creationId xmlns:a16="http://schemas.microsoft.com/office/drawing/2014/main" id="{9F486815-229A-4EC5-0B0A-BF84E9D7C22B}"/>
+              </a:ext>
+            </a:extLst>
+          </p:cNvPr>
+          <p:cNvSpPr/>
+          <p:nvPr/>
+        </p:nvSpPr>
+        <p:spPr bwMode="auto">
+          <a:xfrm>
+            <a:off x="683568" y="3933056"/>
+            <a:ext cx="7848872" cy="1904164"/>
+          </a:xfrm>
+          <a:prstGeom prst="roundRect">
+            <a:avLst>
+              <a:gd name="adj" fmla="val 9009"/>
+            </a:avLst>
+          </a:prstGeom>
+          <a:solidFill>
+            <a:schemeClr val="bg1">
+              <a:lumMod val="85000"/>
+            </a:schemeClr>
+          </a:solidFill>
+          <a:ln w="9525" cap="flat" cmpd="sng" algn="ctr">
+            <a:noFill/>
+            <a:prstDash val="solid"/>
+            <a:round/>
+            <a:headEnd type="none" w="med" len="med"/>
+            <a:tailEnd type="none" w="med" len="med"/>
+          </a:ln>
+          <a:effectLst/>
+        </p:spPr>
+        <p:txBody>
+          <a:bodyPr vert="horz" wrap="square" lIns="91440" tIns="45720" rIns="91440" bIns="45720" numCol="1" rtlCol="0" anchor="ctr" anchorCtr="0" compatLnSpc="1">
+            <a:prstTxWarp prst="textNoShape">
+              <a:avLst/>
+            </a:prstTxWarp>
+          </a:bodyPr>
+          <a:lstStyle/>
+          <a:p>
+            <a:pPr algn="ctr" eaLnBrk="0" fontAlgn="base" hangingPunct="0">
+              <a:spcBef>
+                <a:spcPct val="0"/>
+              </a:spcBef>
+              <a:spcAft>
+                <a:spcPct val="0"/>
+              </a:spcAft>
+            </a:pPr>
+            <a:endParaRPr lang="en-US" sz="2800" b="1">
+              <a:latin typeface="Aptos" panose="020B0004020202020204" pitchFamily="34" charset="0"/>
+              <a:ea typeface="Calibri" panose="020F0502020204030204" pitchFamily="34" charset="0"/>
+              <a:cs typeface="Calibri" panose="020F0502020204030204" pitchFamily="34" charset="0"/>
+            </a:endParaRPr>
+          </a:p>
+        </p:txBody>
+      </p:sp>
+      <p:sp>
+        <p:nvSpPr>
+          <p:cNvPr id="6" name="TextBox 5">
+            <a:extLst>
+              <a:ext uri="{FF2B5EF4-FFF2-40B4-BE49-F238E27FC236}">
+                <a16:creationId xmlns:a16="http://schemas.microsoft.com/office/drawing/2014/main" id="{A5FFA8CC-426F-ADCA-697F-CB233B5327DC}"/>
+              </a:ext>
+            </a:extLst>
+          </p:cNvPr>
+          <p:cNvSpPr txBox="1"/>
+          <p:nvPr/>
+        </p:nvSpPr>
+        <p:spPr>
+          <a:xfrm>
+            <a:off x="683569" y="3949192"/>
+            <a:ext cx="7848872" cy="523220"/>
+          </a:xfrm>
+          <a:prstGeom prst="rect">
+            <a:avLst/>
+          </a:prstGeom>
+          <a:noFill/>
+        </p:spPr>
+        <p:txBody>
+          <a:bodyPr wrap="square" rtlCol="0">
+            <a:spAutoFit/>
+          </a:bodyPr>
+          <a:lstStyle/>
+          <a:p>
+            <a:pPr algn="ctr"/>
+            <a:r>
+              <a:rPr lang="en-US" sz="2800" b="1" dirty="0">
+                <a:latin typeface="Aptos" panose="020B0004020202020204" pitchFamily="34" charset="0"/>
+                <a:ea typeface="Calibri" panose="020F0502020204030204" pitchFamily="34" charset="0"/>
+                <a:cs typeface="Calibri" panose="020F0502020204030204" pitchFamily="34" charset="0"/>
+              </a:rPr>
+              <a:t>Composed from US Core Resources</a:t>
+            </a:r>
+          </a:p>
+        </p:txBody>
+      </p:sp>
+      <p:cxnSp>
+        <p:nvCxnSpPr>
+          <p:cNvPr id="7" name="Connector: Elbow 6">
+            <a:extLst>
+              <a:ext uri="{FF2B5EF4-FFF2-40B4-BE49-F238E27FC236}">
+                <a16:creationId xmlns:a16="http://schemas.microsoft.com/office/drawing/2014/main" id="{FB52AC63-B7A5-EFC3-5AC1-0C45ADB2352C}"/>
+              </a:ext>
+            </a:extLst>
+          </p:cNvPr>
+          <p:cNvCxnSpPr>
+            <a:cxnSpLocks/>
+            <a:stCxn id="8" idx="2"/>
+            <a:endCxn id="5" idx="0"/>
+          </p:cNvCxnSpPr>
+          <p:nvPr/>
+        </p:nvCxnSpPr>
+        <p:spPr bwMode="auto">
+          <a:xfrm rot="5400000">
+            <a:off x="4878883" y="3077832"/>
+            <a:ext cx="584345" cy="1126102"/>
+          </a:xfrm>
+          <a:prstGeom prst="bentConnector3">
+            <a:avLst/>
+          </a:prstGeom>
+          <a:solidFill>
+            <a:schemeClr val="accent1"/>
+          </a:solidFill>
+          <a:ln w="57150" cap="flat" cmpd="sng" algn="ctr">
+            <a:solidFill>
+              <a:schemeClr val="bg1">
+                <a:lumMod val="75000"/>
+              </a:schemeClr>
+            </a:solidFill>
+            <a:prstDash val="solid"/>
+            <a:round/>
+            <a:headEnd type="none" w="med" len="med"/>
+            <a:tailEnd type="none" w="med" len="med"/>
+          </a:ln>
+          <a:effectLst/>
+          <a:extLst>
+            <a:ext uri="{AF507438-7753-43E0-B8FC-AC1667EBCBE1}">
+              <a14:hiddenEffects xmlns:a14="http://schemas.microsoft.com/office/drawing/2010/main">
+                <a:effectLst>
+                  <a:outerShdw dist="35921" dir="2700000" algn="ctr" rotWithShape="0">
+                    <a:schemeClr val="bg2"/>
+                  </a:outerShdw>
+                </a:effectLst>
+              </a14:hiddenEffects>
+            </a:ext>
+          </a:extLst>
+        </p:spPr>
+      </p:cxnSp>
+      <p:sp>
+        <p:nvSpPr>
+          <p:cNvPr id="8" name="Rectangle: Rounded Corners 7">
+            <a:extLst>
+              <a:ext uri="{FF2B5EF4-FFF2-40B4-BE49-F238E27FC236}">
+                <a16:creationId xmlns:a16="http://schemas.microsoft.com/office/drawing/2014/main" id="{F3DD1174-A3B8-A695-1197-F68814A9AB78}"/>
+              </a:ext>
+            </a:extLst>
+          </p:cNvPr>
+          <p:cNvSpPr/>
+          <p:nvPr/>
+        </p:nvSpPr>
+        <p:spPr bwMode="auto">
+          <a:xfrm>
+            <a:off x="3796706" y="116632"/>
+            <a:ext cx="3874799" cy="3232079"/>
+          </a:xfrm>
+          <a:prstGeom prst="roundRect">
+            <a:avLst>
+              <a:gd name="adj" fmla="val 4745"/>
+            </a:avLst>
+          </a:prstGeom>
+          <a:noFill/>
+          <a:ln w="57150" cap="flat" cmpd="sng" algn="ctr">
+            <a:solidFill>
+              <a:srgbClr val="00B0F0"/>
+            </a:solidFill>
+            <a:prstDash val="solid"/>
+            <a:round/>
+            <a:headEnd type="none" w="med" len="med"/>
+            <a:tailEnd type="none" w="med" len="med"/>
+          </a:ln>
+          <a:effectLst/>
+        </p:spPr>
+        <p:txBody>
+          <a:bodyPr vert="horz" wrap="square" lIns="91440" tIns="45720" rIns="91440" bIns="45720" numCol="1" rtlCol="0" anchor="t" anchorCtr="0" compatLnSpc="1">
+            <a:prstTxWarp prst="textNoShape">
+              <a:avLst/>
+            </a:prstTxWarp>
+          </a:bodyPr>
+          <a:lstStyle/>
+          <a:p>
+            <a:pPr marL="0" marR="0" indent="0" algn="l" defTabSz="914400" rtl="0" eaLnBrk="0" fontAlgn="base" latinLnBrk="0" hangingPunct="0">
+              <a:lnSpc>
+                <a:spcPct val="100000"/>
+              </a:lnSpc>
+              <a:spcBef>
+                <a:spcPct val="0"/>
+              </a:spcBef>
+              <a:spcAft>
+                <a:spcPct val="0"/>
+              </a:spcAft>
+              <a:buClrTx/>
+              <a:buSzTx/>
+              <a:buFontTx/>
+              <a:buNone/>
+              <a:tabLst/>
+            </a:pPr>
+            <a:endParaRPr kumimoji="0" lang="en-US" sz="1800" b="0" i="0" u="none" strike="noStrike" cap="none" normalizeH="0" baseline="0">
+              <a:ln>
+                <a:noFill/>
+              </a:ln>
+              <a:solidFill>
+                <a:schemeClr val="tx1"/>
+              </a:solidFill>
+              <a:effectLst/>
+              <a:latin typeface="Arial" charset="0"/>
+            </a:endParaRPr>
+          </a:p>
+        </p:txBody>
+      </p:sp>
+      <p:sp>
+        <p:nvSpPr>
+          <p:cNvPr id="9" name="Rectangle: Rounded Corners 8">
+            <a:extLst>
+              <a:ext uri="{FF2B5EF4-FFF2-40B4-BE49-F238E27FC236}">
+                <a16:creationId xmlns:a16="http://schemas.microsoft.com/office/drawing/2014/main" id="{F662DE05-FAFE-7788-D396-191BCFF09398}"/>
+              </a:ext>
+            </a:extLst>
+          </p:cNvPr>
+          <p:cNvSpPr/>
+          <p:nvPr/>
+        </p:nvSpPr>
+        <p:spPr bwMode="auto">
+          <a:xfrm>
+            <a:off x="5527070" y="4513208"/>
+            <a:ext cx="910712" cy="929216"/>
+          </a:xfrm>
+          <a:prstGeom prst="roundRect">
+            <a:avLst/>
+          </a:prstGeom>
+          <a:solidFill>
+            <a:schemeClr val="bg1"/>
+          </a:solidFill>
+          <a:ln w="38100" cap="flat" cmpd="sng" algn="ctr">
+            <a:solidFill>
+              <a:srgbClr val="E86328"/>
+            </a:solidFill>
+            <a:prstDash val="solid"/>
+            <a:round/>
+            <a:headEnd type="none" w="med" len="med"/>
+            <a:tailEnd type="none" w="med" len="med"/>
+          </a:ln>
+          <a:effectLst/>
+        </p:spPr>
+        <p:txBody>
+          <a:bodyPr vert="horz" wrap="square" lIns="91440" tIns="45720" rIns="91440" bIns="45720" numCol="1" rtlCol="0" anchor="t" anchorCtr="0" compatLnSpc="1">
+            <a:prstTxWarp prst="textNoShape">
+              <a:avLst/>
+            </a:prstTxWarp>
+          </a:bodyPr>
+          <a:lstStyle/>
+          <a:p>
+            <a:pPr eaLnBrk="0" fontAlgn="base" hangingPunct="0">
+              <a:spcBef>
+                <a:spcPct val="0"/>
+              </a:spcBef>
+              <a:spcAft>
+                <a:spcPct val="0"/>
+              </a:spcAft>
+            </a:pPr>
+            <a:endParaRPr lang="en-US">
+              <a:latin typeface="Arial" charset="0"/>
+            </a:endParaRPr>
+          </a:p>
+        </p:txBody>
+      </p:sp>
+      <p:sp>
+        <p:nvSpPr>
+          <p:cNvPr id="10" name="Rectangle: Rounded Corners 9">
+            <a:extLst>
+              <a:ext uri="{FF2B5EF4-FFF2-40B4-BE49-F238E27FC236}">
+                <a16:creationId xmlns:a16="http://schemas.microsoft.com/office/drawing/2014/main" id="{3E83209D-066F-B14A-6B42-B618BAB91370}"/>
+              </a:ext>
+            </a:extLst>
+          </p:cNvPr>
+          <p:cNvSpPr/>
+          <p:nvPr/>
+        </p:nvSpPr>
+        <p:spPr bwMode="auto">
+          <a:xfrm>
+            <a:off x="4584539" y="4513208"/>
+            <a:ext cx="910712" cy="929216"/>
+          </a:xfrm>
+          <a:prstGeom prst="roundRect">
+            <a:avLst/>
+          </a:prstGeom>
+          <a:solidFill>
+            <a:schemeClr val="bg1"/>
+          </a:solidFill>
+          <a:ln w="38100" cap="flat" cmpd="sng" algn="ctr">
+            <a:solidFill>
+              <a:srgbClr val="F7D33E"/>
+            </a:solidFill>
+            <a:prstDash val="solid"/>
+            <a:round/>
+            <a:headEnd type="none" w="med" len="med"/>
+            <a:tailEnd type="none" w="med" len="med"/>
+          </a:ln>
+          <a:effectLst/>
+        </p:spPr>
+        <p:txBody>
+          <a:bodyPr vert="horz" wrap="square" lIns="91440" tIns="45720" rIns="91440" bIns="45720" numCol="1" rtlCol="0" anchor="t" anchorCtr="0" compatLnSpc="1">
+            <a:prstTxWarp prst="textNoShape">
+              <a:avLst/>
+            </a:prstTxWarp>
+          </a:bodyPr>
+          <a:lstStyle/>
+          <a:p>
+            <a:pPr eaLnBrk="0" fontAlgn="base" hangingPunct="0">
+              <a:spcBef>
+                <a:spcPct val="0"/>
+              </a:spcBef>
+              <a:spcAft>
+                <a:spcPct val="0"/>
+              </a:spcAft>
+            </a:pPr>
+            <a:endParaRPr lang="en-US">
+              <a:latin typeface="Arial" charset="0"/>
+            </a:endParaRPr>
+          </a:p>
+        </p:txBody>
+      </p:sp>
+      <p:sp>
+        <p:nvSpPr>
+          <p:cNvPr id="11" name="Rectangle: Rounded Corners 10">
+            <a:extLst>
+              <a:ext uri="{FF2B5EF4-FFF2-40B4-BE49-F238E27FC236}">
+                <a16:creationId xmlns:a16="http://schemas.microsoft.com/office/drawing/2014/main" id="{4AA4BF78-B642-3FFC-5EAC-AF744A5E62B0}"/>
+              </a:ext>
+            </a:extLst>
+          </p:cNvPr>
+          <p:cNvSpPr/>
+          <p:nvPr/>
+        </p:nvSpPr>
+        <p:spPr bwMode="auto">
+          <a:xfrm>
+            <a:off x="3642009" y="4513208"/>
+            <a:ext cx="910712" cy="929216"/>
+          </a:xfrm>
+          <a:prstGeom prst="roundRect">
+            <a:avLst/>
+          </a:prstGeom>
+          <a:solidFill>
+            <a:schemeClr val="bg1"/>
+          </a:solidFill>
+          <a:ln w="38100" cap="flat" cmpd="sng" algn="ctr">
+            <a:solidFill>
+              <a:srgbClr val="CAD404"/>
+            </a:solidFill>
+            <a:prstDash val="solid"/>
+            <a:round/>
+            <a:headEnd type="none" w="med" len="med"/>
+            <a:tailEnd type="none" w="med" len="med"/>
+          </a:ln>
+          <a:effectLst/>
+        </p:spPr>
+        <p:txBody>
+          <a:bodyPr vert="horz" wrap="square" lIns="91440" tIns="45720" rIns="91440" bIns="45720" numCol="1" rtlCol="0" anchor="t" anchorCtr="0" compatLnSpc="1">
+            <a:prstTxWarp prst="textNoShape">
+              <a:avLst/>
+            </a:prstTxWarp>
+          </a:bodyPr>
+          <a:lstStyle/>
+          <a:p>
+            <a:pPr eaLnBrk="0" fontAlgn="base" hangingPunct="0">
+              <a:spcBef>
+                <a:spcPct val="0"/>
+              </a:spcBef>
+              <a:spcAft>
+                <a:spcPct val="0"/>
+              </a:spcAft>
+            </a:pPr>
+            <a:endParaRPr lang="en-US">
+              <a:latin typeface="Arial" charset="0"/>
+            </a:endParaRPr>
+          </a:p>
+        </p:txBody>
+      </p:sp>
+      <p:sp>
+        <p:nvSpPr>
+          <p:cNvPr id="12" name="Rectangle: Rounded Corners 11">
+            <a:extLst>
+              <a:ext uri="{FF2B5EF4-FFF2-40B4-BE49-F238E27FC236}">
+                <a16:creationId xmlns:a16="http://schemas.microsoft.com/office/drawing/2014/main" id="{02F332F6-8C71-99A0-E885-17ED5602BE1B}"/>
+              </a:ext>
+            </a:extLst>
+          </p:cNvPr>
+          <p:cNvSpPr/>
+          <p:nvPr/>
+        </p:nvSpPr>
+        <p:spPr bwMode="auto">
+          <a:xfrm>
+            <a:off x="2699478" y="4513208"/>
+            <a:ext cx="910712" cy="929216"/>
+          </a:xfrm>
+          <a:prstGeom prst="roundRect">
+            <a:avLst/>
+          </a:prstGeom>
+          <a:solidFill>
+            <a:schemeClr val="bg1"/>
+          </a:solidFill>
+          <a:ln w="38100" cap="flat" cmpd="sng" algn="ctr">
+            <a:solidFill>
+              <a:srgbClr val="05953F"/>
+            </a:solidFill>
+            <a:prstDash val="solid"/>
+            <a:round/>
+            <a:headEnd type="none" w="med" len="med"/>
+            <a:tailEnd type="none" w="med" len="med"/>
+          </a:ln>
+          <a:effectLst/>
+        </p:spPr>
+        <p:txBody>
+          <a:bodyPr vert="horz" wrap="square" lIns="91440" tIns="45720" rIns="91440" bIns="45720" numCol="1" rtlCol="0" anchor="t" anchorCtr="0" compatLnSpc="1">
+            <a:prstTxWarp prst="textNoShape">
+              <a:avLst/>
+            </a:prstTxWarp>
+          </a:bodyPr>
+          <a:lstStyle/>
+          <a:p>
+            <a:pPr eaLnBrk="0" fontAlgn="base" hangingPunct="0">
+              <a:spcBef>
+                <a:spcPct val="0"/>
+              </a:spcBef>
+              <a:spcAft>
+                <a:spcPct val="0"/>
+              </a:spcAft>
+            </a:pPr>
+            <a:endParaRPr lang="en-US">
+              <a:latin typeface="Arial" charset="0"/>
+            </a:endParaRPr>
+          </a:p>
+        </p:txBody>
+      </p:sp>
+      <p:sp>
+        <p:nvSpPr>
+          <p:cNvPr id="13" name="Rectangle: Rounded Corners 12">
+            <a:extLst>
+              <a:ext uri="{FF2B5EF4-FFF2-40B4-BE49-F238E27FC236}">
+                <a16:creationId xmlns:a16="http://schemas.microsoft.com/office/drawing/2014/main" id="{FBF6042C-3073-CADF-6EAA-8A51C20752BB}"/>
+              </a:ext>
+            </a:extLst>
+          </p:cNvPr>
+          <p:cNvSpPr/>
+          <p:nvPr/>
+        </p:nvSpPr>
+        <p:spPr bwMode="auto">
+          <a:xfrm>
+            <a:off x="1756948" y="4513208"/>
+            <a:ext cx="910712" cy="929216"/>
+          </a:xfrm>
+          <a:prstGeom prst="roundRect">
+            <a:avLst/>
+          </a:prstGeom>
+          <a:solidFill>
+            <a:schemeClr val="bg1"/>
+          </a:solidFill>
+          <a:ln w="38100" cap="flat" cmpd="sng" algn="ctr">
+            <a:solidFill>
+              <a:srgbClr val="87C9FB"/>
+            </a:solidFill>
+            <a:prstDash val="solid"/>
+            <a:round/>
+            <a:headEnd type="none" w="med" len="med"/>
+            <a:tailEnd type="none" w="med" len="med"/>
+          </a:ln>
+          <a:effectLst/>
+        </p:spPr>
+        <p:txBody>
+          <a:bodyPr vert="horz" wrap="square" lIns="91440" tIns="45720" rIns="91440" bIns="45720" numCol="1" rtlCol="0" anchor="t" anchorCtr="0" compatLnSpc="1">
+            <a:prstTxWarp prst="textNoShape">
+              <a:avLst/>
+            </a:prstTxWarp>
+          </a:bodyPr>
+          <a:lstStyle/>
+          <a:p>
+            <a:pPr eaLnBrk="0" fontAlgn="base" hangingPunct="0">
+              <a:spcBef>
+                <a:spcPct val="0"/>
+              </a:spcBef>
+              <a:spcAft>
+                <a:spcPct val="0"/>
+              </a:spcAft>
+            </a:pPr>
+            <a:endParaRPr lang="en-US">
+              <a:latin typeface="Arial" charset="0"/>
+            </a:endParaRPr>
+          </a:p>
+        </p:txBody>
+      </p:sp>
+      <p:sp>
+        <p:nvSpPr>
+          <p:cNvPr id="14" name="Rectangle: Rounded Corners 13">
+            <a:extLst>
+              <a:ext uri="{FF2B5EF4-FFF2-40B4-BE49-F238E27FC236}">
+                <a16:creationId xmlns:a16="http://schemas.microsoft.com/office/drawing/2014/main" id="{AC2230B9-7344-5662-FA05-1DAF22E09F1C}"/>
+              </a:ext>
+            </a:extLst>
+          </p:cNvPr>
+          <p:cNvSpPr/>
+          <p:nvPr/>
+        </p:nvSpPr>
+        <p:spPr bwMode="auto">
+          <a:xfrm>
+            <a:off x="814417" y="4513208"/>
+            <a:ext cx="910712" cy="929216"/>
+          </a:xfrm>
+          <a:prstGeom prst="roundRect">
+            <a:avLst/>
+          </a:prstGeom>
+          <a:solidFill>
+            <a:schemeClr val="bg1"/>
+          </a:solidFill>
+          <a:ln w="38100" cap="flat" cmpd="sng" algn="ctr">
+            <a:solidFill>
+              <a:srgbClr val="7030A0"/>
+            </a:solidFill>
+            <a:prstDash val="solid"/>
+            <a:round/>
+            <a:headEnd type="none" w="med" len="med"/>
+            <a:tailEnd type="none" w="med" len="med"/>
+          </a:ln>
+          <a:effectLst/>
+        </p:spPr>
+        <p:txBody>
+          <a:bodyPr vert="horz" wrap="square" lIns="91440" tIns="45720" rIns="91440" bIns="45720" numCol="1" rtlCol="0" anchor="t" anchorCtr="0" compatLnSpc="1">
+            <a:prstTxWarp prst="textNoShape">
+              <a:avLst/>
+            </a:prstTxWarp>
+          </a:bodyPr>
+          <a:lstStyle/>
+          <a:p>
+            <a:pPr eaLnBrk="0" fontAlgn="base" hangingPunct="0">
+              <a:spcBef>
+                <a:spcPct val="0"/>
+              </a:spcBef>
+              <a:spcAft>
+                <a:spcPct val="0"/>
+              </a:spcAft>
+            </a:pPr>
+            <a:endParaRPr lang="en-US" dirty="0">
+              <a:latin typeface="Arial" charset="0"/>
+            </a:endParaRPr>
+          </a:p>
+        </p:txBody>
+      </p:sp>
+      <p:sp>
+        <p:nvSpPr>
+          <p:cNvPr id="15" name="Rectangle: Rounded Corners 14">
+            <a:extLst>
+              <a:ext uri="{FF2B5EF4-FFF2-40B4-BE49-F238E27FC236}">
+                <a16:creationId xmlns:a16="http://schemas.microsoft.com/office/drawing/2014/main" id="{5DA91108-D75E-5526-AA91-50172A4A30CC}"/>
+              </a:ext>
+            </a:extLst>
+          </p:cNvPr>
+          <p:cNvSpPr/>
+          <p:nvPr/>
+        </p:nvSpPr>
+        <p:spPr bwMode="auto">
+          <a:xfrm>
+            <a:off x="7406629" y="4513208"/>
+            <a:ext cx="910712" cy="929216"/>
+          </a:xfrm>
+          <a:prstGeom prst="roundRect">
+            <a:avLst/>
+          </a:prstGeom>
+          <a:solidFill>
+            <a:schemeClr val="bg1"/>
+          </a:solidFill>
+          <a:ln w="38100" cap="flat" cmpd="sng" algn="ctr">
+            <a:solidFill>
+              <a:schemeClr val="tx1">
+                <a:lumMod val="50000"/>
+                <a:lumOff val="50000"/>
+              </a:schemeClr>
+            </a:solidFill>
+            <a:prstDash val="solid"/>
+            <a:round/>
+            <a:headEnd type="none" w="med" len="med"/>
+            <a:tailEnd type="none" w="med" len="med"/>
+          </a:ln>
+          <a:effectLst/>
+        </p:spPr>
+        <p:txBody>
+          <a:bodyPr vert="horz" wrap="square" lIns="91440" tIns="45720" rIns="91440" bIns="45720" numCol="1" rtlCol="0" anchor="t" anchorCtr="0" compatLnSpc="1">
+            <a:prstTxWarp prst="textNoShape">
+              <a:avLst/>
+            </a:prstTxWarp>
+          </a:bodyPr>
+          <a:lstStyle/>
+          <a:p>
+            <a:pPr marL="0" marR="0" indent="0" algn="l" defTabSz="914400" rtl="0" eaLnBrk="0" fontAlgn="base" latinLnBrk="0" hangingPunct="0">
+              <a:lnSpc>
+                <a:spcPct val="100000"/>
+              </a:lnSpc>
+              <a:spcBef>
+                <a:spcPct val="0"/>
+              </a:spcBef>
+              <a:spcAft>
+                <a:spcPct val="0"/>
+              </a:spcAft>
+              <a:buClrTx/>
+              <a:buSzTx/>
+              <a:buFontTx/>
+              <a:buNone/>
+              <a:tabLst/>
+            </a:pPr>
+            <a:endParaRPr kumimoji="0" lang="en-US" sz="1800" b="0" i="0" u="none" strike="noStrike" cap="none" normalizeH="0" baseline="0">
+              <a:ln>
+                <a:noFill/>
+              </a:ln>
+              <a:solidFill>
+                <a:schemeClr val="tx1"/>
+              </a:solidFill>
+              <a:effectLst/>
+              <a:latin typeface="Arial" charset="0"/>
+            </a:endParaRPr>
+          </a:p>
+        </p:txBody>
+      </p:sp>
+      <p:sp>
+        <p:nvSpPr>
+          <p:cNvPr id="16" name="TextBox 15">
+            <a:extLst>
+              <a:ext uri="{FF2B5EF4-FFF2-40B4-BE49-F238E27FC236}">
+                <a16:creationId xmlns:a16="http://schemas.microsoft.com/office/drawing/2014/main" id="{5C49516B-5171-95B9-4802-70BDECA7BB1A}"/>
+              </a:ext>
+            </a:extLst>
+          </p:cNvPr>
+          <p:cNvSpPr txBox="1"/>
+          <p:nvPr/>
+        </p:nvSpPr>
+        <p:spPr>
+          <a:xfrm>
+            <a:off x="1923133" y="5182427"/>
+            <a:ext cx="640080" cy="274320"/>
+          </a:xfrm>
+          <a:prstGeom prst="rect">
+            <a:avLst/>
+          </a:prstGeom>
+          <a:noFill/>
+        </p:spPr>
+        <p:txBody>
+          <a:bodyPr wrap="none" rtlCol="0">
+            <a:spAutoFit/>
+          </a:bodyPr>
+          <a:lstStyle/>
+          <a:p>
+            <a:pPr algn="ctr"/>
+            <a:r>
+              <a:rPr lang="en-US" sz="1100" b="1" dirty="0">
+                <a:latin typeface="Aptos" panose="020B0004020202020204" pitchFamily="34" charset="0"/>
+                <a:ea typeface="Calibri" panose="020F0502020204030204" pitchFamily="34" charset="0"/>
+                <a:cs typeface="Calibri" panose="020F0502020204030204" pitchFamily="34" charset="0"/>
+              </a:rPr>
+              <a:t>Allergy</a:t>
+            </a:r>
+          </a:p>
+        </p:txBody>
+      </p:sp>
+      <p:sp>
+        <p:nvSpPr>
+          <p:cNvPr id="17" name="TextBox 16">
+            <a:extLst>
+              <a:ext uri="{FF2B5EF4-FFF2-40B4-BE49-F238E27FC236}">
+                <a16:creationId xmlns:a16="http://schemas.microsoft.com/office/drawing/2014/main" id="{470CAA3A-E678-76D4-D4D7-AB8203346864}"/>
+              </a:ext>
+            </a:extLst>
+          </p:cNvPr>
+          <p:cNvSpPr txBox="1"/>
+          <p:nvPr/>
+        </p:nvSpPr>
+        <p:spPr>
+          <a:xfrm>
+            <a:off x="956250" y="5182427"/>
+            <a:ext cx="640080" cy="274320"/>
+          </a:xfrm>
+          <a:prstGeom prst="rect">
+            <a:avLst/>
+          </a:prstGeom>
+          <a:noFill/>
+        </p:spPr>
+        <p:txBody>
+          <a:bodyPr wrap="none" rtlCol="0">
+            <a:spAutoFit/>
+          </a:bodyPr>
+          <a:lstStyle/>
+          <a:p>
+            <a:pPr algn="ctr"/>
+            <a:r>
+              <a:rPr lang="en-US" sz="1100" b="1" dirty="0">
+                <a:latin typeface="Aptos" panose="020B0004020202020204" pitchFamily="34" charset="0"/>
+                <a:ea typeface="Calibri" panose="020F0502020204030204" pitchFamily="34" charset="0"/>
+                <a:cs typeface="Calibri" panose="020F0502020204030204" pitchFamily="34" charset="0"/>
+              </a:rPr>
+              <a:t>Problem</a:t>
+            </a:r>
+          </a:p>
+        </p:txBody>
+      </p:sp>
+      <p:sp>
+        <p:nvSpPr>
+          <p:cNvPr id="18" name="TextBox 17">
+            <a:extLst>
+              <a:ext uri="{FF2B5EF4-FFF2-40B4-BE49-F238E27FC236}">
+                <a16:creationId xmlns:a16="http://schemas.microsoft.com/office/drawing/2014/main" id="{F0D6D3AA-19C8-5467-EDB2-82C17007007A}"/>
+              </a:ext>
+            </a:extLst>
+          </p:cNvPr>
+          <p:cNvSpPr txBox="1"/>
+          <p:nvPr/>
+        </p:nvSpPr>
+        <p:spPr>
+          <a:xfrm>
+            <a:off x="2855428" y="5182427"/>
+            <a:ext cx="640080" cy="274320"/>
+          </a:xfrm>
+          <a:prstGeom prst="rect">
+            <a:avLst/>
+          </a:prstGeom>
+          <a:noFill/>
+        </p:spPr>
+        <p:txBody>
+          <a:bodyPr wrap="none" rtlCol="0">
+            <a:spAutoFit/>
+          </a:bodyPr>
+          <a:lstStyle/>
+          <a:p>
+            <a:pPr algn="ctr"/>
+            <a:r>
+              <a:rPr lang="en-US" sz="1100" b="1" dirty="0">
+                <a:latin typeface="Aptos" panose="020B0004020202020204" pitchFamily="34" charset="0"/>
+                <a:ea typeface="Calibri" panose="020F0502020204030204" pitchFamily="34" charset="0"/>
+                <a:cs typeface="Calibri" panose="020F0502020204030204" pitchFamily="34" charset="0"/>
+              </a:rPr>
+              <a:t>Medication</a:t>
+            </a:r>
+          </a:p>
+        </p:txBody>
+      </p:sp>
+      <p:sp>
+        <p:nvSpPr>
+          <p:cNvPr id="19" name="TextBox 18">
+            <a:extLst>
+              <a:ext uri="{FF2B5EF4-FFF2-40B4-BE49-F238E27FC236}">
+                <a16:creationId xmlns:a16="http://schemas.microsoft.com/office/drawing/2014/main" id="{F149FD22-2BCD-2135-ACF7-7889DA0582A0}"/>
+              </a:ext>
+            </a:extLst>
+          </p:cNvPr>
+          <p:cNvSpPr txBox="1"/>
+          <p:nvPr/>
+        </p:nvSpPr>
+        <p:spPr>
+          <a:xfrm>
+            <a:off x="3781380" y="5182427"/>
+            <a:ext cx="640080" cy="274320"/>
+          </a:xfrm>
+          <a:prstGeom prst="rect">
+            <a:avLst/>
+          </a:prstGeom>
+          <a:noFill/>
+        </p:spPr>
+        <p:txBody>
+          <a:bodyPr wrap="none" rtlCol="0">
+            <a:spAutoFit/>
+          </a:bodyPr>
+          <a:lstStyle/>
+          <a:p>
+            <a:pPr algn="ctr"/>
+            <a:r>
+              <a:rPr lang="en-US" sz="1100" b="1" spc="-10" dirty="0">
+                <a:latin typeface="Aptos" panose="020B0004020202020204" pitchFamily="34" charset="0"/>
+                <a:ea typeface="Calibri" panose="020F0502020204030204" pitchFamily="34" charset="0"/>
+                <a:cs typeface="Calibri" panose="020F0502020204030204" pitchFamily="34" charset="0"/>
+              </a:rPr>
+              <a:t>Immunization</a:t>
+            </a:r>
+          </a:p>
+        </p:txBody>
+      </p:sp>
+      <p:sp>
+        <p:nvSpPr>
+          <p:cNvPr id="20" name="TextBox 19">
+            <a:extLst>
+              <a:ext uri="{FF2B5EF4-FFF2-40B4-BE49-F238E27FC236}">
+                <a16:creationId xmlns:a16="http://schemas.microsoft.com/office/drawing/2014/main" id="{55884DFF-1E26-0D90-5C1B-A563FBBE670C}"/>
+              </a:ext>
+            </a:extLst>
+          </p:cNvPr>
+          <p:cNvSpPr txBox="1"/>
+          <p:nvPr/>
+        </p:nvSpPr>
+        <p:spPr>
+          <a:xfrm>
+            <a:off x="4717094" y="5182427"/>
+            <a:ext cx="640080" cy="274320"/>
+          </a:xfrm>
+          <a:prstGeom prst="rect">
+            <a:avLst/>
+          </a:prstGeom>
+          <a:noFill/>
+        </p:spPr>
+        <p:txBody>
+          <a:bodyPr wrap="none" rtlCol="0">
+            <a:spAutoFit/>
+          </a:bodyPr>
+          <a:lstStyle/>
+          <a:p>
+            <a:pPr algn="ctr"/>
+            <a:r>
+              <a:rPr lang="en-US" sz="1100" b="1" dirty="0">
+                <a:latin typeface="Aptos" panose="020B0004020202020204" pitchFamily="34" charset="0"/>
+                <a:ea typeface="Calibri" panose="020F0502020204030204" pitchFamily="34" charset="0"/>
+                <a:cs typeface="Calibri" panose="020F0502020204030204" pitchFamily="34" charset="0"/>
+              </a:rPr>
+              <a:t>Result</a:t>
+            </a:r>
+          </a:p>
+        </p:txBody>
+      </p:sp>
+      <p:sp>
+        <p:nvSpPr>
+          <p:cNvPr id="21" name="TextBox 20">
+            <a:extLst>
+              <a:ext uri="{FF2B5EF4-FFF2-40B4-BE49-F238E27FC236}">
+                <a16:creationId xmlns:a16="http://schemas.microsoft.com/office/drawing/2014/main" id="{5A63EB1F-C910-2671-F7F4-EBB2F351A249}"/>
+              </a:ext>
+            </a:extLst>
+          </p:cNvPr>
+          <p:cNvSpPr txBox="1"/>
+          <p:nvPr/>
+        </p:nvSpPr>
+        <p:spPr>
+          <a:xfrm>
+            <a:off x="5668048" y="5182427"/>
+            <a:ext cx="640080" cy="274320"/>
+          </a:xfrm>
+          <a:prstGeom prst="rect">
+            <a:avLst/>
+          </a:prstGeom>
+          <a:noFill/>
+        </p:spPr>
+        <p:txBody>
+          <a:bodyPr wrap="none" rtlCol="0">
+            <a:spAutoFit/>
+          </a:bodyPr>
+          <a:lstStyle/>
+          <a:p>
+            <a:pPr algn="ctr"/>
+            <a:r>
+              <a:rPr lang="en-US" sz="1100" b="1" dirty="0">
+                <a:latin typeface="Aptos" panose="020B0004020202020204" pitchFamily="34" charset="0"/>
+                <a:ea typeface="Calibri" panose="020F0502020204030204" pitchFamily="34" charset="0"/>
+                <a:cs typeface="Calibri" panose="020F0502020204030204" pitchFamily="34" charset="0"/>
+              </a:rPr>
+              <a:t>Procedure</a:t>
+            </a:r>
+          </a:p>
+        </p:txBody>
+      </p:sp>
+      <p:sp>
+        <p:nvSpPr>
+          <p:cNvPr id="22" name="TextBox 21">
+            <a:extLst>
+              <a:ext uri="{FF2B5EF4-FFF2-40B4-BE49-F238E27FC236}">
+                <a16:creationId xmlns:a16="http://schemas.microsoft.com/office/drawing/2014/main" id="{BC00C105-88D4-7803-D546-255AFD78D678}"/>
+              </a:ext>
+            </a:extLst>
+          </p:cNvPr>
+          <p:cNvSpPr txBox="1"/>
+          <p:nvPr/>
+        </p:nvSpPr>
+        <p:spPr>
+          <a:xfrm>
+            <a:off x="7562539" y="5013176"/>
+            <a:ext cx="588597" cy="373854"/>
+          </a:xfrm>
+          <a:prstGeom prst="rect">
+            <a:avLst/>
+          </a:prstGeom>
+          <a:noFill/>
+        </p:spPr>
+        <p:txBody>
+          <a:bodyPr wrap="none" rtlCol="0">
+            <a:spAutoFit/>
+          </a:bodyPr>
+          <a:lstStyle/>
+          <a:p>
+            <a:pPr algn="ctr"/>
+            <a:r>
+              <a:rPr lang="en-US" sz="1100" b="1" dirty="0">
+                <a:latin typeface="Aptos" panose="020B0004020202020204" pitchFamily="34" charset="0"/>
+                <a:ea typeface="Calibri" panose="020F0502020204030204" pitchFamily="34" charset="0"/>
+                <a:cs typeface="Calibri" panose="020F0502020204030204" pitchFamily="34" charset="0"/>
+              </a:rPr>
+              <a:t>Other </a:t>
+            </a:r>
+            <a:br>
+              <a:rPr lang="en-US" sz="1100" b="1" dirty="0">
+                <a:latin typeface="Aptos" panose="020B0004020202020204" pitchFamily="34" charset="0"/>
+                <a:ea typeface="Calibri" panose="020F0502020204030204" pitchFamily="34" charset="0"/>
+                <a:cs typeface="Calibri" panose="020F0502020204030204" pitchFamily="34" charset="0"/>
+              </a:rPr>
+            </a:br>
+            <a:r>
+              <a:rPr lang="en-US" sz="1100" b="1" dirty="0">
+                <a:latin typeface="Aptos" panose="020B0004020202020204" pitchFamily="34" charset="0"/>
+                <a:ea typeface="Calibri" panose="020F0502020204030204" pitchFamily="34" charset="0"/>
+                <a:cs typeface="Calibri" panose="020F0502020204030204" pitchFamily="34" charset="0"/>
+              </a:rPr>
+              <a:t>Profiles</a:t>
+            </a:r>
+          </a:p>
+        </p:txBody>
+      </p:sp>
+      <p:pic>
+        <p:nvPicPr>
+          <p:cNvPr id="23" name="Picture 22" descr="A black and white image of a pair of scissors&#10;&#10;Description automatically generated">
+            <a:extLst>
+              <a:ext uri="{FF2B5EF4-FFF2-40B4-BE49-F238E27FC236}">
+                <a16:creationId xmlns:a16="http://schemas.microsoft.com/office/drawing/2014/main" id="{4DA76DF2-CF62-3C2B-58B1-00E7F990FBF8}"/>
+              </a:ext>
+            </a:extLst>
+          </p:cNvPr>
+          <p:cNvPicPr>
+            <a:picLocks noChangeAspect="1"/>
+          </p:cNvPicPr>
+          <p:nvPr/>
+        </p:nvPicPr>
+        <p:blipFill>
+          <a:blip r:embed="rId3">
+            <a:extLst>
+              <a:ext uri="{28A0092B-C50C-407E-A947-70E740481C1C}">
+                <a14:useLocalDpi xmlns:a14="http://schemas.microsoft.com/office/drawing/2010/main" val="0"/>
+              </a:ext>
+            </a:extLst>
+          </a:blip>
+          <a:stretch>
+            <a:fillRect/>
+          </a:stretch>
+        </p:blipFill>
+        <p:spPr>
+          <a:xfrm>
+            <a:off x="5740812" y="4633208"/>
+            <a:ext cx="528938" cy="528939"/>
+          </a:xfrm>
+          <a:prstGeom prst="rect">
+            <a:avLst/>
+          </a:prstGeom>
+        </p:spPr>
+      </p:pic>
+      <p:pic>
+        <p:nvPicPr>
+          <p:cNvPr id="24" name="Picture 23" descr="A stethoscope with a cord&#10;&#10;Description automatically generated">
+            <a:extLst>
+              <a:ext uri="{FF2B5EF4-FFF2-40B4-BE49-F238E27FC236}">
+                <a16:creationId xmlns:a16="http://schemas.microsoft.com/office/drawing/2014/main" id="{61D6E378-258E-49E3-63A4-8A4467383384}"/>
+              </a:ext>
+            </a:extLst>
+          </p:cNvPr>
+          <p:cNvPicPr>
+            <a:picLocks noChangeAspect="1"/>
+          </p:cNvPicPr>
+          <p:nvPr/>
+        </p:nvPicPr>
+        <p:blipFill>
+          <a:blip r:embed="rId4">
+            <a:extLst>
+              <a:ext uri="{28A0092B-C50C-407E-A947-70E740481C1C}">
+                <a14:useLocalDpi xmlns:a14="http://schemas.microsoft.com/office/drawing/2010/main" val="0"/>
+              </a:ext>
+            </a:extLst>
+          </a:blip>
+          <a:stretch>
+            <a:fillRect/>
+          </a:stretch>
+        </p:blipFill>
+        <p:spPr>
+          <a:xfrm>
+            <a:off x="1004049" y="4642105"/>
+            <a:ext cx="528938" cy="528939"/>
+          </a:xfrm>
+          <a:prstGeom prst="rect">
+            <a:avLst/>
+          </a:prstGeom>
+        </p:spPr>
+      </p:pic>
+      <p:pic>
+        <p:nvPicPr>
+          <p:cNvPr id="25" name="Picture 24" descr="A black and white icon of a syringe and a shield&#10;&#10;Description automatically generated">
+            <a:extLst>
+              <a:ext uri="{FF2B5EF4-FFF2-40B4-BE49-F238E27FC236}">
+                <a16:creationId xmlns:a16="http://schemas.microsoft.com/office/drawing/2014/main" id="{7E3D8486-3023-670D-DDC8-9A4057131DAA}"/>
+              </a:ext>
+            </a:extLst>
+          </p:cNvPr>
+          <p:cNvPicPr>
+            <a:picLocks noChangeAspect="1"/>
+          </p:cNvPicPr>
+          <p:nvPr/>
+        </p:nvPicPr>
+        <p:blipFill>
+          <a:blip r:embed="rId5">
+            <a:extLst>
+              <a:ext uri="{28A0092B-C50C-407E-A947-70E740481C1C}">
+                <a14:useLocalDpi xmlns:a14="http://schemas.microsoft.com/office/drawing/2010/main" val="0"/>
+              </a:ext>
+            </a:extLst>
+          </a:blip>
+          <a:stretch>
+            <a:fillRect/>
+          </a:stretch>
+        </p:blipFill>
+        <p:spPr>
+          <a:xfrm>
+            <a:off x="3842751" y="4620611"/>
+            <a:ext cx="528938" cy="528939"/>
+          </a:xfrm>
+          <a:prstGeom prst="rect">
+            <a:avLst/>
+          </a:prstGeom>
+        </p:spPr>
+      </p:pic>
+      <p:pic>
+        <p:nvPicPr>
+          <p:cNvPr id="26" name="Picture 25" descr="A black and white line drawing of a test tube&#10;&#10;Description automatically generated">
+            <a:extLst>
+              <a:ext uri="{FF2B5EF4-FFF2-40B4-BE49-F238E27FC236}">
+                <a16:creationId xmlns:a16="http://schemas.microsoft.com/office/drawing/2014/main" id="{38DDCEC0-0195-66C0-7A8D-6E0844E3086B}"/>
+              </a:ext>
+            </a:extLst>
+          </p:cNvPr>
+          <p:cNvPicPr>
+            <a:picLocks noChangeAspect="1"/>
+          </p:cNvPicPr>
+          <p:nvPr/>
+        </p:nvPicPr>
+        <p:blipFill>
+          <a:blip r:embed="rId6">
+            <a:extLst>
+              <a:ext uri="{28A0092B-C50C-407E-A947-70E740481C1C}">
+                <a14:useLocalDpi xmlns:a14="http://schemas.microsoft.com/office/drawing/2010/main" val="0"/>
+              </a:ext>
+            </a:extLst>
+          </a:blip>
+          <a:stretch>
+            <a:fillRect/>
+          </a:stretch>
+        </p:blipFill>
+        <p:spPr>
+          <a:xfrm>
+            <a:off x="4775425" y="4642104"/>
+            <a:ext cx="528938" cy="528939"/>
+          </a:xfrm>
+          <a:prstGeom prst="rect">
+            <a:avLst/>
+          </a:prstGeom>
+        </p:spPr>
+      </p:pic>
+      <p:pic>
+        <p:nvPicPr>
+          <p:cNvPr id="27" name="Picture 26" descr="A black and white image of different shapes&#10;&#10;Description automatically generated">
+            <a:extLst>
+              <a:ext uri="{FF2B5EF4-FFF2-40B4-BE49-F238E27FC236}">
+                <a16:creationId xmlns:a16="http://schemas.microsoft.com/office/drawing/2014/main" id="{B59DEE94-668E-D79B-19DE-442B2184D3D8}"/>
+              </a:ext>
+            </a:extLst>
+          </p:cNvPr>
+          <p:cNvPicPr>
+            <a:picLocks noChangeAspect="1"/>
+          </p:cNvPicPr>
+          <p:nvPr/>
+        </p:nvPicPr>
+        <p:blipFill>
+          <a:blip r:embed="rId7">
+            <a:extLst>
+              <a:ext uri="{28A0092B-C50C-407E-A947-70E740481C1C}">
+                <a14:useLocalDpi xmlns:a14="http://schemas.microsoft.com/office/drawing/2010/main" val="0"/>
+              </a:ext>
+            </a:extLst>
+          </a:blip>
+          <a:stretch>
+            <a:fillRect/>
+          </a:stretch>
+        </p:blipFill>
+        <p:spPr>
+          <a:xfrm>
+            <a:off x="2870468" y="4637230"/>
+            <a:ext cx="528938" cy="528939"/>
+          </a:xfrm>
+          <a:prstGeom prst="rect">
+            <a:avLst/>
+          </a:prstGeom>
+        </p:spPr>
+      </p:pic>
+      <p:pic>
+        <p:nvPicPr>
+          <p:cNvPr id="28" name="Picture 27" descr="A black and white clipboard with a cross&#10;&#10;Description automatically generated">
+            <a:extLst>
+              <a:ext uri="{FF2B5EF4-FFF2-40B4-BE49-F238E27FC236}">
+                <a16:creationId xmlns:a16="http://schemas.microsoft.com/office/drawing/2014/main" id="{7106C2E8-93C0-3D9E-0EF0-A32A0BBBDD88}"/>
+              </a:ext>
+            </a:extLst>
+          </p:cNvPr>
+          <p:cNvPicPr>
+            <a:picLocks noChangeAspect="1"/>
+          </p:cNvPicPr>
+          <p:nvPr/>
+        </p:nvPicPr>
+        <p:blipFill>
+          <a:blip r:embed="rId8" cstate="print">
+            <a:extLst>
+              <a:ext uri="{28A0092B-C50C-407E-A947-70E740481C1C}">
+                <a14:useLocalDpi xmlns:a14="http://schemas.microsoft.com/office/drawing/2010/main" val="0"/>
+              </a:ext>
+            </a:extLst>
+          </a:blip>
+          <a:stretch>
+            <a:fillRect/>
+          </a:stretch>
+        </p:blipFill>
+        <p:spPr>
+          <a:xfrm>
+            <a:off x="7502548" y="4616475"/>
+            <a:ext cx="373854" cy="373854"/>
+          </a:xfrm>
+          <a:prstGeom prst="rect">
+            <a:avLst/>
+          </a:prstGeom>
+        </p:spPr>
+      </p:pic>
+      <p:pic>
+        <p:nvPicPr>
+          <p:cNvPr id="29" name="Picture 28">
+            <a:extLst>
+              <a:ext uri="{FF2B5EF4-FFF2-40B4-BE49-F238E27FC236}">
+                <a16:creationId xmlns:a16="http://schemas.microsoft.com/office/drawing/2014/main" id="{21A505F7-93EE-5482-6317-CBEEFE333280}"/>
+              </a:ext>
+            </a:extLst>
+          </p:cNvPr>
+          <p:cNvPicPr>
+            <a:picLocks noChangeAspect="1"/>
+          </p:cNvPicPr>
+          <p:nvPr/>
+        </p:nvPicPr>
+        <p:blipFill rotWithShape="1">
+          <a:blip r:embed="rId9"/>
+          <a:srcRect l="6754" t="18564" r="80644" b="30366"/>
+          <a:stretch/>
+        </p:blipFill>
+        <p:spPr>
+          <a:xfrm>
+            <a:off x="1952172" y="4642104"/>
+            <a:ext cx="526591" cy="524064"/>
+          </a:xfrm>
+          <a:prstGeom prst="rect">
+            <a:avLst/>
+          </a:prstGeom>
+        </p:spPr>
+      </p:pic>
+      <p:pic>
+        <p:nvPicPr>
+          <p:cNvPr id="30" name="Picture 29">
+            <a:extLst>
+              <a:ext uri="{FF2B5EF4-FFF2-40B4-BE49-F238E27FC236}">
+                <a16:creationId xmlns:a16="http://schemas.microsoft.com/office/drawing/2014/main" id="{1A833FBC-0469-D844-BA8D-9B1904F7F1DC}"/>
+              </a:ext>
+            </a:extLst>
+          </p:cNvPr>
+          <p:cNvPicPr>
+            <a:picLocks noChangeAspect="1"/>
+          </p:cNvPicPr>
+          <p:nvPr/>
+        </p:nvPicPr>
+        <p:blipFill rotWithShape="1">
+          <a:blip r:embed="rId10"/>
+          <a:srcRect t="14434" r="85778" b="20996"/>
+          <a:stretch/>
+        </p:blipFill>
+        <p:spPr>
+          <a:xfrm>
+            <a:off x="7707815" y="4597158"/>
+            <a:ext cx="515199" cy="425006"/>
+          </a:xfrm>
+          <a:prstGeom prst="rect">
+            <a:avLst/>
+          </a:prstGeom>
+        </p:spPr>
+      </p:pic>
+      <p:sp>
+        <p:nvSpPr>
+          <p:cNvPr id="31" name="TextBox 30">
+            <a:extLst>
+              <a:ext uri="{FF2B5EF4-FFF2-40B4-BE49-F238E27FC236}">
+                <a16:creationId xmlns:a16="http://schemas.microsoft.com/office/drawing/2014/main" id="{E63E906F-2F3B-A818-61D5-1A0BEA7FAB5F}"/>
+              </a:ext>
+            </a:extLst>
+          </p:cNvPr>
+          <p:cNvSpPr txBox="1"/>
+          <p:nvPr/>
+        </p:nvSpPr>
+        <p:spPr>
+          <a:xfrm>
+            <a:off x="814415" y="5467888"/>
+            <a:ext cx="7502925" cy="338554"/>
+          </a:xfrm>
+          <a:prstGeom prst="rect">
+            <a:avLst/>
+          </a:prstGeom>
+          <a:noFill/>
+        </p:spPr>
+        <p:txBody>
+          <a:bodyPr wrap="square" rtlCol="0">
+            <a:spAutoFit/>
+          </a:bodyPr>
+          <a:lstStyle/>
+          <a:p>
+            <a:pPr algn="ctr"/>
+            <a:r>
+              <a:rPr lang="en-US" sz="1600" dirty="0">
+                <a:solidFill>
+                  <a:schemeClr val="tx1">
+                    <a:lumMod val="75000"/>
+                    <a:lumOff val="25000"/>
+                  </a:schemeClr>
+                </a:solidFill>
+              </a:rPr>
+              <a:t>US Core 6.1.0 Resources are defined in a separate implementation guide</a:t>
+            </a:r>
+          </a:p>
+        </p:txBody>
+      </p:sp>
+      <p:sp>
+        <p:nvSpPr>
+          <p:cNvPr id="36" name="Rectangle: Rounded Corners 35">
+            <a:extLst>
+              <a:ext uri="{FF2B5EF4-FFF2-40B4-BE49-F238E27FC236}">
+                <a16:creationId xmlns:a16="http://schemas.microsoft.com/office/drawing/2014/main" id="{335DDA96-CD7C-6133-01F0-31BA7E023124}"/>
+              </a:ext>
+            </a:extLst>
+          </p:cNvPr>
+          <p:cNvSpPr/>
+          <p:nvPr/>
+        </p:nvSpPr>
+        <p:spPr bwMode="auto">
+          <a:xfrm>
+            <a:off x="6471073" y="4513208"/>
+            <a:ext cx="910712" cy="929216"/>
+          </a:xfrm>
+          <a:prstGeom prst="roundRect">
+            <a:avLst/>
+          </a:prstGeom>
+          <a:solidFill>
+            <a:schemeClr val="bg1"/>
+          </a:solidFill>
+          <a:ln w="38100" cap="flat" cmpd="sng" algn="ctr">
+            <a:solidFill>
+              <a:srgbClr val="FF0000"/>
+            </a:solidFill>
+            <a:prstDash val="solid"/>
+            <a:round/>
+            <a:headEnd type="none" w="med" len="med"/>
+            <a:tailEnd type="none" w="med" len="med"/>
+          </a:ln>
+          <a:effectLst/>
+        </p:spPr>
+        <p:txBody>
+          <a:bodyPr vert="horz" wrap="square" lIns="91440" tIns="45720" rIns="91440" bIns="45720" numCol="1" rtlCol="0" anchor="t" anchorCtr="0" compatLnSpc="1">
+            <a:prstTxWarp prst="textNoShape">
+              <a:avLst/>
+            </a:prstTxWarp>
+          </a:bodyPr>
+          <a:lstStyle/>
+          <a:p>
+            <a:pPr marL="0" marR="0" indent="0" algn="l" defTabSz="914400" rtl="0" eaLnBrk="0" fontAlgn="base" latinLnBrk="0" hangingPunct="0">
+              <a:lnSpc>
+                <a:spcPct val="100000"/>
+              </a:lnSpc>
+              <a:spcBef>
+                <a:spcPct val="0"/>
+              </a:spcBef>
+              <a:spcAft>
+                <a:spcPct val="0"/>
+              </a:spcAft>
+              <a:buClrTx/>
+              <a:buSzTx/>
+              <a:buFontTx/>
+              <a:buNone/>
+              <a:tabLst/>
+            </a:pPr>
+            <a:endParaRPr kumimoji="0" lang="en-US" sz="1800" b="0" i="0" u="none" strike="noStrike" cap="none" normalizeH="0" baseline="0">
+              <a:ln>
+                <a:noFill/>
+              </a:ln>
+              <a:solidFill>
+                <a:schemeClr val="tx1"/>
+              </a:solidFill>
+              <a:effectLst/>
+              <a:latin typeface="Arial" charset="0"/>
+            </a:endParaRPr>
+          </a:p>
+        </p:txBody>
+      </p:sp>
+      <p:sp>
+        <p:nvSpPr>
+          <p:cNvPr id="37" name="TextBox 36">
+            <a:extLst>
+              <a:ext uri="{FF2B5EF4-FFF2-40B4-BE49-F238E27FC236}">
+                <a16:creationId xmlns:a16="http://schemas.microsoft.com/office/drawing/2014/main" id="{2E6290D4-C751-6D03-A863-AFE8B9116A50}"/>
+              </a:ext>
+            </a:extLst>
+          </p:cNvPr>
+          <p:cNvSpPr txBox="1"/>
+          <p:nvPr/>
+        </p:nvSpPr>
+        <p:spPr>
+          <a:xfrm>
+            <a:off x="6628203" y="5182427"/>
+            <a:ext cx="640080" cy="274320"/>
+          </a:xfrm>
+          <a:prstGeom prst="rect">
+            <a:avLst/>
+          </a:prstGeom>
+          <a:noFill/>
+        </p:spPr>
+        <p:txBody>
+          <a:bodyPr wrap="none" rtlCol="0">
+            <a:spAutoFit/>
+          </a:bodyPr>
+          <a:lstStyle/>
+          <a:p>
+            <a:pPr algn="ctr"/>
+            <a:r>
+              <a:rPr lang="en-US" sz="1100" b="1" dirty="0">
+                <a:latin typeface="Aptos" panose="020B0004020202020204" pitchFamily="34" charset="0"/>
+                <a:ea typeface="Calibri" panose="020F0502020204030204" pitchFamily="34" charset="0"/>
+                <a:cs typeface="Calibri" panose="020F0502020204030204" pitchFamily="34" charset="0"/>
+              </a:rPr>
+              <a:t>Encounter</a:t>
+            </a:r>
+          </a:p>
+        </p:txBody>
+      </p:sp>
+      <p:pic>
+        <p:nvPicPr>
+          <p:cNvPr id="41" name="Picture 40">
+            <a:extLst>
+              <a:ext uri="{FF2B5EF4-FFF2-40B4-BE49-F238E27FC236}">
+                <a16:creationId xmlns:a16="http://schemas.microsoft.com/office/drawing/2014/main" id="{6C209347-FE96-5A3D-C1E0-923C3480CDF6}"/>
+              </a:ext>
+            </a:extLst>
+          </p:cNvPr>
+          <p:cNvPicPr>
+            <a:picLocks noChangeAspect="1"/>
+          </p:cNvPicPr>
+          <p:nvPr/>
+        </p:nvPicPr>
+        <p:blipFill>
+          <a:blip r:embed="rId11">
+            <a:extLst>
+              <a:ext uri="{28A0092B-C50C-407E-A947-70E740481C1C}">
+                <a14:useLocalDpi xmlns:a14="http://schemas.microsoft.com/office/drawing/2010/main" val="0"/>
+              </a:ext>
+            </a:extLst>
+          </a:blip>
+          <a:stretch>
+            <a:fillRect/>
+          </a:stretch>
+        </p:blipFill>
+        <p:spPr>
+          <a:xfrm>
+            <a:off x="6624977" y="4605261"/>
+            <a:ext cx="609631" cy="609631"/>
+          </a:xfrm>
+          <a:prstGeom prst="rect">
+            <a:avLst/>
+          </a:prstGeom>
+        </p:spPr>
+      </p:pic>
+      <p:sp>
+        <p:nvSpPr>
+          <p:cNvPr id="44" name="TextBox 43">
+            <a:extLst>
+              <a:ext uri="{FF2B5EF4-FFF2-40B4-BE49-F238E27FC236}">
+                <a16:creationId xmlns:a16="http://schemas.microsoft.com/office/drawing/2014/main" id="{97D829CF-92C0-2AD4-C217-0D9575FA9E17}"/>
+              </a:ext>
+            </a:extLst>
+          </p:cNvPr>
+          <p:cNvSpPr txBox="1"/>
+          <p:nvPr/>
+        </p:nvSpPr>
+        <p:spPr>
+          <a:xfrm>
+            <a:off x="4688787" y="2448422"/>
+            <a:ext cx="2632987" cy="646331"/>
+          </a:xfrm>
+          <a:prstGeom prst="rect">
+            <a:avLst/>
+          </a:prstGeom>
+          <a:noFill/>
+        </p:spPr>
+        <p:txBody>
+          <a:bodyPr wrap="square" lIns="0" rtlCol="0">
+            <a:spAutoFit/>
+          </a:bodyPr>
+          <a:lstStyle/>
+          <a:p>
+            <a:pPr marL="60325" algn="ctr"/>
+            <a:r>
+              <a:rPr lang="en-US" sz="900" dirty="0">
+                <a:solidFill>
+                  <a:schemeClr val="tx1">
+                    <a:lumMod val="50000"/>
+                    <a:lumOff val="50000"/>
+                  </a:schemeClr>
+                </a:solidFill>
+                <a:latin typeface="Aptos" panose="020B0004020202020204" pitchFamily="34" charset="0"/>
+              </a:rPr>
+              <a:t>+ 10 Optional Sections: Alerts, Advance Directives, Functional Status, Past Problems, Medical Devices, Patient Story, Plan of Care, Social History and Vital Signs</a:t>
+            </a:r>
+          </a:p>
+        </p:txBody>
+      </p:sp>
+    </p:spTree>
+    <p:extLst>
+      <p:ext uri="{BB962C8B-B14F-4D97-AF65-F5344CB8AC3E}">
+        <p14:creationId xmlns:p14="http://schemas.microsoft.com/office/powerpoint/2010/main" val="1092305603"/>
+      </p:ext>
+    </p:extLst>
+  </p:cSld>
+  <p:clrMapOvr>
+    <a:masterClrMapping/>
+  </p:clrMapOvr>
+</p:sld>
+</file>
+
+<file path=ppt/slides/slide4.xml><?xml version="1.0" encoding="utf-8"?>
+<p:sld xmlns:a="http://schemas.openxmlformats.org/drawingml/2006/main" xmlns:r="http://schemas.openxmlformats.org/officeDocument/2006/relationships" xmlns:p="http://schemas.openxmlformats.org/presentationml/2006/main">
+  <p:cSld>
+    <p:spTree>
+      <p:nvGrpSpPr>
+        <p:cNvPr id="1" name="">
+          <a:extLst>
+            <a:ext uri="{FF2B5EF4-FFF2-40B4-BE49-F238E27FC236}">
+              <a16:creationId xmlns:a16="http://schemas.microsoft.com/office/drawing/2014/main" id="{AB4C46FB-22C6-D0A3-5996-E0DA95F2CD58}"/>
+            </a:ext>
+          </a:extLst>
+        </p:cNvPr>
+        <p:cNvGrpSpPr/>
+        <p:nvPr/>
+      </p:nvGrpSpPr>
+      <p:grpSpPr>
+        <a:xfrm>
+          <a:off x="0" y="0"/>
+          <a:ext cx="0" cy="0"/>
+          <a:chOff x="0" y="0"/>
+          <a:chExt cx="0" cy="0"/>
+        </a:xfrm>
+      </p:grpSpPr>
+      <p:sp>
+        <p:nvSpPr>
+          <p:cNvPr id="5" name="Arrow: Right 4">
+            <a:extLst>
+              <a:ext uri="{FF2B5EF4-FFF2-40B4-BE49-F238E27FC236}">
+                <a16:creationId xmlns:a16="http://schemas.microsoft.com/office/drawing/2014/main" id="{C7C68B5F-5710-F402-DDF6-1872CF11B605}"/>
+              </a:ext>
+            </a:extLst>
+          </p:cNvPr>
+          <p:cNvSpPr/>
+          <p:nvPr/>
+        </p:nvSpPr>
+        <p:spPr bwMode="auto">
+          <a:xfrm>
+            <a:off x="683568" y="1203653"/>
+            <a:ext cx="3050389" cy="1080120"/>
+          </a:xfrm>
+          <a:prstGeom prst="rightArrow">
+            <a:avLst/>
+          </a:prstGeom>
+          <a:solidFill>
+            <a:srgbClr val="00B0F0"/>
+          </a:solidFill>
+          <a:ln w="9525" cap="flat" cmpd="sng" algn="ctr">
+            <a:noFill/>
+            <a:prstDash val="solid"/>
+            <a:round/>
+            <a:headEnd type="none" w="med" len="med"/>
+            <a:tailEnd type="none" w="med" len="med"/>
+          </a:ln>
+          <a:effectLst/>
+        </p:spPr>
+        <p:txBody>
+          <a:bodyPr vert="horz" wrap="square" lIns="91440" tIns="45720" rIns="91440" bIns="45720" numCol="1" rtlCol="0" anchor="ctr" anchorCtr="0" compatLnSpc="1">
+            <a:prstTxWarp prst="textNoShape">
+              <a:avLst/>
+            </a:prstTxWarp>
+          </a:bodyPr>
+          <a:lstStyle/>
+          <a:p>
+            <a:pPr marL="0" marR="0" indent="0" algn="ctr" defTabSz="914400" rtl="0" eaLnBrk="0" fontAlgn="base" latinLnBrk="0" hangingPunct="0">
+              <a:lnSpc>
+                <a:spcPct val="100000"/>
+              </a:lnSpc>
+              <a:spcBef>
+                <a:spcPct val="0"/>
+              </a:spcBef>
+              <a:spcAft>
+                <a:spcPct val="0"/>
+              </a:spcAft>
+              <a:buClrTx/>
+              <a:buSzTx/>
+              <a:buFontTx/>
+              <a:buNone/>
+              <a:tabLst/>
+            </a:pPr>
+            <a:r>
+              <a:rPr kumimoji="0" lang="en-US" sz="2800" b="1" i="0" u="none" strike="noStrike" cap="none" normalizeH="0" baseline="0" dirty="0">
+                <a:ln>
+                  <a:noFill/>
+                </a:ln>
+                <a:solidFill>
+                  <a:schemeClr val="tx1"/>
+                </a:solidFill>
+                <a:effectLst/>
+                <a:latin typeface="Aptos" panose="020B0004020202020204" pitchFamily="34" charset="0"/>
+                <a:ea typeface="Calibri" panose="020F0502020204030204" pitchFamily="34" charset="0"/>
+                <a:cs typeface="Calibri" panose="020F0502020204030204" pitchFamily="34" charset="0"/>
+              </a:rPr>
+              <a:t>The US-PCS</a:t>
+            </a:r>
+          </a:p>
+        </p:txBody>
+      </p:sp>
+      <p:sp>
+        <p:nvSpPr>
+          <p:cNvPr id="9" name="Rectangle: Rounded Corners 8">
+            <a:extLst>
+              <a:ext uri="{FF2B5EF4-FFF2-40B4-BE49-F238E27FC236}">
+                <a16:creationId xmlns:a16="http://schemas.microsoft.com/office/drawing/2014/main" id="{D59F3E04-444E-4176-A0F6-65877522FA6F}"/>
+              </a:ext>
+            </a:extLst>
+          </p:cNvPr>
+          <p:cNvSpPr/>
+          <p:nvPr/>
+        </p:nvSpPr>
+        <p:spPr bwMode="auto">
+          <a:xfrm>
+            <a:off x="683568" y="3573015"/>
+            <a:ext cx="7848872" cy="2081332"/>
+          </a:xfrm>
+          <a:prstGeom prst="roundRect">
+            <a:avLst>
+              <a:gd name="adj" fmla="val 9009"/>
+            </a:avLst>
+          </a:prstGeom>
+          <a:solidFill>
+            <a:schemeClr val="bg1">
+              <a:lumMod val="85000"/>
+            </a:schemeClr>
+          </a:solidFill>
+          <a:ln w="9525" cap="flat" cmpd="sng" algn="ctr">
+            <a:noFill/>
+            <a:prstDash val="solid"/>
+            <a:round/>
+            <a:headEnd type="none" w="med" len="med"/>
+            <a:tailEnd type="none" w="med" len="med"/>
+          </a:ln>
+          <a:effectLst/>
+        </p:spPr>
+        <p:txBody>
+          <a:bodyPr vert="horz" wrap="square" lIns="91440" tIns="45720" rIns="91440" bIns="45720" numCol="1" rtlCol="0" anchor="ctr" anchorCtr="0" compatLnSpc="1">
+            <a:prstTxWarp prst="textNoShape">
+              <a:avLst/>
+            </a:prstTxWarp>
+          </a:bodyPr>
+          <a:lstStyle/>
+          <a:p>
+            <a:pPr algn="ctr" eaLnBrk="0" fontAlgn="base" hangingPunct="0">
+              <a:spcBef>
+                <a:spcPct val="0"/>
+              </a:spcBef>
+              <a:spcAft>
+                <a:spcPct val="0"/>
+              </a:spcAft>
+            </a:pPr>
+            <a:endParaRPr lang="en-US" sz="2800" b="1">
+              <a:latin typeface="Aptos" panose="020B0004020202020204" pitchFamily="34" charset="0"/>
+              <a:ea typeface="Calibri" panose="020F0502020204030204" pitchFamily="34" charset="0"/>
+              <a:cs typeface="Calibri" panose="020F0502020204030204" pitchFamily="34" charset="0"/>
+            </a:endParaRPr>
+          </a:p>
+        </p:txBody>
+      </p:sp>
+      <p:sp>
+        <p:nvSpPr>
+          <p:cNvPr id="10" name="TextBox 9">
+            <a:extLst>
+              <a:ext uri="{FF2B5EF4-FFF2-40B4-BE49-F238E27FC236}">
+                <a16:creationId xmlns:a16="http://schemas.microsoft.com/office/drawing/2014/main" id="{EBCD2639-5DFF-3BAF-9F90-6CDAB7C60D5D}"/>
+              </a:ext>
+            </a:extLst>
+          </p:cNvPr>
+          <p:cNvSpPr txBox="1"/>
+          <p:nvPr/>
+        </p:nvSpPr>
+        <p:spPr>
+          <a:xfrm>
+            <a:off x="683569" y="3589151"/>
+            <a:ext cx="7848872" cy="523220"/>
+          </a:xfrm>
+          <a:prstGeom prst="rect">
+            <a:avLst/>
+          </a:prstGeom>
+          <a:noFill/>
+        </p:spPr>
+        <p:txBody>
+          <a:bodyPr wrap="square" rtlCol="0">
+            <a:spAutoFit/>
+          </a:bodyPr>
+          <a:lstStyle/>
+          <a:p>
+            <a:pPr algn="ctr"/>
+            <a:r>
+              <a:rPr lang="en-US" sz="2800" b="1" dirty="0">
+                <a:latin typeface="Aptos" panose="020B0004020202020204" pitchFamily="34" charset="0"/>
+                <a:ea typeface="Calibri" panose="020F0502020204030204" pitchFamily="34" charset="0"/>
+                <a:cs typeface="Calibri" panose="020F0502020204030204" pitchFamily="34" charset="0"/>
+              </a:rPr>
+              <a:t>Composed from US Core Resources</a:t>
+            </a:r>
+          </a:p>
+        </p:txBody>
+      </p:sp>
+      <p:pic>
+        <p:nvPicPr>
+          <p:cNvPr id="22" name="Picture 21">
+            <a:extLst>
+              <a:ext uri="{FF2B5EF4-FFF2-40B4-BE49-F238E27FC236}">
+                <a16:creationId xmlns:a16="http://schemas.microsoft.com/office/drawing/2014/main" id="{ED6288EB-AFFB-BC4F-13D9-E4ACF7D3D9AE}"/>
+              </a:ext>
+            </a:extLst>
+          </p:cNvPr>
+          <p:cNvPicPr>
+            <a:picLocks noChangeAspect="1"/>
+          </p:cNvPicPr>
+          <p:nvPr/>
+        </p:nvPicPr>
+        <p:blipFill>
+          <a:blip r:embed="rId2"/>
+          <a:stretch>
+            <a:fillRect/>
+          </a:stretch>
+        </p:blipFill>
+        <p:spPr>
+          <a:xfrm>
+            <a:off x="3878472" y="169030"/>
+            <a:ext cx="3243967" cy="3149367"/>
+          </a:xfrm>
+          <a:prstGeom prst="rect">
+            <a:avLst/>
+          </a:prstGeom>
+        </p:spPr>
+      </p:pic>
+      <p:sp>
+        <p:nvSpPr>
+          <p:cNvPr id="23" name="TextBox 22">
+            <a:extLst>
+              <a:ext uri="{FF2B5EF4-FFF2-40B4-BE49-F238E27FC236}">
+                <a16:creationId xmlns:a16="http://schemas.microsoft.com/office/drawing/2014/main" id="{3BE81991-0106-B1EB-2A89-77F5536E90E2}"/>
+              </a:ext>
+            </a:extLst>
+          </p:cNvPr>
+          <p:cNvSpPr txBox="1"/>
+          <p:nvPr/>
+        </p:nvSpPr>
+        <p:spPr>
+          <a:xfrm>
+            <a:off x="5076357" y="1139423"/>
+            <a:ext cx="1552209" cy="276999"/>
+          </a:xfrm>
+          <a:prstGeom prst="rect">
+            <a:avLst/>
+          </a:prstGeom>
+          <a:noFill/>
+        </p:spPr>
+        <p:txBody>
+          <a:bodyPr wrap="square" rtlCol="0">
+            <a:spAutoFit/>
+          </a:bodyPr>
+          <a:lstStyle/>
+          <a:p>
+            <a:r>
+              <a:rPr lang="en-US" sz="1200" b="1" dirty="0">
+                <a:solidFill>
+                  <a:schemeClr val="bg1"/>
+                </a:solidFill>
+                <a:latin typeface="Aptos" panose="020B0004020202020204" pitchFamily="34" charset="0"/>
+              </a:rPr>
+              <a:t>Medications</a:t>
+            </a:r>
+          </a:p>
+        </p:txBody>
+      </p:sp>
+      <p:sp>
+        <p:nvSpPr>
+          <p:cNvPr id="24" name="TextBox 23">
+            <a:extLst>
+              <a:ext uri="{FF2B5EF4-FFF2-40B4-BE49-F238E27FC236}">
+                <a16:creationId xmlns:a16="http://schemas.microsoft.com/office/drawing/2014/main" id="{DE6FED39-43E9-B4E1-39D0-6CE39DB9DC5A}"/>
+              </a:ext>
+            </a:extLst>
+          </p:cNvPr>
+          <p:cNvSpPr txBox="1"/>
+          <p:nvPr/>
+        </p:nvSpPr>
+        <p:spPr>
+          <a:xfrm>
+            <a:off x="5135067" y="765732"/>
+            <a:ext cx="1901566" cy="276999"/>
+          </a:xfrm>
+          <a:prstGeom prst="rect">
+            <a:avLst/>
+          </a:prstGeom>
+          <a:noFill/>
+        </p:spPr>
+        <p:txBody>
+          <a:bodyPr wrap="square" rtlCol="0">
+            <a:spAutoFit/>
+          </a:bodyPr>
+          <a:lstStyle/>
+          <a:p>
+            <a:r>
+              <a:rPr lang="en-US" sz="1200" b="1" dirty="0">
+                <a:solidFill>
+                  <a:schemeClr val="bg1"/>
+                </a:solidFill>
+                <a:latin typeface="Aptos" panose="020B0004020202020204" pitchFamily="34" charset="0"/>
+              </a:rPr>
+              <a:t>Allergies / Intolerances</a:t>
+            </a:r>
+          </a:p>
+        </p:txBody>
+      </p:sp>
+      <p:sp>
+        <p:nvSpPr>
+          <p:cNvPr id="25" name="TextBox 24">
+            <a:extLst>
+              <a:ext uri="{FF2B5EF4-FFF2-40B4-BE49-F238E27FC236}">
+                <a16:creationId xmlns:a16="http://schemas.microsoft.com/office/drawing/2014/main" id="{882CB8C7-307B-8125-D9F7-A17102F073E2}"/>
+              </a:ext>
+            </a:extLst>
+          </p:cNvPr>
+          <p:cNvSpPr txBox="1"/>
+          <p:nvPr/>
+        </p:nvSpPr>
+        <p:spPr>
+          <a:xfrm>
+            <a:off x="5076358" y="368677"/>
+            <a:ext cx="1901566" cy="276999"/>
+          </a:xfrm>
+          <a:prstGeom prst="rect">
+            <a:avLst/>
+          </a:prstGeom>
+          <a:noFill/>
+        </p:spPr>
+        <p:txBody>
+          <a:bodyPr wrap="square" rtlCol="0">
+            <a:spAutoFit/>
+          </a:bodyPr>
+          <a:lstStyle/>
+          <a:p>
+            <a:r>
+              <a:rPr lang="en-US" sz="1200" b="1" dirty="0">
+                <a:solidFill>
+                  <a:schemeClr val="bg1"/>
+                </a:solidFill>
+                <a:latin typeface="Aptos" panose="020B0004020202020204" pitchFamily="34" charset="0"/>
+              </a:rPr>
+              <a:t>Problems</a:t>
+            </a:r>
+          </a:p>
+        </p:txBody>
+      </p:sp>
+      <p:sp>
+        <p:nvSpPr>
+          <p:cNvPr id="26" name="TextBox 25">
+            <a:extLst>
+              <a:ext uri="{FF2B5EF4-FFF2-40B4-BE49-F238E27FC236}">
+                <a16:creationId xmlns:a16="http://schemas.microsoft.com/office/drawing/2014/main" id="{F1FABB8A-EF1A-B52F-7302-B92D2BB84136}"/>
+              </a:ext>
+            </a:extLst>
+          </p:cNvPr>
+          <p:cNvSpPr txBox="1"/>
+          <p:nvPr/>
+        </p:nvSpPr>
+        <p:spPr>
+          <a:xfrm>
+            <a:off x="5076358" y="2295540"/>
+            <a:ext cx="1901566" cy="276999"/>
+          </a:xfrm>
+          <a:prstGeom prst="rect">
+            <a:avLst/>
+          </a:prstGeom>
+          <a:noFill/>
+        </p:spPr>
+        <p:txBody>
+          <a:bodyPr wrap="square" rtlCol="0">
+            <a:spAutoFit/>
+          </a:bodyPr>
+          <a:lstStyle/>
+          <a:p>
+            <a:r>
+              <a:rPr lang="en-US" sz="1200" b="1" dirty="0">
+                <a:solidFill>
+                  <a:schemeClr val="bg1"/>
+                </a:solidFill>
+                <a:latin typeface="Aptos" panose="020B0004020202020204" pitchFamily="34" charset="0"/>
+              </a:rPr>
+              <a:t>Procedures</a:t>
+            </a:r>
+          </a:p>
+        </p:txBody>
+      </p:sp>
+      <p:sp>
+        <p:nvSpPr>
+          <p:cNvPr id="27" name="TextBox 26">
+            <a:extLst>
+              <a:ext uri="{FF2B5EF4-FFF2-40B4-BE49-F238E27FC236}">
+                <a16:creationId xmlns:a16="http://schemas.microsoft.com/office/drawing/2014/main" id="{603B436F-488B-4147-2F07-AC082890CF72}"/>
+              </a:ext>
+            </a:extLst>
+          </p:cNvPr>
+          <p:cNvSpPr txBox="1"/>
+          <p:nvPr/>
+        </p:nvSpPr>
+        <p:spPr>
+          <a:xfrm>
+            <a:off x="5076358" y="1524796"/>
+            <a:ext cx="1901566" cy="276999"/>
+          </a:xfrm>
+          <a:prstGeom prst="rect">
+            <a:avLst/>
+          </a:prstGeom>
+          <a:noFill/>
+        </p:spPr>
+        <p:txBody>
+          <a:bodyPr wrap="square" rtlCol="0">
+            <a:spAutoFit/>
+          </a:bodyPr>
+          <a:lstStyle/>
+          <a:p>
+            <a:r>
+              <a:rPr lang="en-US" sz="1200" b="1" dirty="0">
+                <a:solidFill>
+                  <a:srgbClr val="54A831"/>
+                </a:solidFill>
+                <a:latin typeface="Aptos" panose="020B0004020202020204" pitchFamily="34" charset="0"/>
+              </a:rPr>
+              <a:t>Immunizations</a:t>
+            </a:r>
+          </a:p>
+        </p:txBody>
+      </p:sp>
+      <p:sp>
+        <p:nvSpPr>
+          <p:cNvPr id="28" name="TextBox 27">
+            <a:extLst>
+              <a:ext uri="{FF2B5EF4-FFF2-40B4-BE49-F238E27FC236}">
+                <a16:creationId xmlns:a16="http://schemas.microsoft.com/office/drawing/2014/main" id="{A3A3A697-E7AD-86BC-00DA-A0254BDCBBED}"/>
+              </a:ext>
+            </a:extLst>
+          </p:cNvPr>
+          <p:cNvSpPr txBox="1"/>
+          <p:nvPr/>
+        </p:nvSpPr>
+        <p:spPr>
+          <a:xfrm>
+            <a:off x="5076358" y="1910169"/>
+            <a:ext cx="1901566" cy="276999"/>
+          </a:xfrm>
+          <a:prstGeom prst="rect">
+            <a:avLst/>
+          </a:prstGeom>
+          <a:noFill/>
+        </p:spPr>
+        <p:txBody>
+          <a:bodyPr wrap="square" rtlCol="0">
+            <a:spAutoFit/>
+          </a:bodyPr>
+          <a:lstStyle/>
+          <a:p>
+            <a:r>
+              <a:rPr lang="en-US" sz="1200" b="1" dirty="0">
+                <a:solidFill>
+                  <a:srgbClr val="E86328"/>
+                </a:solidFill>
+                <a:latin typeface="Aptos" panose="020B0004020202020204" pitchFamily="34" charset="0"/>
+              </a:rPr>
+              <a:t>Results</a:t>
+            </a:r>
+          </a:p>
+        </p:txBody>
+      </p:sp>
+      <p:cxnSp>
+        <p:nvCxnSpPr>
+          <p:cNvPr id="31" name="Connector: Elbow 30">
+            <a:extLst>
+              <a:ext uri="{FF2B5EF4-FFF2-40B4-BE49-F238E27FC236}">
+                <a16:creationId xmlns:a16="http://schemas.microsoft.com/office/drawing/2014/main" id="{60EDF3A7-0432-54AA-ABC2-F8D867B45F44}"/>
+              </a:ext>
+            </a:extLst>
+          </p:cNvPr>
+          <p:cNvCxnSpPr>
+            <a:cxnSpLocks/>
+            <a:stCxn id="29" idx="2"/>
+            <a:endCxn id="9" idx="0"/>
+          </p:cNvCxnSpPr>
+          <p:nvPr/>
+        </p:nvCxnSpPr>
+        <p:spPr bwMode="auto">
+          <a:xfrm rot="5400000">
+            <a:off x="4889774" y="3003216"/>
+            <a:ext cx="288030" cy="851569"/>
+          </a:xfrm>
+          <a:prstGeom prst="bentConnector3">
+            <a:avLst/>
+          </a:prstGeom>
+          <a:solidFill>
+            <a:schemeClr val="accent1"/>
+          </a:solidFill>
+          <a:ln w="57150" cap="flat" cmpd="sng" algn="ctr">
+            <a:solidFill>
+              <a:schemeClr val="bg1">
+                <a:lumMod val="75000"/>
+              </a:schemeClr>
+            </a:solidFill>
+            <a:prstDash val="solid"/>
+            <a:round/>
+            <a:headEnd type="none" w="med" len="med"/>
+            <a:tailEnd type="none" w="med" len="med"/>
+          </a:ln>
+          <a:effectLst/>
+          <a:extLst>
+            <a:ext uri="{AF507438-7753-43E0-B8FC-AC1667EBCBE1}">
+              <a14:hiddenEffects xmlns:a14="http://schemas.microsoft.com/office/drawing/2010/main">
+                <a:effectLst>
+                  <a:outerShdw dist="35921" dir="2700000" algn="ctr" rotWithShape="0">
+                    <a:schemeClr val="bg2"/>
+                  </a:outerShdw>
+                </a:effectLst>
+              </a14:hiddenEffects>
+            </a:ext>
+          </a:extLst>
+        </p:spPr>
+      </p:cxnSp>
+      <p:sp>
+        <p:nvSpPr>
+          <p:cNvPr id="37" name="Rectangle: Rounded Corners 36">
+            <a:extLst>
+              <a:ext uri="{FF2B5EF4-FFF2-40B4-BE49-F238E27FC236}">
+                <a16:creationId xmlns:a16="http://schemas.microsoft.com/office/drawing/2014/main" id="{09E8988F-DE68-C454-CE73-B2B9623C1232}"/>
+              </a:ext>
+            </a:extLst>
+          </p:cNvPr>
+          <p:cNvSpPr/>
+          <p:nvPr/>
+        </p:nvSpPr>
+        <p:spPr bwMode="auto">
+          <a:xfrm>
+            <a:off x="6246011" y="4153167"/>
+            <a:ext cx="1049646" cy="1070973"/>
+          </a:xfrm>
+          <a:prstGeom prst="roundRect">
+            <a:avLst/>
+          </a:prstGeom>
+          <a:solidFill>
+            <a:schemeClr val="bg1"/>
+          </a:solidFill>
+          <a:ln w="38100" cap="flat" cmpd="sng" algn="ctr">
+            <a:solidFill>
+              <a:srgbClr val="E86328"/>
+            </a:solidFill>
+            <a:prstDash val="solid"/>
+            <a:round/>
+            <a:headEnd type="none" w="med" len="med"/>
+            <a:tailEnd type="none" w="med" len="med"/>
+          </a:ln>
+          <a:effectLst/>
+        </p:spPr>
+        <p:txBody>
+          <a:bodyPr vert="horz" wrap="square" lIns="91440" tIns="45720" rIns="91440" bIns="45720" numCol="1" rtlCol="0" anchor="t" anchorCtr="0" compatLnSpc="1">
+            <a:prstTxWarp prst="textNoShape">
+              <a:avLst/>
+            </a:prstTxWarp>
+          </a:bodyPr>
+          <a:lstStyle/>
+          <a:p>
+            <a:pPr eaLnBrk="0" fontAlgn="base" hangingPunct="0">
+              <a:spcBef>
+                <a:spcPct val="0"/>
+              </a:spcBef>
+              <a:spcAft>
+                <a:spcPct val="0"/>
+              </a:spcAft>
+            </a:pPr>
+            <a:endParaRPr lang="en-US">
+              <a:latin typeface="Arial" charset="0"/>
+            </a:endParaRPr>
+          </a:p>
+        </p:txBody>
+      </p:sp>
+      <p:sp>
+        <p:nvSpPr>
+          <p:cNvPr id="38" name="Rectangle: Rounded Corners 37">
+            <a:extLst>
+              <a:ext uri="{FF2B5EF4-FFF2-40B4-BE49-F238E27FC236}">
+                <a16:creationId xmlns:a16="http://schemas.microsoft.com/office/drawing/2014/main" id="{39C150A3-CD4B-2C36-B92E-32664E4267B6}"/>
+              </a:ext>
+            </a:extLst>
+          </p:cNvPr>
+          <p:cNvSpPr/>
+          <p:nvPr/>
+        </p:nvSpPr>
+        <p:spPr bwMode="auto">
+          <a:xfrm>
+            <a:off x="5159692" y="4153167"/>
+            <a:ext cx="1049646" cy="1070973"/>
+          </a:xfrm>
+          <a:prstGeom prst="roundRect">
+            <a:avLst/>
+          </a:prstGeom>
+          <a:solidFill>
+            <a:schemeClr val="bg1"/>
+          </a:solidFill>
+          <a:ln w="38100" cap="flat" cmpd="sng" algn="ctr">
+            <a:solidFill>
+              <a:srgbClr val="F7D33E"/>
+            </a:solidFill>
+            <a:prstDash val="solid"/>
+            <a:round/>
+            <a:headEnd type="none" w="med" len="med"/>
+            <a:tailEnd type="none" w="med" len="med"/>
+          </a:ln>
+          <a:effectLst/>
+        </p:spPr>
+        <p:txBody>
+          <a:bodyPr vert="horz" wrap="square" lIns="91440" tIns="45720" rIns="91440" bIns="45720" numCol="1" rtlCol="0" anchor="t" anchorCtr="0" compatLnSpc="1">
+            <a:prstTxWarp prst="textNoShape">
+              <a:avLst/>
+            </a:prstTxWarp>
+          </a:bodyPr>
+          <a:lstStyle/>
+          <a:p>
+            <a:pPr eaLnBrk="0" fontAlgn="base" hangingPunct="0">
+              <a:spcBef>
+                <a:spcPct val="0"/>
+              </a:spcBef>
+              <a:spcAft>
+                <a:spcPct val="0"/>
+              </a:spcAft>
+            </a:pPr>
+            <a:endParaRPr lang="en-US">
+              <a:latin typeface="Arial" charset="0"/>
+            </a:endParaRPr>
+          </a:p>
+        </p:txBody>
+      </p:sp>
+      <p:sp>
+        <p:nvSpPr>
+          <p:cNvPr id="39" name="Rectangle: Rounded Corners 38">
+            <a:extLst>
+              <a:ext uri="{FF2B5EF4-FFF2-40B4-BE49-F238E27FC236}">
+                <a16:creationId xmlns:a16="http://schemas.microsoft.com/office/drawing/2014/main" id="{AA93C4CF-CF59-CA36-4BFB-FA382C354C0A}"/>
+              </a:ext>
+            </a:extLst>
+          </p:cNvPr>
+          <p:cNvSpPr/>
+          <p:nvPr/>
+        </p:nvSpPr>
+        <p:spPr bwMode="auto">
+          <a:xfrm>
+            <a:off x="4073373" y="4153167"/>
+            <a:ext cx="1049646" cy="1070973"/>
+          </a:xfrm>
+          <a:prstGeom prst="roundRect">
+            <a:avLst/>
+          </a:prstGeom>
+          <a:solidFill>
+            <a:schemeClr val="bg1"/>
+          </a:solidFill>
+          <a:ln w="38100" cap="flat" cmpd="sng" algn="ctr">
+            <a:solidFill>
+              <a:srgbClr val="CAD404"/>
+            </a:solidFill>
+            <a:prstDash val="solid"/>
+            <a:round/>
+            <a:headEnd type="none" w="med" len="med"/>
+            <a:tailEnd type="none" w="med" len="med"/>
+          </a:ln>
+          <a:effectLst/>
+        </p:spPr>
+        <p:txBody>
+          <a:bodyPr vert="horz" wrap="square" lIns="91440" tIns="45720" rIns="91440" bIns="45720" numCol="1" rtlCol="0" anchor="t" anchorCtr="0" compatLnSpc="1">
+            <a:prstTxWarp prst="textNoShape">
+              <a:avLst/>
+            </a:prstTxWarp>
+          </a:bodyPr>
+          <a:lstStyle/>
+          <a:p>
+            <a:pPr eaLnBrk="0" fontAlgn="base" hangingPunct="0">
+              <a:spcBef>
+                <a:spcPct val="0"/>
+              </a:spcBef>
+              <a:spcAft>
+                <a:spcPct val="0"/>
+              </a:spcAft>
+            </a:pPr>
+            <a:endParaRPr lang="en-US">
+              <a:latin typeface="Arial" charset="0"/>
+            </a:endParaRPr>
+          </a:p>
+        </p:txBody>
+      </p:sp>
+      <p:sp>
+        <p:nvSpPr>
+          <p:cNvPr id="40" name="Rectangle: Rounded Corners 39">
+            <a:extLst>
+              <a:ext uri="{FF2B5EF4-FFF2-40B4-BE49-F238E27FC236}">
+                <a16:creationId xmlns:a16="http://schemas.microsoft.com/office/drawing/2014/main" id="{8CC8489E-BE78-CCA7-0ECC-158CE4467AE4}"/>
+              </a:ext>
+            </a:extLst>
+          </p:cNvPr>
+          <p:cNvSpPr/>
+          <p:nvPr/>
+        </p:nvSpPr>
+        <p:spPr bwMode="auto">
+          <a:xfrm>
+            <a:off x="2987054" y="4153167"/>
+            <a:ext cx="1049646" cy="1070973"/>
+          </a:xfrm>
+          <a:prstGeom prst="roundRect">
+            <a:avLst/>
+          </a:prstGeom>
+          <a:solidFill>
+            <a:schemeClr val="bg1"/>
+          </a:solidFill>
+          <a:ln w="38100" cap="flat" cmpd="sng" algn="ctr">
+            <a:solidFill>
+              <a:srgbClr val="05953F"/>
+            </a:solidFill>
+            <a:prstDash val="solid"/>
+            <a:round/>
+            <a:headEnd type="none" w="med" len="med"/>
+            <a:tailEnd type="none" w="med" len="med"/>
+          </a:ln>
+          <a:effectLst/>
+        </p:spPr>
+        <p:txBody>
+          <a:bodyPr vert="horz" wrap="square" lIns="91440" tIns="45720" rIns="91440" bIns="45720" numCol="1" rtlCol="0" anchor="t" anchorCtr="0" compatLnSpc="1">
+            <a:prstTxWarp prst="textNoShape">
+              <a:avLst/>
+            </a:prstTxWarp>
+          </a:bodyPr>
+          <a:lstStyle/>
+          <a:p>
+            <a:pPr eaLnBrk="0" fontAlgn="base" hangingPunct="0">
+              <a:spcBef>
+                <a:spcPct val="0"/>
+              </a:spcBef>
+              <a:spcAft>
+                <a:spcPct val="0"/>
+              </a:spcAft>
+            </a:pPr>
+            <a:endParaRPr lang="en-US">
+              <a:latin typeface="Arial" charset="0"/>
+            </a:endParaRPr>
+          </a:p>
+        </p:txBody>
+      </p:sp>
+      <p:sp>
+        <p:nvSpPr>
+          <p:cNvPr id="41" name="Rectangle: Rounded Corners 40">
+            <a:extLst>
+              <a:ext uri="{FF2B5EF4-FFF2-40B4-BE49-F238E27FC236}">
+                <a16:creationId xmlns:a16="http://schemas.microsoft.com/office/drawing/2014/main" id="{9EFD4498-4871-A26E-E394-7F456281B3A5}"/>
+              </a:ext>
+            </a:extLst>
+          </p:cNvPr>
+          <p:cNvSpPr/>
+          <p:nvPr/>
+        </p:nvSpPr>
+        <p:spPr bwMode="auto">
+          <a:xfrm>
+            <a:off x="1900735" y="4153167"/>
+            <a:ext cx="1049646" cy="1070973"/>
+          </a:xfrm>
+          <a:prstGeom prst="roundRect">
+            <a:avLst/>
+          </a:prstGeom>
+          <a:solidFill>
+            <a:schemeClr val="bg1"/>
+          </a:solidFill>
+          <a:ln w="38100" cap="flat" cmpd="sng" algn="ctr">
+            <a:solidFill>
+              <a:srgbClr val="1BA5CC"/>
+            </a:solidFill>
+            <a:prstDash val="solid"/>
+            <a:round/>
+            <a:headEnd type="none" w="med" len="med"/>
+            <a:tailEnd type="none" w="med" len="med"/>
+          </a:ln>
+          <a:effectLst/>
+        </p:spPr>
+        <p:txBody>
+          <a:bodyPr vert="horz" wrap="square" lIns="91440" tIns="45720" rIns="91440" bIns="45720" numCol="1" rtlCol="0" anchor="t" anchorCtr="0" compatLnSpc="1">
+            <a:prstTxWarp prst="textNoShape">
+              <a:avLst/>
+            </a:prstTxWarp>
+          </a:bodyPr>
+          <a:lstStyle/>
+          <a:p>
+            <a:pPr eaLnBrk="0" fontAlgn="base" hangingPunct="0">
+              <a:spcBef>
+                <a:spcPct val="0"/>
+              </a:spcBef>
+              <a:spcAft>
+                <a:spcPct val="0"/>
+              </a:spcAft>
+            </a:pPr>
+            <a:endParaRPr lang="en-US">
+              <a:latin typeface="Arial" charset="0"/>
+            </a:endParaRPr>
+          </a:p>
+        </p:txBody>
+      </p:sp>
+      <p:sp>
+        <p:nvSpPr>
+          <p:cNvPr id="42" name="Rectangle: Rounded Corners 41">
+            <a:extLst>
+              <a:ext uri="{FF2B5EF4-FFF2-40B4-BE49-F238E27FC236}">
+                <a16:creationId xmlns:a16="http://schemas.microsoft.com/office/drawing/2014/main" id="{56435543-E0B7-1153-C41F-4F678D2CA29C}"/>
+              </a:ext>
+            </a:extLst>
+          </p:cNvPr>
+          <p:cNvSpPr/>
+          <p:nvPr/>
+        </p:nvSpPr>
+        <p:spPr bwMode="auto">
+          <a:xfrm>
+            <a:off x="814416" y="4153167"/>
+            <a:ext cx="1049646" cy="1070973"/>
+          </a:xfrm>
+          <a:prstGeom prst="roundRect">
+            <a:avLst/>
+          </a:prstGeom>
+          <a:solidFill>
+            <a:schemeClr val="bg1"/>
+          </a:solidFill>
+          <a:ln w="38100" cap="flat" cmpd="sng" algn="ctr">
+            <a:solidFill>
+              <a:srgbClr val="87C9FB"/>
+            </a:solidFill>
+            <a:prstDash val="solid"/>
+            <a:round/>
+            <a:headEnd type="none" w="med" len="med"/>
+            <a:tailEnd type="none" w="med" len="med"/>
+          </a:ln>
+          <a:effectLst/>
+        </p:spPr>
+        <p:txBody>
+          <a:bodyPr vert="horz" wrap="square" lIns="91440" tIns="45720" rIns="91440" bIns="45720" numCol="1" rtlCol="0" anchor="t" anchorCtr="0" compatLnSpc="1">
+            <a:prstTxWarp prst="textNoShape">
+              <a:avLst/>
+            </a:prstTxWarp>
+          </a:bodyPr>
+          <a:lstStyle/>
+          <a:p>
+            <a:pPr eaLnBrk="0" fontAlgn="base" hangingPunct="0">
+              <a:spcBef>
+                <a:spcPct val="0"/>
+              </a:spcBef>
+              <a:spcAft>
+                <a:spcPct val="0"/>
+              </a:spcAft>
+            </a:pPr>
+            <a:endParaRPr lang="en-US" dirty="0">
+              <a:latin typeface="Arial" charset="0"/>
+            </a:endParaRPr>
+          </a:p>
+        </p:txBody>
+      </p:sp>
+      <p:sp>
+        <p:nvSpPr>
+          <p:cNvPr id="43" name="Rectangle: Rounded Corners 42">
+            <a:extLst>
+              <a:ext uri="{FF2B5EF4-FFF2-40B4-BE49-F238E27FC236}">
+                <a16:creationId xmlns:a16="http://schemas.microsoft.com/office/drawing/2014/main" id="{9AAF8DAB-4B64-343F-D759-B40ACDAF741A}"/>
+              </a:ext>
+            </a:extLst>
+          </p:cNvPr>
+          <p:cNvSpPr/>
+          <p:nvPr/>
+        </p:nvSpPr>
+        <p:spPr bwMode="auto">
+          <a:xfrm>
+            <a:off x="7332331" y="4153167"/>
+            <a:ext cx="1049646" cy="1070973"/>
+          </a:xfrm>
+          <a:prstGeom prst="roundRect">
+            <a:avLst/>
+          </a:prstGeom>
+          <a:solidFill>
+            <a:schemeClr val="bg1"/>
+          </a:solidFill>
+          <a:ln w="38100" cap="flat" cmpd="sng" algn="ctr">
+            <a:solidFill>
+              <a:schemeClr val="tx1">
+                <a:lumMod val="50000"/>
+                <a:lumOff val="50000"/>
+              </a:schemeClr>
+            </a:solidFill>
+            <a:prstDash val="solid"/>
+            <a:round/>
+            <a:headEnd type="none" w="med" len="med"/>
+            <a:tailEnd type="none" w="med" len="med"/>
+          </a:ln>
+          <a:effectLst/>
+        </p:spPr>
+        <p:txBody>
+          <a:bodyPr vert="horz" wrap="square" lIns="91440" tIns="45720" rIns="91440" bIns="45720" numCol="1" rtlCol="0" anchor="t" anchorCtr="0" compatLnSpc="1">
+            <a:prstTxWarp prst="textNoShape">
+              <a:avLst/>
+            </a:prstTxWarp>
+          </a:bodyPr>
+          <a:lstStyle/>
+          <a:p>
+            <a:pPr marL="0" marR="0" indent="0" algn="l" defTabSz="914400" rtl="0" eaLnBrk="0" fontAlgn="base" latinLnBrk="0" hangingPunct="0">
+              <a:lnSpc>
+                <a:spcPct val="100000"/>
+              </a:lnSpc>
+              <a:spcBef>
+                <a:spcPct val="0"/>
+              </a:spcBef>
+              <a:spcAft>
+                <a:spcPct val="0"/>
+              </a:spcAft>
+              <a:buClrTx/>
+              <a:buSzTx/>
+              <a:buFontTx/>
+              <a:buNone/>
+              <a:tabLst/>
+            </a:pPr>
+            <a:endParaRPr kumimoji="0" lang="en-US" sz="1800" b="0" i="0" u="none" strike="noStrike" cap="none" normalizeH="0" baseline="0">
+              <a:ln>
+                <a:noFill/>
+              </a:ln>
+              <a:solidFill>
+                <a:schemeClr val="tx1"/>
+              </a:solidFill>
+              <a:effectLst/>
+              <a:latin typeface="Arial" charset="0"/>
+            </a:endParaRPr>
+          </a:p>
+        </p:txBody>
+      </p:sp>
+      <p:sp>
+        <p:nvSpPr>
+          <p:cNvPr id="11" name="TextBox 10">
+            <a:extLst>
+              <a:ext uri="{FF2B5EF4-FFF2-40B4-BE49-F238E27FC236}">
+                <a16:creationId xmlns:a16="http://schemas.microsoft.com/office/drawing/2014/main" id="{15A061A9-4EBE-CD72-678A-ABCAFC09C15E}"/>
+              </a:ext>
+            </a:extLst>
+          </p:cNvPr>
+          <p:cNvSpPr txBox="1"/>
+          <p:nvPr/>
+        </p:nvSpPr>
+        <p:spPr>
+          <a:xfrm>
+            <a:off x="2092274" y="4884570"/>
+            <a:ext cx="627095" cy="261610"/>
+          </a:xfrm>
+          <a:prstGeom prst="rect">
+            <a:avLst/>
+          </a:prstGeom>
+          <a:noFill/>
+        </p:spPr>
+        <p:txBody>
+          <a:bodyPr wrap="none" rtlCol="0">
+            <a:spAutoFit/>
+          </a:bodyPr>
+          <a:lstStyle/>
+          <a:p>
+            <a:pPr algn="ctr"/>
+            <a:r>
+              <a:rPr lang="en-US" sz="1100" b="1" dirty="0">
+                <a:latin typeface="Aptos" panose="020B0004020202020204" pitchFamily="34" charset="0"/>
+                <a:ea typeface="Calibri" panose="020F0502020204030204" pitchFamily="34" charset="0"/>
+                <a:cs typeface="Calibri" panose="020F0502020204030204" pitchFamily="34" charset="0"/>
+              </a:rPr>
+              <a:t>Allergy</a:t>
+            </a:r>
+          </a:p>
+        </p:txBody>
+      </p:sp>
+      <p:sp>
+        <p:nvSpPr>
+          <p:cNvPr id="12" name="TextBox 11">
+            <a:extLst>
+              <a:ext uri="{FF2B5EF4-FFF2-40B4-BE49-F238E27FC236}">
+                <a16:creationId xmlns:a16="http://schemas.microsoft.com/office/drawing/2014/main" id="{2F4A61B6-7D43-ECE1-A7CD-7D97BFC5E865}"/>
+              </a:ext>
+            </a:extLst>
+          </p:cNvPr>
+          <p:cNvSpPr txBox="1"/>
+          <p:nvPr/>
+        </p:nvSpPr>
+        <p:spPr>
+          <a:xfrm>
+            <a:off x="977888" y="4884570"/>
+            <a:ext cx="729687" cy="261610"/>
+          </a:xfrm>
+          <a:prstGeom prst="rect">
+            <a:avLst/>
+          </a:prstGeom>
+          <a:noFill/>
+        </p:spPr>
+        <p:txBody>
+          <a:bodyPr wrap="none" rtlCol="0">
+            <a:spAutoFit/>
+          </a:bodyPr>
+          <a:lstStyle/>
+          <a:p>
+            <a:pPr algn="ctr"/>
+            <a:r>
+              <a:rPr lang="en-US" sz="1100" b="1" dirty="0">
+                <a:latin typeface="Aptos" panose="020B0004020202020204" pitchFamily="34" charset="0"/>
+                <a:ea typeface="Calibri" panose="020F0502020204030204" pitchFamily="34" charset="0"/>
+                <a:cs typeface="Calibri" panose="020F0502020204030204" pitchFamily="34" charset="0"/>
+              </a:rPr>
+              <a:t>Problem</a:t>
+            </a:r>
+          </a:p>
+        </p:txBody>
+      </p:sp>
+      <p:sp>
+        <p:nvSpPr>
+          <p:cNvPr id="13" name="TextBox 12">
+            <a:extLst>
+              <a:ext uri="{FF2B5EF4-FFF2-40B4-BE49-F238E27FC236}">
+                <a16:creationId xmlns:a16="http://schemas.microsoft.com/office/drawing/2014/main" id="{2476524D-49C9-6E07-29AE-9C2BFDE5B31E}"/>
+              </a:ext>
+            </a:extLst>
+          </p:cNvPr>
+          <p:cNvSpPr txBox="1"/>
+          <p:nvPr/>
+        </p:nvSpPr>
+        <p:spPr>
+          <a:xfrm>
+            <a:off x="3061847" y="4884570"/>
+            <a:ext cx="906017" cy="261610"/>
+          </a:xfrm>
+          <a:prstGeom prst="rect">
+            <a:avLst/>
+          </a:prstGeom>
+          <a:noFill/>
+        </p:spPr>
+        <p:txBody>
+          <a:bodyPr wrap="none" rtlCol="0">
+            <a:spAutoFit/>
+          </a:bodyPr>
+          <a:lstStyle/>
+          <a:p>
+            <a:pPr algn="ctr"/>
+            <a:r>
+              <a:rPr lang="en-US" sz="1100" b="1" dirty="0">
+                <a:latin typeface="Aptos" panose="020B0004020202020204" pitchFamily="34" charset="0"/>
+                <a:ea typeface="Calibri" panose="020F0502020204030204" pitchFamily="34" charset="0"/>
+                <a:cs typeface="Calibri" panose="020F0502020204030204" pitchFamily="34" charset="0"/>
+              </a:rPr>
+              <a:t>Medication</a:t>
+            </a:r>
+          </a:p>
+        </p:txBody>
+      </p:sp>
+      <p:sp>
+        <p:nvSpPr>
+          <p:cNvPr id="14" name="TextBox 13">
+            <a:extLst>
+              <a:ext uri="{FF2B5EF4-FFF2-40B4-BE49-F238E27FC236}">
+                <a16:creationId xmlns:a16="http://schemas.microsoft.com/office/drawing/2014/main" id="{86CBE721-F72E-CF6C-645E-1608A7C6AB98}"/>
+              </a:ext>
+            </a:extLst>
+          </p:cNvPr>
+          <p:cNvSpPr txBox="1"/>
+          <p:nvPr/>
+        </p:nvSpPr>
+        <p:spPr>
+          <a:xfrm>
+            <a:off x="4062337" y="4884570"/>
+            <a:ext cx="1072730" cy="261610"/>
+          </a:xfrm>
+          <a:prstGeom prst="rect">
+            <a:avLst/>
+          </a:prstGeom>
+          <a:noFill/>
+        </p:spPr>
+        <p:txBody>
+          <a:bodyPr wrap="none" rtlCol="0">
+            <a:spAutoFit/>
+          </a:bodyPr>
+          <a:lstStyle/>
+          <a:p>
+            <a:pPr algn="ctr"/>
+            <a:r>
+              <a:rPr lang="en-US" sz="1100" b="1" dirty="0">
+                <a:latin typeface="Aptos" panose="020B0004020202020204" pitchFamily="34" charset="0"/>
+                <a:ea typeface="Calibri" panose="020F0502020204030204" pitchFamily="34" charset="0"/>
+                <a:cs typeface="Calibri" panose="020F0502020204030204" pitchFamily="34" charset="0"/>
+              </a:rPr>
+              <a:t>Immunization</a:t>
+            </a:r>
+          </a:p>
+        </p:txBody>
+      </p:sp>
+      <p:sp>
+        <p:nvSpPr>
+          <p:cNvPr id="15" name="TextBox 14">
+            <a:extLst>
+              <a:ext uri="{FF2B5EF4-FFF2-40B4-BE49-F238E27FC236}">
+                <a16:creationId xmlns:a16="http://schemas.microsoft.com/office/drawing/2014/main" id="{FE146C21-C4EC-E6D1-146D-CD0817271720}"/>
+              </a:ext>
+            </a:extLst>
+          </p:cNvPr>
+          <p:cNvSpPr txBox="1"/>
+          <p:nvPr/>
+        </p:nvSpPr>
+        <p:spPr>
+          <a:xfrm>
+            <a:off x="5389686" y="4884570"/>
+            <a:ext cx="598241" cy="261610"/>
+          </a:xfrm>
+          <a:prstGeom prst="rect">
+            <a:avLst/>
+          </a:prstGeom>
+          <a:noFill/>
+        </p:spPr>
+        <p:txBody>
+          <a:bodyPr wrap="none" rtlCol="0">
+            <a:spAutoFit/>
+          </a:bodyPr>
+          <a:lstStyle/>
+          <a:p>
+            <a:pPr algn="ctr"/>
+            <a:r>
+              <a:rPr lang="en-US" sz="1100" b="1" dirty="0">
+                <a:latin typeface="Aptos" panose="020B0004020202020204" pitchFamily="34" charset="0"/>
+                <a:ea typeface="Calibri" panose="020F0502020204030204" pitchFamily="34" charset="0"/>
+                <a:cs typeface="Calibri" panose="020F0502020204030204" pitchFamily="34" charset="0"/>
+              </a:rPr>
+              <a:t>Result</a:t>
+            </a:r>
+          </a:p>
+        </p:txBody>
+      </p:sp>
+      <p:sp>
+        <p:nvSpPr>
+          <p:cNvPr id="16" name="TextBox 15">
+            <a:extLst>
+              <a:ext uri="{FF2B5EF4-FFF2-40B4-BE49-F238E27FC236}">
+                <a16:creationId xmlns:a16="http://schemas.microsoft.com/office/drawing/2014/main" id="{9E66E985-5B3A-E36F-76BF-C42806537BF3}"/>
+              </a:ext>
+            </a:extLst>
+          </p:cNvPr>
+          <p:cNvSpPr txBox="1"/>
+          <p:nvPr/>
+        </p:nvSpPr>
+        <p:spPr>
+          <a:xfrm>
+            <a:off x="6355802" y="4884570"/>
+            <a:ext cx="851515" cy="261610"/>
+          </a:xfrm>
+          <a:prstGeom prst="rect">
+            <a:avLst/>
+          </a:prstGeom>
+          <a:noFill/>
+        </p:spPr>
+        <p:txBody>
+          <a:bodyPr wrap="none" rtlCol="0">
+            <a:spAutoFit/>
+          </a:bodyPr>
+          <a:lstStyle/>
+          <a:p>
+            <a:pPr algn="ctr"/>
+            <a:r>
+              <a:rPr lang="en-US" sz="1100" b="1" dirty="0">
+                <a:latin typeface="Aptos" panose="020B0004020202020204" pitchFamily="34" charset="0"/>
+                <a:ea typeface="Calibri" panose="020F0502020204030204" pitchFamily="34" charset="0"/>
+                <a:cs typeface="Calibri" panose="020F0502020204030204" pitchFamily="34" charset="0"/>
+              </a:rPr>
+              <a:t>Procedure</a:t>
+            </a:r>
+          </a:p>
+        </p:txBody>
+      </p:sp>
+      <p:sp>
+        <p:nvSpPr>
+          <p:cNvPr id="17" name="TextBox 16">
+            <a:extLst>
+              <a:ext uri="{FF2B5EF4-FFF2-40B4-BE49-F238E27FC236}">
+                <a16:creationId xmlns:a16="http://schemas.microsoft.com/office/drawing/2014/main" id="{53B4C931-833E-AD51-B84D-248839F9A0C9}"/>
+              </a:ext>
+            </a:extLst>
+          </p:cNvPr>
+          <p:cNvSpPr txBox="1"/>
+          <p:nvPr/>
+        </p:nvSpPr>
+        <p:spPr>
+          <a:xfrm>
+            <a:off x="7517958" y="4819364"/>
+            <a:ext cx="678391" cy="430887"/>
+          </a:xfrm>
+          <a:prstGeom prst="rect">
+            <a:avLst/>
+          </a:prstGeom>
+          <a:noFill/>
+        </p:spPr>
+        <p:txBody>
+          <a:bodyPr wrap="none" rtlCol="0">
+            <a:spAutoFit/>
+          </a:bodyPr>
+          <a:lstStyle/>
+          <a:p>
+            <a:pPr algn="ctr"/>
+            <a:r>
+              <a:rPr lang="en-US" sz="1100" b="1" dirty="0">
+                <a:latin typeface="Aptos" panose="020B0004020202020204" pitchFamily="34" charset="0"/>
+                <a:ea typeface="Calibri" panose="020F0502020204030204" pitchFamily="34" charset="0"/>
+                <a:cs typeface="Calibri" panose="020F0502020204030204" pitchFamily="34" charset="0"/>
+              </a:rPr>
+              <a:t>Other </a:t>
+            </a:r>
+            <a:br>
+              <a:rPr lang="en-US" sz="1100" b="1" dirty="0">
+                <a:latin typeface="Aptos" panose="020B0004020202020204" pitchFamily="34" charset="0"/>
+                <a:ea typeface="Calibri" panose="020F0502020204030204" pitchFamily="34" charset="0"/>
+                <a:cs typeface="Calibri" panose="020F0502020204030204" pitchFamily="34" charset="0"/>
+              </a:rPr>
+            </a:br>
+            <a:r>
+              <a:rPr lang="en-US" sz="1100" b="1" dirty="0">
+                <a:latin typeface="Aptos" panose="020B0004020202020204" pitchFamily="34" charset="0"/>
+                <a:ea typeface="Calibri" panose="020F0502020204030204" pitchFamily="34" charset="0"/>
+                <a:cs typeface="Calibri" panose="020F0502020204030204" pitchFamily="34" charset="0"/>
+              </a:rPr>
+              <a:t>Profiles</a:t>
+            </a:r>
+          </a:p>
+        </p:txBody>
+      </p:sp>
+      <p:pic>
+        <p:nvPicPr>
+          <p:cNvPr id="36" name="Picture 35" descr="A black and white image of a pair of scissors&#10;&#10;Description automatically generated">
+            <a:extLst>
+              <a:ext uri="{FF2B5EF4-FFF2-40B4-BE49-F238E27FC236}">
+                <a16:creationId xmlns:a16="http://schemas.microsoft.com/office/drawing/2014/main" id="{E66702C4-1616-AB45-EB4F-84AA4BAE45F1}"/>
+              </a:ext>
+            </a:extLst>
+          </p:cNvPr>
+          <p:cNvPicPr>
+            <a:picLocks noChangeAspect="1"/>
+          </p:cNvPicPr>
+          <p:nvPr/>
+        </p:nvPicPr>
+        <p:blipFill>
+          <a:blip r:embed="rId3">
+            <a:extLst>
+              <a:ext uri="{28A0092B-C50C-407E-A947-70E740481C1C}">
+                <a14:useLocalDpi xmlns:a14="http://schemas.microsoft.com/office/drawing/2010/main" val="0"/>
+              </a:ext>
+            </a:extLst>
+          </a:blip>
+          <a:stretch>
+            <a:fillRect/>
+          </a:stretch>
+        </p:blipFill>
+        <p:spPr>
+          <a:xfrm>
+            <a:off x="6492361" y="4265126"/>
+            <a:ext cx="609631" cy="609631"/>
+          </a:xfrm>
+          <a:prstGeom prst="rect">
+            <a:avLst/>
+          </a:prstGeom>
+        </p:spPr>
+      </p:pic>
+      <p:pic>
+        <p:nvPicPr>
+          <p:cNvPr id="47" name="Picture 46" descr="A stethoscope with a cord&#10;&#10;Description automatically generated">
+            <a:extLst>
+              <a:ext uri="{FF2B5EF4-FFF2-40B4-BE49-F238E27FC236}">
+                <a16:creationId xmlns:a16="http://schemas.microsoft.com/office/drawing/2014/main" id="{C4625836-1CD0-5A72-30EF-DCE1F74DFD1F}"/>
+              </a:ext>
+            </a:extLst>
+          </p:cNvPr>
+          <p:cNvPicPr>
+            <a:picLocks noChangeAspect="1"/>
+          </p:cNvPicPr>
+          <p:nvPr/>
+        </p:nvPicPr>
+        <p:blipFill>
+          <a:blip r:embed="rId4">
+            <a:extLst>
+              <a:ext uri="{28A0092B-C50C-407E-A947-70E740481C1C}">
+                <a14:useLocalDpi xmlns:a14="http://schemas.microsoft.com/office/drawing/2010/main" val="0"/>
+              </a:ext>
+            </a:extLst>
+          </a:blip>
+          <a:stretch>
+            <a:fillRect/>
+          </a:stretch>
+        </p:blipFill>
+        <p:spPr>
+          <a:xfrm>
+            <a:off x="1032977" y="4301728"/>
+            <a:ext cx="609631" cy="609631"/>
+          </a:xfrm>
+          <a:prstGeom prst="rect">
+            <a:avLst/>
+          </a:prstGeom>
+        </p:spPr>
+      </p:pic>
+      <p:pic>
+        <p:nvPicPr>
+          <p:cNvPr id="49" name="Picture 48" descr="A black and white icon of a syringe and a shield&#10;&#10;Description automatically generated">
+            <a:extLst>
+              <a:ext uri="{FF2B5EF4-FFF2-40B4-BE49-F238E27FC236}">
+                <a16:creationId xmlns:a16="http://schemas.microsoft.com/office/drawing/2014/main" id="{093C8F13-341A-7203-B98B-98D243B54495}"/>
+              </a:ext>
+            </a:extLst>
+          </p:cNvPr>
+          <p:cNvPicPr>
+            <a:picLocks noChangeAspect="1"/>
+          </p:cNvPicPr>
+          <p:nvPr/>
+        </p:nvPicPr>
+        <p:blipFill>
+          <a:blip r:embed="rId5">
+            <a:extLst>
+              <a:ext uri="{28A0092B-C50C-407E-A947-70E740481C1C}">
+                <a14:useLocalDpi xmlns:a14="http://schemas.microsoft.com/office/drawing/2010/main" val="0"/>
+              </a:ext>
+            </a:extLst>
+          </a:blip>
+          <a:stretch>
+            <a:fillRect/>
+          </a:stretch>
+        </p:blipFill>
+        <p:spPr>
+          <a:xfrm>
+            <a:off x="4304740" y="4276955"/>
+            <a:ext cx="609631" cy="609631"/>
+          </a:xfrm>
+          <a:prstGeom prst="rect">
+            <a:avLst/>
+          </a:prstGeom>
+        </p:spPr>
+      </p:pic>
+      <p:pic>
+        <p:nvPicPr>
+          <p:cNvPr id="51" name="Picture 50" descr="A black and white line drawing of a test tube&#10;&#10;Description automatically generated">
+            <a:extLst>
+              <a:ext uri="{FF2B5EF4-FFF2-40B4-BE49-F238E27FC236}">
+                <a16:creationId xmlns:a16="http://schemas.microsoft.com/office/drawing/2014/main" id="{F67C267E-C6F5-72DD-1908-433EBAC3D7A3}"/>
+              </a:ext>
+            </a:extLst>
+          </p:cNvPr>
+          <p:cNvPicPr>
+            <a:picLocks noChangeAspect="1"/>
+          </p:cNvPicPr>
+          <p:nvPr/>
+        </p:nvPicPr>
+        <p:blipFill>
+          <a:blip r:embed="rId6">
+            <a:extLst>
+              <a:ext uri="{28A0092B-C50C-407E-A947-70E740481C1C}">
+                <a14:useLocalDpi xmlns:a14="http://schemas.microsoft.com/office/drawing/2010/main" val="0"/>
+              </a:ext>
+            </a:extLst>
+          </a:blip>
+          <a:stretch>
+            <a:fillRect/>
+          </a:stretch>
+        </p:blipFill>
+        <p:spPr>
+          <a:xfrm>
+            <a:off x="5379699" y="4301727"/>
+            <a:ext cx="609631" cy="609631"/>
+          </a:xfrm>
+          <a:prstGeom prst="rect">
+            <a:avLst/>
+          </a:prstGeom>
+        </p:spPr>
+      </p:pic>
+      <p:pic>
+        <p:nvPicPr>
+          <p:cNvPr id="53" name="Picture 52" descr="A black and white image of different shapes&#10;&#10;Description automatically generated">
+            <a:extLst>
+              <a:ext uri="{FF2B5EF4-FFF2-40B4-BE49-F238E27FC236}">
+                <a16:creationId xmlns:a16="http://schemas.microsoft.com/office/drawing/2014/main" id="{C215E95D-B00D-2045-C56B-CE01598440FE}"/>
+              </a:ext>
+            </a:extLst>
+          </p:cNvPr>
+          <p:cNvPicPr>
+            <a:picLocks noChangeAspect="1"/>
+          </p:cNvPicPr>
+          <p:nvPr/>
+        </p:nvPicPr>
+        <p:blipFill>
+          <a:blip r:embed="rId7">
+            <a:extLst>
+              <a:ext uri="{28A0092B-C50C-407E-A947-70E740481C1C}">
+                <a14:useLocalDpi xmlns:a14="http://schemas.microsoft.com/office/drawing/2010/main" val="0"/>
+              </a:ext>
+            </a:extLst>
+          </a:blip>
+          <a:stretch>
+            <a:fillRect/>
+          </a:stretch>
+        </p:blipFill>
+        <p:spPr>
+          <a:xfrm>
+            <a:off x="3184129" y="4296109"/>
+            <a:ext cx="609631" cy="609631"/>
+          </a:xfrm>
+          <a:prstGeom prst="rect">
+            <a:avLst/>
+          </a:prstGeom>
+        </p:spPr>
+      </p:pic>
+      <p:pic>
+        <p:nvPicPr>
+          <p:cNvPr id="62" name="Picture 61" descr="A black and white clipboard with a cross&#10;&#10;Description automatically generated">
+            <a:extLst>
+              <a:ext uri="{FF2B5EF4-FFF2-40B4-BE49-F238E27FC236}">
+                <a16:creationId xmlns:a16="http://schemas.microsoft.com/office/drawing/2014/main" id="{A86FF2D1-06AF-35EE-3680-D1861D3A0D0F}"/>
+              </a:ext>
+            </a:extLst>
+          </p:cNvPr>
+          <p:cNvPicPr>
+            <a:picLocks noChangeAspect="1"/>
+          </p:cNvPicPr>
+          <p:nvPr/>
+        </p:nvPicPr>
+        <p:blipFill>
+          <a:blip r:embed="rId8">
+            <a:extLst>
+              <a:ext uri="{28A0092B-C50C-407E-A947-70E740481C1C}">
+                <a14:useLocalDpi xmlns:a14="http://schemas.microsoft.com/office/drawing/2010/main" val="0"/>
+              </a:ext>
+            </a:extLst>
+          </a:blip>
+          <a:stretch>
+            <a:fillRect/>
+          </a:stretch>
+        </p:blipFill>
+        <p:spPr>
+          <a:xfrm>
+            <a:off x="7434924" y="4362053"/>
+            <a:ext cx="430887" cy="430887"/>
+          </a:xfrm>
+          <a:prstGeom prst="rect">
+            <a:avLst/>
+          </a:prstGeom>
+        </p:spPr>
+      </p:pic>
+      <p:pic>
+        <p:nvPicPr>
+          <p:cNvPr id="66" name="Picture 65">
+            <a:extLst>
+              <a:ext uri="{FF2B5EF4-FFF2-40B4-BE49-F238E27FC236}">
+                <a16:creationId xmlns:a16="http://schemas.microsoft.com/office/drawing/2014/main" id="{4802D7DB-7378-E5A9-38E0-95A69C9CCD95}"/>
+              </a:ext>
+            </a:extLst>
+          </p:cNvPr>
+          <p:cNvPicPr>
+            <a:picLocks noChangeAspect="1"/>
+          </p:cNvPicPr>
+          <p:nvPr/>
+        </p:nvPicPr>
+        <p:blipFill rotWithShape="1">
+          <a:blip r:embed="rId9"/>
+          <a:srcRect l="6754" t="18564" r="80644" b="30366"/>
+          <a:stretch/>
+        </p:blipFill>
+        <p:spPr>
+          <a:xfrm>
+            <a:off x="2125742" y="4301727"/>
+            <a:ext cx="606925" cy="604013"/>
+          </a:xfrm>
+          <a:prstGeom prst="rect">
+            <a:avLst/>
+          </a:prstGeom>
+        </p:spPr>
+      </p:pic>
+      <p:pic>
+        <p:nvPicPr>
+          <p:cNvPr id="67" name="Picture 66">
+            <a:extLst>
+              <a:ext uri="{FF2B5EF4-FFF2-40B4-BE49-F238E27FC236}">
+                <a16:creationId xmlns:a16="http://schemas.microsoft.com/office/drawing/2014/main" id="{B8518EE4-E8DF-96FA-CD6D-6923083E553C}"/>
+              </a:ext>
+            </a:extLst>
+          </p:cNvPr>
+          <p:cNvPicPr>
+            <a:picLocks noChangeAspect="1"/>
+          </p:cNvPicPr>
+          <p:nvPr/>
+        </p:nvPicPr>
+        <p:blipFill rotWithShape="1">
+          <a:blip r:embed="rId10"/>
+          <a:srcRect t="14434" r="85778" b="20996"/>
+          <a:stretch/>
+        </p:blipFill>
+        <p:spPr>
+          <a:xfrm>
+            <a:off x="7671506" y="4339789"/>
+            <a:ext cx="593795" cy="489843"/>
+          </a:xfrm>
+          <a:prstGeom prst="rect">
+            <a:avLst/>
+          </a:prstGeom>
+        </p:spPr>
+      </p:pic>
+      <p:sp>
+        <p:nvSpPr>
+          <p:cNvPr id="68" name="TextBox 67">
+            <a:extLst>
+              <a:ext uri="{FF2B5EF4-FFF2-40B4-BE49-F238E27FC236}">
+                <a16:creationId xmlns:a16="http://schemas.microsoft.com/office/drawing/2014/main" id="{0B933ED0-93F3-B61F-7A4D-1A63496A399B}"/>
+              </a:ext>
+            </a:extLst>
+          </p:cNvPr>
+          <p:cNvSpPr txBox="1"/>
+          <p:nvPr/>
+        </p:nvSpPr>
+        <p:spPr>
+          <a:xfrm>
+            <a:off x="4840947" y="2689810"/>
+            <a:ext cx="1619354" cy="307777"/>
+          </a:xfrm>
+          <a:prstGeom prst="rect">
+            <a:avLst/>
+          </a:prstGeom>
+          <a:noFill/>
+        </p:spPr>
+        <p:txBody>
+          <a:bodyPr wrap="none" rtlCol="0">
+            <a:spAutoFit/>
+          </a:bodyPr>
+          <a:lstStyle/>
+          <a:p>
+            <a:r>
+              <a:rPr lang="en-US" sz="1400" dirty="0">
+                <a:solidFill>
+                  <a:schemeClr val="tx1">
+                    <a:lumMod val="50000"/>
+                    <a:lumOff val="50000"/>
+                  </a:schemeClr>
+                </a:solidFill>
+                <a:latin typeface="Aptos" panose="020B0004020202020204" pitchFamily="34" charset="0"/>
+              </a:rPr>
+              <a:t>+11 other sections</a:t>
+            </a:r>
+          </a:p>
+        </p:txBody>
+      </p:sp>
+      <p:sp>
+        <p:nvSpPr>
+          <p:cNvPr id="29" name="Rectangle: Rounded Corners 28">
+            <a:extLst>
+              <a:ext uri="{FF2B5EF4-FFF2-40B4-BE49-F238E27FC236}">
+                <a16:creationId xmlns:a16="http://schemas.microsoft.com/office/drawing/2014/main" id="{87DCCCE1-3079-4C55-AAD2-E2FF3053AAB9}"/>
+              </a:ext>
+            </a:extLst>
+          </p:cNvPr>
+          <p:cNvSpPr/>
+          <p:nvPr/>
+        </p:nvSpPr>
+        <p:spPr bwMode="auto">
+          <a:xfrm>
+            <a:off x="3796707" y="169030"/>
+            <a:ext cx="3325732" cy="3115955"/>
+          </a:xfrm>
+          <a:prstGeom prst="roundRect">
+            <a:avLst>
+              <a:gd name="adj" fmla="val 4745"/>
+            </a:avLst>
+          </a:prstGeom>
+          <a:noFill/>
+          <a:ln w="57150" cap="flat" cmpd="sng" algn="ctr">
+            <a:solidFill>
+              <a:srgbClr val="00B0F0"/>
+            </a:solidFill>
+            <a:prstDash val="solid"/>
+            <a:round/>
+            <a:headEnd type="none" w="med" len="med"/>
+            <a:tailEnd type="none" w="med" len="med"/>
+          </a:ln>
+          <a:effectLst/>
+        </p:spPr>
+        <p:txBody>
+          <a:bodyPr vert="horz" wrap="square" lIns="91440" tIns="45720" rIns="91440" bIns="45720" numCol="1" rtlCol="0" anchor="t" anchorCtr="0" compatLnSpc="1">
+            <a:prstTxWarp prst="textNoShape">
+              <a:avLst/>
+            </a:prstTxWarp>
+          </a:bodyPr>
+          <a:lstStyle/>
+          <a:p>
+            <a:pPr marL="0" marR="0" indent="0" algn="l" defTabSz="914400" rtl="0" eaLnBrk="0" fontAlgn="base" latinLnBrk="0" hangingPunct="0">
+              <a:lnSpc>
+                <a:spcPct val="100000"/>
+              </a:lnSpc>
+              <a:spcBef>
+                <a:spcPct val="0"/>
+              </a:spcBef>
+              <a:spcAft>
+                <a:spcPct val="0"/>
+              </a:spcAft>
+              <a:buClrTx/>
+              <a:buSzTx/>
+              <a:buFontTx/>
+              <a:buNone/>
+              <a:tabLst/>
+            </a:pPr>
+            <a:endParaRPr kumimoji="0" lang="en-US" sz="1800" b="0" i="0" u="none" strike="noStrike" cap="none" normalizeH="0" baseline="0">
+              <a:ln>
+                <a:noFill/>
+              </a:ln>
+              <a:solidFill>
+                <a:schemeClr val="tx1"/>
+              </a:solidFill>
+              <a:effectLst/>
+              <a:latin typeface="Arial" charset="0"/>
+            </a:endParaRPr>
+          </a:p>
+        </p:txBody>
+      </p:sp>
+      <p:sp>
+        <p:nvSpPr>
+          <p:cNvPr id="3" name="TextBox 2">
+            <a:extLst>
+              <a:ext uri="{FF2B5EF4-FFF2-40B4-BE49-F238E27FC236}">
+                <a16:creationId xmlns:a16="http://schemas.microsoft.com/office/drawing/2014/main" id="{8DBA0334-B443-F79E-67DF-33AF2DDF78F5}"/>
+              </a:ext>
+            </a:extLst>
+          </p:cNvPr>
+          <p:cNvSpPr txBox="1"/>
+          <p:nvPr/>
+        </p:nvSpPr>
+        <p:spPr>
+          <a:xfrm>
+            <a:off x="814416" y="5262939"/>
+            <a:ext cx="7686720" cy="369332"/>
+          </a:xfrm>
+          <a:prstGeom prst="rect">
+            <a:avLst/>
+          </a:prstGeom>
+          <a:noFill/>
+        </p:spPr>
+        <p:txBody>
+          <a:bodyPr wrap="none" rtlCol="0">
+            <a:spAutoFit/>
+          </a:bodyPr>
+          <a:lstStyle/>
+          <a:p>
+            <a:r>
+              <a:rPr lang="en-US" dirty="0">
+                <a:solidFill>
+                  <a:schemeClr val="tx1">
+                    <a:lumMod val="75000"/>
+                    <a:lumOff val="25000"/>
+                  </a:schemeClr>
+                </a:solidFill>
+              </a:rPr>
+              <a:t>US Core 6.1.0 Resources are defined in a </a:t>
+            </a:r>
+            <a:r>
+              <a:rPr lang="en-US">
+                <a:solidFill>
+                  <a:schemeClr val="tx1">
+                    <a:lumMod val="75000"/>
+                    <a:lumOff val="25000"/>
+                  </a:schemeClr>
+                </a:solidFill>
+              </a:rPr>
+              <a:t>separate implementation guide</a:t>
+            </a:r>
+            <a:endParaRPr lang="en-US" dirty="0">
+              <a:solidFill>
+                <a:schemeClr val="tx1">
+                  <a:lumMod val="75000"/>
+                  <a:lumOff val="25000"/>
+                </a:schemeClr>
+              </a:solidFill>
+            </a:endParaRPr>
+          </a:p>
+        </p:txBody>
+      </p:sp>
+    </p:spTree>
+    <p:extLst>
+      <p:ext uri="{BB962C8B-B14F-4D97-AF65-F5344CB8AC3E}">
+        <p14:creationId xmlns:p14="http://schemas.microsoft.com/office/powerpoint/2010/main" val="4158657776"/>
+      </p:ext>
+    </p:extLst>
+  </p:cSld>
+  <p:clrMapOvr>
+    <a:masterClrMapping/>
+  </p:clrMapOvr>
+</p:sld>
+</file>
+
+<file path=ppt/slides/slide5.xml><?xml version="1.0" encoding="utf-8"?>
+<p:sld xmlns:a="http://schemas.openxmlformats.org/drawingml/2006/main" xmlns:r="http://schemas.openxmlformats.org/officeDocument/2006/relationships" xmlns:p="http://schemas.openxmlformats.org/presentationml/2006/main">
+  <p:cSld>
+    <p:spTree>
+      <p:nvGrpSpPr>
+        <p:cNvPr id="1" name=""/>
+        <p:cNvGrpSpPr/>
+        <p:nvPr/>
+      </p:nvGrpSpPr>
+      <p:grpSpPr>
+        <a:xfrm>
+          <a:off x="0" y="0"/>
+          <a:ext cx="0" cy="0"/>
+          <a:chOff x="0" y="0"/>
+          <a:chExt cx="0" cy="0"/>
+        </a:xfrm>
+      </p:grpSpPr>
+      <p:sp>
+        <p:nvSpPr>
           <p:cNvPr id="14" name="Rechteck 13">
             <a:extLst>
               <a:ext uri="{FF2B5EF4-FFF2-40B4-BE49-F238E27FC236}">
@@ -14895,7 +19528,7 @@
 </p:sld>
 </file>
 
-<file path=ppt/slides/slide3.xml><?xml version="1.0" encoding="utf-8"?>
+<file path=ppt/slides/slide6.xml><?xml version="1.0" encoding="utf-8"?>
 <p:sld xmlns:a="http://schemas.openxmlformats.org/drawingml/2006/main" xmlns:r="http://schemas.openxmlformats.org/officeDocument/2006/relationships" xmlns:p="http://schemas.openxmlformats.org/presentationml/2006/main">
   <p:cSld>
     <p:spTree>
@@ -15833,7 +20466,7 @@
 </p:sld>
 </file>
 
-<file path=ppt/slides/slide4.xml><?xml version="1.0" encoding="utf-8"?>
+<file path=ppt/slides/slide7.xml><?xml version="1.0" encoding="utf-8"?>
 <p:sld xmlns:a="http://schemas.openxmlformats.org/drawingml/2006/main" xmlns:r="http://schemas.openxmlformats.org/officeDocument/2006/relationships" xmlns:p="http://schemas.openxmlformats.org/presentationml/2006/main">
   <p:cSld>
     <p:spTree>
@@ -16493,7 +21126,7 @@
 </p:sld>
 </file>
 
-<file path=ppt/slides/slide5.xml><?xml version="1.0" encoding="utf-8"?>
+<file path=ppt/slides/slide8.xml><?xml version="1.0" encoding="utf-8"?>
 <p:sld xmlns:a="http://schemas.openxmlformats.org/drawingml/2006/main" xmlns:r="http://schemas.openxmlformats.org/officeDocument/2006/relationships" xmlns:p="http://schemas.openxmlformats.org/presentationml/2006/main">
   <p:cSld>
     <p:spTree>

</xml_diff>

<commit_message>
Updates to PPT images, no guide changes
</commit_message>
<xml_diff>
--- a/US-PCS ballot images 2026.pptx
+++ b/US-PCS ballot images 2026.pptx
@@ -6,17 +6,18 @@
     <p:sldMasterId id="2147483670" r:id="rId2"/>
   </p:sldMasterIdLst>
   <p:notesMasterIdLst>
-    <p:notesMasterId r:id="rId11"/>
+    <p:notesMasterId r:id="rId12"/>
   </p:notesMasterIdLst>
   <p:sldIdLst>
     <p:sldId id="801" r:id="rId3"/>
     <p:sldId id="806" r:id="rId4"/>
     <p:sldId id="807" r:id="rId5"/>
-    <p:sldId id="805" r:id="rId6"/>
-    <p:sldId id="258" r:id="rId7"/>
-    <p:sldId id="802" r:id="rId8"/>
-    <p:sldId id="803" r:id="rId9"/>
-    <p:sldId id="804" r:id="rId10"/>
+    <p:sldId id="808" r:id="rId6"/>
+    <p:sldId id="805" r:id="rId7"/>
+    <p:sldId id="258" r:id="rId8"/>
+    <p:sldId id="802" r:id="rId9"/>
+    <p:sldId id="803" r:id="rId10"/>
+    <p:sldId id="804" r:id="rId11"/>
   </p:sldIdLst>
   <p:sldSz cx="9144000" cy="6858000" type="screen4x3"/>
   <p:notesSz cx="6858000" cy="9144000"/>
@@ -123,6 +124,7 @@
             <p14:sldId id="801"/>
             <p14:sldId id="806"/>
             <p14:sldId id="807"/>
+            <p14:sldId id="808"/>
             <p14:sldId id="805"/>
             <p14:sldId id="258"/>
             <p14:sldId id="802"/>
@@ -867,7 +869,7 @@
           <a:p>
             <a:fld id="{10B9A41D-2C14-4FD9-A8FE-469DBFAB3809}" type="datetimeFigureOut">
               <a:rPr lang="en-CA" smtClean="0"/>
-              <a:t>2026-03-19</a:t>
+              <a:t>2026-06-04</a:t>
             </a:fld>
             <a:endParaRPr lang="en-CA" dirty="0"/>
           </a:p>
@@ -1719,7 +1721,7 @@
           <a:p>
             <a:fld id="{0D2F0FE0-C0B2-431B-95AF-3256C55C95DF}" type="datetimeFigureOut">
               <a:rPr lang="en-US" smtClean="0"/>
-              <a:t>3/19/2026</a:t>
+              <a:t>6/4/2026</a:t>
             </a:fld>
             <a:endParaRPr lang="en-US"/>
           </a:p>
@@ -1917,7 +1919,7 @@
           <a:p>
             <a:fld id="{0D2F0FE0-C0B2-431B-95AF-3256C55C95DF}" type="datetimeFigureOut">
               <a:rPr lang="en-US" smtClean="0"/>
-              <a:t>3/19/2026</a:t>
+              <a:t>6/4/2026</a:t>
             </a:fld>
             <a:endParaRPr lang="en-US"/>
           </a:p>
@@ -2192,7 +2194,7 @@
           <a:p>
             <a:fld id="{0D2F0FE0-C0B2-431B-95AF-3256C55C95DF}" type="datetimeFigureOut">
               <a:rPr lang="en-US" smtClean="0"/>
-              <a:t>3/19/2026</a:t>
+              <a:t>6/4/2026</a:t>
             </a:fld>
             <a:endParaRPr lang="en-US"/>
           </a:p>
@@ -2457,7 +2459,7 @@
           <a:p>
             <a:fld id="{0D2F0FE0-C0B2-431B-95AF-3256C55C95DF}" type="datetimeFigureOut">
               <a:rPr lang="en-US" smtClean="0"/>
-              <a:t>3/19/2026</a:t>
+              <a:t>6/4/2026</a:t>
             </a:fld>
             <a:endParaRPr lang="en-US"/>
           </a:p>
@@ -2869,7 +2871,7 @@
           <a:p>
             <a:fld id="{0D2F0FE0-C0B2-431B-95AF-3256C55C95DF}" type="datetimeFigureOut">
               <a:rPr lang="en-US" smtClean="0"/>
-              <a:t>3/19/2026</a:t>
+              <a:t>6/4/2026</a:t>
             </a:fld>
             <a:endParaRPr lang="en-US"/>
           </a:p>
@@ -3010,7 +3012,7 @@
           <a:p>
             <a:fld id="{0D2F0FE0-C0B2-431B-95AF-3256C55C95DF}" type="datetimeFigureOut">
               <a:rPr lang="en-US" smtClean="0"/>
-              <a:t>3/19/2026</a:t>
+              <a:t>6/4/2026</a:t>
             </a:fld>
             <a:endParaRPr lang="en-US"/>
           </a:p>
@@ -3123,7 +3125,7 @@
           <a:p>
             <a:fld id="{0D2F0FE0-C0B2-431B-95AF-3256C55C95DF}" type="datetimeFigureOut">
               <a:rPr lang="en-US" smtClean="0"/>
-              <a:t>3/19/2026</a:t>
+              <a:t>6/4/2026</a:t>
             </a:fld>
             <a:endParaRPr lang="en-US"/>
           </a:p>
@@ -3434,7 +3436,7 @@
           <a:p>
             <a:fld id="{0D2F0FE0-C0B2-431B-95AF-3256C55C95DF}" type="datetimeFigureOut">
               <a:rPr lang="en-US" smtClean="0"/>
-              <a:t>3/19/2026</a:t>
+              <a:t>6/4/2026</a:t>
             </a:fld>
             <a:endParaRPr lang="en-US"/>
           </a:p>
@@ -3722,7 +3724,7 @@
           <a:p>
             <a:fld id="{0D2F0FE0-C0B2-431B-95AF-3256C55C95DF}" type="datetimeFigureOut">
               <a:rPr lang="en-US" smtClean="0"/>
-              <a:t>3/19/2026</a:t>
+              <a:t>6/4/2026</a:t>
             </a:fld>
             <a:endParaRPr lang="en-US"/>
           </a:p>
@@ -3920,7 +3922,7 @@
           <a:p>
             <a:fld id="{0D2F0FE0-C0B2-431B-95AF-3256C55C95DF}" type="datetimeFigureOut">
               <a:rPr lang="en-US" smtClean="0"/>
-              <a:t>3/19/2026</a:t>
+              <a:t>6/4/2026</a:t>
             </a:fld>
             <a:endParaRPr lang="en-US"/>
           </a:p>
@@ -4371,7 +4373,7 @@
           <a:p>
             <a:fld id="{0D2F0FE0-C0B2-431B-95AF-3256C55C95DF}" type="datetimeFigureOut">
               <a:rPr lang="en-US" smtClean="0"/>
-              <a:t>3/19/2026</a:t>
+              <a:t>6/4/2026</a:t>
             </a:fld>
             <a:endParaRPr lang="en-US"/>
           </a:p>
@@ -7953,7 +7955,7 @@
           <a:p>
             <a:fld id="{0D2F0FE0-C0B2-431B-95AF-3256C55C95DF}" type="datetimeFigureOut">
               <a:rPr lang="en-US" smtClean="0"/>
-              <a:t>3/19/2026</a:t>
+              <a:t>6/4/2026</a:t>
             </a:fld>
             <a:endParaRPr lang="en-US"/>
           </a:p>
@@ -12982,7 +12984,7 @@
         <p:cNvPr id="1" name="">
           <a:extLst>
             <a:ext uri="{FF2B5EF4-FFF2-40B4-BE49-F238E27FC236}">
-              <a16:creationId xmlns:a16="http://schemas.microsoft.com/office/drawing/2014/main" id="{AB4C46FB-22C6-D0A3-5996-E0DA95F2CD58}"/>
+              <a16:creationId xmlns:a16="http://schemas.microsoft.com/office/drawing/2014/main" id="{A26F4F2A-75EF-F58C-AFDB-9520EC8E6541}"/>
             </a:ext>
           </a:extLst>
         </p:cNvPr>
@@ -12997,12 +12999,72 @@
           <a:chExt cx="0" cy="0"/>
         </a:xfrm>
       </p:grpSpPr>
-      <p:sp>
-        <p:nvSpPr>
-          <p:cNvPr id="5" name="Arrow: Right 4">
-            <a:extLst>
-              <a:ext uri="{FF2B5EF4-FFF2-40B4-BE49-F238E27FC236}">
-                <a16:creationId xmlns:a16="http://schemas.microsoft.com/office/drawing/2014/main" id="{C7C68B5F-5710-F402-DDF6-1872CF11B605}"/>
+      <p:pic>
+        <p:nvPicPr>
+          <p:cNvPr id="45" name="Picture 44">
+            <a:extLst>
+              <a:ext uri="{FF2B5EF4-FFF2-40B4-BE49-F238E27FC236}">
+                <a16:creationId xmlns:a16="http://schemas.microsoft.com/office/drawing/2014/main" id="{B4491178-B254-AB47-DDF6-320353A423E6}"/>
+              </a:ext>
+            </a:extLst>
+          </p:cNvPr>
+          <p:cNvPicPr>
+            <a:picLocks noChangeAspect="1"/>
+          </p:cNvPicPr>
+          <p:nvPr/>
+        </p:nvPicPr>
+        <p:blipFill>
+          <a:blip r:embed="rId2"/>
+          <a:stretch>
+            <a:fillRect/>
+          </a:stretch>
+        </p:blipFill>
+        <p:spPr>
+          <a:xfrm>
+            <a:off x="3970270" y="259705"/>
+            <a:ext cx="3470619" cy="2991233"/>
+          </a:xfrm>
+          <a:prstGeom prst="rect">
+            <a:avLst/>
+          </a:prstGeom>
+        </p:spPr>
+      </p:pic>
+      <p:sp>
+        <p:nvSpPr>
+          <p:cNvPr id="2" name="Slide Number Placeholder 1">
+            <a:extLst>
+              <a:ext uri="{FF2B5EF4-FFF2-40B4-BE49-F238E27FC236}">
+                <a16:creationId xmlns:a16="http://schemas.microsoft.com/office/drawing/2014/main" id="{271635A0-0881-6126-C538-80CC0CA5E426}"/>
+              </a:ext>
+            </a:extLst>
+          </p:cNvPr>
+          <p:cNvSpPr>
+            <a:spLocks noGrp="1"/>
+          </p:cNvSpPr>
+          <p:nvPr>
+            <p:ph type="sldNum" sz="quarter" idx="4"/>
+          </p:nvPr>
+        </p:nvSpPr>
+        <p:spPr/>
+        <p:txBody>
+          <a:bodyPr/>
+          <a:lstStyle/>
+          <a:p>
+            <a:fld id="{5CC3E5C4-3E2B-40F1-9F2B-C46CEB0C88DF}" type="slidenum">
+              <a:rPr lang="en-CA" smtClean="0"/>
+              <a:pPr/>
+              <a:t>4</a:t>
+            </a:fld>
+            <a:endParaRPr lang="en-CA" dirty="0"/>
+          </a:p>
+        </p:txBody>
+      </p:sp>
+      <p:sp>
+        <p:nvSpPr>
+          <p:cNvPr id="4" name="Arrow: Right 3">
+            <a:extLst>
+              <a:ext uri="{FF2B5EF4-FFF2-40B4-BE49-F238E27FC236}">
+                <a16:creationId xmlns:a16="http://schemas.microsoft.com/office/drawing/2014/main" id="{6AF522F1-7DF7-8FA8-3D82-33EF2446B564}"/>
               </a:ext>
             </a:extLst>
           </p:cNvPr>
@@ -13073,10 +13135,10 @@
       </p:sp>
       <p:sp>
         <p:nvSpPr>
-          <p:cNvPr id="9" name="Rectangle: Rounded Corners 8">
-            <a:extLst>
-              <a:ext uri="{FF2B5EF4-FFF2-40B4-BE49-F238E27FC236}">
-                <a16:creationId xmlns:a16="http://schemas.microsoft.com/office/drawing/2014/main" id="{D59F3E04-444E-4176-A0F6-65877522FA6F}"/>
+          <p:cNvPr id="5" name="Rectangle: Rounded Corners 4">
+            <a:extLst>
+              <a:ext uri="{FF2B5EF4-FFF2-40B4-BE49-F238E27FC236}">
+                <a16:creationId xmlns:a16="http://schemas.microsoft.com/office/drawing/2014/main" id="{7937753B-8FBE-D8DB-806F-A8DB40C5E137}"/>
               </a:ext>
             </a:extLst>
           </p:cNvPr>
@@ -13085,8 +13147,8 @@
         </p:nvSpPr>
         <p:spPr bwMode="auto">
           <a:xfrm>
-            <a:off x="683568" y="3573015"/>
-            <a:ext cx="7848872" cy="2081332"/>
+            <a:off x="683568" y="3933056"/>
+            <a:ext cx="7848872" cy="1904164"/>
           </a:xfrm>
           <a:prstGeom prst="roundRect">
             <a:avLst>
@@ -13133,10 +13195,10 @@
       </p:sp>
       <p:sp>
         <p:nvSpPr>
-          <p:cNvPr id="10" name="TextBox 9">
-            <a:extLst>
-              <a:ext uri="{FF2B5EF4-FFF2-40B4-BE49-F238E27FC236}">
-                <a16:creationId xmlns:a16="http://schemas.microsoft.com/office/drawing/2014/main" id="{EBCD2639-5DFF-3BAF-9F90-6CDAB7C60D5D}"/>
+          <p:cNvPr id="6" name="TextBox 5">
+            <a:extLst>
+              <a:ext uri="{FF2B5EF4-FFF2-40B4-BE49-F238E27FC236}">
+                <a16:creationId xmlns:a16="http://schemas.microsoft.com/office/drawing/2014/main" id="{11ADD68E-659C-D860-9AD8-81A5231FE260}"/>
               </a:ext>
             </a:extLst>
           </p:cNvPr>
@@ -13145,7 +13207,7 @@
         </p:nvSpPr>
         <p:spPr>
           <a:xfrm>
-            <a:off x="683569" y="3589151"/>
+            <a:off x="683569" y="3949192"/>
             <a:ext cx="7848872" cy="523220"/>
           </a:xfrm>
           <a:prstGeom prst="rect">
@@ -13171,296 +13233,26 @@
           </a:p>
         </p:txBody>
       </p:sp>
-      <p:pic>
-        <p:nvPicPr>
-          <p:cNvPr id="22" name="Picture 21">
-            <a:extLst>
-              <a:ext uri="{FF2B5EF4-FFF2-40B4-BE49-F238E27FC236}">
-                <a16:creationId xmlns:a16="http://schemas.microsoft.com/office/drawing/2014/main" id="{ED6288EB-AFFB-BC4F-13D9-E4ACF7D3D9AE}"/>
-              </a:ext>
-            </a:extLst>
-          </p:cNvPr>
-          <p:cNvPicPr>
-            <a:picLocks noChangeAspect="1"/>
-          </p:cNvPicPr>
-          <p:nvPr/>
-        </p:nvPicPr>
-        <p:blipFill>
-          <a:blip r:embed="rId2"/>
-          <a:stretch>
-            <a:fillRect/>
-          </a:stretch>
-        </p:blipFill>
-        <p:spPr>
-          <a:xfrm>
-            <a:off x="3878472" y="169030"/>
-            <a:ext cx="3243967" cy="3149367"/>
-          </a:xfrm>
-          <a:prstGeom prst="rect">
-            <a:avLst/>
-          </a:prstGeom>
-        </p:spPr>
-      </p:pic>
-      <p:sp>
-        <p:nvSpPr>
-          <p:cNvPr id="23" name="TextBox 22">
-            <a:extLst>
-              <a:ext uri="{FF2B5EF4-FFF2-40B4-BE49-F238E27FC236}">
-                <a16:creationId xmlns:a16="http://schemas.microsoft.com/office/drawing/2014/main" id="{3BE81991-0106-B1EB-2A89-77F5536E90E2}"/>
-              </a:ext>
-            </a:extLst>
-          </p:cNvPr>
-          <p:cNvSpPr txBox="1"/>
-          <p:nvPr/>
-        </p:nvSpPr>
-        <p:spPr>
-          <a:xfrm>
-            <a:off x="5076357" y="1139423"/>
-            <a:ext cx="1552209" cy="276999"/>
-          </a:xfrm>
-          <a:prstGeom prst="rect">
-            <a:avLst/>
-          </a:prstGeom>
-          <a:noFill/>
-        </p:spPr>
-        <p:txBody>
-          <a:bodyPr wrap="square" rtlCol="0">
-            <a:spAutoFit/>
-          </a:bodyPr>
-          <a:lstStyle/>
-          <a:p>
-            <a:r>
-              <a:rPr lang="en-US" sz="1200" b="1" dirty="0">
-                <a:solidFill>
-                  <a:schemeClr val="bg1"/>
-                </a:solidFill>
-                <a:latin typeface="Aptos" panose="020B0004020202020204" pitchFamily="34" charset="0"/>
-              </a:rPr>
-              <a:t>Medications</a:t>
-            </a:r>
-          </a:p>
-        </p:txBody>
-      </p:sp>
-      <p:sp>
-        <p:nvSpPr>
-          <p:cNvPr id="24" name="TextBox 23">
-            <a:extLst>
-              <a:ext uri="{FF2B5EF4-FFF2-40B4-BE49-F238E27FC236}">
-                <a16:creationId xmlns:a16="http://schemas.microsoft.com/office/drawing/2014/main" id="{DE6FED39-43E9-B4E1-39D0-6CE39DB9DC5A}"/>
-              </a:ext>
-            </a:extLst>
-          </p:cNvPr>
-          <p:cNvSpPr txBox="1"/>
-          <p:nvPr/>
-        </p:nvSpPr>
-        <p:spPr>
-          <a:xfrm>
-            <a:off x="5135067" y="765732"/>
-            <a:ext cx="1901566" cy="276999"/>
-          </a:xfrm>
-          <a:prstGeom prst="rect">
-            <a:avLst/>
-          </a:prstGeom>
-          <a:noFill/>
-        </p:spPr>
-        <p:txBody>
-          <a:bodyPr wrap="square" rtlCol="0">
-            <a:spAutoFit/>
-          </a:bodyPr>
-          <a:lstStyle/>
-          <a:p>
-            <a:r>
-              <a:rPr lang="en-US" sz="1200" b="1" dirty="0">
-                <a:solidFill>
-                  <a:schemeClr val="bg1"/>
-                </a:solidFill>
-                <a:latin typeface="Aptos" panose="020B0004020202020204" pitchFamily="34" charset="0"/>
-              </a:rPr>
-              <a:t>Allergies / Intolerances</a:t>
-            </a:r>
-          </a:p>
-        </p:txBody>
-      </p:sp>
-      <p:sp>
-        <p:nvSpPr>
-          <p:cNvPr id="25" name="TextBox 24">
-            <a:extLst>
-              <a:ext uri="{FF2B5EF4-FFF2-40B4-BE49-F238E27FC236}">
-                <a16:creationId xmlns:a16="http://schemas.microsoft.com/office/drawing/2014/main" id="{882CB8C7-307B-8125-D9F7-A17102F073E2}"/>
-              </a:ext>
-            </a:extLst>
-          </p:cNvPr>
-          <p:cNvSpPr txBox="1"/>
-          <p:nvPr/>
-        </p:nvSpPr>
-        <p:spPr>
-          <a:xfrm>
-            <a:off x="5076358" y="368677"/>
-            <a:ext cx="1901566" cy="276999"/>
-          </a:xfrm>
-          <a:prstGeom prst="rect">
-            <a:avLst/>
-          </a:prstGeom>
-          <a:noFill/>
-        </p:spPr>
-        <p:txBody>
-          <a:bodyPr wrap="square" rtlCol="0">
-            <a:spAutoFit/>
-          </a:bodyPr>
-          <a:lstStyle/>
-          <a:p>
-            <a:r>
-              <a:rPr lang="en-US" sz="1200" b="1" dirty="0">
-                <a:solidFill>
-                  <a:schemeClr val="bg1"/>
-                </a:solidFill>
-                <a:latin typeface="Aptos" panose="020B0004020202020204" pitchFamily="34" charset="0"/>
-              </a:rPr>
-              <a:t>Problems</a:t>
-            </a:r>
-          </a:p>
-        </p:txBody>
-      </p:sp>
-      <p:sp>
-        <p:nvSpPr>
-          <p:cNvPr id="26" name="TextBox 25">
-            <a:extLst>
-              <a:ext uri="{FF2B5EF4-FFF2-40B4-BE49-F238E27FC236}">
-                <a16:creationId xmlns:a16="http://schemas.microsoft.com/office/drawing/2014/main" id="{F1FABB8A-EF1A-B52F-7302-B92D2BB84136}"/>
-              </a:ext>
-            </a:extLst>
-          </p:cNvPr>
-          <p:cNvSpPr txBox="1"/>
-          <p:nvPr/>
-        </p:nvSpPr>
-        <p:spPr>
-          <a:xfrm>
-            <a:off x="5076358" y="2295540"/>
-            <a:ext cx="1901566" cy="276999"/>
-          </a:xfrm>
-          <a:prstGeom prst="rect">
-            <a:avLst/>
-          </a:prstGeom>
-          <a:noFill/>
-        </p:spPr>
-        <p:txBody>
-          <a:bodyPr wrap="square" rtlCol="0">
-            <a:spAutoFit/>
-          </a:bodyPr>
-          <a:lstStyle/>
-          <a:p>
-            <a:r>
-              <a:rPr lang="en-US" sz="1200" b="1" dirty="0">
-                <a:solidFill>
-                  <a:schemeClr val="bg1"/>
-                </a:solidFill>
-                <a:latin typeface="Aptos" panose="020B0004020202020204" pitchFamily="34" charset="0"/>
-              </a:rPr>
-              <a:t>Procedures</a:t>
-            </a:r>
-          </a:p>
-        </p:txBody>
-      </p:sp>
-      <p:sp>
-        <p:nvSpPr>
-          <p:cNvPr id="27" name="TextBox 26">
-            <a:extLst>
-              <a:ext uri="{FF2B5EF4-FFF2-40B4-BE49-F238E27FC236}">
-                <a16:creationId xmlns:a16="http://schemas.microsoft.com/office/drawing/2014/main" id="{603B436F-488B-4147-2F07-AC082890CF72}"/>
-              </a:ext>
-            </a:extLst>
-          </p:cNvPr>
-          <p:cNvSpPr txBox="1"/>
-          <p:nvPr/>
-        </p:nvSpPr>
-        <p:spPr>
-          <a:xfrm>
-            <a:off x="5076358" y="1524796"/>
-            <a:ext cx="1901566" cy="276999"/>
-          </a:xfrm>
-          <a:prstGeom prst="rect">
-            <a:avLst/>
-          </a:prstGeom>
-          <a:noFill/>
-        </p:spPr>
-        <p:txBody>
-          <a:bodyPr wrap="square" rtlCol="0">
-            <a:spAutoFit/>
-          </a:bodyPr>
-          <a:lstStyle/>
-          <a:p>
-            <a:r>
-              <a:rPr lang="en-US" sz="1200" b="1" dirty="0">
-                <a:solidFill>
-                  <a:srgbClr val="54A831"/>
-                </a:solidFill>
-                <a:latin typeface="Aptos" panose="020B0004020202020204" pitchFamily="34" charset="0"/>
-              </a:rPr>
-              <a:t>Immunizations</a:t>
-            </a:r>
-          </a:p>
-        </p:txBody>
-      </p:sp>
-      <p:sp>
-        <p:nvSpPr>
-          <p:cNvPr id="28" name="TextBox 27">
-            <a:extLst>
-              <a:ext uri="{FF2B5EF4-FFF2-40B4-BE49-F238E27FC236}">
-                <a16:creationId xmlns:a16="http://schemas.microsoft.com/office/drawing/2014/main" id="{A3A3A697-E7AD-86BC-00DA-A0254BDCBBED}"/>
-              </a:ext>
-            </a:extLst>
-          </p:cNvPr>
-          <p:cNvSpPr txBox="1"/>
-          <p:nvPr/>
-        </p:nvSpPr>
-        <p:spPr>
-          <a:xfrm>
-            <a:off x="5076358" y="1910169"/>
-            <a:ext cx="1901566" cy="276999"/>
-          </a:xfrm>
-          <a:prstGeom prst="rect">
-            <a:avLst/>
-          </a:prstGeom>
-          <a:noFill/>
-        </p:spPr>
-        <p:txBody>
-          <a:bodyPr wrap="square" rtlCol="0">
-            <a:spAutoFit/>
-          </a:bodyPr>
-          <a:lstStyle/>
-          <a:p>
-            <a:r>
-              <a:rPr lang="en-US" sz="1200" b="1" dirty="0">
-                <a:solidFill>
-                  <a:srgbClr val="E86328"/>
-                </a:solidFill>
-                <a:latin typeface="Aptos" panose="020B0004020202020204" pitchFamily="34" charset="0"/>
-              </a:rPr>
-              <a:t>Results</a:t>
-            </a:r>
-          </a:p>
-        </p:txBody>
-      </p:sp>
       <p:cxnSp>
         <p:nvCxnSpPr>
-          <p:cNvPr id="31" name="Connector: Elbow 30">
-            <a:extLst>
-              <a:ext uri="{FF2B5EF4-FFF2-40B4-BE49-F238E27FC236}">
-                <a16:creationId xmlns:a16="http://schemas.microsoft.com/office/drawing/2014/main" id="{60EDF3A7-0432-54AA-ABC2-F8D867B45F44}"/>
+          <p:cNvPr id="7" name="Connector: Elbow 6">
+            <a:extLst>
+              <a:ext uri="{FF2B5EF4-FFF2-40B4-BE49-F238E27FC236}">
+                <a16:creationId xmlns:a16="http://schemas.microsoft.com/office/drawing/2014/main" id="{471D082B-D56A-20EF-D790-C06B3AE96205}"/>
               </a:ext>
             </a:extLst>
           </p:cNvPr>
           <p:cNvCxnSpPr>
             <a:cxnSpLocks/>
-            <a:stCxn id="29" idx="2"/>
-            <a:endCxn id="9" idx="0"/>
+            <a:stCxn id="8" idx="2"/>
+            <a:endCxn id="5" idx="0"/>
           </p:cNvCxnSpPr>
           <p:nvPr/>
         </p:nvCxnSpPr>
         <p:spPr bwMode="auto">
           <a:xfrm rot="5400000">
-            <a:off x="4889774" y="3003216"/>
-            <a:ext cx="288030" cy="851569"/>
+            <a:off x="4878883" y="3077832"/>
+            <a:ext cx="584345" cy="1126102"/>
           </a:xfrm>
           <a:prstGeom prst="bentConnector3">
             <a:avLst/>
@@ -13495,10 +13287,10 @@
       </p:cxnSp>
       <p:sp>
         <p:nvSpPr>
-          <p:cNvPr id="37" name="Rectangle: Rounded Corners 36">
-            <a:extLst>
-              <a:ext uri="{FF2B5EF4-FFF2-40B4-BE49-F238E27FC236}">
-                <a16:creationId xmlns:a16="http://schemas.microsoft.com/office/drawing/2014/main" id="{09E8988F-DE68-C454-CE73-B2B9623C1232}"/>
+          <p:cNvPr id="8" name="Rectangle: Rounded Corners 7">
+            <a:extLst>
+              <a:ext uri="{FF2B5EF4-FFF2-40B4-BE49-F238E27FC236}">
+                <a16:creationId xmlns:a16="http://schemas.microsoft.com/office/drawing/2014/main" id="{B82C77BB-708F-4724-86F6-5083814B4986}"/>
               </a:ext>
             </a:extLst>
           </p:cNvPr>
@@ -13507,357 +13299,18 @@
         </p:nvSpPr>
         <p:spPr bwMode="auto">
           <a:xfrm>
-            <a:off x="6246011" y="4153167"/>
-            <a:ext cx="1049646" cy="1070973"/>
+            <a:off x="3796706" y="116632"/>
+            <a:ext cx="3874799" cy="3232079"/>
           </a:xfrm>
           <a:prstGeom prst="roundRect">
-            <a:avLst/>
+            <a:avLst>
+              <a:gd name="adj" fmla="val 4745"/>
+            </a:avLst>
           </a:prstGeom>
-          <a:solidFill>
-            <a:schemeClr val="bg1"/>
-          </a:solidFill>
-          <a:ln w="38100" cap="flat" cmpd="sng" algn="ctr">
+          <a:noFill/>
+          <a:ln w="57150" cap="flat" cmpd="sng" algn="ctr">
             <a:solidFill>
-              <a:srgbClr val="E86328"/>
-            </a:solidFill>
-            <a:prstDash val="solid"/>
-            <a:round/>
-            <a:headEnd type="none" w="med" len="med"/>
-            <a:tailEnd type="none" w="med" len="med"/>
-          </a:ln>
-          <a:effectLst/>
-        </p:spPr>
-        <p:txBody>
-          <a:bodyPr vert="horz" wrap="square" lIns="91440" tIns="45720" rIns="91440" bIns="45720" numCol="1" rtlCol="0" anchor="t" anchorCtr="0" compatLnSpc="1">
-            <a:prstTxWarp prst="textNoShape">
-              <a:avLst/>
-            </a:prstTxWarp>
-          </a:bodyPr>
-          <a:lstStyle/>
-          <a:p>
-            <a:pPr eaLnBrk="0" fontAlgn="base" hangingPunct="0">
-              <a:spcBef>
-                <a:spcPct val="0"/>
-              </a:spcBef>
-              <a:spcAft>
-                <a:spcPct val="0"/>
-              </a:spcAft>
-            </a:pPr>
-            <a:endParaRPr lang="en-US">
-              <a:latin typeface="Arial" charset="0"/>
-            </a:endParaRPr>
-          </a:p>
-        </p:txBody>
-      </p:sp>
-      <p:sp>
-        <p:nvSpPr>
-          <p:cNvPr id="38" name="Rectangle: Rounded Corners 37">
-            <a:extLst>
-              <a:ext uri="{FF2B5EF4-FFF2-40B4-BE49-F238E27FC236}">
-                <a16:creationId xmlns:a16="http://schemas.microsoft.com/office/drawing/2014/main" id="{39C150A3-CD4B-2C36-B92E-32664E4267B6}"/>
-              </a:ext>
-            </a:extLst>
-          </p:cNvPr>
-          <p:cNvSpPr/>
-          <p:nvPr/>
-        </p:nvSpPr>
-        <p:spPr bwMode="auto">
-          <a:xfrm>
-            <a:off x="5159692" y="4153167"/>
-            <a:ext cx="1049646" cy="1070973"/>
-          </a:xfrm>
-          <a:prstGeom prst="roundRect">
-            <a:avLst/>
-          </a:prstGeom>
-          <a:solidFill>
-            <a:schemeClr val="bg1"/>
-          </a:solidFill>
-          <a:ln w="38100" cap="flat" cmpd="sng" algn="ctr">
-            <a:solidFill>
-              <a:srgbClr val="F7D33E"/>
-            </a:solidFill>
-            <a:prstDash val="solid"/>
-            <a:round/>
-            <a:headEnd type="none" w="med" len="med"/>
-            <a:tailEnd type="none" w="med" len="med"/>
-          </a:ln>
-          <a:effectLst/>
-        </p:spPr>
-        <p:txBody>
-          <a:bodyPr vert="horz" wrap="square" lIns="91440" tIns="45720" rIns="91440" bIns="45720" numCol="1" rtlCol="0" anchor="t" anchorCtr="0" compatLnSpc="1">
-            <a:prstTxWarp prst="textNoShape">
-              <a:avLst/>
-            </a:prstTxWarp>
-          </a:bodyPr>
-          <a:lstStyle/>
-          <a:p>
-            <a:pPr eaLnBrk="0" fontAlgn="base" hangingPunct="0">
-              <a:spcBef>
-                <a:spcPct val="0"/>
-              </a:spcBef>
-              <a:spcAft>
-                <a:spcPct val="0"/>
-              </a:spcAft>
-            </a:pPr>
-            <a:endParaRPr lang="en-US">
-              <a:latin typeface="Arial" charset="0"/>
-            </a:endParaRPr>
-          </a:p>
-        </p:txBody>
-      </p:sp>
-      <p:sp>
-        <p:nvSpPr>
-          <p:cNvPr id="39" name="Rectangle: Rounded Corners 38">
-            <a:extLst>
-              <a:ext uri="{FF2B5EF4-FFF2-40B4-BE49-F238E27FC236}">
-                <a16:creationId xmlns:a16="http://schemas.microsoft.com/office/drawing/2014/main" id="{AA93C4CF-CF59-CA36-4BFB-FA382C354C0A}"/>
-              </a:ext>
-            </a:extLst>
-          </p:cNvPr>
-          <p:cNvSpPr/>
-          <p:nvPr/>
-        </p:nvSpPr>
-        <p:spPr bwMode="auto">
-          <a:xfrm>
-            <a:off x="4073373" y="4153167"/>
-            <a:ext cx="1049646" cy="1070973"/>
-          </a:xfrm>
-          <a:prstGeom prst="roundRect">
-            <a:avLst/>
-          </a:prstGeom>
-          <a:solidFill>
-            <a:schemeClr val="bg1"/>
-          </a:solidFill>
-          <a:ln w="38100" cap="flat" cmpd="sng" algn="ctr">
-            <a:solidFill>
-              <a:srgbClr val="CAD404"/>
-            </a:solidFill>
-            <a:prstDash val="solid"/>
-            <a:round/>
-            <a:headEnd type="none" w="med" len="med"/>
-            <a:tailEnd type="none" w="med" len="med"/>
-          </a:ln>
-          <a:effectLst/>
-        </p:spPr>
-        <p:txBody>
-          <a:bodyPr vert="horz" wrap="square" lIns="91440" tIns="45720" rIns="91440" bIns="45720" numCol="1" rtlCol="0" anchor="t" anchorCtr="0" compatLnSpc="1">
-            <a:prstTxWarp prst="textNoShape">
-              <a:avLst/>
-            </a:prstTxWarp>
-          </a:bodyPr>
-          <a:lstStyle/>
-          <a:p>
-            <a:pPr eaLnBrk="0" fontAlgn="base" hangingPunct="0">
-              <a:spcBef>
-                <a:spcPct val="0"/>
-              </a:spcBef>
-              <a:spcAft>
-                <a:spcPct val="0"/>
-              </a:spcAft>
-            </a:pPr>
-            <a:endParaRPr lang="en-US">
-              <a:latin typeface="Arial" charset="0"/>
-            </a:endParaRPr>
-          </a:p>
-        </p:txBody>
-      </p:sp>
-      <p:sp>
-        <p:nvSpPr>
-          <p:cNvPr id="40" name="Rectangle: Rounded Corners 39">
-            <a:extLst>
-              <a:ext uri="{FF2B5EF4-FFF2-40B4-BE49-F238E27FC236}">
-                <a16:creationId xmlns:a16="http://schemas.microsoft.com/office/drawing/2014/main" id="{8CC8489E-BE78-CCA7-0ECC-158CE4467AE4}"/>
-              </a:ext>
-            </a:extLst>
-          </p:cNvPr>
-          <p:cNvSpPr/>
-          <p:nvPr/>
-        </p:nvSpPr>
-        <p:spPr bwMode="auto">
-          <a:xfrm>
-            <a:off x="2987054" y="4153167"/>
-            <a:ext cx="1049646" cy="1070973"/>
-          </a:xfrm>
-          <a:prstGeom prst="roundRect">
-            <a:avLst/>
-          </a:prstGeom>
-          <a:solidFill>
-            <a:schemeClr val="bg1"/>
-          </a:solidFill>
-          <a:ln w="38100" cap="flat" cmpd="sng" algn="ctr">
-            <a:solidFill>
-              <a:srgbClr val="05953F"/>
-            </a:solidFill>
-            <a:prstDash val="solid"/>
-            <a:round/>
-            <a:headEnd type="none" w="med" len="med"/>
-            <a:tailEnd type="none" w="med" len="med"/>
-          </a:ln>
-          <a:effectLst/>
-        </p:spPr>
-        <p:txBody>
-          <a:bodyPr vert="horz" wrap="square" lIns="91440" tIns="45720" rIns="91440" bIns="45720" numCol="1" rtlCol="0" anchor="t" anchorCtr="0" compatLnSpc="1">
-            <a:prstTxWarp prst="textNoShape">
-              <a:avLst/>
-            </a:prstTxWarp>
-          </a:bodyPr>
-          <a:lstStyle/>
-          <a:p>
-            <a:pPr eaLnBrk="0" fontAlgn="base" hangingPunct="0">
-              <a:spcBef>
-                <a:spcPct val="0"/>
-              </a:spcBef>
-              <a:spcAft>
-                <a:spcPct val="0"/>
-              </a:spcAft>
-            </a:pPr>
-            <a:endParaRPr lang="en-US">
-              <a:latin typeface="Arial" charset="0"/>
-            </a:endParaRPr>
-          </a:p>
-        </p:txBody>
-      </p:sp>
-      <p:sp>
-        <p:nvSpPr>
-          <p:cNvPr id="41" name="Rectangle: Rounded Corners 40">
-            <a:extLst>
-              <a:ext uri="{FF2B5EF4-FFF2-40B4-BE49-F238E27FC236}">
-                <a16:creationId xmlns:a16="http://schemas.microsoft.com/office/drawing/2014/main" id="{9EFD4498-4871-A26E-E394-7F456281B3A5}"/>
-              </a:ext>
-            </a:extLst>
-          </p:cNvPr>
-          <p:cNvSpPr/>
-          <p:nvPr/>
-        </p:nvSpPr>
-        <p:spPr bwMode="auto">
-          <a:xfrm>
-            <a:off x="1900735" y="4153167"/>
-            <a:ext cx="1049646" cy="1070973"/>
-          </a:xfrm>
-          <a:prstGeom prst="roundRect">
-            <a:avLst/>
-          </a:prstGeom>
-          <a:solidFill>
-            <a:schemeClr val="bg1"/>
-          </a:solidFill>
-          <a:ln w="38100" cap="flat" cmpd="sng" algn="ctr">
-            <a:solidFill>
-              <a:srgbClr val="1BA5CC"/>
-            </a:solidFill>
-            <a:prstDash val="solid"/>
-            <a:round/>
-            <a:headEnd type="none" w="med" len="med"/>
-            <a:tailEnd type="none" w="med" len="med"/>
-          </a:ln>
-          <a:effectLst/>
-        </p:spPr>
-        <p:txBody>
-          <a:bodyPr vert="horz" wrap="square" lIns="91440" tIns="45720" rIns="91440" bIns="45720" numCol="1" rtlCol="0" anchor="t" anchorCtr="0" compatLnSpc="1">
-            <a:prstTxWarp prst="textNoShape">
-              <a:avLst/>
-            </a:prstTxWarp>
-          </a:bodyPr>
-          <a:lstStyle/>
-          <a:p>
-            <a:pPr eaLnBrk="0" fontAlgn="base" hangingPunct="0">
-              <a:spcBef>
-                <a:spcPct val="0"/>
-              </a:spcBef>
-              <a:spcAft>
-                <a:spcPct val="0"/>
-              </a:spcAft>
-            </a:pPr>
-            <a:endParaRPr lang="en-US">
-              <a:latin typeface="Arial" charset="0"/>
-            </a:endParaRPr>
-          </a:p>
-        </p:txBody>
-      </p:sp>
-      <p:sp>
-        <p:nvSpPr>
-          <p:cNvPr id="42" name="Rectangle: Rounded Corners 41">
-            <a:extLst>
-              <a:ext uri="{FF2B5EF4-FFF2-40B4-BE49-F238E27FC236}">
-                <a16:creationId xmlns:a16="http://schemas.microsoft.com/office/drawing/2014/main" id="{56435543-E0B7-1153-C41F-4F678D2CA29C}"/>
-              </a:ext>
-            </a:extLst>
-          </p:cNvPr>
-          <p:cNvSpPr/>
-          <p:nvPr/>
-        </p:nvSpPr>
-        <p:spPr bwMode="auto">
-          <a:xfrm>
-            <a:off x="814416" y="4153167"/>
-            <a:ext cx="1049646" cy="1070973"/>
-          </a:xfrm>
-          <a:prstGeom prst="roundRect">
-            <a:avLst/>
-          </a:prstGeom>
-          <a:solidFill>
-            <a:schemeClr val="bg1"/>
-          </a:solidFill>
-          <a:ln w="38100" cap="flat" cmpd="sng" algn="ctr">
-            <a:solidFill>
-              <a:srgbClr val="87C9FB"/>
-            </a:solidFill>
-            <a:prstDash val="solid"/>
-            <a:round/>
-            <a:headEnd type="none" w="med" len="med"/>
-            <a:tailEnd type="none" w="med" len="med"/>
-          </a:ln>
-          <a:effectLst/>
-        </p:spPr>
-        <p:txBody>
-          <a:bodyPr vert="horz" wrap="square" lIns="91440" tIns="45720" rIns="91440" bIns="45720" numCol="1" rtlCol="0" anchor="t" anchorCtr="0" compatLnSpc="1">
-            <a:prstTxWarp prst="textNoShape">
-              <a:avLst/>
-            </a:prstTxWarp>
-          </a:bodyPr>
-          <a:lstStyle/>
-          <a:p>
-            <a:pPr eaLnBrk="0" fontAlgn="base" hangingPunct="0">
-              <a:spcBef>
-                <a:spcPct val="0"/>
-              </a:spcBef>
-              <a:spcAft>
-                <a:spcPct val="0"/>
-              </a:spcAft>
-            </a:pPr>
-            <a:endParaRPr lang="en-US" dirty="0">
-              <a:latin typeface="Arial" charset="0"/>
-            </a:endParaRPr>
-          </a:p>
-        </p:txBody>
-      </p:sp>
-      <p:sp>
-        <p:nvSpPr>
-          <p:cNvPr id="43" name="Rectangle: Rounded Corners 42">
-            <a:extLst>
-              <a:ext uri="{FF2B5EF4-FFF2-40B4-BE49-F238E27FC236}">
-                <a16:creationId xmlns:a16="http://schemas.microsoft.com/office/drawing/2014/main" id="{9AAF8DAB-4B64-343F-D759-B40ACDAF741A}"/>
-              </a:ext>
-            </a:extLst>
-          </p:cNvPr>
-          <p:cNvSpPr/>
-          <p:nvPr/>
-        </p:nvSpPr>
-        <p:spPr bwMode="auto">
-          <a:xfrm>
-            <a:off x="7332331" y="4153167"/>
-            <a:ext cx="1049646" cy="1070973"/>
-          </a:xfrm>
-          <a:prstGeom prst="roundRect">
-            <a:avLst/>
-          </a:prstGeom>
-          <a:solidFill>
-            <a:schemeClr val="bg1"/>
-          </a:solidFill>
-          <a:ln w="38100" cap="flat" cmpd="sng" algn="ctr">
-            <a:solidFill>
-              <a:schemeClr val="tx1">
-                <a:lumMod val="50000"/>
-                <a:lumOff val="50000"/>
-              </a:schemeClr>
+              <a:srgbClr val="00B0F0"/>
             </a:solidFill>
             <a:prstDash val="solid"/>
             <a:round/>
@@ -13905,642 +13358,369 @@
       </p:sp>
       <p:sp>
         <p:nvSpPr>
-          <p:cNvPr id="11" name="TextBox 10">
-            <a:extLst>
-              <a:ext uri="{FF2B5EF4-FFF2-40B4-BE49-F238E27FC236}">
-                <a16:creationId xmlns:a16="http://schemas.microsoft.com/office/drawing/2014/main" id="{15A061A9-4EBE-CD72-678A-ABCAFC09C15E}"/>
-              </a:ext>
-            </a:extLst>
-          </p:cNvPr>
-          <p:cNvSpPr txBox="1"/>
+          <p:cNvPr id="9" name="Rectangle: Rounded Corners 8">
+            <a:extLst>
+              <a:ext uri="{FF2B5EF4-FFF2-40B4-BE49-F238E27FC236}">
+                <a16:creationId xmlns:a16="http://schemas.microsoft.com/office/drawing/2014/main" id="{AC149171-6B82-665F-9374-06D53A7CEC38}"/>
+              </a:ext>
+            </a:extLst>
+          </p:cNvPr>
+          <p:cNvSpPr/>
           <p:nvPr/>
         </p:nvSpPr>
-        <p:spPr>
-          <a:xfrm>
-            <a:off x="2092274" y="4884570"/>
-            <a:ext cx="627095" cy="261610"/>
-          </a:xfrm>
-          <a:prstGeom prst="rect">
+        <p:spPr bwMode="auto">
+          <a:xfrm>
+            <a:off x="5527070" y="4513208"/>
+            <a:ext cx="910712" cy="929216"/>
+          </a:xfrm>
+          <a:prstGeom prst="roundRect">
             <a:avLst/>
           </a:prstGeom>
-          <a:noFill/>
-        </p:spPr>
-        <p:txBody>
-          <a:bodyPr wrap="none" rtlCol="0">
-            <a:spAutoFit/>
+          <a:solidFill>
+            <a:schemeClr val="bg1"/>
+          </a:solidFill>
+          <a:ln w="38100" cap="flat" cmpd="sng" algn="ctr">
+            <a:solidFill>
+              <a:srgbClr val="E86328"/>
+            </a:solidFill>
+            <a:prstDash val="solid"/>
+            <a:round/>
+            <a:headEnd type="none" w="med" len="med"/>
+            <a:tailEnd type="none" w="med" len="med"/>
+          </a:ln>
+          <a:effectLst/>
+        </p:spPr>
+        <p:txBody>
+          <a:bodyPr vert="horz" wrap="square" lIns="91440" tIns="45720" rIns="91440" bIns="45720" numCol="1" rtlCol="0" anchor="t" anchorCtr="0" compatLnSpc="1">
+            <a:prstTxWarp prst="textNoShape">
+              <a:avLst/>
+            </a:prstTxWarp>
           </a:bodyPr>
           <a:lstStyle/>
           <a:p>
-            <a:pPr algn="ctr"/>
-            <a:r>
-              <a:rPr lang="en-US" sz="1100" b="1" dirty="0">
-                <a:latin typeface="Aptos" panose="020B0004020202020204" pitchFamily="34" charset="0"/>
-                <a:ea typeface="Calibri" panose="020F0502020204030204" pitchFamily="34" charset="0"/>
-                <a:cs typeface="Calibri" panose="020F0502020204030204" pitchFamily="34" charset="0"/>
-              </a:rPr>
-              <a:t>Allergy</a:t>
-            </a:r>
-          </a:p>
-        </p:txBody>
-      </p:sp>
-      <p:sp>
-        <p:nvSpPr>
-          <p:cNvPr id="12" name="TextBox 11">
-            <a:extLst>
-              <a:ext uri="{FF2B5EF4-FFF2-40B4-BE49-F238E27FC236}">
-                <a16:creationId xmlns:a16="http://schemas.microsoft.com/office/drawing/2014/main" id="{2F4A61B6-7D43-ECE1-A7CD-7D97BFC5E865}"/>
-              </a:ext>
-            </a:extLst>
-          </p:cNvPr>
-          <p:cNvSpPr txBox="1"/>
+            <a:pPr eaLnBrk="0" fontAlgn="base" hangingPunct="0">
+              <a:spcBef>
+                <a:spcPct val="0"/>
+              </a:spcBef>
+              <a:spcAft>
+                <a:spcPct val="0"/>
+              </a:spcAft>
+            </a:pPr>
+            <a:endParaRPr lang="en-US">
+              <a:latin typeface="Arial" charset="0"/>
+            </a:endParaRPr>
+          </a:p>
+        </p:txBody>
+      </p:sp>
+      <p:sp>
+        <p:nvSpPr>
+          <p:cNvPr id="10" name="Rectangle: Rounded Corners 9">
+            <a:extLst>
+              <a:ext uri="{FF2B5EF4-FFF2-40B4-BE49-F238E27FC236}">
+                <a16:creationId xmlns:a16="http://schemas.microsoft.com/office/drawing/2014/main" id="{6EE9946D-1529-8C2B-BFD4-FFE6FBAF29A8}"/>
+              </a:ext>
+            </a:extLst>
+          </p:cNvPr>
+          <p:cNvSpPr/>
           <p:nvPr/>
         </p:nvSpPr>
-        <p:spPr>
-          <a:xfrm>
-            <a:off x="977888" y="4884570"/>
-            <a:ext cx="729687" cy="261610"/>
-          </a:xfrm>
-          <a:prstGeom prst="rect">
+        <p:spPr bwMode="auto">
+          <a:xfrm>
+            <a:off x="4584539" y="4513208"/>
+            <a:ext cx="910712" cy="929216"/>
+          </a:xfrm>
+          <a:prstGeom prst="roundRect">
             <a:avLst/>
           </a:prstGeom>
-          <a:noFill/>
-        </p:spPr>
-        <p:txBody>
-          <a:bodyPr wrap="none" rtlCol="0">
-            <a:spAutoFit/>
+          <a:solidFill>
+            <a:schemeClr val="bg1"/>
+          </a:solidFill>
+          <a:ln w="38100" cap="flat" cmpd="sng" algn="ctr">
+            <a:solidFill>
+              <a:srgbClr val="F7D33E"/>
+            </a:solidFill>
+            <a:prstDash val="solid"/>
+            <a:round/>
+            <a:headEnd type="none" w="med" len="med"/>
+            <a:tailEnd type="none" w="med" len="med"/>
+          </a:ln>
+          <a:effectLst/>
+        </p:spPr>
+        <p:txBody>
+          <a:bodyPr vert="horz" wrap="square" lIns="91440" tIns="45720" rIns="91440" bIns="45720" numCol="1" rtlCol="0" anchor="t" anchorCtr="0" compatLnSpc="1">
+            <a:prstTxWarp prst="textNoShape">
+              <a:avLst/>
+            </a:prstTxWarp>
           </a:bodyPr>
           <a:lstStyle/>
           <a:p>
-            <a:pPr algn="ctr"/>
-            <a:r>
-              <a:rPr lang="en-US" sz="1100" b="1" dirty="0">
-                <a:latin typeface="Aptos" panose="020B0004020202020204" pitchFamily="34" charset="0"/>
-                <a:ea typeface="Calibri" panose="020F0502020204030204" pitchFamily="34" charset="0"/>
-                <a:cs typeface="Calibri" panose="020F0502020204030204" pitchFamily="34" charset="0"/>
-              </a:rPr>
-              <a:t>Problem</a:t>
-            </a:r>
-          </a:p>
-        </p:txBody>
-      </p:sp>
-      <p:sp>
-        <p:nvSpPr>
-          <p:cNvPr id="13" name="TextBox 12">
-            <a:extLst>
-              <a:ext uri="{FF2B5EF4-FFF2-40B4-BE49-F238E27FC236}">
-                <a16:creationId xmlns:a16="http://schemas.microsoft.com/office/drawing/2014/main" id="{2476524D-49C9-6E07-29AE-9C2BFDE5B31E}"/>
-              </a:ext>
-            </a:extLst>
-          </p:cNvPr>
-          <p:cNvSpPr txBox="1"/>
+            <a:pPr eaLnBrk="0" fontAlgn="base" hangingPunct="0">
+              <a:spcBef>
+                <a:spcPct val="0"/>
+              </a:spcBef>
+              <a:spcAft>
+                <a:spcPct val="0"/>
+              </a:spcAft>
+            </a:pPr>
+            <a:endParaRPr lang="en-US">
+              <a:latin typeface="Arial" charset="0"/>
+            </a:endParaRPr>
+          </a:p>
+        </p:txBody>
+      </p:sp>
+      <p:sp>
+        <p:nvSpPr>
+          <p:cNvPr id="11" name="Rectangle: Rounded Corners 10">
+            <a:extLst>
+              <a:ext uri="{FF2B5EF4-FFF2-40B4-BE49-F238E27FC236}">
+                <a16:creationId xmlns:a16="http://schemas.microsoft.com/office/drawing/2014/main" id="{91FFBDBD-B278-0299-2B77-DEEB1039A77E}"/>
+              </a:ext>
+            </a:extLst>
+          </p:cNvPr>
+          <p:cNvSpPr/>
           <p:nvPr/>
         </p:nvSpPr>
-        <p:spPr>
-          <a:xfrm>
-            <a:off x="3061847" y="4884570"/>
-            <a:ext cx="906017" cy="261610"/>
-          </a:xfrm>
-          <a:prstGeom prst="rect">
+        <p:spPr bwMode="auto">
+          <a:xfrm>
+            <a:off x="3642009" y="4513208"/>
+            <a:ext cx="910712" cy="929216"/>
+          </a:xfrm>
+          <a:prstGeom prst="roundRect">
             <a:avLst/>
           </a:prstGeom>
-          <a:noFill/>
-        </p:spPr>
-        <p:txBody>
-          <a:bodyPr wrap="none" rtlCol="0">
-            <a:spAutoFit/>
+          <a:solidFill>
+            <a:schemeClr val="bg1"/>
+          </a:solidFill>
+          <a:ln w="38100" cap="flat" cmpd="sng" algn="ctr">
+            <a:solidFill>
+              <a:srgbClr val="CAD404"/>
+            </a:solidFill>
+            <a:prstDash val="solid"/>
+            <a:round/>
+            <a:headEnd type="none" w="med" len="med"/>
+            <a:tailEnd type="none" w="med" len="med"/>
+          </a:ln>
+          <a:effectLst/>
+        </p:spPr>
+        <p:txBody>
+          <a:bodyPr vert="horz" wrap="square" lIns="91440" tIns="45720" rIns="91440" bIns="45720" numCol="1" rtlCol="0" anchor="t" anchorCtr="0" compatLnSpc="1">
+            <a:prstTxWarp prst="textNoShape">
+              <a:avLst/>
+            </a:prstTxWarp>
           </a:bodyPr>
           <a:lstStyle/>
           <a:p>
-            <a:pPr algn="ctr"/>
-            <a:r>
-              <a:rPr lang="en-US" sz="1100" b="1" dirty="0">
-                <a:latin typeface="Aptos" panose="020B0004020202020204" pitchFamily="34" charset="0"/>
-                <a:ea typeface="Calibri" panose="020F0502020204030204" pitchFamily="34" charset="0"/>
-                <a:cs typeface="Calibri" panose="020F0502020204030204" pitchFamily="34" charset="0"/>
-              </a:rPr>
-              <a:t>Medication</a:t>
-            </a:r>
-          </a:p>
-        </p:txBody>
-      </p:sp>
-      <p:sp>
-        <p:nvSpPr>
-          <p:cNvPr id="14" name="TextBox 13">
-            <a:extLst>
-              <a:ext uri="{FF2B5EF4-FFF2-40B4-BE49-F238E27FC236}">
-                <a16:creationId xmlns:a16="http://schemas.microsoft.com/office/drawing/2014/main" id="{86CBE721-F72E-CF6C-645E-1608A7C6AB98}"/>
-              </a:ext>
-            </a:extLst>
-          </p:cNvPr>
-          <p:cNvSpPr txBox="1"/>
+            <a:pPr eaLnBrk="0" fontAlgn="base" hangingPunct="0">
+              <a:spcBef>
+                <a:spcPct val="0"/>
+              </a:spcBef>
+              <a:spcAft>
+                <a:spcPct val="0"/>
+              </a:spcAft>
+            </a:pPr>
+            <a:endParaRPr lang="en-US">
+              <a:latin typeface="Arial" charset="0"/>
+            </a:endParaRPr>
+          </a:p>
+        </p:txBody>
+      </p:sp>
+      <p:sp>
+        <p:nvSpPr>
+          <p:cNvPr id="12" name="Rectangle: Rounded Corners 11">
+            <a:extLst>
+              <a:ext uri="{FF2B5EF4-FFF2-40B4-BE49-F238E27FC236}">
+                <a16:creationId xmlns:a16="http://schemas.microsoft.com/office/drawing/2014/main" id="{E935B7D2-FA62-D44D-BB2A-E386B72CCFE6}"/>
+              </a:ext>
+            </a:extLst>
+          </p:cNvPr>
+          <p:cNvSpPr/>
           <p:nvPr/>
         </p:nvSpPr>
-        <p:spPr>
-          <a:xfrm>
-            <a:off x="4062337" y="4884570"/>
-            <a:ext cx="1072730" cy="261610"/>
-          </a:xfrm>
-          <a:prstGeom prst="rect">
+        <p:spPr bwMode="auto">
+          <a:xfrm>
+            <a:off x="2699478" y="4513208"/>
+            <a:ext cx="910712" cy="929216"/>
+          </a:xfrm>
+          <a:prstGeom prst="roundRect">
             <a:avLst/>
           </a:prstGeom>
-          <a:noFill/>
-        </p:spPr>
-        <p:txBody>
-          <a:bodyPr wrap="none" rtlCol="0">
-            <a:spAutoFit/>
+          <a:solidFill>
+            <a:schemeClr val="bg1"/>
+          </a:solidFill>
+          <a:ln w="38100" cap="flat" cmpd="sng" algn="ctr">
+            <a:solidFill>
+              <a:srgbClr val="05953F"/>
+            </a:solidFill>
+            <a:prstDash val="solid"/>
+            <a:round/>
+            <a:headEnd type="none" w="med" len="med"/>
+            <a:tailEnd type="none" w="med" len="med"/>
+          </a:ln>
+          <a:effectLst/>
+        </p:spPr>
+        <p:txBody>
+          <a:bodyPr vert="horz" wrap="square" lIns="91440" tIns="45720" rIns="91440" bIns="45720" numCol="1" rtlCol="0" anchor="t" anchorCtr="0" compatLnSpc="1">
+            <a:prstTxWarp prst="textNoShape">
+              <a:avLst/>
+            </a:prstTxWarp>
           </a:bodyPr>
           <a:lstStyle/>
           <a:p>
-            <a:pPr algn="ctr"/>
-            <a:r>
-              <a:rPr lang="en-US" sz="1100" b="1" dirty="0">
-                <a:latin typeface="Aptos" panose="020B0004020202020204" pitchFamily="34" charset="0"/>
-                <a:ea typeface="Calibri" panose="020F0502020204030204" pitchFamily="34" charset="0"/>
-                <a:cs typeface="Calibri" panose="020F0502020204030204" pitchFamily="34" charset="0"/>
-              </a:rPr>
-              <a:t>Immunization</a:t>
-            </a:r>
-          </a:p>
-        </p:txBody>
-      </p:sp>
-      <p:sp>
-        <p:nvSpPr>
-          <p:cNvPr id="15" name="TextBox 14">
-            <a:extLst>
-              <a:ext uri="{FF2B5EF4-FFF2-40B4-BE49-F238E27FC236}">
-                <a16:creationId xmlns:a16="http://schemas.microsoft.com/office/drawing/2014/main" id="{FE146C21-C4EC-E6D1-146D-CD0817271720}"/>
-              </a:ext>
-            </a:extLst>
-          </p:cNvPr>
-          <p:cNvSpPr txBox="1"/>
+            <a:pPr eaLnBrk="0" fontAlgn="base" hangingPunct="0">
+              <a:spcBef>
+                <a:spcPct val="0"/>
+              </a:spcBef>
+              <a:spcAft>
+                <a:spcPct val="0"/>
+              </a:spcAft>
+            </a:pPr>
+            <a:endParaRPr lang="en-US">
+              <a:latin typeface="Arial" charset="0"/>
+            </a:endParaRPr>
+          </a:p>
+        </p:txBody>
+      </p:sp>
+      <p:sp>
+        <p:nvSpPr>
+          <p:cNvPr id="13" name="Rectangle: Rounded Corners 12">
+            <a:extLst>
+              <a:ext uri="{FF2B5EF4-FFF2-40B4-BE49-F238E27FC236}">
+                <a16:creationId xmlns:a16="http://schemas.microsoft.com/office/drawing/2014/main" id="{7F0A8D3D-B1AA-28D3-96FE-524D87A45028}"/>
+              </a:ext>
+            </a:extLst>
+          </p:cNvPr>
+          <p:cNvSpPr/>
           <p:nvPr/>
         </p:nvSpPr>
-        <p:spPr>
-          <a:xfrm>
-            <a:off x="5389686" y="4884570"/>
-            <a:ext cx="598241" cy="261610"/>
-          </a:xfrm>
-          <a:prstGeom prst="rect">
+        <p:spPr bwMode="auto">
+          <a:xfrm>
+            <a:off x="1756948" y="4513208"/>
+            <a:ext cx="910712" cy="929216"/>
+          </a:xfrm>
+          <a:prstGeom prst="roundRect">
             <a:avLst/>
           </a:prstGeom>
-          <a:noFill/>
-        </p:spPr>
-        <p:txBody>
-          <a:bodyPr wrap="none" rtlCol="0">
-            <a:spAutoFit/>
+          <a:solidFill>
+            <a:schemeClr val="bg1"/>
+          </a:solidFill>
+          <a:ln w="38100" cap="flat" cmpd="sng" algn="ctr">
+            <a:solidFill>
+              <a:srgbClr val="87C9FB"/>
+            </a:solidFill>
+            <a:prstDash val="solid"/>
+            <a:round/>
+            <a:headEnd type="none" w="med" len="med"/>
+            <a:tailEnd type="none" w="med" len="med"/>
+          </a:ln>
+          <a:effectLst/>
+        </p:spPr>
+        <p:txBody>
+          <a:bodyPr vert="horz" wrap="square" lIns="91440" tIns="45720" rIns="91440" bIns="45720" numCol="1" rtlCol="0" anchor="t" anchorCtr="0" compatLnSpc="1">
+            <a:prstTxWarp prst="textNoShape">
+              <a:avLst/>
+            </a:prstTxWarp>
           </a:bodyPr>
           <a:lstStyle/>
           <a:p>
-            <a:pPr algn="ctr"/>
-            <a:r>
-              <a:rPr lang="en-US" sz="1100" b="1" dirty="0">
-                <a:latin typeface="Aptos" panose="020B0004020202020204" pitchFamily="34" charset="0"/>
-                <a:ea typeface="Calibri" panose="020F0502020204030204" pitchFamily="34" charset="0"/>
-                <a:cs typeface="Calibri" panose="020F0502020204030204" pitchFamily="34" charset="0"/>
-              </a:rPr>
-              <a:t>Result</a:t>
-            </a:r>
-          </a:p>
-        </p:txBody>
-      </p:sp>
-      <p:sp>
-        <p:nvSpPr>
-          <p:cNvPr id="16" name="TextBox 15">
-            <a:extLst>
-              <a:ext uri="{FF2B5EF4-FFF2-40B4-BE49-F238E27FC236}">
-                <a16:creationId xmlns:a16="http://schemas.microsoft.com/office/drawing/2014/main" id="{9E66E985-5B3A-E36F-76BF-C42806537BF3}"/>
-              </a:ext>
-            </a:extLst>
-          </p:cNvPr>
-          <p:cNvSpPr txBox="1"/>
+            <a:pPr eaLnBrk="0" fontAlgn="base" hangingPunct="0">
+              <a:spcBef>
+                <a:spcPct val="0"/>
+              </a:spcBef>
+              <a:spcAft>
+                <a:spcPct val="0"/>
+              </a:spcAft>
+            </a:pPr>
+            <a:endParaRPr lang="en-US">
+              <a:latin typeface="Arial" charset="0"/>
+            </a:endParaRPr>
+          </a:p>
+        </p:txBody>
+      </p:sp>
+      <p:sp>
+        <p:nvSpPr>
+          <p:cNvPr id="14" name="Rectangle: Rounded Corners 13">
+            <a:extLst>
+              <a:ext uri="{FF2B5EF4-FFF2-40B4-BE49-F238E27FC236}">
+                <a16:creationId xmlns:a16="http://schemas.microsoft.com/office/drawing/2014/main" id="{AFB24494-C3CE-FF47-65A3-C380E527405C}"/>
+              </a:ext>
+            </a:extLst>
+          </p:cNvPr>
+          <p:cNvSpPr/>
           <p:nvPr/>
         </p:nvSpPr>
-        <p:spPr>
-          <a:xfrm>
-            <a:off x="6355802" y="4884570"/>
-            <a:ext cx="851515" cy="261610"/>
-          </a:xfrm>
-          <a:prstGeom prst="rect">
+        <p:spPr bwMode="auto">
+          <a:xfrm>
+            <a:off x="814417" y="4513208"/>
+            <a:ext cx="910712" cy="929216"/>
+          </a:xfrm>
+          <a:prstGeom prst="roundRect">
             <a:avLst/>
           </a:prstGeom>
-          <a:noFill/>
-        </p:spPr>
-        <p:txBody>
-          <a:bodyPr wrap="none" rtlCol="0">
-            <a:spAutoFit/>
+          <a:solidFill>
+            <a:schemeClr val="bg1"/>
+          </a:solidFill>
+          <a:ln w="38100" cap="flat" cmpd="sng" algn="ctr">
+            <a:solidFill>
+              <a:srgbClr val="7030A0"/>
+            </a:solidFill>
+            <a:prstDash val="solid"/>
+            <a:round/>
+            <a:headEnd type="none" w="med" len="med"/>
+            <a:tailEnd type="none" w="med" len="med"/>
+          </a:ln>
+          <a:effectLst/>
+        </p:spPr>
+        <p:txBody>
+          <a:bodyPr vert="horz" wrap="square" lIns="91440" tIns="45720" rIns="91440" bIns="45720" numCol="1" rtlCol="0" anchor="t" anchorCtr="0" compatLnSpc="1">
+            <a:prstTxWarp prst="textNoShape">
+              <a:avLst/>
+            </a:prstTxWarp>
           </a:bodyPr>
           <a:lstStyle/>
           <a:p>
-            <a:pPr algn="ctr"/>
-            <a:r>
-              <a:rPr lang="en-US" sz="1100" b="1" dirty="0">
-                <a:latin typeface="Aptos" panose="020B0004020202020204" pitchFamily="34" charset="0"/>
-                <a:ea typeface="Calibri" panose="020F0502020204030204" pitchFamily="34" charset="0"/>
-                <a:cs typeface="Calibri" panose="020F0502020204030204" pitchFamily="34" charset="0"/>
-              </a:rPr>
-              <a:t>Procedure</a:t>
-            </a:r>
-          </a:p>
-        </p:txBody>
-      </p:sp>
-      <p:sp>
-        <p:nvSpPr>
-          <p:cNvPr id="17" name="TextBox 16">
-            <a:extLst>
-              <a:ext uri="{FF2B5EF4-FFF2-40B4-BE49-F238E27FC236}">
-                <a16:creationId xmlns:a16="http://schemas.microsoft.com/office/drawing/2014/main" id="{53B4C931-833E-AD51-B84D-248839F9A0C9}"/>
-              </a:ext>
-            </a:extLst>
-          </p:cNvPr>
-          <p:cNvSpPr txBox="1"/>
+            <a:pPr eaLnBrk="0" fontAlgn="base" hangingPunct="0">
+              <a:spcBef>
+                <a:spcPct val="0"/>
+              </a:spcBef>
+              <a:spcAft>
+                <a:spcPct val="0"/>
+              </a:spcAft>
+            </a:pPr>
+            <a:endParaRPr lang="en-US" dirty="0">
+              <a:latin typeface="Arial" charset="0"/>
+            </a:endParaRPr>
+          </a:p>
+        </p:txBody>
+      </p:sp>
+      <p:sp>
+        <p:nvSpPr>
+          <p:cNvPr id="15" name="Rectangle: Rounded Corners 14">
+            <a:extLst>
+              <a:ext uri="{FF2B5EF4-FFF2-40B4-BE49-F238E27FC236}">
+                <a16:creationId xmlns:a16="http://schemas.microsoft.com/office/drawing/2014/main" id="{B28585F6-BCCE-75E7-43A4-FE802C68283D}"/>
+              </a:ext>
+            </a:extLst>
+          </p:cNvPr>
+          <p:cNvSpPr/>
           <p:nvPr/>
         </p:nvSpPr>
-        <p:spPr>
-          <a:xfrm>
-            <a:off x="7517958" y="4819364"/>
-            <a:ext cx="678391" cy="430887"/>
-          </a:xfrm>
-          <a:prstGeom prst="rect">
+        <p:spPr bwMode="auto">
+          <a:xfrm>
+            <a:off x="7406629" y="4513208"/>
+            <a:ext cx="910712" cy="929216"/>
+          </a:xfrm>
+          <a:prstGeom prst="roundRect">
             <a:avLst/>
           </a:prstGeom>
-          <a:noFill/>
-        </p:spPr>
-        <p:txBody>
-          <a:bodyPr wrap="none" rtlCol="0">
-            <a:spAutoFit/>
-          </a:bodyPr>
-          <a:lstStyle/>
-          <a:p>
-            <a:pPr algn="ctr"/>
-            <a:r>
-              <a:rPr lang="en-US" sz="1100" b="1" dirty="0">
-                <a:latin typeface="Aptos" panose="020B0004020202020204" pitchFamily="34" charset="0"/>
-                <a:ea typeface="Calibri" panose="020F0502020204030204" pitchFamily="34" charset="0"/>
-                <a:cs typeface="Calibri" panose="020F0502020204030204" pitchFamily="34" charset="0"/>
-              </a:rPr>
-              <a:t>Other </a:t>
-            </a:r>
-            <a:br>
-              <a:rPr lang="en-US" sz="1100" b="1" dirty="0">
-                <a:latin typeface="Aptos" panose="020B0004020202020204" pitchFamily="34" charset="0"/>
-                <a:ea typeface="Calibri" panose="020F0502020204030204" pitchFamily="34" charset="0"/>
-                <a:cs typeface="Calibri" panose="020F0502020204030204" pitchFamily="34" charset="0"/>
-              </a:rPr>
-            </a:br>
-            <a:r>
-              <a:rPr lang="en-US" sz="1100" b="1" dirty="0">
-                <a:latin typeface="Aptos" panose="020B0004020202020204" pitchFamily="34" charset="0"/>
-                <a:ea typeface="Calibri" panose="020F0502020204030204" pitchFamily="34" charset="0"/>
-                <a:cs typeface="Calibri" panose="020F0502020204030204" pitchFamily="34" charset="0"/>
-              </a:rPr>
-              <a:t>Profiles</a:t>
-            </a:r>
-          </a:p>
-        </p:txBody>
-      </p:sp>
-      <p:pic>
-        <p:nvPicPr>
-          <p:cNvPr id="36" name="Picture 35" descr="A black and white image of a pair of scissors&#10;&#10;Description automatically generated">
-            <a:extLst>
-              <a:ext uri="{FF2B5EF4-FFF2-40B4-BE49-F238E27FC236}">
-                <a16:creationId xmlns:a16="http://schemas.microsoft.com/office/drawing/2014/main" id="{E66702C4-1616-AB45-EB4F-84AA4BAE45F1}"/>
-              </a:ext>
-            </a:extLst>
-          </p:cNvPr>
-          <p:cNvPicPr>
-            <a:picLocks noChangeAspect="1"/>
-          </p:cNvPicPr>
-          <p:nvPr/>
-        </p:nvPicPr>
-        <p:blipFill>
-          <a:blip r:embed="rId3">
-            <a:extLst>
-              <a:ext uri="{28A0092B-C50C-407E-A947-70E740481C1C}">
-                <a14:useLocalDpi xmlns:a14="http://schemas.microsoft.com/office/drawing/2010/main" val="0"/>
-              </a:ext>
-            </a:extLst>
-          </a:blip>
-          <a:stretch>
-            <a:fillRect/>
-          </a:stretch>
-        </p:blipFill>
-        <p:spPr>
-          <a:xfrm>
-            <a:off x="6492361" y="4265126"/>
-            <a:ext cx="609631" cy="609631"/>
-          </a:xfrm>
-          <a:prstGeom prst="rect">
-            <a:avLst/>
-          </a:prstGeom>
-        </p:spPr>
-      </p:pic>
-      <p:pic>
-        <p:nvPicPr>
-          <p:cNvPr id="47" name="Picture 46" descr="A stethoscope with a cord&#10;&#10;Description automatically generated">
-            <a:extLst>
-              <a:ext uri="{FF2B5EF4-FFF2-40B4-BE49-F238E27FC236}">
-                <a16:creationId xmlns:a16="http://schemas.microsoft.com/office/drawing/2014/main" id="{C4625836-1CD0-5A72-30EF-DCE1F74DFD1F}"/>
-              </a:ext>
-            </a:extLst>
-          </p:cNvPr>
-          <p:cNvPicPr>
-            <a:picLocks noChangeAspect="1"/>
-          </p:cNvPicPr>
-          <p:nvPr/>
-        </p:nvPicPr>
-        <p:blipFill>
-          <a:blip r:embed="rId4">
-            <a:extLst>
-              <a:ext uri="{28A0092B-C50C-407E-A947-70E740481C1C}">
-                <a14:useLocalDpi xmlns:a14="http://schemas.microsoft.com/office/drawing/2010/main" val="0"/>
-              </a:ext>
-            </a:extLst>
-          </a:blip>
-          <a:stretch>
-            <a:fillRect/>
-          </a:stretch>
-        </p:blipFill>
-        <p:spPr>
-          <a:xfrm>
-            <a:off x="1032977" y="4301728"/>
-            <a:ext cx="609631" cy="609631"/>
-          </a:xfrm>
-          <a:prstGeom prst="rect">
-            <a:avLst/>
-          </a:prstGeom>
-        </p:spPr>
-      </p:pic>
-      <p:pic>
-        <p:nvPicPr>
-          <p:cNvPr id="49" name="Picture 48" descr="A black and white icon of a syringe and a shield&#10;&#10;Description automatically generated">
-            <a:extLst>
-              <a:ext uri="{FF2B5EF4-FFF2-40B4-BE49-F238E27FC236}">
-                <a16:creationId xmlns:a16="http://schemas.microsoft.com/office/drawing/2014/main" id="{093C8F13-341A-7203-B98B-98D243B54495}"/>
-              </a:ext>
-            </a:extLst>
-          </p:cNvPr>
-          <p:cNvPicPr>
-            <a:picLocks noChangeAspect="1"/>
-          </p:cNvPicPr>
-          <p:nvPr/>
-        </p:nvPicPr>
-        <p:blipFill>
-          <a:blip r:embed="rId5">
-            <a:extLst>
-              <a:ext uri="{28A0092B-C50C-407E-A947-70E740481C1C}">
-                <a14:useLocalDpi xmlns:a14="http://schemas.microsoft.com/office/drawing/2010/main" val="0"/>
-              </a:ext>
-            </a:extLst>
-          </a:blip>
-          <a:stretch>
-            <a:fillRect/>
-          </a:stretch>
-        </p:blipFill>
-        <p:spPr>
-          <a:xfrm>
-            <a:off x="4304740" y="4276955"/>
-            <a:ext cx="609631" cy="609631"/>
-          </a:xfrm>
-          <a:prstGeom prst="rect">
-            <a:avLst/>
-          </a:prstGeom>
-        </p:spPr>
-      </p:pic>
-      <p:pic>
-        <p:nvPicPr>
-          <p:cNvPr id="51" name="Picture 50" descr="A black and white line drawing of a test tube&#10;&#10;Description automatically generated">
-            <a:extLst>
-              <a:ext uri="{FF2B5EF4-FFF2-40B4-BE49-F238E27FC236}">
-                <a16:creationId xmlns:a16="http://schemas.microsoft.com/office/drawing/2014/main" id="{F67C267E-C6F5-72DD-1908-433EBAC3D7A3}"/>
-              </a:ext>
-            </a:extLst>
-          </p:cNvPr>
-          <p:cNvPicPr>
-            <a:picLocks noChangeAspect="1"/>
-          </p:cNvPicPr>
-          <p:nvPr/>
-        </p:nvPicPr>
-        <p:blipFill>
-          <a:blip r:embed="rId6">
-            <a:extLst>
-              <a:ext uri="{28A0092B-C50C-407E-A947-70E740481C1C}">
-                <a14:useLocalDpi xmlns:a14="http://schemas.microsoft.com/office/drawing/2010/main" val="0"/>
-              </a:ext>
-            </a:extLst>
-          </a:blip>
-          <a:stretch>
-            <a:fillRect/>
-          </a:stretch>
-        </p:blipFill>
-        <p:spPr>
-          <a:xfrm>
-            <a:off x="5379699" y="4301727"/>
-            <a:ext cx="609631" cy="609631"/>
-          </a:xfrm>
-          <a:prstGeom prst="rect">
-            <a:avLst/>
-          </a:prstGeom>
-        </p:spPr>
-      </p:pic>
-      <p:pic>
-        <p:nvPicPr>
-          <p:cNvPr id="53" name="Picture 52" descr="A black and white image of different shapes&#10;&#10;Description automatically generated">
-            <a:extLst>
-              <a:ext uri="{FF2B5EF4-FFF2-40B4-BE49-F238E27FC236}">
-                <a16:creationId xmlns:a16="http://schemas.microsoft.com/office/drawing/2014/main" id="{C215E95D-B00D-2045-C56B-CE01598440FE}"/>
-              </a:ext>
-            </a:extLst>
-          </p:cNvPr>
-          <p:cNvPicPr>
-            <a:picLocks noChangeAspect="1"/>
-          </p:cNvPicPr>
-          <p:nvPr/>
-        </p:nvPicPr>
-        <p:blipFill>
-          <a:blip r:embed="rId7">
-            <a:extLst>
-              <a:ext uri="{28A0092B-C50C-407E-A947-70E740481C1C}">
-                <a14:useLocalDpi xmlns:a14="http://schemas.microsoft.com/office/drawing/2010/main" val="0"/>
-              </a:ext>
-            </a:extLst>
-          </a:blip>
-          <a:stretch>
-            <a:fillRect/>
-          </a:stretch>
-        </p:blipFill>
-        <p:spPr>
-          <a:xfrm>
-            <a:off x="3184129" y="4296109"/>
-            <a:ext cx="609631" cy="609631"/>
-          </a:xfrm>
-          <a:prstGeom prst="rect">
-            <a:avLst/>
-          </a:prstGeom>
-        </p:spPr>
-      </p:pic>
-      <p:pic>
-        <p:nvPicPr>
-          <p:cNvPr id="62" name="Picture 61" descr="A black and white clipboard with a cross&#10;&#10;Description automatically generated">
-            <a:extLst>
-              <a:ext uri="{FF2B5EF4-FFF2-40B4-BE49-F238E27FC236}">
-                <a16:creationId xmlns:a16="http://schemas.microsoft.com/office/drawing/2014/main" id="{A86FF2D1-06AF-35EE-3680-D1861D3A0D0F}"/>
-              </a:ext>
-            </a:extLst>
-          </p:cNvPr>
-          <p:cNvPicPr>
-            <a:picLocks noChangeAspect="1"/>
-          </p:cNvPicPr>
-          <p:nvPr/>
-        </p:nvPicPr>
-        <p:blipFill>
-          <a:blip r:embed="rId8">
-            <a:extLst>
-              <a:ext uri="{28A0092B-C50C-407E-A947-70E740481C1C}">
-                <a14:useLocalDpi xmlns:a14="http://schemas.microsoft.com/office/drawing/2010/main" val="0"/>
-              </a:ext>
-            </a:extLst>
-          </a:blip>
-          <a:stretch>
-            <a:fillRect/>
-          </a:stretch>
-        </p:blipFill>
-        <p:spPr>
-          <a:xfrm>
-            <a:off x="7434924" y="4362053"/>
-            <a:ext cx="430887" cy="430887"/>
-          </a:xfrm>
-          <a:prstGeom prst="rect">
-            <a:avLst/>
-          </a:prstGeom>
-        </p:spPr>
-      </p:pic>
-      <p:pic>
-        <p:nvPicPr>
-          <p:cNvPr id="66" name="Picture 65">
-            <a:extLst>
-              <a:ext uri="{FF2B5EF4-FFF2-40B4-BE49-F238E27FC236}">
-                <a16:creationId xmlns:a16="http://schemas.microsoft.com/office/drawing/2014/main" id="{4802D7DB-7378-E5A9-38E0-95A69C9CCD95}"/>
-              </a:ext>
-            </a:extLst>
-          </p:cNvPr>
-          <p:cNvPicPr>
-            <a:picLocks noChangeAspect="1"/>
-          </p:cNvPicPr>
-          <p:nvPr/>
-        </p:nvPicPr>
-        <p:blipFill rotWithShape="1">
-          <a:blip r:embed="rId9"/>
-          <a:srcRect l="6754" t="18564" r="80644" b="30366"/>
-          <a:stretch/>
-        </p:blipFill>
-        <p:spPr>
-          <a:xfrm>
-            <a:off x="2125742" y="4301727"/>
-            <a:ext cx="606925" cy="604013"/>
-          </a:xfrm>
-          <a:prstGeom prst="rect">
-            <a:avLst/>
-          </a:prstGeom>
-        </p:spPr>
-      </p:pic>
-      <p:pic>
-        <p:nvPicPr>
-          <p:cNvPr id="67" name="Picture 66">
-            <a:extLst>
-              <a:ext uri="{FF2B5EF4-FFF2-40B4-BE49-F238E27FC236}">
-                <a16:creationId xmlns:a16="http://schemas.microsoft.com/office/drawing/2014/main" id="{B8518EE4-E8DF-96FA-CD6D-6923083E553C}"/>
-              </a:ext>
-            </a:extLst>
-          </p:cNvPr>
-          <p:cNvPicPr>
-            <a:picLocks noChangeAspect="1"/>
-          </p:cNvPicPr>
-          <p:nvPr/>
-        </p:nvPicPr>
-        <p:blipFill rotWithShape="1">
-          <a:blip r:embed="rId10"/>
-          <a:srcRect t="14434" r="85778" b="20996"/>
-          <a:stretch/>
-        </p:blipFill>
-        <p:spPr>
-          <a:xfrm>
-            <a:off x="7671506" y="4339789"/>
-            <a:ext cx="593795" cy="489843"/>
-          </a:xfrm>
-          <a:prstGeom prst="rect">
-            <a:avLst/>
-          </a:prstGeom>
-        </p:spPr>
-      </p:pic>
-      <p:sp>
-        <p:nvSpPr>
-          <p:cNvPr id="68" name="TextBox 67">
-            <a:extLst>
-              <a:ext uri="{FF2B5EF4-FFF2-40B4-BE49-F238E27FC236}">
-                <a16:creationId xmlns:a16="http://schemas.microsoft.com/office/drawing/2014/main" id="{0B933ED0-93F3-B61F-7A4D-1A63496A399B}"/>
-              </a:ext>
-            </a:extLst>
-          </p:cNvPr>
-          <p:cNvSpPr txBox="1"/>
-          <p:nvPr/>
-        </p:nvSpPr>
-        <p:spPr>
-          <a:xfrm>
-            <a:off x="4840947" y="2689810"/>
-            <a:ext cx="1619354" cy="307777"/>
-          </a:xfrm>
-          <a:prstGeom prst="rect">
-            <a:avLst/>
-          </a:prstGeom>
-          <a:noFill/>
-        </p:spPr>
-        <p:txBody>
-          <a:bodyPr wrap="none" rtlCol="0">
-            <a:spAutoFit/>
-          </a:bodyPr>
-          <a:lstStyle/>
-          <a:p>
-            <a:r>
-              <a:rPr lang="en-US" sz="1400" dirty="0">
-                <a:solidFill>
-                  <a:schemeClr val="tx1">
-                    <a:lumMod val="50000"/>
-                    <a:lumOff val="50000"/>
-                  </a:schemeClr>
-                </a:solidFill>
-                <a:latin typeface="Aptos" panose="020B0004020202020204" pitchFamily="34" charset="0"/>
-              </a:rPr>
-              <a:t>+11 other sections</a:t>
-            </a:r>
-          </a:p>
-        </p:txBody>
-      </p:sp>
-      <p:sp>
-        <p:nvSpPr>
-          <p:cNvPr id="29" name="Rectangle: Rounded Corners 28">
-            <a:extLst>
-              <a:ext uri="{FF2B5EF4-FFF2-40B4-BE49-F238E27FC236}">
-                <a16:creationId xmlns:a16="http://schemas.microsoft.com/office/drawing/2014/main" id="{87DCCCE1-3079-4C55-AAD2-E2FF3053AAB9}"/>
-              </a:ext>
-            </a:extLst>
-          </p:cNvPr>
-          <p:cNvSpPr/>
-          <p:nvPr/>
-        </p:nvSpPr>
-        <p:spPr bwMode="auto">
-          <a:xfrm>
-            <a:off x="3796707" y="169030"/>
-            <a:ext cx="3325732" cy="3115955"/>
-          </a:xfrm>
-          <a:prstGeom prst="roundRect">
-            <a:avLst>
-              <a:gd name="adj" fmla="val 4745"/>
-            </a:avLst>
-          </a:prstGeom>
-          <a:noFill/>
-          <a:ln w="57150" cap="flat" cmpd="sng" algn="ctr">
+          <a:solidFill>
+            <a:schemeClr val="bg1"/>
+          </a:solidFill>
+          <a:ln w="38100" cap="flat" cmpd="sng" algn="ctr">
             <a:solidFill>
-              <a:srgbClr val="00B0F0"/>
+              <a:schemeClr val="tx1">
+                <a:lumMod val="50000"/>
+                <a:lumOff val="50000"/>
+              </a:schemeClr>
             </a:solidFill>
             <a:prstDash val="solid"/>
             <a:round/>
@@ -14588,6 +13768,2434 @@
       </p:sp>
       <p:sp>
         <p:nvSpPr>
+          <p:cNvPr id="16" name="TextBox 15">
+            <a:extLst>
+              <a:ext uri="{FF2B5EF4-FFF2-40B4-BE49-F238E27FC236}">
+                <a16:creationId xmlns:a16="http://schemas.microsoft.com/office/drawing/2014/main" id="{036BD2FB-41E9-5E32-82D8-77C1DCFB0043}"/>
+              </a:ext>
+            </a:extLst>
+          </p:cNvPr>
+          <p:cNvSpPr txBox="1"/>
+          <p:nvPr/>
+        </p:nvSpPr>
+        <p:spPr>
+          <a:xfrm>
+            <a:off x="1923133" y="5182427"/>
+            <a:ext cx="640080" cy="274320"/>
+          </a:xfrm>
+          <a:prstGeom prst="rect">
+            <a:avLst/>
+          </a:prstGeom>
+          <a:noFill/>
+        </p:spPr>
+        <p:txBody>
+          <a:bodyPr wrap="none" rtlCol="0">
+            <a:spAutoFit/>
+          </a:bodyPr>
+          <a:lstStyle/>
+          <a:p>
+            <a:pPr algn="ctr"/>
+            <a:r>
+              <a:rPr lang="en-US" sz="1100" b="1" dirty="0">
+                <a:latin typeface="Aptos" panose="020B0004020202020204" pitchFamily="34" charset="0"/>
+                <a:ea typeface="Calibri" panose="020F0502020204030204" pitchFamily="34" charset="0"/>
+                <a:cs typeface="Calibri" panose="020F0502020204030204" pitchFamily="34" charset="0"/>
+              </a:rPr>
+              <a:t>Allergy</a:t>
+            </a:r>
+          </a:p>
+        </p:txBody>
+      </p:sp>
+      <p:sp>
+        <p:nvSpPr>
+          <p:cNvPr id="17" name="TextBox 16">
+            <a:extLst>
+              <a:ext uri="{FF2B5EF4-FFF2-40B4-BE49-F238E27FC236}">
+                <a16:creationId xmlns:a16="http://schemas.microsoft.com/office/drawing/2014/main" id="{593A9D8D-8902-8471-B3AB-B7C378920737}"/>
+              </a:ext>
+            </a:extLst>
+          </p:cNvPr>
+          <p:cNvSpPr txBox="1"/>
+          <p:nvPr/>
+        </p:nvSpPr>
+        <p:spPr>
+          <a:xfrm>
+            <a:off x="956250" y="5182427"/>
+            <a:ext cx="640080" cy="274320"/>
+          </a:xfrm>
+          <a:prstGeom prst="rect">
+            <a:avLst/>
+          </a:prstGeom>
+          <a:noFill/>
+        </p:spPr>
+        <p:txBody>
+          <a:bodyPr wrap="none" rtlCol="0">
+            <a:spAutoFit/>
+          </a:bodyPr>
+          <a:lstStyle/>
+          <a:p>
+            <a:pPr algn="ctr"/>
+            <a:r>
+              <a:rPr lang="en-US" sz="1100" b="1" dirty="0">
+                <a:latin typeface="Aptos" panose="020B0004020202020204" pitchFamily="34" charset="0"/>
+                <a:ea typeface="Calibri" panose="020F0502020204030204" pitchFamily="34" charset="0"/>
+                <a:cs typeface="Calibri" panose="020F0502020204030204" pitchFamily="34" charset="0"/>
+              </a:rPr>
+              <a:t>Problem</a:t>
+            </a:r>
+          </a:p>
+        </p:txBody>
+      </p:sp>
+      <p:sp>
+        <p:nvSpPr>
+          <p:cNvPr id="18" name="TextBox 17">
+            <a:extLst>
+              <a:ext uri="{FF2B5EF4-FFF2-40B4-BE49-F238E27FC236}">
+                <a16:creationId xmlns:a16="http://schemas.microsoft.com/office/drawing/2014/main" id="{4ABE1F66-B0B9-7839-618B-70977F3B8A74}"/>
+              </a:ext>
+            </a:extLst>
+          </p:cNvPr>
+          <p:cNvSpPr txBox="1"/>
+          <p:nvPr/>
+        </p:nvSpPr>
+        <p:spPr>
+          <a:xfrm>
+            <a:off x="2855428" y="5182427"/>
+            <a:ext cx="640080" cy="274320"/>
+          </a:xfrm>
+          <a:prstGeom prst="rect">
+            <a:avLst/>
+          </a:prstGeom>
+          <a:noFill/>
+        </p:spPr>
+        <p:txBody>
+          <a:bodyPr wrap="none" rtlCol="0">
+            <a:spAutoFit/>
+          </a:bodyPr>
+          <a:lstStyle/>
+          <a:p>
+            <a:pPr algn="ctr"/>
+            <a:r>
+              <a:rPr lang="en-US" sz="1100" b="1" dirty="0">
+                <a:latin typeface="Aptos" panose="020B0004020202020204" pitchFamily="34" charset="0"/>
+                <a:ea typeface="Calibri" panose="020F0502020204030204" pitchFamily="34" charset="0"/>
+                <a:cs typeface="Calibri" panose="020F0502020204030204" pitchFamily="34" charset="0"/>
+              </a:rPr>
+              <a:t>Medication</a:t>
+            </a:r>
+          </a:p>
+        </p:txBody>
+      </p:sp>
+      <p:sp>
+        <p:nvSpPr>
+          <p:cNvPr id="19" name="TextBox 18">
+            <a:extLst>
+              <a:ext uri="{FF2B5EF4-FFF2-40B4-BE49-F238E27FC236}">
+                <a16:creationId xmlns:a16="http://schemas.microsoft.com/office/drawing/2014/main" id="{EC33CB52-1645-B8E7-A68F-370DF6E0F33F}"/>
+              </a:ext>
+            </a:extLst>
+          </p:cNvPr>
+          <p:cNvSpPr txBox="1"/>
+          <p:nvPr/>
+        </p:nvSpPr>
+        <p:spPr>
+          <a:xfrm>
+            <a:off x="3781380" y="5182427"/>
+            <a:ext cx="640080" cy="274320"/>
+          </a:xfrm>
+          <a:prstGeom prst="rect">
+            <a:avLst/>
+          </a:prstGeom>
+          <a:noFill/>
+        </p:spPr>
+        <p:txBody>
+          <a:bodyPr wrap="none" rtlCol="0">
+            <a:spAutoFit/>
+          </a:bodyPr>
+          <a:lstStyle/>
+          <a:p>
+            <a:pPr algn="ctr"/>
+            <a:r>
+              <a:rPr lang="en-US" sz="1100" b="1" spc="-10" dirty="0">
+                <a:latin typeface="Aptos" panose="020B0004020202020204" pitchFamily="34" charset="0"/>
+                <a:ea typeface="Calibri" panose="020F0502020204030204" pitchFamily="34" charset="0"/>
+                <a:cs typeface="Calibri" panose="020F0502020204030204" pitchFamily="34" charset="0"/>
+              </a:rPr>
+              <a:t>Immunization</a:t>
+            </a:r>
+          </a:p>
+        </p:txBody>
+      </p:sp>
+      <p:sp>
+        <p:nvSpPr>
+          <p:cNvPr id="20" name="TextBox 19">
+            <a:extLst>
+              <a:ext uri="{FF2B5EF4-FFF2-40B4-BE49-F238E27FC236}">
+                <a16:creationId xmlns:a16="http://schemas.microsoft.com/office/drawing/2014/main" id="{2D62A424-8FC8-53B0-6450-1EF5B8B691D8}"/>
+              </a:ext>
+            </a:extLst>
+          </p:cNvPr>
+          <p:cNvSpPr txBox="1"/>
+          <p:nvPr/>
+        </p:nvSpPr>
+        <p:spPr>
+          <a:xfrm>
+            <a:off x="4717094" y="5182427"/>
+            <a:ext cx="640080" cy="274320"/>
+          </a:xfrm>
+          <a:prstGeom prst="rect">
+            <a:avLst/>
+          </a:prstGeom>
+          <a:noFill/>
+        </p:spPr>
+        <p:txBody>
+          <a:bodyPr wrap="none" rtlCol="0">
+            <a:spAutoFit/>
+          </a:bodyPr>
+          <a:lstStyle/>
+          <a:p>
+            <a:pPr algn="ctr"/>
+            <a:r>
+              <a:rPr lang="en-US" sz="1100" b="1" dirty="0">
+                <a:latin typeface="Aptos" panose="020B0004020202020204" pitchFamily="34" charset="0"/>
+                <a:ea typeface="Calibri" panose="020F0502020204030204" pitchFamily="34" charset="0"/>
+                <a:cs typeface="Calibri" panose="020F0502020204030204" pitchFamily="34" charset="0"/>
+              </a:rPr>
+              <a:t>Result</a:t>
+            </a:r>
+          </a:p>
+        </p:txBody>
+      </p:sp>
+      <p:sp>
+        <p:nvSpPr>
+          <p:cNvPr id="21" name="TextBox 20">
+            <a:extLst>
+              <a:ext uri="{FF2B5EF4-FFF2-40B4-BE49-F238E27FC236}">
+                <a16:creationId xmlns:a16="http://schemas.microsoft.com/office/drawing/2014/main" id="{DD4CC493-71D1-E5BB-E158-9833F3BF17EB}"/>
+              </a:ext>
+            </a:extLst>
+          </p:cNvPr>
+          <p:cNvSpPr txBox="1"/>
+          <p:nvPr/>
+        </p:nvSpPr>
+        <p:spPr>
+          <a:xfrm>
+            <a:off x="5668048" y="5182427"/>
+            <a:ext cx="640080" cy="274320"/>
+          </a:xfrm>
+          <a:prstGeom prst="rect">
+            <a:avLst/>
+          </a:prstGeom>
+          <a:noFill/>
+        </p:spPr>
+        <p:txBody>
+          <a:bodyPr wrap="none" rtlCol="0">
+            <a:spAutoFit/>
+          </a:bodyPr>
+          <a:lstStyle/>
+          <a:p>
+            <a:pPr algn="ctr"/>
+            <a:r>
+              <a:rPr lang="en-US" sz="1100" b="1" dirty="0">
+                <a:latin typeface="Aptos" panose="020B0004020202020204" pitchFamily="34" charset="0"/>
+                <a:ea typeface="Calibri" panose="020F0502020204030204" pitchFamily="34" charset="0"/>
+                <a:cs typeface="Calibri" panose="020F0502020204030204" pitchFamily="34" charset="0"/>
+              </a:rPr>
+              <a:t>Procedure</a:t>
+            </a:r>
+          </a:p>
+        </p:txBody>
+      </p:sp>
+      <p:sp>
+        <p:nvSpPr>
+          <p:cNvPr id="22" name="TextBox 21">
+            <a:extLst>
+              <a:ext uri="{FF2B5EF4-FFF2-40B4-BE49-F238E27FC236}">
+                <a16:creationId xmlns:a16="http://schemas.microsoft.com/office/drawing/2014/main" id="{B1F8B2D4-6031-F858-D6A2-30FB6B984E0F}"/>
+              </a:ext>
+            </a:extLst>
+          </p:cNvPr>
+          <p:cNvSpPr txBox="1"/>
+          <p:nvPr/>
+        </p:nvSpPr>
+        <p:spPr>
+          <a:xfrm>
+            <a:off x="7562539" y="5013176"/>
+            <a:ext cx="588597" cy="373854"/>
+          </a:xfrm>
+          <a:prstGeom prst="rect">
+            <a:avLst/>
+          </a:prstGeom>
+          <a:noFill/>
+        </p:spPr>
+        <p:txBody>
+          <a:bodyPr wrap="none" rtlCol="0">
+            <a:spAutoFit/>
+          </a:bodyPr>
+          <a:lstStyle/>
+          <a:p>
+            <a:pPr algn="ctr"/>
+            <a:r>
+              <a:rPr lang="en-US" sz="1100" b="1" dirty="0">
+                <a:latin typeface="Aptos" panose="020B0004020202020204" pitchFamily="34" charset="0"/>
+                <a:ea typeface="Calibri" panose="020F0502020204030204" pitchFamily="34" charset="0"/>
+                <a:cs typeface="Calibri" panose="020F0502020204030204" pitchFamily="34" charset="0"/>
+              </a:rPr>
+              <a:t>Other </a:t>
+            </a:r>
+            <a:br>
+              <a:rPr lang="en-US" sz="1100" b="1" dirty="0">
+                <a:latin typeface="Aptos" panose="020B0004020202020204" pitchFamily="34" charset="0"/>
+                <a:ea typeface="Calibri" panose="020F0502020204030204" pitchFamily="34" charset="0"/>
+                <a:cs typeface="Calibri" panose="020F0502020204030204" pitchFamily="34" charset="0"/>
+              </a:rPr>
+            </a:br>
+            <a:r>
+              <a:rPr lang="en-US" sz="1100" b="1" dirty="0">
+                <a:latin typeface="Aptos" panose="020B0004020202020204" pitchFamily="34" charset="0"/>
+                <a:ea typeface="Calibri" panose="020F0502020204030204" pitchFamily="34" charset="0"/>
+                <a:cs typeface="Calibri" panose="020F0502020204030204" pitchFamily="34" charset="0"/>
+              </a:rPr>
+              <a:t>Profiles</a:t>
+            </a:r>
+          </a:p>
+        </p:txBody>
+      </p:sp>
+      <p:pic>
+        <p:nvPicPr>
+          <p:cNvPr id="23" name="Picture 22" descr="A black and white image of a pair of scissors&#10;&#10;Description automatically generated">
+            <a:extLst>
+              <a:ext uri="{FF2B5EF4-FFF2-40B4-BE49-F238E27FC236}">
+                <a16:creationId xmlns:a16="http://schemas.microsoft.com/office/drawing/2014/main" id="{1FE4BAD2-22B3-2570-6A82-2347F5FC56A1}"/>
+              </a:ext>
+            </a:extLst>
+          </p:cNvPr>
+          <p:cNvPicPr>
+            <a:picLocks noChangeAspect="1"/>
+          </p:cNvPicPr>
+          <p:nvPr/>
+        </p:nvPicPr>
+        <p:blipFill>
+          <a:blip r:embed="rId3">
+            <a:extLst>
+              <a:ext uri="{28A0092B-C50C-407E-A947-70E740481C1C}">
+                <a14:useLocalDpi xmlns:a14="http://schemas.microsoft.com/office/drawing/2010/main" val="0"/>
+              </a:ext>
+            </a:extLst>
+          </a:blip>
+          <a:stretch>
+            <a:fillRect/>
+          </a:stretch>
+        </p:blipFill>
+        <p:spPr>
+          <a:xfrm>
+            <a:off x="5740812" y="4633208"/>
+            <a:ext cx="528938" cy="528939"/>
+          </a:xfrm>
+          <a:prstGeom prst="rect">
+            <a:avLst/>
+          </a:prstGeom>
+        </p:spPr>
+      </p:pic>
+      <p:pic>
+        <p:nvPicPr>
+          <p:cNvPr id="24" name="Picture 23" descr="A stethoscope with a cord&#10;&#10;Description automatically generated">
+            <a:extLst>
+              <a:ext uri="{FF2B5EF4-FFF2-40B4-BE49-F238E27FC236}">
+                <a16:creationId xmlns:a16="http://schemas.microsoft.com/office/drawing/2014/main" id="{BB0187C8-BC90-8708-832B-85E7B3865B3C}"/>
+              </a:ext>
+            </a:extLst>
+          </p:cNvPr>
+          <p:cNvPicPr>
+            <a:picLocks noChangeAspect="1"/>
+          </p:cNvPicPr>
+          <p:nvPr/>
+        </p:nvPicPr>
+        <p:blipFill>
+          <a:blip r:embed="rId4">
+            <a:extLst>
+              <a:ext uri="{28A0092B-C50C-407E-A947-70E740481C1C}">
+                <a14:useLocalDpi xmlns:a14="http://schemas.microsoft.com/office/drawing/2010/main" val="0"/>
+              </a:ext>
+            </a:extLst>
+          </a:blip>
+          <a:stretch>
+            <a:fillRect/>
+          </a:stretch>
+        </p:blipFill>
+        <p:spPr>
+          <a:xfrm>
+            <a:off x="1004049" y="4642105"/>
+            <a:ext cx="528938" cy="528939"/>
+          </a:xfrm>
+          <a:prstGeom prst="rect">
+            <a:avLst/>
+          </a:prstGeom>
+        </p:spPr>
+      </p:pic>
+      <p:pic>
+        <p:nvPicPr>
+          <p:cNvPr id="25" name="Picture 24" descr="A black and white icon of a syringe and a shield&#10;&#10;Description automatically generated">
+            <a:extLst>
+              <a:ext uri="{FF2B5EF4-FFF2-40B4-BE49-F238E27FC236}">
+                <a16:creationId xmlns:a16="http://schemas.microsoft.com/office/drawing/2014/main" id="{6970B4AA-5DA2-4731-60DA-933AF50C9385}"/>
+              </a:ext>
+            </a:extLst>
+          </p:cNvPr>
+          <p:cNvPicPr>
+            <a:picLocks noChangeAspect="1"/>
+          </p:cNvPicPr>
+          <p:nvPr/>
+        </p:nvPicPr>
+        <p:blipFill>
+          <a:blip r:embed="rId5">
+            <a:extLst>
+              <a:ext uri="{28A0092B-C50C-407E-A947-70E740481C1C}">
+                <a14:useLocalDpi xmlns:a14="http://schemas.microsoft.com/office/drawing/2010/main" val="0"/>
+              </a:ext>
+            </a:extLst>
+          </a:blip>
+          <a:stretch>
+            <a:fillRect/>
+          </a:stretch>
+        </p:blipFill>
+        <p:spPr>
+          <a:xfrm>
+            <a:off x="3842751" y="4620611"/>
+            <a:ext cx="528938" cy="528939"/>
+          </a:xfrm>
+          <a:prstGeom prst="rect">
+            <a:avLst/>
+          </a:prstGeom>
+        </p:spPr>
+      </p:pic>
+      <p:pic>
+        <p:nvPicPr>
+          <p:cNvPr id="26" name="Picture 25" descr="A black and white line drawing of a test tube&#10;&#10;Description automatically generated">
+            <a:extLst>
+              <a:ext uri="{FF2B5EF4-FFF2-40B4-BE49-F238E27FC236}">
+                <a16:creationId xmlns:a16="http://schemas.microsoft.com/office/drawing/2014/main" id="{CC8332F9-E1C3-EE8B-4F2A-C754EA37181A}"/>
+              </a:ext>
+            </a:extLst>
+          </p:cNvPr>
+          <p:cNvPicPr>
+            <a:picLocks noChangeAspect="1"/>
+          </p:cNvPicPr>
+          <p:nvPr/>
+        </p:nvPicPr>
+        <p:blipFill>
+          <a:blip r:embed="rId6">
+            <a:extLst>
+              <a:ext uri="{28A0092B-C50C-407E-A947-70E740481C1C}">
+                <a14:useLocalDpi xmlns:a14="http://schemas.microsoft.com/office/drawing/2010/main" val="0"/>
+              </a:ext>
+            </a:extLst>
+          </a:blip>
+          <a:stretch>
+            <a:fillRect/>
+          </a:stretch>
+        </p:blipFill>
+        <p:spPr>
+          <a:xfrm>
+            <a:off x="4775425" y="4642104"/>
+            <a:ext cx="528938" cy="528939"/>
+          </a:xfrm>
+          <a:prstGeom prst="rect">
+            <a:avLst/>
+          </a:prstGeom>
+        </p:spPr>
+      </p:pic>
+      <p:pic>
+        <p:nvPicPr>
+          <p:cNvPr id="27" name="Picture 26" descr="A black and white image of different shapes&#10;&#10;Description automatically generated">
+            <a:extLst>
+              <a:ext uri="{FF2B5EF4-FFF2-40B4-BE49-F238E27FC236}">
+                <a16:creationId xmlns:a16="http://schemas.microsoft.com/office/drawing/2014/main" id="{FE291B3F-651F-A8E8-CFF3-7A109D9FC216}"/>
+              </a:ext>
+            </a:extLst>
+          </p:cNvPr>
+          <p:cNvPicPr>
+            <a:picLocks noChangeAspect="1"/>
+          </p:cNvPicPr>
+          <p:nvPr/>
+        </p:nvPicPr>
+        <p:blipFill>
+          <a:blip r:embed="rId7">
+            <a:extLst>
+              <a:ext uri="{28A0092B-C50C-407E-A947-70E740481C1C}">
+                <a14:useLocalDpi xmlns:a14="http://schemas.microsoft.com/office/drawing/2010/main" val="0"/>
+              </a:ext>
+            </a:extLst>
+          </a:blip>
+          <a:stretch>
+            <a:fillRect/>
+          </a:stretch>
+        </p:blipFill>
+        <p:spPr>
+          <a:xfrm>
+            <a:off x="2870468" y="4637230"/>
+            <a:ext cx="528938" cy="528939"/>
+          </a:xfrm>
+          <a:prstGeom prst="rect">
+            <a:avLst/>
+          </a:prstGeom>
+        </p:spPr>
+      </p:pic>
+      <p:pic>
+        <p:nvPicPr>
+          <p:cNvPr id="28" name="Picture 27" descr="A black and white clipboard with a cross&#10;&#10;Description automatically generated">
+            <a:extLst>
+              <a:ext uri="{FF2B5EF4-FFF2-40B4-BE49-F238E27FC236}">
+                <a16:creationId xmlns:a16="http://schemas.microsoft.com/office/drawing/2014/main" id="{4AF1C9EA-E0F4-EF17-FD1A-DBF8DEEB0D7C}"/>
+              </a:ext>
+            </a:extLst>
+          </p:cNvPr>
+          <p:cNvPicPr>
+            <a:picLocks noChangeAspect="1"/>
+          </p:cNvPicPr>
+          <p:nvPr/>
+        </p:nvPicPr>
+        <p:blipFill>
+          <a:blip r:embed="rId8" cstate="print">
+            <a:extLst>
+              <a:ext uri="{28A0092B-C50C-407E-A947-70E740481C1C}">
+                <a14:useLocalDpi xmlns:a14="http://schemas.microsoft.com/office/drawing/2010/main" val="0"/>
+              </a:ext>
+            </a:extLst>
+          </a:blip>
+          <a:stretch>
+            <a:fillRect/>
+          </a:stretch>
+        </p:blipFill>
+        <p:spPr>
+          <a:xfrm>
+            <a:off x="7502548" y="4616475"/>
+            <a:ext cx="373854" cy="373854"/>
+          </a:xfrm>
+          <a:prstGeom prst="rect">
+            <a:avLst/>
+          </a:prstGeom>
+        </p:spPr>
+      </p:pic>
+      <p:pic>
+        <p:nvPicPr>
+          <p:cNvPr id="29" name="Picture 28">
+            <a:extLst>
+              <a:ext uri="{FF2B5EF4-FFF2-40B4-BE49-F238E27FC236}">
+                <a16:creationId xmlns:a16="http://schemas.microsoft.com/office/drawing/2014/main" id="{614D60A9-EA8E-E732-B1EF-3922D4B4A0AF}"/>
+              </a:ext>
+            </a:extLst>
+          </p:cNvPr>
+          <p:cNvPicPr>
+            <a:picLocks noChangeAspect="1"/>
+          </p:cNvPicPr>
+          <p:nvPr/>
+        </p:nvPicPr>
+        <p:blipFill rotWithShape="1">
+          <a:blip r:embed="rId9"/>
+          <a:srcRect l="6754" t="18564" r="80644" b="30366"/>
+          <a:stretch/>
+        </p:blipFill>
+        <p:spPr>
+          <a:xfrm>
+            <a:off x="1952172" y="4642104"/>
+            <a:ext cx="526591" cy="524064"/>
+          </a:xfrm>
+          <a:prstGeom prst="rect">
+            <a:avLst/>
+          </a:prstGeom>
+        </p:spPr>
+      </p:pic>
+      <p:pic>
+        <p:nvPicPr>
+          <p:cNvPr id="30" name="Picture 29">
+            <a:extLst>
+              <a:ext uri="{FF2B5EF4-FFF2-40B4-BE49-F238E27FC236}">
+                <a16:creationId xmlns:a16="http://schemas.microsoft.com/office/drawing/2014/main" id="{CADED9CD-9C79-A62D-295F-5E02C55730C0}"/>
+              </a:ext>
+            </a:extLst>
+          </p:cNvPr>
+          <p:cNvPicPr>
+            <a:picLocks noChangeAspect="1"/>
+          </p:cNvPicPr>
+          <p:nvPr/>
+        </p:nvPicPr>
+        <p:blipFill rotWithShape="1">
+          <a:blip r:embed="rId10"/>
+          <a:srcRect t="14434" r="85778" b="20996"/>
+          <a:stretch/>
+        </p:blipFill>
+        <p:spPr>
+          <a:xfrm>
+            <a:off x="7707815" y="4597158"/>
+            <a:ext cx="515199" cy="425006"/>
+          </a:xfrm>
+          <a:prstGeom prst="rect">
+            <a:avLst/>
+          </a:prstGeom>
+        </p:spPr>
+      </p:pic>
+      <p:sp>
+        <p:nvSpPr>
+          <p:cNvPr id="31" name="TextBox 30">
+            <a:extLst>
+              <a:ext uri="{FF2B5EF4-FFF2-40B4-BE49-F238E27FC236}">
+                <a16:creationId xmlns:a16="http://schemas.microsoft.com/office/drawing/2014/main" id="{13C156C6-AABA-2F13-2CF4-263129DD4E3E}"/>
+              </a:ext>
+            </a:extLst>
+          </p:cNvPr>
+          <p:cNvSpPr txBox="1"/>
+          <p:nvPr/>
+        </p:nvSpPr>
+        <p:spPr>
+          <a:xfrm>
+            <a:off x="814415" y="5467888"/>
+            <a:ext cx="7502925" cy="338554"/>
+          </a:xfrm>
+          <a:prstGeom prst="rect">
+            <a:avLst/>
+          </a:prstGeom>
+          <a:noFill/>
+        </p:spPr>
+        <p:txBody>
+          <a:bodyPr wrap="square" rtlCol="0">
+            <a:spAutoFit/>
+          </a:bodyPr>
+          <a:lstStyle/>
+          <a:p>
+            <a:pPr algn="ctr"/>
+            <a:r>
+              <a:rPr lang="en-US" sz="1600" dirty="0">
+                <a:solidFill>
+                  <a:schemeClr val="tx1">
+                    <a:lumMod val="75000"/>
+                    <a:lumOff val="25000"/>
+                  </a:schemeClr>
+                </a:solidFill>
+              </a:rPr>
+              <a:t>US Core 6.1.0 Resources are defined in a separate implementation guide</a:t>
+            </a:r>
+          </a:p>
+        </p:txBody>
+      </p:sp>
+      <p:sp>
+        <p:nvSpPr>
+          <p:cNvPr id="36" name="Rectangle: Rounded Corners 35">
+            <a:extLst>
+              <a:ext uri="{FF2B5EF4-FFF2-40B4-BE49-F238E27FC236}">
+                <a16:creationId xmlns:a16="http://schemas.microsoft.com/office/drawing/2014/main" id="{930FE0BE-A2D4-9B40-3D84-FD9A8EBFF2D4}"/>
+              </a:ext>
+            </a:extLst>
+          </p:cNvPr>
+          <p:cNvSpPr/>
+          <p:nvPr/>
+        </p:nvSpPr>
+        <p:spPr bwMode="auto">
+          <a:xfrm>
+            <a:off x="6471073" y="4513208"/>
+            <a:ext cx="910712" cy="929216"/>
+          </a:xfrm>
+          <a:prstGeom prst="roundRect">
+            <a:avLst/>
+          </a:prstGeom>
+          <a:solidFill>
+            <a:schemeClr val="bg1"/>
+          </a:solidFill>
+          <a:ln w="38100" cap="flat" cmpd="sng" algn="ctr">
+            <a:solidFill>
+              <a:srgbClr val="FF0000"/>
+            </a:solidFill>
+            <a:prstDash val="solid"/>
+            <a:round/>
+            <a:headEnd type="none" w="med" len="med"/>
+            <a:tailEnd type="none" w="med" len="med"/>
+          </a:ln>
+          <a:effectLst/>
+        </p:spPr>
+        <p:txBody>
+          <a:bodyPr vert="horz" wrap="square" lIns="91440" tIns="45720" rIns="91440" bIns="45720" numCol="1" rtlCol="0" anchor="t" anchorCtr="0" compatLnSpc="1">
+            <a:prstTxWarp prst="textNoShape">
+              <a:avLst/>
+            </a:prstTxWarp>
+          </a:bodyPr>
+          <a:lstStyle/>
+          <a:p>
+            <a:pPr marL="0" marR="0" indent="0" algn="l" defTabSz="914400" rtl="0" eaLnBrk="0" fontAlgn="base" latinLnBrk="0" hangingPunct="0">
+              <a:lnSpc>
+                <a:spcPct val="100000"/>
+              </a:lnSpc>
+              <a:spcBef>
+                <a:spcPct val="0"/>
+              </a:spcBef>
+              <a:spcAft>
+                <a:spcPct val="0"/>
+              </a:spcAft>
+              <a:buClrTx/>
+              <a:buSzTx/>
+              <a:buFontTx/>
+              <a:buNone/>
+              <a:tabLst/>
+            </a:pPr>
+            <a:endParaRPr kumimoji="0" lang="en-US" sz="1800" b="0" i="0" u="none" strike="noStrike" cap="none" normalizeH="0" baseline="0">
+              <a:ln>
+                <a:noFill/>
+              </a:ln>
+              <a:solidFill>
+                <a:schemeClr val="tx1"/>
+              </a:solidFill>
+              <a:effectLst/>
+              <a:latin typeface="Arial" charset="0"/>
+            </a:endParaRPr>
+          </a:p>
+        </p:txBody>
+      </p:sp>
+      <p:sp>
+        <p:nvSpPr>
+          <p:cNvPr id="37" name="TextBox 36">
+            <a:extLst>
+              <a:ext uri="{FF2B5EF4-FFF2-40B4-BE49-F238E27FC236}">
+                <a16:creationId xmlns:a16="http://schemas.microsoft.com/office/drawing/2014/main" id="{5E82338F-8FB3-79DC-A16D-493C2CE3B3AA}"/>
+              </a:ext>
+            </a:extLst>
+          </p:cNvPr>
+          <p:cNvSpPr txBox="1"/>
+          <p:nvPr/>
+        </p:nvSpPr>
+        <p:spPr>
+          <a:xfrm>
+            <a:off x="6628203" y="5182427"/>
+            <a:ext cx="640080" cy="274320"/>
+          </a:xfrm>
+          <a:prstGeom prst="rect">
+            <a:avLst/>
+          </a:prstGeom>
+          <a:noFill/>
+        </p:spPr>
+        <p:txBody>
+          <a:bodyPr wrap="none" rtlCol="0">
+            <a:spAutoFit/>
+          </a:bodyPr>
+          <a:lstStyle/>
+          <a:p>
+            <a:pPr algn="ctr"/>
+            <a:r>
+              <a:rPr lang="en-US" sz="1100" b="1" dirty="0">
+                <a:latin typeface="Aptos" panose="020B0004020202020204" pitchFamily="34" charset="0"/>
+                <a:ea typeface="Calibri" panose="020F0502020204030204" pitchFamily="34" charset="0"/>
+                <a:cs typeface="Calibri" panose="020F0502020204030204" pitchFamily="34" charset="0"/>
+              </a:rPr>
+              <a:t>Encounter</a:t>
+            </a:r>
+          </a:p>
+        </p:txBody>
+      </p:sp>
+      <p:pic>
+        <p:nvPicPr>
+          <p:cNvPr id="41" name="Picture 40">
+            <a:extLst>
+              <a:ext uri="{FF2B5EF4-FFF2-40B4-BE49-F238E27FC236}">
+                <a16:creationId xmlns:a16="http://schemas.microsoft.com/office/drawing/2014/main" id="{77EE3DB7-E016-A4CD-88FD-4D32592704FB}"/>
+              </a:ext>
+            </a:extLst>
+          </p:cNvPr>
+          <p:cNvPicPr>
+            <a:picLocks noChangeAspect="1"/>
+          </p:cNvPicPr>
+          <p:nvPr/>
+        </p:nvPicPr>
+        <p:blipFill>
+          <a:blip r:embed="rId11">
+            <a:extLst>
+              <a:ext uri="{28A0092B-C50C-407E-A947-70E740481C1C}">
+                <a14:useLocalDpi xmlns:a14="http://schemas.microsoft.com/office/drawing/2010/main" val="0"/>
+              </a:ext>
+            </a:extLst>
+          </a:blip>
+          <a:stretch>
+            <a:fillRect/>
+          </a:stretch>
+        </p:blipFill>
+        <p:spPr>
+          <a:xfrm>
+            <a:off x="6624977" y="4605261"/>
+            <a:ext cx="609631" cy="609631"/>
+          </a:xfrm>
+          <a:prstGeom prst="rect">
+            <a:avLst/>
+          </a:prstGeom>
+        </p:spPr>
+      </p:pic>
+      <p:sp>
+        <p:nvSpPr>
+          <p:cNvPr id="44" name="TextBox 43">
+            <a:extLst>
+              <a:ext uri="{FF2B5EF4-FFF2-40B4-BE49-F238E27FC236}">
+                <a16:creationId xmlns:a16="http://schemas.microsoft.com/office/drawing/2014/main" id="{A5684ADD-9DB4-5130-5BEC-96E278B1C46A}"/>
+              </a:ext>
+            </a:extLst>
+          </p:cNvPr>
+          <p:cNvSpPr txBox="1"/>
+          <p:nvPr/>
+        </p:nvSpPr>
+        <p:spPr>
+          <a:xfrm>
+            <a:off x="4688787" y="2448422"/>
+            <a:ext cx="2692998" cy="584775"/>
+          </a:xfrm>
+          <a:prstGeom prst="rect">
+            <a:avLst/>
+          </a:prstGeom>
+          <a:noFill/>
+        </p:spPr>
+        <p:txBody>
+          <a:bodyPr wrap="square" lIns="0" rtlCol="0">
+            <a:spAutoFit/>
+          </a:bodyPr>
+          <a:lstStyle/>
+          <a:p>
+            <a:pPr marL="60325" algn="ctr"/>
+            <a:r>
+              <a:rPr lang="en-US" sz="1600" dirty="0">
+                <a:solidFill>
+                  <a:schemeClr val="tx1">
+                    <a:lumMod val="50000"/>
+                    <a:lumOff val="50000"/>
+                  </a:schemeClr>
+                </a:solidFill>
+                <a:latin typeface="Aptos" panose="020B0004020202020204" pitchFamily="34" charset="0"/>
+              </a:rPr>
+              <a:t>+ Optional sections included when clinically relevant</a:t>
+            </a:r>
+          </a:p>
+        </p:txBody>
+      </p:sp>
+    </p:spTree>
+    <p:extLst>
+      <p:ext uri="{BB962C8B-B14F-4D97-AF65-F5344CB8AC3E}">
+        <p14:creationId xmlns:p14="http://schemas.microsoft.com/office/powerpoint/2010/main" val="822919367"/>
+      </p:ext>
+    </p:extLst>
+  </p:cSld>
+  <p:clrMapOvr>
+    <a:masterClrMapping/>
+  </p:clrMapOvr>
+</p:sld>
+</file>
+
+<file path=ppt/slides/slide5.xml><?xml version="1.0" encoding="utf-8"?>
+<p:sld xmlns:a="http://schemas.openxmlformats.org/drawingml/2006/main" xmlns:r="http://schemas.openxmlformats.org/officeDocument/2006/relationships" xmlns:p="http://schemas.openxmlformats.org/presentationml/2006/main">
+  <p:cSld>
+    <p:spTree>
+      <p:nvGrpSpPr>
+        <p:cNvPr id="1" name="">
+          <a:extLst>
+            <a:ext uri="{FF2B5EF4-FFF2-40B4-BE49-F238E27FC236}">
+              <a16:creationId xmlns:a16="http://schemas.microsoft.com/office/drawing/2014/main" id="{AB4C46FB-22C6-D0A3-5996-E0DA95F2CD58}"/>
+            </a:ext>
+          </a:extLst>
+        </p:cNvPr>
+        <p:cNvGrpSpPr/>
+        <p:nvPr/>
+      </p:nvGrpSpPr>
+      <p:grpSpPr>
+        <a:xfrm>
+          <a:off x="0" y="0"/>
+          <a:ext cx="0" cy="0"/>
+          <a:chOff x="0" y="0"/>
+          <a:chExt cx="0" cy="0"/>
+        </a:xfrm>
+      </p:grpSpPr>
+      <p:sp>
+        <p:nvSpPr>
+          <p:cNvPr id="5" name="Arrow: Right 4">
+            <a:extLst>
+              <a:ext uri="{FF2B5EF4-FFF2-40B4-BE49-F238E27FC236}">
+                <a16:creationId xmlns:a16="http://schemas.microsoft.com/office/drawing/2014/main" id="{C7C68B5F-5710-F402-DDF6-1872CF11B605}"/>
+              </a:ext>
+            </a:extLst>
+          </p:cNvPr>
+          <p:cNvSpPr/>
+          <p:nvPr/>
+        </p:nvSpPr>
+        <p:spPr bwMode="auto">
+          <a:xfrm>
+            <a:off x="683568" y="1203653"/>
+            <a:ext cx="3050389" cy="1080120"/>
+          </a:xfrm>
+          <a:prstGeom prst="rightArrow">
+            <a:avLst/>
+          </a:prstGeom>
+          <a:solidFill>
+            <a:srgbClr val="00B0F0"/>
+          </a:solidFill>
+          <a:ln w="9525" cap="flat" cmpd="sng" algn="ctr">
+            <a:noFill/>
+            <a:prstDash val="solid"/>
+            <a:round/>
+            <a:headEnd type="none" w="med" len="med"/>
+            <a:tailEnd type="none" w="med" len="med"/>
+          </a:ln>
+          <a:effectLst/>
+        </p:spPr>
+        <p:txBody>
+          <a:bodyPr vert="horz" wrap="square" lIns="91440" tIns="45720" rIns="91440" bIns="45720" numCol="1" rtlCol="0" anchor="ctr" anchorCtr="0" compatLnSpc="1">
+            <a:prstTxWarp prst="textNoShape">
+              <a:avLst/>
+            </a:prstTxWarp>
+          </a:bodyPr>
+          <a:lstStyle/>
+          <a:p>
+            <a:pPr marL="0" marR="0" indent="0" algn="ctr" defTabSz="914400" rtl="0" eaLnBrk="0" fontAlgn="base" latinLnBrk="0" hangingPunct="0">
+              <a:lnSpc>
+                <a:spcPct val="100000"/>
+              </a:lnSpc>
+              <a:spcBef>
+                <a:spcPct val="0"/>
+              </a:spcBef>
+              <a:spcAft>
+                <a:spcPct val="0"/>
+              </a:spcAft>
+              <a:buClrTx/>
+              <a:buSzTx/>
+              <a:buFontTx/>
+              <a:buNone/>
+              <a:tabLst/>
+            </a:pPr>
+            <a:r>
+              <a:rPr kumimoji="0" lang="en-US" sz="2800" b="1" i="0" u="none" strike="noStrike" cap="none" normalizeH="0" baseline="0" dirty="0">
+                <a:ln>
+                  <a:noFill/>
+                </a:ln>
+                <a:solidFill>
+                  <a:schemeClr val="tx1"/>
+                </a:solidFill>
+                <a:effectLst/>
+                <a:latin typeface="Aptos" panose="020B0004020202020204" pitchFamily="34" charset="0"/>
+                <a:ea typeface="Calibri" panose="020F0502020204030204" pitchFamily="34" charset="0"/>
+                <a:cs typeface="Calibri" panose="020F0502020204030204" pitchFamily="34" charset="0"/>
+              </a:rPr>
+              <a:t>The US-PCS</a:t>
+            </a:r>
+          </a:p>
+        </p:txBody>
+      </p:sp>
+      <p:sp>
+        <p:nvSpPr>
+          <p:cNvPr id="9" name="Rectangle: Rounded Corners 8">
+            <a:extLst>
+              <a:ext uri="{FF2B5EF4-FFF2-40B4-BE49-F238E27FC236}">
+                <a16:creationId xmlns:a16="http://schemas.microsoft.com/office/drawing/2014/main" id="{D59F3E04-444E-4176-A0F6-65877522FA6F}"/>
+              </a:ext>
+            </a:extLst>
+          </p:cNvPr>
+          <p:cNvSpPr/>
+          <p:nvPr/>
+        </p:nvSpPr>
+        <p:spPr bwMode="auto">
+          <a:xfrm>
+            <a:off x="683568" y="3573015"/>
+            <a:ext cx="7848872" cy="2081332"/>
+          </a:xfrm>
+          <a:prstGeom prst="roundRect">
+            <a:avLst>
+              <a:gd name="adj" fmla="val 9009"/>
+            </a:avLst>
+          </a:prstGeom>
+          <a:solidFill>
+            <a:schemeClr val="bg1">
+              <a:lumMod val="85000"/>
+            </a:schemeClr>
+          </a:solidFill>
+          <a:ln w="9525" cap="flat" cmpd="sng" algn="ctr">
+            <a:noFill/>
+            <a:prstDash val="solid"/>
+            <a:round/>
+            <a:headEnd type="none" w="med" len="med"/>
+            <a:tailEnd type="none" w="med" len="med"/>
+          </a:ln>
+          <a:effectLst/>
+        </p:spPr>
+        <p:txBody>
+          <a:bodyPr vert="horz" wrap="square" lIns="91440" tIns="45720" rIns="91440" bIns="45720" numCol="1" rtlCol="0" anchor="ctr" anchorCtr="0" compatLnSpc="1">
+            <a:prstTxWarp prst="textNoShape">
+              <a:avLst/>
+            </a:prstTxWarp>
+          </a:bodyPr>
+          <a:lstStyle/>
+          <a:p>
+            <a:pPr algn="ctr" eaLnBrk="0" fontAlgn="base" hangingPunct="0">
+              <a:spcBef>
+                <a:spcPct val="0"/>
+              </a:spcBef>
+              <a:spcAft>
+                <a:spcPct val="0"/>
+              </a:spcAft>
+            </a:pPr>
+            <a:endParaRPr lang="en-US" sz="2800" b="1">
+              <a:latin typeface="Aptos" panose="020B0004020202020204" pitchFamily="34" charset="0"/>
+              <a:ea typeface="Calibri" panose="020F0502020204030204" pitchFamily="34" charset="0"/>
+              <a:cs typeface="Calibri" panose="020F0502020204030204" pitchFamily="34" charset="0"/>
+            </a:endParaRPr>
+          </a:p>
+        </p:txBody>
+      </p:sp>
+      <p:sp>
+        <p:nvSpPr>
+          <p:cNvPr id="10" name="TextBox 9">
+            <a:extLst>
+              <a:ext uri="{FF2B5EF4-FFF2-40B4-BE49-F238E27FC236}">
+                <a16:creationId xmlns:a16="http://schemas.microsoft.com/office/drawing/2014/main" id="{EBCD2639-5DFF-3BAF-9F90-6CDAB7C60D5D}"/>
+              </a:ext>
+            </a:extLst>
+          </p:cNvPr>
+          <p:cNvSpPr txBox="1"/>
+          <p:nvPr/>
+        </p:nvSpPr>
+        <p:spPr>
+          <a:xfrm>
+            <a:off x="683569" y="3589151"/>
+            <a:ext cx="7848872" cy="523220"/>
+          </a:xfrm>
+          <a:prstGeom prst="rect">
+            <a:avLst/>
+          </a:prstGeom>
+          <a:noFill/>
+        </p:spPr>
+        <p:txBody>
+          <a:bodyPr wrap="square" rtlCol="0">
+            <a:spAutoFit/>
+          </a:bodyPr>
+          <a:lstStyle/>
+          <a:p>
+            <a:pPr algn="ctr"/>
+            <a:r>
+              <a:rPr lang="en-US" sz="2800" b="1" dirty="0">
+                <a:latin typeface="Aptos" panose="020B0004020202020204" pitchFamily="34" charset="0"/>
+                <a:ea typeface="Calibri" panose="020F0502020204030204" pitchFamily="34" charset="0"/>
+                <a:cs typeface="Calibri" panose="020F0502020204030204" pitchFamily="34" charset="0"/>
+              </a:rPr>
+              <a:t>Composed from US Core Resources</a:t>
+            </a:r>
+          </a:p>
+        </p:txBody>
+      </p:sp>
+      <p:pic>
+        <p:nvPicPr>
+          <p:cNvPr id="22" name="Picture 21">
+            <a:extLst>
+              <a:ext uri="{FF2B5EF4-FFF2-40B4-BE49-F238E27FC236}">
+                <a16:creationId xmlns:a16="http://schemas.microsoft.com/office/drawing/2014/main" id="{ED6288EB-AFFB-BC4F-13D9-E4ACF7D3D9AE}"/>
+              </a:ext>
+            </a:extLst>
+          </p:cNvPr>
+          <p:cNvPicPr>
+            <a:picLocks noChangeAspect="1"/>
+          </p:cNvPicPr>
+          <p:nvPr/>
+        </p:nvPicPr>
+        <p:blipFill>
+          <a:blip r:embed="rId2"/>
+          <a:stretch>
+            <a:fillRect/>
+          </a:stretch>
+        </p:blipFill>
+        <p:spPr>
+          <a:xfrm>
+            <a:off x="3878472" y="169030"/>
+            <a:ext cx="3243967" cy="3149367"/>
+          </a:xfrm>
+          <a:prstGeom prst="rect">
+            <a:avLst/>
+          </a:prstGeom>
+        </p:spPr>
+      </p:pic>
+      <p:sp>
+        <p:nvSpPr>
+          <p:cNvPr id="23" name="TextBox 22">
+            <a:extLst>
+              <a:ext uri="{FF2B5EF4-FFF2-40B4-BE49-F238E27FC236}">
+                <a16:creationId xmlns:a16="http://schemas.microsoft.com/office/drawing/2014/main" id="{3BE81991-0106-B1EB-2A89-77F5536E90E2}"/>
+              </a:ext>
+            </a:extLst>
+          </p:cNvPr>
+          <p:cNvSpPr txBox="1"/>
+          <p:nvPr/>
+        </p:nvSpPr>
+        <p:spPr>
+          <a:xfrm>
+            <a:off x="5076357" y="1139423"/>
+            <a:ext cx="1552209" cy="276999"/>
+          </a:xfrm>
+          <a:prstGeom prst="rect">
+            <a:avLst/>
+          </a:prstGeom>
+          <a:noFill/>
+        </p:spPr>
+        <p:txBody>
+          <a:bodyPr wrap="square" rtlCol="0">
+            <a:spAutoFit/>
+          </a:bodyPr>
+          <a:lstStyle/>
+          <a:p>
+            <a:r>
+              <a:rPr lang="en-US" sz="1200" b="1" dirty="0">
+                <a:solidFill>
+                  <a:schemeClr val="bg1"/>
+                </a:solidFill>
+                <a:latin typeface="Aptos" panose="020B0004020202020204" pitchFamily="34" charset="0"/>
+              </a:rPr>
+              <a:t>Medications</a:t>
+            </a:r>
+          </a:p>
+        </p:txBody>
+      </p:sp>
+      <p:sp>
+        <p:nvSpPr>
+          <p:cNvPr id="24" name="TextBox 23">
+            <a:extLst>
+              <a:ext uri="{FF2B5EF4-FFF2-40B4-BE49-F238E27FC236}">
+                <a16:creationId xmlns:a16="http://schemas.microsoft.com/office/drawing/2014/main" id="{DE6FED39-43E9-B4E1-39D0-6CE39DB9DC5A}"/>
+              </a:ext>
+            </a:extLst>
+          </p:cNvPr>
+          <p:cNvSpPr txBox="1"/>
+          <p:nvPr/>
+        </p:nvSpPr>
+        <p:spPr>
+          <a:xfrm>
+            <a:off x="5135067" y="765732"/>
+            <a:ext cx="1901566" cy="276999"/>
+          </a:xfrm>
+          <a:prstGeom prst="rect">
+            <a:avLst/>
+          </a:prstGeom>
+          <a:noFill/>
+        </p:spPr>
+        <p:txBody>
+          <a:bodyPr wrap="square" rtlCol="0">
+            <a:spAutoFit/>
+          </a:bodyPr>
+          <a:lstStyle/>
+          <a:p>
+            <a:r>
+              <a:rPr lang="en-US" sz="1200" b="1" dirty="0">
+                <a:solidFill>
+                  <a:schemeClr val="bg1"/>
+                </a:solidFill>
+                <a:latin typeface="Aptos" panose="020B0004020202020204" pitchFamily="34" charset="0"/>
+              </a:rPr>
+              <a:t>Allergies / Intolerances</a:t>
+            </a:r>
+          </a:p>
+        </p:txBody>
+      </p:sp>
+      <p:sp>
+        <p:nvSpPr>
+          <p:cNvPr id="25" name="TextBox 24">
+            <a:extLst>
+              <a:ext uri="{FF2B5EF4-FFF2-40B4-BE49-F238E27FC236}">
+                <a16:creationId xmlns:a16="http://schemas.microsoft.com/office/drawing/2014/main" id="{882CB8C7-307B-8125-D9F7-A17102F073E2}"/>
+              </a:ext>
+            </a:extLst>
+          </p:cNvPr>
+          <p:cNvSpPr txBox="1"/>
+          <p:nvPr/>
+        </p:nvSpPr>
+        <p:spPr>
+          <a:xfrm>
+            <a:off x="5076358" y="368677"/>
+            <a:ext cx="1901566" cy="276999"/>
+          </a:xfrm>
+          <a:prstGeom prst="rect">
+            <a:avLst/>
+          </a:prstGeom>
+          <a:noFill/>
+        </p:spPr>
+        <p:txBody>
+          <a:bodyPr wrap="square" rtlCol="0">
+            <a:spAutoFit/>
+          </a:bodyPr>
+          <a:lstStyle/>
+          <a:p>
+            <a:r>
+              <a:rPr lang="en-US" sz="1200" b="1" dirty="0">
+                <a:solidFill>
+                  <a:schemeClr val="bg1"/>
+                </a:solidFill>
+                <a:latin typeface="Aptos" panose="020B0004020202020204" pitchFamily="34" charset="0"/>
+              </a:rPr>
+              <a:t>Problems</a:t>
+            </a:r>
+          </a:p>
+        </p:txBody>
+      </p:sp>
+      <p:sp>
+        <p:nvSpPr>
+          <p:cNvPr id="26" name="TextBox 25">
+            <a:extLst>
+              <a:ext uri="{FF2B5EF4-FFF2-40B4-BE49-F238E27FC236}">
+                <a16:creationId xmlns:a16="http://schemas.microsoft.com/office/drawing/2014/main" id="{F1FABB8A-EF1A-B52F-7302-B92D2BB84136}"/>
+              </a:ext>
+            </a:extLst>
+          </p:cNvPr>
+          <p:cNvSpPr txBox="1"/>
+          <p:nvPr/>
+        </p:nvSpPr>
+        <p:spPr>
+          <a:xfrm>
+            <a:off x="5076358" y="2295540"/>
+            <a:ext cx="1901566" cy="276999"/>
+          </a:xfrm>
+          <a:prstGeom prst="rect">
+            <a:avLst/>
+          </a:prstGeom>
+          <a:noFill/>
+        </p:spPr>
+        <p:txBody>
+          <a:bodyPr wrap="square" rtlCol="0">
+            <a:spAutoFit/>
+          </a:bodyPr>
+          <a:lstStyle/>
+          <a:p>
+            <a:r>
+              <a:rPr lang="en-US" sz="1200" b="1" dirty="0">
+                <a:solidFill>
+                  <a:schemeClr val="bg1"/>
+                </a:solidFill>
+                <a:latin typeface="Aptos" panose="020B0004020202020204" pitchFamily="34" charset="0"/>
+              </a:rPr>
+              <a:t>Procedures</a:t>
+            </a:r>
+          </a:p>
+        </p:txBody>
+      </p:sp>
+      <p:sp>
+        <p:nvSpPr>
+          <p:cNvPr id="27" name="TextBox 26">
+            <a:extLst>
+              <a:ext uri="{FF2B5EF4-FFF2-40B4-BE49-F238E27FC236}">
+                <a16:creationId xmlns:a16="http://schemas.microsoft.com/office/drawing/2014/main" id="{603B436F-488B-4147-2F07-AC082890CF72}"/>
+              </a:ext>
+            </a:extLst>
+          </p:cNvPr>
+          <p:cNvSpPr txBox="1"/>
+          <p:nvPr/>
+        </p:nvSpPr>
+        <p:spPr>
+          <a:xfrm>
+            <a:off x="5076358" y="1524796"/>
+            <a:ext cx="1901566" cy="276999"/>
+          </a:xfrm>
+          <a:prstGeom prst="rect">
+            <a:avLst/>
+          </a:prstGeom>
+          <a:noFill/>
+        </p:spPr>
+        <p:txBody>
+          <a:bodyPr wrap="square" rtlCol="0">
+            <a:spAutoFit/>
+          </a:bodyPr>
+          <a:lstStyle/>
+          <a:p>
+            <a:r>
+              <a:rPr lang="en-US" sz="1200" b="1" dirty="0">
+                <a:solidFill>
+                  <a:srgbClr val="54A831"/>
+                </a:solidFill>
+                <a:latin typeface="Aptos" panose="020B0004020202020204" pitchFamily="34" charset="0"/>
+              </a:rPr>
+              <a:t>Immunizations</a:t>
+            </a:r>
+          </a:p>
+        </p:txBody>
+      </p:sp>
+      <p:sp>
+        <p:nvSpPr>
+          <p:cNvPr id="28" name="TextBox 27">
+            <a:extLst>
+              <a:ext uri="{FF2B5EF4-FFF2-40B4-BE49-F238E27FC236}">
+                <a16:creationId xmlns:a16="http://schemas.microsoft.com/office/drawing/2014/main" id="{A3A3A697-E7AD-86BC-00DA-A0254BDCBBED}"/>
+              </a:ext>
+            </a:extLst>
+          </p:cNvPr>
+          <p:cNvSpPr txBox="1"/>
+          <p:nvPr/>
+        </p:nvSpPr>
+        <p:spPr>
+          <a:xfrm>
+            <a:off x="5076358" y="1910169"/>
+            <a:ext cx="1901566" cy="276999"/>
+          </a:xfrm>
+          <a:prstGeom prst="rect">
+            <a:avLst/>
+          </a:prstGeom>
+          <a:noFill/>
+        </p:spPr>
+        <p:txBody>
+          <a:bodyPr wrap="square" rtlCol="0">
+            <a:spAutoFit/>
+          </a:bodyPr>
+          <a:lstStyle/>
+          <a:p>
+            <a:r>
+              <a:rPr lang="en-US" sz="1200" b="1" dirty="0">
+                <a:solidFill>
+                  <a:srgbClr val="E86328"/>
+                </a:solidFill>
+                <a:latin typeface="Aptos" panose="020B0004020202020204" pitchFamily="34" charset="0"/>
+              </a:rPr>
+              <a:t>Results</a:t>
+            </a:r>
+          </a:p>
+        </p:txBody>
+      </p:sp>
+      <p:cxnSp>
+        <p:nvCxnSpPr>
+          <p:cNvPr id="31" name="Connector: Elbow 30">
+            <a:extLst>
+              <a:ext uri="{FF2B5EF4-FFF2-40B4-BE49-F238E27FC236}">
+                <a16:creationId xmlns:a16="http://schemas.microsoft.com/office/drawing/2014/main" id="{60EDF3A7-0432-54AA-ABC2-F8D867B45F44}"/>
+              </a:ext>
+            </a:extLst>
+          </p:cNvPr>
+          <p:cNvCxnSpPr>
+            <a:cxnSpLocks/>
+            <a:stCxn id="29" idx="2"/>
+            <a:endCxn id="9" idx="0"/>
+          </p:cNvCxnSpPr>
+          <p:nvPr/>
+        </p:nvCxnSpPr>
+        <p:spPr bwMode="auto">
+          <a:xfrm rot="5400000">
+            <a:off x="4889774" y="3003216"/>
+            <a:ext cx="288030" cy="851569"/>
+          </a:xfrm>
+          <a:prstGeom prst="bentConnector3">
+            <a:avLst/>
+          </a:prstGeom>
+          <a:solidFill>
+            <a:schemeClr val="accent1"/>
+          </a:solidFill>
+          <a:ln w="57150" cap="flat" cmpd="sng" algn="ctr">
+            <a:solidFill>
+              <a:schemeClr val="bg1">
+                <a:lumMod val="75000"/>
+              </a:schemeClr>
+            </a:solidFill>
+            <a:prstDash val="solid"/>
+            <a:round/>
+            <a:headEnd type="none" w="med" len="med"/>
+            <a:tailEnd type="none" w="med" len="med"/>
+          </a:ln>
+          <a:effectLst/>
+          <a:extLst>
+            <a:ext uri="{AF507438-7753-43E0-B8FC-AC1667EBCBE1}">
+              <a14:hiddenEffects xmlns:a14="http://schemas.microsoft.com/office/drawing/2010/main">
+                <a:effectLst>
+                  <a:outerShdw dist="35921" dir="2700000" algn="ctr" rotWithShape="0">
+                    <a:schemeClr val="bg2"/>
+                  </a:outerShdw>
+                </a:effectLst>
+              </a14:hiddenEffects>
+            </a:ext>
+          </a:extLst>
+        </p:spPr>
+      </p:cxnSp>
+      <p:sp>
+        <p:nvSpPr>
+          <p:cNvPr id="37" name="Rectangle: Rounded Corners 36">
+            <a:extLst>
+              <a:ext uri="{FF2B5EF4-FFF2-40B4-BE49-F238E27FC236}">
+                <a16:creationId xmlns:a16="http://schemas.microsoft.com/office/drawing/2014/main" id="{09E8988F-DE68-C454-CE73-B2B9623C1232}"/>
+              </a:ext>
+            </a:extLst>
+          </p:cNvPr>
+          <p:cNvSpPr/>
+          <p:nvPr/>
+        </p:nvSpPr>
+        <p:spPr bwMode="auto">
+          <a:xfrm>
+            <a:off x="6246011" y="4153167"/>
+            <a:ext cx="1049646" cy="1070973"/>
+          </a:xfrm>
+          <a:prstGeom prst="roundRect">
+            <a:avLst/>
+          </a:prstGeom>
+          <a:solidFill>
+            <a:schemeClr val="bg1"/>
+          </a:solidFill>
+          <a:ln w="38100" cap="flat" cmpd="sng" algn="ctr">
+            <a:solidFill>
+              <a:srgbClr val="E86328"/>
+            </a:solidFill>
+            <a:prstDash val="solid"/>
+            <a:round/>
+            <a:headEnd type="none" w="med" len="med"/>
+            <a:tailEnd type="none" w="med" len="med"/>
+          </a:ln>
+          <a:effectLst/>
+        </p:spPr>
+        <p:txBody>
+          <a:bodyPr vert="horz" wrap="square" lIns="91440" tIns="45720" rIns="91440" bIns="45720" numCol="1" rtlCol="0" anchor="t" anchorCtr="0" compatLnSpc="1">
+            <a:prstTxWarp prst="textNoShape">
+              <a:avLst/>
+            </a:prstTxWarp>
+          </a:bodyPr>
+          <a:lstStyle/>
+          <a:p>
+            <a:pPr eaLnBrk="0" fontAlgn="base" hangingPunct="0">
+              <a:spcBef>
+                <a:spcPct val="0"/>
+              </a:spcBef>
+              <a:spcAft>
+                <a:spcPct val="0"/>
+              </a:spcAft>
+            </a:pPr>
+            <a:endParaRPr lang="en-US">
+              <a:latin typeface="Arial" charset="0"/>
+            </a:endParaRPr>
+          </a:p>
+        </p:txBody>
+      </p:sp>
+      <p:sp>
+        <p:nvSpPr>
+          <p:cNvPr id="38" name="Rectangle: Rounded Corners 37">
+            <a:extLst>
+              <a:ext uri="{FF2B5EF4-FFF2-40B4-BE49-F238E27FC236}">
+                <a16:creationId xmlns:a16="http://schemas.microsoft.com/office/drawing/2014/main" id="{39C150A3-CD4B-2C36-B92E-32664E4267B6}"/>
+              </a:ext>
+            </a:extLst>
+          </p:cNvPr>
+          <p:cNvSpPr/>
+          <p:nvPr/>
+        </p:nvSpPr>
+        <p:spPr bwMode="auto">
+          <a:xfrm>
+            <a:off x="5159692" y="4153167"/>
+            <a:ext cx="1049646" cy="1070973"/>
+          </a:xfrm>
+          <a:prstGeom prst="roundRect">
+            <a:avLst/>
+          </a:prstGeom>
+          <a:solidFill>
+            <a:schemeClr val="bg1"/>
+          </a:solidFill>
+          <a:ln w="38100" cap="flat" cmpd="sng" algn="ctr">
+            <a:solidFill>
+              <a:srgbClr val="F7D33E"/>
+            </a:solidFill>
+            <a:prstDash val="solid"/>
+            <a:round/>
+            <a:headEnd type="none" w="med" len="med"/>
+            <a:tailEnd type="none" w="med" len="med"/>
+          </a:ln>
+          <a:effectLst/>
+        </p:spPr>
+        <p:txBody>
+          <a:bodyPr vert="horz" wrap="square" lIns="91440" tIns="45720" rIns="91440" bIns="45720" numCol="1" rtlCol="0" anchor="t" anchorCtr="0" compatLnSpc="1">
+            <a:prstTxWarp prst="textNoShape">
+              <a:avLst/>
+            </a:prstTxWarp>
+          </a:bodyPr>
+          <a:lstStyle/>
+          <a:p>
+            <a:pPr eaLnBrk="0" fontAlgn="base" hangingPunct="0">
+              <a:spcBef>
+                <a:spcPct val="0"/>
+              </a:spcBef>
+              <a:spcAft>
+                <a:spcPct val="0"/>
+              </a:spcAft>
+            </a:pPr>
+            <a:endParaRPr lang="en-US">
+              <a:latin typeface="Arial" charset="0"/>
+            </a:endParaRPr>
+          </a:p>
+        </p:txBody>
+      </p:sp>
+      <p:sp>
+        <p:nvSpPr>
+          <p:cNvPr id="39" name="Rectangle: Rounded Corners 38">
+            <a:extLst>
+              <a:ext uri="{FF2B5EF4-FFF2-40B4-BE49-F238E27FC236}">
+                <a16:creationId xmlns:a16="http://schemas.microsoft.com/office/drawing/2014/main" id="{AA93C4CF-CF59-CA36-4BFB-FA382C354C0A}"/>
+              </a:ext>
+            </a:extLst>
+          </p:cNvPr>
+          <p:cNvSpPr/>
+          <p:nvPr/>
+        </p:nvSpPr>
+        <p:spPr bwMode="auto">
+          <a:xfrm>
+            <a:off x="4073373" y="4153167"/>
+            <a:ext cx="1049646" cy="1070973"/>
+          </a:xfrm>
+          <a:prstGeom prst="roundRect">
+            <a:avLst/>
+          </a:prstGeom>
+          <a:solidFill>
+            <a:schemeClr val="bg1"/>
+          </a:solidFill>
+          <a:ln w="38100" cap="flat" cmpd="sng" algn="ctr">
+            <a:solidFill>
+              <a:srgbClr val="CAD404"/>
+            </a:solidFill>
+            <a:prstDash val="solid"/>
+            <a:round/>
+            <a:headEnd type="none" w="med" len="med"/>
+            <a:tailEnd type="none" w="med" len="med"/>
+          </a:ln>
+          <a:effectLst/>
+        </p:spPr>
+        <p:txBody>
+          <a:bodyPr vert="horz" wrap="square" lIns="91440" tIns="45720" rIns="91440" bIns="45720" numCol="1" rtlCol="0" anchor="t" anchorCtr="0" compatLnSpc="1">
+            <a:prstTxWarp prst="textNoShape">
+              <a:avLst/>
+            </a:prstTxWarp>
+          </a:bodyPr>
+          <a:lstStyle/>
+          <a:p>
+            <a:pPr eaLnBrk="0" fontAlgn="base" hangingPunct="0">
+              <a:spcBef>
+                <a:spcPct val="0"/>
+              </a:spcBef>
+              <a:spcAft>
+                <a:spcPct val="0"/>
+              </a:spcAft>
+            </a:pPr>
+            <a:endParaRPr lang="en-US">
+              <a:latin typeface="Arial" charset="0"/>
+            </a:endParaRPr>
+          </a:p>
+        </p:txBody>
+      </p:sp>
+      <p:sp>
+        <p:nvSpPr>
+          <p:cNvPr id="40" name="Rectangle: Rounded Corners 39">
+            <a:extLst>
+              <a:ext uri="{FF2B5EF4-FFF2-40B4-BE49-F238E27FC236}">
+                <a16:creationId xmlns:a16="http://schemas.microsoft.com/office/drawing/2014/main" id="{8CC8489E-BE78-CCA7-0ECC-158CE4467AE4}"/>
+              </a:ext>
+            </a:extLst>
+          </p:cNvPr>
+          <p:cNvSpPr/>
+          <p:nvPr/>
+        </p:nvSpPr>
+        <p:spPr bwMode="auto">
+          <a:xfrm>
+            <a:off x="2987054" y="4153167"/>
+            <a:ext cx="1049646" cy="1070973"/>
+          </a:xfrm>
+          <a:prstGeom prst="roundRect">
+            <a:avLst/>
+          </a:prstGeom>
+          <a:solidFill>
+            <a:schemeClr val="bg1"/>
+          </a:solidFill>
+          <a:ln w="38100" cap="flat" cmpd="sng" algn="ctr">
+            <a:solidFill>
+              <a:srgbClr val="05953F"/>
+            </a:solidFill>
+            <a:prstDash val="solid"/>
+            <a:round/>
+            <a:headEnd type="none" w="med" len="med"/>
+            <a:tailEnd type="none" w="med" len="med"/>
+          </a:ln>
+          <a:effectLst/>
+        </p:spPr>
+        <p:txBody>
+          <a:bodyPr vert="horz" wrap="square" lIns="91440" tIns="45720" rIns="91440" bIns="45720" numCol="1" rtlCol="0" anchor="t" anchorCtr="0" compatLnSpc="1">
+            <a:prstTxWarp prst="textNoShape">
+              <a:avLst/>
+            </a:prstTxWarp>
+          </a:bodyPr>
+          <a:lstStyle/>
+          <a:p>
+            <a:pPr eaLnBrk="0" fontAlgn="base" hangingPunct="0">
+              <a:spcBef>
+                <a:spcPct val="0"/>
+              </a:spcBef>
+              <a:spcAft>
+                <a:spcPct val="0"/>
+              </a:spcAft>
+            </a:pPr>
+            <a:endParaRPr lang="en-US">
+              <a:latin typeface="Arial" charset="0"/>
+            </a:endParaRPr>
+          </a:p>
+        </p:txBody>
+      </p:sp>
+      <p:sp>
+        <p:nvSpPr>
+          <p:cNvPr id="41" name="Rectangle: Rounded Corners 40">
+            <a:extLst>
+              <a:ext uri="{FF2B5EF4-FFF2-40B4-BE49-F238E27FC236}">
+                <a16:creationId xmlns:a16="http://schemas.microsoft.com/office/drawing/2014/main" id="{9EFD4498-4871-A26E-E394-7F456281B3A5}"/>
+              </a:ext>
+            </a:extLst>
+          </p:cNvPr>
+          <p:cNvSpPr/>
+          <p:nvPr/>
+        </p:nvSpPr>
+        <p:spPr bwMode="auto">
+          <a:xfrm>
+            <a:off x="1900735" y="4153167"/>
+            <a:ext cx="1049646" cy="1070973"/>
+          </a:xfrm>
+          <a:prstGeom prst="roundRect">
+            <a:avLst/>
+          </a:prstGeom>
+          <a:solidFill>
+            <a:schemeClr val="bg1"/>
+          </a:solidFill>
+          <a:ln w="38100" cap="flat" cmpd="sng" algn="ctr">
+            <a:solidFill>
+              <a:srgbClr val="1BA5CC"/>
+            </a:solidFill>
+            <a:prstDash val="solid"/>
+            <a:round/>
+            <a:headEnd type="none" w="med" len="med"/>
+            <a:tailEnd type="none" w="med" len="med"/>
+          </a:ln>
+          <a:effectLst/>
+        </p:spPr>
+        <p:txBody>
+          <a:bodyPr vert="horz" wrap="square" lIns="91440" tIns="45720" rIns="91440" bIns="45720" numCol="1" rtlCol="0" anchor="t" anchorCtr="0" compatLnSpc="1">
+            <a:prstTxWarp prst="textNoShape">
+              <a:avLst/>
+            </a:prstTxWarp>
+          </a:bodyPr>
+          <a:lstStyle/>
+          <a:p>
+            <a:pPr eaLnBrk="0" fontAlgn="base" hangingPunct="0">
+              <a:spcBef>
+                <a:spcPct val="0"/>
+              </a:spcBef>
+              <a:spcAft>
+                <a:spcPct val="0"/>
+              </a:spcAft>
+            </a:pPr>
+            <a:endParaRPr lang="en-US">
+              <a:latin typeface="Arial" charset="0"/>
+            </a:endParaRPr>
+          </a:p>
+        </p:txBody>
+      </p:sp>
+      <p:sp>
+        <p:nvSpPr>
+          <p:cNvPr id="42" name="Rectangle: Rounded Corners 41">
+            <a:extLst>
+              <a:ext uri="{FF2B5EF4-FFF2-40B4-BE49-F238E27FC236}">
+                <a16:creationId xmlns:a16="http://schemas.microsoft.com/office/drawing/2014/main" id="{56435543-E0B7-1153-C41F-4F678D2CA29C}"/>
+              </a:ext>
+            </a:extLst>
+          </p:cNvPr>
+          <p:cNvSpPr/>
+          <p:nvPr/>
+        </p:nvSpPr>
+        <p:spPr bwMode="auto">
+          <a:xfrm>
+            <a:off x="814416" y="4153167"/>
+            <a:ext cx="1049646" cy="1070973"/>
+          </a:xfrm>
+          <a:prstGeom prst="roundRect">
+            <a:avLst/>
+          </a:prstGeom>
+          <a:solidFill>
+            <a:schemeClr val="bg1"/>
+          </a:solidFill>
+          <a:ln w="38100" cap="flat" cmpd="sng" algn="ctr">
+            <a:solidFill>
+              <a:srgbClr val="87C9FB"/>
+            </a:solidFill>
+            <a:prstDash val="solid"/>
+            <a:round/>
+            <a:headEnd type="none" w="med" len="med"/>
+            <a:tailEnd type="none" w="med" len="med"/>
+          </a:ln>
+          <a:effectLst/>
+        </p:spPr>
+        <p:txBody>
+          <a:bodyPr vert="horz" wrap="square" lIns="91440" tIns="45720" rIns="91440" bIns="45720" numCol="1" rtlCol="0" anchor="t" anchorCtr="0" compatLnSpc="1">
+            <a:prstTxWarp prst="textNoShape">
+              <a:avLst/>
+            </a:prstTxWarp>
+          </a:bodyPr>
+          <a:lstStyle/>
+          <a:p>
+            <a:pPr eaLnBrk="0" fontAlgn="base" hangingPunct="0">
+              <a:spcBef>
+                <a:spcPct val="0"/>
+              </a:spcBef>
+              <a:spcAft>
+                <a:spcPct val="0"/>
+              </a:spcAft>
+            </a:pPr>
+            <a:endParaRPr lang="en-US" dirty="0">
+              <a:latin typeface="Arial" charset="0"/>
+            </a:endParaRPr>
+          </a:p>
+        </p:txBody>
+      </p:sp>
+      <p:sp>
+        <p:nvSpPr>
+          <p:cNvPr id="43" name="Rectangle: Rounded Corners 42">
+            <a:extLst>
+              <a:ext uri="{FF2B5EF4-FFF2-40B4-BE49-F238E27FC236}">
+                <a16:creationId xmlns:a16="http://schemas.microsoft.com/office/drawing/2014/main" id="{9AAF8DAB-4B64-343F-D759-B40ACDAF741A}"/>
+              </a:ext>
+            </a:extLst>
+          </p:cNvPr>
+          <p:cNvSpPr/>
+          <p:nvPr/>
+        </p:nvSpPr>
+        <p:spPr bwMode="auto">
+          <a:xfrm>
+            <a:off x="7332331" y="4153167"/>
+            <a:ext cx="1049646" cy="1070973"/>
+          </a:xfrm>
+          <a:prstGeom prst="roundRect">
+            <a:avLst/>
+          </a:prstGeom>
+          <a:solidFill>
+            <a:schemeClr val="bg1"/>
+          </a:solidFill>
+          <a:ln w="38100" cap="flat" cmpd="sng" algn="ctr">
+            <a:solidFill>
+              <a:schemeClr val="tx1">
+                <a:lumMod val="50000"/>
+                <a:lumOff val="50000"/>
+              </a:schemeClr>
+            </a:solidFill>
+            <a:prstDash val="solid"/>
+            <a:round/>
+            <a:headEnd type="none" w="med" len="med"/>
+            <a:tailEnd type="none" w="med" len="med"/>
+          </a:ln>
+          <a:effectLst/>
+        </p:spPr>
+        <p:txBody>
+          <a:bodyPr vert="horz" wrap="square" lIns="91440" tIns="45720" rIns="91440" bIns="45720" numCol="1" rtlCol="0" anchor="t" anchorCtr="0" compatLnSpc="1">
+            <a:prstTxWarp prst="textNoShape">
+              <a:avLst/>
+            </a:prstTxWarp>
+          </a:bodyPr>
+          <a:lstStyle/>
+          <a:p>
+            <a:pPr marL="0" marR="0" indent="0" algn="l" defTabSz="914400" rtl="0" eaLnBrk="0" fontAlgn="base" latinLnBrk="0" hangingPunct="0">
+              <a:lnSpc>
+                <a:spcPct val="100000"/>
+              </a:lnSpc>
+              <a:spcBef>
+                <a:spcPct val="0"/>
+              </a:spcBef>
+              <a:spcAft>
+                <a:spcPct val="0"/>
+              </a:spcAft>
+              <a:buClrTx/>
+              <a:buSzTx/>
+              <a:buFontTx/>
+              <a:buNone/>
+              <a:tabLst/>
+            </a:pPr>
+            <a:endParaRPr kumimoji="0" lang="en-US" sz="1800" b="0" i="0" u="none" strike="noStrike" cap="none" normalizeH="0" baseline="0">
+              <a:ln>
+                <a:noFill/>
+              </a:ln>
+              <a:solidFill>
+                <a:schemeClr val="tx1"/>
+              </a:solidFill>
+              <a:effectLst/>
+              <a:latin typeface="Arial" charset="0"/>
+            </a:endParaRPr>
+          </a:p>
+        </p:txBody>
+      </p:sp>
+      <p:sp>
+        <p:nvSpPr>
+          <p:cNvPr id="11" name="TextBox 10">
+            <a:extLst>
+              <a:ext uri="{FF2B5EF4-FFF2-40B4-BE49-F238E27FC236}">
+                <a16:creationId xmlns:a16="http://schemas.microsoft.com/office/drawing/2014/main" id="{15A061A9-4EBE-CD72-678A-ABCAFC09C15E}"/>
+              </a:ext>
+            </a:extLst>
+          </p:cNvPr>
+          <p:cNvSpPr txBox="1"/>
+          <p:nvPr/>
+        </p:nvSpPr>
+        <p:spPr>
+          <a:xfrm>
+            <a:off x="2092274" y="4884570"/>
+            <a:ext cx="627095" cy="261610"/>
+          </a:xfrm>
+          <a:prstGeom prst="rect">
+            <a:avLst/>
+          </a:prstGeom>
+          <a:noFill/>
+        </p:spPr>
+        <p:txBody>
+          <a:bodyPr wrap="none" rtlCol="0">
+            <a:spAutoFit/>
+          </a:bodyPr>
+          <a:lstStyle/>
+          <a:p>
+            <a:pPr algn="ctr"/>
+            <a:r>
+              <a:rPr lang="en-US" sz="1100" b="1" dirty="0">
+                <a:latin typeface="Aptos" panose="020B0004020202020204" pitchFamily="34" charset="0"/>
+                <a:ea typeface="Calibri" panose="020F0502020204030204" pitchFamily="34" charset="0"/>
+                <a:cs typeface="Calibri" panose="020F0502020204030204" pitchFamily="34" charset="0"/>
+              </a:rPr>
+              <a:t>Allergy</a:t>
+            </a:r>
+          </a:p>
+        </p:txBody>
+      </p:sp>
+      <p:sp>
+        <p:nvSpPr>
+          <p:cNvPr id="12" name="TextBox 11">
+            <a:extLst>
+              <a:ext uri="{FF2B5EF4-FFF2-40B4-BE49-F238E27FC236}">
+                <a16:creationId xmlns:a16="http://schemas.microsoft.com/office/drawing/2014/main" id="{2F4A61B6-7D43-ECE1-A7CD-7D97BFC5E865}"/>
+              </a:ext>
+            </a:extLst>
+          </p:cNvPr>
+          <p:cNvSpPr txBox="1"/>
+          <p:nvPr/>
+        </p:nvSpPr>
+        <p:spPr>
+          <a:xfrm>
+            <a:off x="977888" y="4884570"/>
+            <a:ext cx="729687" cy="261610"/>
+          </a:xfrm>
+          <a:prstGeom prst="rect">
+            <a:avLst/>
+          </a:prstGeom>
+          <a:noFill/>
+        </p:spPr>
+        <p:txBody>
+          <a:bodyPr wrap="none" rtlCol="0">
+            <a:spAutoFit/>
+          </a:bodyPr>
+          <a:lstStyle/>
+          <a:p>
+            <a:pPr algn="ctr"/>
+            <a:r>
+              <a:rPr lang="en-US" sz="1100" b="1" dirty="0">
+                <a:latin typeface="Aptos" panose="020B0004020202020204" pitchFamily="34" charset="0"/>
+                <a:ea typeface="Calibri" panose="020F0502020204030204" pitchFamily="34" charset="0"/>
+                <a:cs typeface="Calibri" panose="020F0502020204030204" pitchFamily="34" charset="0"/>
+              </a:rPr>
+              <a:t>Problem</a:t>
+            </a:r>
+          </a:p>
+        </p:txBody>
+      </p:sp>
+      <p:sp>
+        <p:nvSpPr>
+          <p:cNvPr id="13" name="TextBox 12">
+            <a:extLst>
+              <a:ext uri="{FF2B5EF4-FFF2-40B4-BE49-F238E27FC236}">
+                <a16:creationId xmlns:a16="http://schemas.microsoft.com/office/drawing/2014/main" id="{2476524D-49C9-6E07-29AE-9C2BFDE5B31E}"/>
+              </a:ext>
+            </a:extLst>
+          </p:cNvPr>
+          <p:cNvSpPr txBox="1"/>
+          <p:nvPr/>
+        </p:nvSpPr>
+        <p:spPr>
+          <a:xfrm>
+            <a:off x="3061847" y="4884570"/>
+            <a:ext cx="906017" cy="261610"/>
+          </a:xfrm>
+          <a:prstGeom prst="rect">
+            <a:avLst/>
+          </a:prstGeom>
+          <a:noFill/>
+        </p:spPr>
+        <p:txBody>
+          <a:bodyPr wrap="none" rtlCol="0">
+            <a:spAutoFit/>
+          </a:bodyPr>
+          <a:lstStyle/>
+          <a:p>
+            <a:pPr algn="ctr"/>
+            <a:r>
+              <a:rPr lang="en-US" sz="1100" b="1" dirty="0">
+                <a:latin typeface="Aptos" panose="020B0004020202020204" pitchFamily="34" charset="0"/>
+                <a:ea typeface="Calibri" panose="020F0502020204030204" pitchFamily="34" charset="0"/>
+                <a:cs typeface="Calibri" panose="020F0502020204030204" pitchFamily="34" charset="0"/>
+              </a:rPr>
+              <a:t>Medication</a:t>
+            </a:r>
+          </a:p>
+        </p:txBody>
+      </p:sp>
+      <p:sp>
+        <p:nvSpPr>
+          <p:cNvPr id="14" name="TextBox 13">
+            <a:extLst>
+              <a:ext uri="{FF2B5EF4-FFF2-40B4-BE49-F238E27FC236}">
+                <a16:creationId xmlns:a16="http://schemas.microsoft.com/office/drawing/2014/main" id="{86CBE721-F72E-CF6C-645E-1608A7C6AB98}"/>
+              </a:ext>
+            </a:extLst>
+          </p:cNvPr>
+          <p:cNvSpPr txBox="1"/>
+          <p:nvPr/>
+        </p:nvSpPr>
+        <p:spPr>
+          <a:xfrm>
+            <a:off x="4062337" y="4884570"/>
+            <a:ext cx="1072730" cy="261610"/>
+          </a:xfrm>
+          <a:prstGeom prst="rect">
+            <a:avLst/>
+          </a:prstGeom>
+          <a:noFill/>
+        </p:spPr>
+        <p:txBody>
+          <a:bodyPr wrap="none" rtlCol="0">
+            <a:spAutoFit/>
+          </a:bodyPr>
+          <a:lstStyle/>
+          <a:p>
+            <a:pPr algn="ctr"/>
+            <a:r>
+              <a:rPr lang="en-US" sz="1100" b="1" dirty="0">
+                <a:latin typeface="Aptos" panose="020B0004020202020204" pitchFamily="34" charset="0"/>
+                <a:ea typeface="Calibri" panose="020F0502020204030204" pitchFamily="34" charset="0"/>
+                <a:cs typeface="Calibri" panose="020F0502020204030204" pitchFamily="34" charset="0"/>
+              </a:rPr>
+              <a:t>Immunization</a:t>
+            </a:r>
+          </a:p>
+        </p:txBody>
+      </p:sp>
+      <p:sp>
+        <p:nvSpPr>
+          <p:cNvPr id="15" name="TextBox 14">
+            <a:extLst>
+              <a:ext uri="{FF2B5EF4-FFF2-40B4-BE49-F238E27FC236}">
+                <a16:creationId xmlns:a16="http://schemas.microsoft.com/office/drawing/2014/main" id="{FE146C21-C4EC-E6D1-146D-CD0817271720}"/>
+              </a:ext>
+            </a:extLst>
+          </p:cNvPr>
+          <p:cNvSpPr txBox="1"/>
+          <p:nvPr/>
+        </p:nvSpPr>
+        <p:spPr>
+          <a:xfrm>
+            <a:off x="5389686" y="4884570"/>
+            <a:ext cx="598241" cy="261610"/>
+          </a:xfrm>
+          <a:prstGeom prst="rect">
+            <a:avLst/>
+          </a:prstGeom>
+          <a:noFill/>
+        </p:spPr>
+        <p:txBody>
+          <a:bodyPr wrap="none" rtlCol="0">
+            <a:spAutoFit/>
+          </a:bodyPr>
+          <a:lstStyle/>
+          <a:p>
+            <a:pPr algn="ctr"/>
+            <a:r>
+              <a:rPr lang="en-US" sz="1100" b="1" dirty="0">
+                <a:latin typeface="Aptos" panose="020B0004020202020204" pitchFamily="34" charset="0"/>
+                <a:ea typeface="Calibri" panose="020F0502020204030204" pitchFamily="34" charset="0"/>
+                <a:cs typeface="Calibri" panose="020F0502020204030204" pitchFamily="34" charset="0"/>
+              </a:rPr>
+              <a:t>Result</a:t>
+            </a:r>
+          </a:p>
+        </p:txBody>
+      </p:sp>
+      <p:sp>
+        <p:nvSpPr>
+          <p:cNvPr id="16" name="TextBox 15">
+            <a:extLst>
+              <a:ext uri="{FF2B5EF4-FFF2-40B4-BE49-F238E27FC236}">
+                <a16:creationId xmlns:a16="http://schemas.microsoft.com/office/drawing/2014/main" id="{9E66E985-5B3A-E36F-76BF-C42806537BF3}"/>
+              </a:ext>
+            </a:extLst>
+          </p:cNvPr>
+          <p:cNvSpPr txBox="1"/>
+          <p:nvPr/>
+        </p:nvSpPr>
+        <p:spPr>
+          <a:xfrm>
+            <a:off x="6355802" y="4884570"/>
+            <a:ext cx="851515" cy="261610"/>
+          </a:xfrm>
+          <a:prstGeom prst="rect">
+            <a:avLst/>
+          </a:prstGeom>
+          <a:noFill/>
+        </p:spPr>
+        <p:txBody>
+          <a:bodyPr wrap="none" rtlCol="0">
+            <a:spAutoFit/>
+          </a:bodyPr>
+          <a:lstStyle/>
+          <a:p>
+            <a:pPr algn="ctr"/>
+            <a:r>
+              <a:rPr lang="en-US" sz="1100" b="1" dirty="0">
+                <a:latin typeface="Aptos" panose="020B0004020202020204" pitchFamily="34" charset="0"/>
+                <a:ea typeface="Calibri" panose="020F0502020204030204" pitchFamily="34" charset="0"/>
+                <a:cs typeface="Calibri" panose="020F0502020204030204" pitchFamily="34" charset="0"/>
+              </a:rPr>
+              <a:t>Procedure</a:t>
+            </a:r>
+          </a:p>
+        </p:txBody>
+      </p:sp>
+      <p:sp>
+        <p:nvSpPr>
+          <p:cNvPr id="17" name="TextBox 16">
+            <a:extLst>
+              <a:ext uri="{FF2B5EF4-FFF2-40B4-BE49-F238E27FC236}">
+                <a16:creationId xmlns:a16="http://schemas.microsoft.com/office/drawing/2014/main" id="{53B4C931-833E-AD51-B84D-248839F9A0C9}"/>
+              </a:ext>
+            </a:extLst>
+          </p:cNvPr>
+          <p:cNvSpPr txBox="1"/>
+          <p:nvPr/>
+        </p:nvSpPr>
+        <p:spPr>
+          <a:xfrm>
+            <a:off x="7517958" y="4819364"/>
+            <a:ext cx="678391" cy="430887"/>
+          </a:xfrm>
+          <a:prstGeom prst="rect">
+            <a:avLst/>
+          </a:prstGeom>
+          <a:noFill/>
+        </p:spPr>
+        <p:txBody>
+          <a:bodyPr wrap="none" rtlCol="0">
+            <a:spAutoFit/>
+          </a:bodyPr>
+          <a:lstStyle/>
+          <a:p>
+            <a:pPr algn="ctr"/>
+            <a:r>
+              <a:rPr lang="en-US" sz="1100" b="1" dirty="0">
+                <a:latin typeface="Aptos" panose="020B0004020202020204" pitchFamily="34" charset="0"/>
+                <a:ea typeface="Calibri" panose="020F0502020204030204" pitchFamily="34" charset="0"/>
+                <a:cs typeface="Calibri" panose="020F0502020204030204" pitchFamily="34" charset="0"/>
+              </a:rPr>
+              <a:t>Other </a:t>
+            </a:r>
+            <a:br>
+              <a:rPr lang="en-US" sz="1100" b="1" dirty="0">
+                <a:latin typeface="Aptos" panose="020B0004020202020204" pitchFamily="34" charset="0"/>
+                <a:ea typeface="Calibri" panose="020F0502020204030204" pitchFamily="34" charset="0"/>
+                <a:cs typeface="Calibri" panose="020F0502020204030204" pitchFamily="34" charset="0"/>
+              </a:rPr>
+            </a:br>
+            <a:r>
+              <a:rPr lang="en-US" sz="1100" b="1" dirty="0">
+                <a:latin typeface="Aptos" panose="020B0004020202020204" pitchFamily="34" charset="0"/>
+                <a:ea typeface="Calibri" panose="020F0502020204030204" pitchFamily="34" charset="0"/>
+                <a:cs typeface="Calibri" panose="020F0502020204030204" pitchFamily="34" charset="0"/>
+              </a:rPr>
+              <a:t>Profiles</a:t>
+            </a:r>
+          </a:p>
+        </p:txBody>
+      </p:sp>
+      <p:pic>
+        <p:nvPicPr>
+          <p:cNvPr id="36" name="Picture 35" descr="A black and white image of a pair of scissors&#10;&#10;Description automatically generated">
+            <a:extLst>
+              <a:ext uri="{FF2B5EF4-FFF2-40B4-BE49-F238E27FC236}">
+                <a16:creationId xmlns:a16="http://schemas.microsoft.com/office/drawing/2014/main" id="{E66702C4-1616-AB45-EB4F-84AA4BAE45F1}"/>
+              </a:ext>
+            </a:extLst>
+          </p:cNvPr>
+          <p:cNvPicPr>
+            <a:picLocks noChangeAspect="1"/>
+          </p:cNvPicPr>
+          <p:nvPr/>
+        </p:nvPicPr>
+        <p:blipFill>
+          <a:blip r:embed="rId3">
+            <a:extLst>
+              <a:ext uri="{28A0092B-C50C-407E-A947-70E740481C1C}">
+                <a14:useLocalDpi xmlns:a14="http://schemas.microsoft.com/office/drawing/2010/main" val="0"/>
+              </a:ext>
+            </a:extLst>
+          </a:blip>
+          <a:stretch>
+            <a:fillRect/>
+          </a:stretch>
+        </p:blipFill>
+        <p:spPr>
+          <a:xfrm>
+            <a:off x="6492361" y="4265126"/>
+            <a:ext cx="609631" cy="609631"/>
+          </a:xfrm>
+          <a:prstGeom prst="rect">
+            <a:avLst/>
+          </a:prstGeom>
+        </p:spPr>
+      </p:pic>
+      <p:pic>
+        <p:nvPicPr>
+          <p:cNvPr id="47" name="Picture 46" descr="A stethoscope with a cord&#10;&#10;Description automatically generated">
+            <a:extLst>
+              <a:ext uri="{FF2B5EF4-FFF2-40B4-BE49-F238E27FC236}">
+                <a16:creationId xmlns:a16="http://schemas.microsoft.com/office/drawing/2014/main" id="{C4625836-1CD0-5A72-30EF-DCE1F74DFD1F}"/>
+              </a:ext>
+            </a:extLst>
+          </p:cNvPr>
+          <p:cNvPicPr>
+            <a:picLocks noChangeAspect="1"/>
+          </p:cNvPicPr>
+          <p:nvPr/>
+        </p:nvPicPr>
+        <p:blipFill>
+          <a:blip r:embed="rId4">
+            <a:extLst>
+              <a:ext uri="{28A0092B-C50C-407E-A947-70E740481C1C}">
+                <a14:useLocalDpi xmlns:a14="http://schemas.microsoft.com/office/drawing/2010/main" val="0"/>
+              </a:ext>
+            </a:extLst>
+          </a:blip>
+          <a:stretch>
+            <a:fillRect/>
+          </a:stretch>
+        </p:blipFill>
+        <p:spPr>
+          <a:xfrm>
+            <a:off x="1032977" y="4301728"/>
+            <a:ext cx="609631" cy="609631"/>
+          </a:xfrm>
+          <a:prstGeom prst="rect">
+            <a:avLst/>
+          </a:prstGeom>
+        </p:spPr>
+      </p:pic>
+      <p:pic>
+        <p:nvPicPr>
+          <p:cNvPr id="49" name="Picture 48" descr="A black and white icon of a syringe and a shield&#10;&#10;Description automatically generated">
+            <a:extLst>
+              <a:ext uri="{FF2B5EF4-FFF2-40B4-BE49-F238E27FC236}">
+                <a16:creationId xmlns:a16="http://schemas.microsoft.com/office/drawing/2014/main" id="{093C8F13-341A-7203-B98B-98D243B54495}"/>
+              </a:ext>
+            </a:extLst>
+          </p:cNvPr>
+          <p:cNvPicPr>
+            <a:picLocks noChangeAspect="1"/>
+          </p:cNvPicPr>
+          <p:nvPr/>
+        </p:nvPicPr>
+        <p:blipFill>
+          <a:blip r:embed="rId5">
+            <a:extLst>
+              <a:ext uri="{28A0092B-C50C-407E-A947-70E740481C1C}">
+                <a14:useLocalDpi xmlns:a14="http://schemas.microsoft.com/office/drawing/2010/main" val="0"/>
+              </a:ext>
+            </a:extLst>
+          </a:blip>
+          <a:stretch>
+            <a:fillRect/>
+          </a:stretch>
+        </p:blipFill>
+        <p:spPr>
+          <a:xfrm>
+            <a:off x="4304740" y="4276955"/>
+            <a:ext cx="609631" cy="609631"/>
+          </a:xfrm>
+          <a:prstGeom prst="rect">
+            <a:avLst/>
+          </a:prstGeom>
+        </p:spPr>
+      </p:pic>
+      <p:pic>
+        <p:nvPicPr>
+          <p:cNvPr id="51" name="Picture 50" descr="A black and white line drawing of a test tube&#10;&#10;Description automatically generated">
+            <a:extLst>
+              <a:ext uri="{FF2B5EF4-FFF2-40B4-BE49-F238E27FC236}">
+                <a16:creationId xmlns:a16="http://schemas.microsoft.com/office/drawing/2014/main" id="{F67C267E-C6F5-72DD-1908-433EBAC3D7A3}"/>
+              </a:ext>
+            </a:extLst>
+          </p:cNvPr>
+          <p:cNvPicPr>
+            <a:picLocks noChangeAspect="1"/>
+          </p:cNvPicPr>
+          <p:nvPr/>
+        </p:nvPicPr>
+        <p:blipFill>
+          <a:blip r:embed="rId6">
+            <a:extLst>
+              <a:ext uri="{28A0092B-C50C-407E-A947-70E740481C1C}">
+                <a14:useLocalDpi xmlns:a14="http://schemas.microsoft.com/office/drawing/2010/main" val="0"/>
+              </a:ext>
+            </a:extLst>
+          </a:blip>
+          <a:stretch>
+            <a:fillRect/>
+          </a:stretch>
+        </p:blipFill>
+        <p:spPr>
+          <a:xfrm>
+            <a:off x="5379699" y="4301727"/>
+            <a:ext cx="609631" cy="609631"/>
+          </a:xfrm>
+          <a:prstGeom prst="rect">
+            <a:avLst/>
+          </a:prstGeom>
+        </p:spPr>
+      </p:pic>
+      <p:pic>
+        <p:nvPicPr>
+          <p:cNvPr id="53" name="Picture 52" descr="A black and white image of different shapes&#10;&#10;Description automatically generated">
+            <a:extLst>
+              <a:ext uri="{FF2B5EF4-FFF2-40B4-BE49-F238E27FC236}">
+                <a16:creationId xmlns:a16="http://schemas.microsoft.com/office/drawing/2014/main" id="{C215E95D-B00D-2045-C56B-CE01598440FE}"/>
+              </a:ext>
+            </a:extLst>
+          </p:cNvPr>
+          <p:cNvPicPr>
+            <a:picLocks noChangeAspect="1"/>
+          </p:cNvPicPr>
+          <p:nvPr/>
+        </p:nvPicPr>
+        <p:blipFill>
+          <a:blip r:embed="rId7">
+            <a:extLst>
+              <a:ext uri="{28A0092B-C50C-407E-A947-70E740481C1C}">
+                <a14:useLocalDpi xmlns:a14="http://schemas.microsoft.com/office/drawing/2010/main" val="0"/>
+              </a:ext>
+            </a:extLst>
+          </a:blip>
+          <a:stretch>
+            <a:fillRect/>
+          </a:stretch>
+        </p:blipFill>
+        <p:spPr>
+          <a:xfrm>
+            <a:off x="3184129" y="4296109"/>
+            <a:ext cx="609631" cy="609631"/>
+          </a:xfrm>
+          <a:prstGeom prst="rect">
+            <a:avLst/>
+          </a:prstGeom>
+        </p:spPr>
+      </p:pic>
+      <p:pic>
+        <p:nvPicPr>
+          <p:cNvPr id="62" name="Picture 61" descr="A black and white clipboard with a cross&#10;&#10;Description automatically generated">
+            <a:extLst>
+              <a:ext uri="{FF2B5EF4-FFF2-40B4-BE49-F238E27FC236}">
+                <a16:creationId xmlns:a16="http://schemas.microsoft.com/office/drawing/2014/main" id="{A86FF2D1-06AF-35EE-3680-D1861D3A0D0F}"/>
+              </a:ext>
+            </a:extLst>
+          </p:cNvPr>
+          <p:cNvPicPr>
+            <a:picLocks noChangeAspect="1"/>
+          </p:cNvPicPr>
+          <p:nvPr/>
+        </p:nvPicPr>
+        <p:blipFill>
+          <a:blip r:embed="rId8">
+            <a:extLst>
+              <a:ext uri="{28A0092B-C50C-407E-A947-70E740481C1C}">
+                <a14:useLocalDpi xmlns:a14="http://schemas.microsoft.com/office/drawing/2010/main" val="0"/>
+              </a:ext>
+            </a:extLst>
+          </a:blip>
+          <a:stretch>
+            <a:fillRect/>
+          </a:stretch>
+        </p:blipFill>
+        <p:spPr>
+          <a:xfrm>
+            <a:off x="7434924" y="4362053"/>
+            <a:ext cx="430887" cy="430887"/>
+          </a:xfrm>
+          <a:prstGeom prst="rect">
+            <a:avLst/>
+          </a:prstGeom>
+        </p:spPr>
+      </p:pic>
+      <p:pic>
+        <p:nvPicPr>
+          <p:cNvPr id="66" name="Picture 65">
+            <a:extLst>
+              <a:ext uri="{FF2B5EF4-FFF2-40B4-BE49-F238E27FC236}">
+                <a16:creationId xmlns:a16="http://schemas.microsoft.com/office/drawing/2014/main" id="{4802D7DB-7378-E5A9-38E0-95A69C9CCD95}"/>
+              </a:ext>
+            </a:extLst>
+          </p:cNvPr>
+          <p:cNvPicPr>
+            <a:picLocks noChangeAspect="1"/>
+          </p:cNvPicPr>
+          <p:nvPr/>
+        </p:nvPicPr>
+        <p:blipFill rotWithShape="1">
+          <a:blip r:embed="rId9"/>
+          <a:srcRect l="6754" t="18564" r="80644" b="30366"/>
+          <a:stretch/>
+        </p:blipFill>
+        <p:spPr>
+          <a:xfrm>
+            <a:off x="2125742" y="4301727"/>
+            <a:ext cx="606925" cy="604013"/>
+          </a:xfrm>
+          <a:prstGeom prst="rect">
+            <a:avLst/>
+          </a:prstGeom>
+        </p:spPr>
+      </p:pic>
+      <p:pic>
+        <p:nvPicPr>
+          <p:cNvPr id="67" name="Picture 66">
+            <a:extLst>
+              <a:ext uri="{FF2B5EF4-FFF2-40B4-BE49-F238E27FC236}">
+                <a16:creationId xmlns:a16="http://schemas.microsoft.com/office/drawing/2014/main" id="{B8518EE4-E8DF-96FA-CD6D-6923083E553C}"/>
+              </a:ext>
+            </a:extLst>
+          </p:cNvPr>
+          <p:cNvPicPr>
+            <a:picLocks noChangeAspect="1"/>
+          </p:cNvPicPr>
+          <p:nvPr/>
+        </p:nvPicPr>
+        <p:blipFill rotWithShape="1">
+          <a:blip r:embed="rId10"/>
+          <a:srcRect t="14434" r="85778" b="20996"/>
+          <a:stretch/>
+        </p:blipFill>
+        <p:spPr>
+          <a:xfrm>
+            <a:off x="7671506" y="4339789"/>
+            <a:ext cx="593795" cy="489843"/>
+          </a:xfrm>
+          <a:prstGeom prst="rect">
+            <a:avLst/>
+          </a:prstGeom>
+        </p:spPr>
+      </p:pic>
+      <p:sp>
+        <p:nvSpPr>
+          <p:cNvPr id="68" name="TextBox 67">
+            <a:extLst>
+              <a:ext uri="{FF2B5EF4-FFF2-40B4-BE49-F238E27FC236}">
+                <a16:creationId xmlns:a16="http://schemas.microsoft.com/office/drawing/2014/main" id="{0B933ED0-93F3-B61F-7A4D-1A63496A399B}"/>
+              </a:ext>
+            </a:extLst>
+          </p:cNvPr>
+          <p:cNvSpPr txBox="1"/>
+          <p:nvPr/>
+        </p:nvSpPr>
+        <p:spPr>
+          <a:xfrm>
+            <a:off x="4840947" y="2689810"/>
+            <a:ext cx="1619354" cy="307777"/>
+          </a:xfrm>
+          <a:prstGeom prst="rect">
+            <a:avLst/>
+          </a:prstGeom>
+          <a:noFill/>
+        </p:spPr>
+        <p:txBody>
+          <a:bodyPr wrap="none" rtlCol="0">
+            <a:spAutoFit/>
+          </a:bodyPr>
+          <a:lstStyle/>
+          <a:p>
+            <a:r>
+              <a:rPr lang="en-US" sz="1400" dirty="0">
+                <a:solidFill>
+                  <a:schemeClr val="tx1">
+                    <a:lumMod val="50000"/>
+                    <a:lumOff val="50000"/>
+                  </a:schemeClr>
+                </a:solidFill>
+                <a:latin typeface="Aptos" panose="020B0004020202020204" pitchFamily="34" charset="0"/>
+              </a:rPr>
+              <a:t>+11 other sections</a:t>
+            </a:r>
+          </a:p>
+        </p:txBody>
+      </p:sp>
+      <p:sp>
+        <p:nvSpPr>
+          <p:cNvPr id="29" name="Rectangle: Rounded Corners 28">
+            <a:extLst>
+              <a:ext uri="{FF2B5EF4-FFF2-40B4-BE49-F238E27FC236}">
+                <a16:creationId xmlns:a16="http://schemas.microsoft.com/office/drawing/2014/main" id="{87DCCCE1-3079-4C55-AAD2-E2FF3053AAB9}"/>
+              </a:ext>
+            </a:extLst>
+          </p:cNvPr>
+          <p:cNvSpPr/>
+          <p:nvPr/>
+        </p:nvSpPr>
+        <p:spPr bwMode="auto">
+          <a:xfrm>
+            <a:off x="3796707" y="169030"/>
+            <a:ext cx="3325732" cy="3115955"/>
+          </a:xfrm>
+          <a:prstGeom prst="roundRect">
+            <a:avLst>
+              <a:gd name="adj" fmla="val 4745"/>
+            </a:avLst>
+          </a:prstGeom>
+          <a:noFill/>
+          <a:ln w="57150" cap="flat" cmpd="sng" algn="ctr">
+            <a:solidFill>
+              <a:srgbClr val="00B0F0"/>
+            </a:solidFill>
+            <a:prstDash val="solid"/>
+            <a:round/>
+            <a:headEnd type="none" w="med" len="med"/>
+            <a:tailEnd type="none" w="med" len="med"/>
+          </a:ln>
+          <a:effectLst/>
+        </p:spPr>
+        <p:txBody>
+          <a:bodyPr vert="horz" wrap="square" lIns="91440" tIns="45720" rIns="91440" bIns="45720" numCol="1" rtlCol="0" anchor="t" anchorCtr="0" compatLnSpc="1">
+            <a:prstTxWarp prst="textNoShape">
+              <a:avLst/>
+            </a:prstTxWarp>
+          </a:bodyPr>
+          <a:lstStyle/>
+          <a:p>
+            <a:pPr marL="0" marR="0" indent="0" algn="l" defTabSz="914400" rtl="0" eaLnBrk="0" fontAlgn="base" latinLnBrk="0" hangingPunct="0">
+              <a:lnSpc>
+                <a:spcPct val="100000"/>
+              </a:lnSpc>
+              <a:spcBef>
+                <a:spcPct val="0"/>
+              </a:spcBef>
+              <a:spcAft>
+                <a:spcPct val="0"/>
+              </a:spcAft>
+              <a:buClrTx/>
+              <a:buSzTx/>
+              <a:buFontTx/>
+              <a:buNone/>
+              <a:tabLst/>
+            </a:pPr>
+            <a:endParaRPr kumimoji="0" lang="en-US" sz="1800" b="0" i="0" u="none" strike="noStrike" cap="none" normalizeH="0" baseline="0">
+              <a:ln>
+                <a:noFill/>
+              </a:ln>
+              <a:solidFill>
+                <a:schemeClr val="tx1"/>
+              </a:solidFill>
+              <a:effectLst/>
+              <a:latin typeface="Arial" charset="0"/>
+            </a:endParaRPr>
+          </a:p>
+        </p:txBody>
+      </p:sp>
+      <p:sp>
+        <p:nvSpPr>
           <p:cNvPr id="3" name="TextBox 2">
             <a:extLst>
               <a:ext uri="{FF2B5EF4-FFF2-40B4-BE49-F238E27FC236}">
@@ -14660,7 +16268,7 @@
 </p:sld>
 </file>
 
-<file path=ppt/slides/slide5.xml><?xml version="1.0" encoding="utf-8"?>
+<file path=ppt/slides/slide6.xml><?xml version="1.0" encoding="utf-8"?>
 <p:sld xmlns:a="http://schemas.openxmlformats.org/drawingml/2006/main" xmlns:r="http://schemas.openxmlformats.org/officeDocument/2006/relationships" xmlns:p="http://schemas.openxmlformats.org/presentationml/2006/main">
   <p:cSld>
     <p:spTree>
@@ -19528,7 +21136,7 @@
 </p:sld>
 </file>
 
-<file path=ppt/slides/slide6.xml><?xml version="1.0" encoding="utf-8"?>
+<file path=ppt/slides/slide7.xml><?xml version="1.0" encoding="utf-8"?>
 <p:sld xmlns:a="http://schemas.openxmlformats.org/drawingml/2006/main" xmlns:r="http://schemas.openxmlformats.org/officeDocument/2006/relationships" xmlns:p="http://schemas.openxmlformats.org/presentationml/2006/main">
   <p:cSld>
     <p:spTree>
@@ -20466,7 +22074,7 @@
 </p:sld>
 </file>
 
-<file path=ppt/slides/slide7.xml><?xml version="1.0" encoding="utf-8"?>
+<file path=ppt/slides/slide8.xml><?xml version="1.0" encoding="utf-8"?>
 <p:sld xmlns:a="http://schemas.openxmlformats.org/drawingml/2006/main" xmlns:r="http://schemas.openxmlformats.org/officeDocument/2006/relationships" xmlns:p="http://schemas.openxmlformats.org/presentationml/2006/main">
   <p:cSld>
     <p:spTree>
@@ -21126,7 +22734,7 @@
 </p:sld>
 </file>
 
-<file path=ppt/slides/slide8.xml><?xml version="1.0" encoding="utf-8"?>
+<file path=ppt/slides/slide9.xml><?xml version="1.0" encoding="utf-8"?>
 <p:sld xmlns:a="http://schemas.openxmlformats.org/drawingml/2006/main" xmlns:r="http://schemas.openxmlformats.org/officeDocument/2006/relationships" xmlns:p="http://schemas.openxmlformats.org/presentationml/2006/main">
   <p:cSld>
     <p:spTree>

</xml_diff>

<commit_message>
Changes on ballot images per June 4 CGP
</commit_message>
<xml_diff>
--- a/US-PCS ballot images 2026.pptx
+++ b/US-PCS ballot images 2026.pptx
@@ -10701,7 +10701,7 @@
           </p:nvSpPr>
           <p:spPr>
             <a:xfrm>
-              <a:off x="4317285" y="4739086"/>
+              <a:off x="4317285" y="4774526"/>
               <a:ext cx="2133469" cy="523220"/>
             </a:xfrm>
             <a:prstGeom prst="rect">
@@ -12999,36 +12999,6 @@
           <a:chExt cx="0" cy="0"/>
         </a:xfrm>
       </p:grpSpPr>
-      <p:pic>
-        <p:nvPicPr>
-          <p:cNvPr id="45" name="Picture 44">
-            <a:extLst>
-              <a:ext uri="{FF2B5EF4-FFF2-40B4-BE49-F238E27FC236}">
-                <a16:creationId xmlns:a16="http://schemas.microsoft.com/office/drawing/2014/main" id="{B4491178-B254-AB47-DDF6-320353A423E6}"/>
-              </a:ext>
-            </a:extLst>
-          </p:cNvPr>
-          <p:cNvPicPr>
-            <a:picLocks noChangeAspect="1"/>
-          </p:cNvPicPr>
-          <p:nvPr/>
-        </p:nvPicPr>
-        <p:blipFill>
-          <a:blip r:embed="rId2"/>
-          <a:stretch>
-            <a:fillRect/>
-          </a:stretch>
-        </p:blipFill>
-        <p:spPr>
-          <a:xfrm>
-            <a:off x="3970270" y="259705"/>
-            <a:ext cx="3470619" cy="2991233"/>
-          </a:xfrm>
-          <a:prstGeom prst="rect">
-            <a:avLst/>
-          </a:prstGeom>
-        </p:spPr>
-      </p:pic>
       <p:sp>
         <p:nvSpPr>
           <p:cNvPr id="2" name="Slide Number Placeholder 1">
@@ -13207,7 +13177,7 @@
         </p:nvSpPr>
         <p:spPr>
           <a:xfrm>
-            <a:off x="683569" y="3949192"/>
+            <a:off x="683569" y="4081685"/>
             <a:ext cx="7848872" cy="523220"/>
           </a:xfrm>
           <a:prstGeom prst="rect">
@@ -13370,7 +13340,7 @@
         </p:nvSpPr>
         <p:spPr bwMode="auto">
           <a:xfrm>
-            <a:off x="5527070" y="4513208"/>
+            <a:off x="5527070" y="4645701"/>
             <a:ext cx="910712" cy="929216"/>
           </a:xfrm>
           <a:prstGeom prst="roundRect">
@@ -13426,7 +13396,7 @@
         </p:nvSpPr>
         <p:spPr bwMode="auto">
           <a:xfrm>
-            <a:off x="4584539" y="4513208"/>
+            <a:off x="4584539" y="4645701"/>
             <a:ext cx="910712" cy="929216"/>
           </a:xfrm>
           <a:prstGeom prst="roundRect">
@@ -13482,7 +13452,7 @@
         </p:nvSpPr>
         <p:spPr bwMode="auto">
           <a:xfrm>
-            <a:off x="3642009" y="4513208"/>
+            <a:off x="3642009" y="4645701"/>
             <a:ext cx="910712" cy="929216"/>
           </a:xfrm>
           <a:prstGeom prst="roundRect">
@@ -13538,7 +13508,7 @@
         </p:nvSpPr>
         <p:spPr bwMode="auto">
           <a:xfrm>
-            <a:off x="2699478" y="4513208"/>
+            <a:off x="2699478" y="4645701"/>
             <a:ext cx="910712" cy="929216"/>
           </a:xfrm>
           <a:prstGeom prst="roundRect">
@@ -13594,7 +13564,7 @@
         </p:nvSpPr>
         <p:spPr bwMode="auto">
           <a:xfrm>
-            <a:off x="1756948" y="4513208"/>
+            <a:off x="1756948" y="4645701"/>
             <a:ext cx="910712" cy="929216"/>
           </a:xfrm>
           <a:prstGeom prst="roundRect">
@@ -13650,7 +13620,7 @@
         </p:nvSpPr>
         <p:spPr bwMode="auto">
           <a:xfrm>
-            <a:off x="814417" y="4513208"/>
+            <a:off x="814417" y="4645701"/>
             <a:ext cx="910712" cy="929216"/>
           </a:xfrm>
           <a:prstGeom prst="roundRect">
@@ -13706,7 +13676,7 @@
         </p:nvSpPr>
         <p:spPr bwMode="auto">
           <a:xfrm>
-            <a:off x="7406629" y="4513208"/>
+            <a:off x="7406629" y="4645701"/>
             <a:ext cx="910712" cy="929216"/>
           </a:xfrm>
           <a:prstGeom prst="roundRect">
@@ -13780,7 +13750,7 @@
         </p:nvSpPr>
         <p:spPr>
           <a:xfrm>
-            <a:off x="1923133" y="5182427"/>
+            <a:off x="1887693" y="5314920"/>
             <a:ext cx="640080" cy="274320"/>
           </a:xfrm>
           <a:prstGeom prst="rect">
@@ -13820,7 +13790,7 @@
         </p:nvSpPr>
         <p:spPr>
           <a:xfrm>
-            <a:off x="956250" y="5182427"/>
+            <a:off x="956250" y="5314920"/>
             <a:ext cx="640080" cy="274320"/>
           </a:xfrm>
           <a:prstGeom prst="rect">
@@ -13860,7 +13830,7 @@
         </p:nvSpPr>
         <p:spPr>
           <a:xfrm>
-            <a:off x="2855428" y="5182427"/>
+            <a:off x="2855428" y="5314920"/>
             <a:ext cx="640080" cy="274320"/>
           </a:xfrm>
           <a:prstGeom prst="rect">
@@ -13900,7 +13870,7 @@
         </p:nvSpPr>
         <p:spPr>
           <a:xfrm>
-            <a:off x="3781380" y="5182427"/>
+            <a:off x="3781380" y="5314920"/>
             <a:ext cx="640080" cy="274320"/>
           </a:xfrm>
           <a:prstGeom prst="rect">
@@ -13940,7 +13910,7 @@
         </p:nvSpPr>
         <p:spPr>
           <a:xfrm>
-            <a:off x="4717094" y="5182427"/>
+            <a:off x="4717094" y="5314920"/>
             <a:ext cx="640080" cy="274320"/>
           </a:xfrm>
           <a:prstGeom prst="rect">
@@ -13980,7 +13950,7 @@
         </p:nvSpPr>
         <p:spPr>
           <a:xfrm>
-            <a:off x="5668048" y="5182427"/>
+            <a:off x="5668048" y="5314920"/>
             <a:ext cx="640080" cy="274320"/>
           </a:xfrm>
           <a:prstGeom prst="rect">
@@ -14020,7 +13990,7 @@
         </p:nvSpPr>
         <p:spPr>
           <a:xfrm>
-            <a:off x="7562539" y="5013176"/>
+            <a:off x="7562539" y="5145669"/>
             <a:ext cx="588597" cy="373854"/>
           </a:xfrm>
           <a:prstGeom prst="rect">
@@ -14076,7 +14046,7 @@
           <p:nvPr/>
         </p:nvPicPr>
         <p:blipFill>
-          <a:blip r:embed="rId3">
+          <a:blip r:embed="rId2">
             <a:extLst>
               <a:ext uri="{28A0092B-C50C-407E-A947-70E740481C1C}">
                 <a14:useLocalDpi xmlns:a14="http://schemas.microsoft.com/office/drawing/2010/main" val="0"/>
@@ -14089,7 +14059,7 @@
         </p:blipFill>
         <p:spPr>
           <a:xfrm>
-            <a:off x="5740812" y="4633208"/>
+            <a:off x="5740812" y="4765701"/>
             <a:ext cx="528938" cy="528939"/>
           </a:xfrm>
           <a:prstGeom prst="rect">
@@ -14103,6 +14073,42 @@
             <a:extLst>
               <a:ext uri="{FF2B5EF4-FFF2-40B4-BE49-F238E27FC236}">
                 <a16:creationId xmlns:a16="http://schemas.microsoft.com/office/drawing/2014/main" id="{BB0187C8-BC90-8708-832B-85E7B3865B3C}"/>
+              </a:ext>
+            </a:extLst>
+          </p:cNvPr>
+          <p:cNvPicPr>
+            <a:picLocks noChangeAspect="1"/>
+          </p:cNvPicPr>
+          <p:nvPr/>
+        </p:nvPicPr>
+        <p:blipFill>
+          <a:blip r:embed="rId3">
+            <a:extLst>
+              <a:ext uri="{28A0092B-C50C-407E-A947-70E740481C1C}">
+                <a14:useLocalDpi xmlns:a14="http://schemas.microsoft.com/office/drawing/2010/main" val="0"/>
+              </a:ext>
+            </a:extLst>
+          </a:blip>
+          <a:stretch>
+            <a:fillRect/>
+          </a:stretch>
+        </p:blipFill>
+        <p:spPr>
+          <a:xfrm>
+            <a:off x="1004049" y="4774598"/>
+            <a:ext cx="528938" cy="528939"/>
+          </a:xfrm>
+          <a:prstGeom prst="rect">
+            <a:avLst/>
+          </a:prstGeom>
+        </p:spPr>
+      </p:pic>
+      <p:pic>
+        <p:nvPicPr>
+          <p:cNvPr id="25" name="Picture 24" descr="A black and white icon of a syringe and a shield&#10;&#10;Description automatically generated">
+            <a:extLst>
+              <a:ext uri="{FF2B5EF4-FFF2-40B4-BE49-F238E27FC236}">
+                <a16:creationId xmlns:a16="http://schemas.microsoft.com/office/drawing/2014/main" id="{6970B4AA-5DA2-4731-60DA-933AF50C9385}"/>
               </a:ext>
             </a:extLst>
           </p:cNvPr>
@@ -14125,7 +14131,7 @@
         </p:blipFill>
         <p:spPr>
           <a:xfrm>
-            <a:off x="1004049" y="4642105"/>
+            <a:off x="3842751" y="4753104"/>
             <a:ext cx="528938" cy="528939"/>
           </a:xfrm>
           <a:prstGeom prst="rect">
@@ -14135,10 +14141,10 @@
       </p:pic>
       <p:pic>
         <p:nvPicPr>
-          <p:cNvPr id="25" name="Picture 24" descr="A black and white icon of a syringe and a shield&#10;&#10;Description automatically generated">
-            <a:extLst>
-              <a:ext uri="{FF2B5EF4-FFF2-40B4-BE49-F238E27FC236}">
-                <a16:creationId xmlns:a16="http://schemas.microsoft.com/office/drawing/2014/main" id="{6970B4AA-5DA2-4731-60DA-933AF50C9385}"/>
+          <p:cNvPr id="26" name="Picture 25" descr="A black and white line drawing of a test tube&#10;&#10;Description automatically generated">
+            <a:extLst>
+              <a:ext uri="{FF2B5EF4-FFF2-40B4-BE49-F238E27FC236}">
+                <a16:creationId xmlns:a16="http://schemas.microsoft.com/office/drawing/2014/main" id="{CC8332F9-E1C3-EE8B-4F2A-C754EA37181A}"/>
               </a:ext>
             </a:extLst>
           </p:cNvPr>
@@ -14161,7 +14167,7 @@
         </p:blipFill>
         <p:spPr>
           <a:xfrm>
-            <a:off x="3842751" y="4620611"/>
+            <a:off x="4775425" y="4774597"/>
             <a:ext cx="528938" cy="528939"/>
           </a:xfrm>
           <a:prstGeom prst="rect">
@@ -14171,10 +14177,10 @@
       </p:pic>
       <p:pic>
         <p:nvPicPr>
-          <p:cNvPr id="26" name="Picture 25" descr="A black and white line drawing of a test tube&#10;&#10;Description automatically generated">
-            <a:extLst>
-              <a:ext uri="{FF2B5EF4-FFF2-40B4-BE49-F238E27FC236}">
-                <a16:creationId xmlns:a16="http://schemas.microsoft.com/office/drawing/2014/main" id="{CC8332F9-E1C3-EE8B-4F2A-C754EA37181A}"/>
+          <p:cNvPr id="27" name="Picture 26" descr="A black and white image of different shapes&#10;&#10;Description automatically generated">
+            <a:extLst>
+              <a:ext uri="{FF2B5EF4-FFF2-40B4-BE49-F238E27FC236}">
+                <a16:creationId xmlns:a16="http://schemas.microsoft.com/office/drawing/2014/main" id="{FE291B3F-651F-A8E8-CFF3-7A109D9FC216}"/>
               </a:ext>
             </a:extLst>
           </p:cNvPr>
@@ -14197,7 +14203,7 @@
         </p:blipFill>
         <p:spPr>
           <a:xfrm>
-            <a:off x="4775425" y="4642104"/>
+            <a:off x="2870468" y="4769723"/>
             <a:ext cx="528938" cy="528939"/>
           </a:xfrm>
           <a:prstGeom prst="rect">
@@ -14207,10 +14213,10 @@
       </p:pic>
       <p:pic>
         <p:nvPicPr>
-          <p:cNvPr id="27" name="Picture 26" descr="A black and white image of different shapes&#10;&#10;Description automatically generated">
-            <a:extLst>
-              <a:ext uri="{FF2B5EF4-FFF2-40B4-BE49-F238E27FC236}">
-                <a16:creationId xmlns:a16="http://schemas.microsoft.com/office/drawing/2014/main" id="{FE291B3F-651F-A8E8-CFF3-7A109D9FC216}"/>
+          <p:cNvPr id="28" name="Picture 27" descr="A black and white clipboard with a cross&#10;&#10;Description automatically generated">
+            <a:extLst>
+              <a:ext uri="{FF2B5EF4-FFF2-40B4-BE49-F238E27FC236}">
+                <a16:creationId xmlns:a16="http://schemas.microsoft.com/office/drawing/2014/main" id="{4AF1C9EA-E0F4-EF17-FD1A-DBF8DEEB0D7C}"/>
               </a:ext>
             </a:extLst>
           </p:cNvPr>
@@ -14220,7 +14226,7 @@
           <p:nvPr/>
         </p:nvPicPr>
         <p:blipFill>
-          <a:blip r:embed="rId7">
+          <a:blip r:embed="rId7" cstate="print">
             <a:extLst>
               <a:ext uri="{28A0092B-C50C-407E-A947-70E740481C1C}">
                 <a14:useLocalDpi xmlns:a14="http://schemas.microsoft.com/office/drawing/2010/main" val="0"/>
@@ -14233,8 +14239,8 @@
         </p:blipFill>
         <p:spPr>
           <a:xfrm>
-            <a:off x="2870468" y="4637230"/>
-            <a:ext cx="528938" cy="528939"/>
+            <a:off x="7502548" y="4748968"/>
+            <a:ext cx="373854" cy="373854"/>
           </a:xfrm>
           <a:prstGeom prst="rect">
             <a:avLst/>
@@ -14243,10 +14249,10 @@
       </p:pic>
       <p:pic>
         <p:nvPicPr>
-          <p:cNvPr id="28" name="Picture 27" descr="A black and white clipboard with a cross&#10;&#10;Description automatically generated">
-            <a:extLst>
-              <a:ext uri="{FF2B5EF4-FFF2-40B4-BE49-F238E27FC236}">
-                <a16:creationId xmlns:a16="http://schemas.microsoft.com/office/drawing/2014/main" id="{4AF1C9EA-E0F4-EF17-FD1A-DBF8DEEB0D7C}"/>
+          <p:cNvPr id="29" name="Picture 28">
+            <a:extLst>
+              <a:ext uri="{FF2B5EF4-FFF2-40B4-BE49-F238E27FC236}">
+                <a16:creationId xmlns:a16="http://schemas.microsoft.com/office/drawing/2014/main" id="{614D60A9-EA8E-E732-B1EF-3922D4B4A0AF}"/>
               </a:ext>
             </a:extLst>
           </p:cNvPr>
@@ -14255,22 +14261,15 @@
           </p:cNvPicPr>
           <p:nvPr/>
         </p:nvPicPr>
-        <p:blipFill>
-          <a:blip r:embed="rId8" cstate="print">
-            <a:extLst>
-              <a:ext uri="{28A0092B-C50C-407E-A947-70E740481C1C}">
-                <a14:useLocalDpi xmlns:a14="http://schemas.microsoft.com/office/drawing/2010/main" val="0"/>
-              </a:ext>
-            </a:extLst>
-          </a:blip>
-          <a:stretch>
-            <a:fillRect/>
-          </a:stretch>
+        <p:blipFill rotWithShape="1">
+          <a:blip r:embed="rId8"/>
+          <a:srcRect l="6754" t="18564" r="80644" b="30366"/>
+          <a:stretch/>
         </p:blipFill>
         <p:spPr>
           <a:xfrm>
-            <a:off x="7502548" y="4616475"/>
-            <a:ext cx="373854" cy="373854"/>
+            <a:off x="1952172" y="4774597"/>
+            <a:ext cx="526591" cy="524064"/>
           </a:xfrm>
           <a:prstGeom prst="rect">
             <a:avLst/>
@@ -14279,10 +14278,10 @@
       </p:pic>
       <p:pic>
         <p:nvPicPr>
-          <p:cNvPr id="29" name="Picture 28">
-            <a:extLst>
-              <a:ext uri="{FF2B5EF4-FFF2-40B4-BE49-F238E27FC236}">
-                <a16:creationId xmlns:a16="http://schemas.microsoft.com/office/drawing/2014/main" id="{614D60A9-EA8E-E732-B1EF-3922D4B4A0AF}"/>
+          <p:cNvPr id="30" name="Picture 29">
+            <a:extLst>
+              <a:ext uri="{FF2B5EF4-FFF2-40B4-BE49-F238E27FC236}">
+                <a16:creationId xmlns:a16="http://schemas.microsoft.com/office/drawing/2014/main" id="{CADED9CD-9C79-A62D-295F-5E02C55730C0}"/>
               </a:ext>
             </a:extLst>
           </p:cNvPr>
@@ -14293,41 +14292,12 @@
         </p:nvPicPr>
         <p:blipFill rotWithShape="1">
           <a:blip r:embed="rId9"/>
-          <a:srcRect l="6754" t="18564" r="80644" b="30366"/>
-          <a:stretch/>
-        </p:blipFill>
-        <p:spPr>
-          <a:xfrm>
-            <a:off x="1952172" y="4642104"/>
-            <a:ext cx="526591" cy="524064"/>
-          </a:xfrm>
-          <a:prstGeom prst="rect">
-            <a:avLst/>
-          </a:prstGeom>
-        </p:spPr>
-      </p:pic>
-      <p:pic>
-        <p:nvPicPr>
-          <p:cNvPr id="30" name="Picture 29">
-            <a:extLst>
-              <a:ext uri="{FF2B5EF4-FFF2-40B4-BE49-F238E27FC236}">
-                <a16:creationId xmlns:a16="http://schemas.microsoft.com/office/drawing/2014/main" id="{CADED9CD-9C79-A62D-295F-5E02C55730C0}"/>
-              </a:ext>
-            </a:extLst>
-          </p:cNvPr>
-          <p:cNvPicPr>
-            <a:picLocks noChangeAspect="1"/>
-          </p:cNvPicPr>
-          <p:nvPr/>
-        </p:nvPicPr>
-        <p:blipFill rotWithShape="1">
-          <a:blip r:embed="rId10"/>
           <a:srcRect t="14434" r="85778" b="20996"/>
           <a:stretch/>
         </p:blipFill>
         <p:spPr>
           <a:xfrm>
-            <a:off x="7707815" y="4597158"/>
+            <a:off x="7707815" y="4729651"/>
             <a:ext cx="515199" cy="425006"/>
           </a:xfrm>
           <a:prstGeom prst="rect">
@@ -14337,49 +14307,6 @@
       </p:pic>
       <p:sp>
         <p:nvSpPr>
-          <p:cNvPr id="31" name="TextBox 30">
-            <a:extLst>
-              <a:ext uri="{FF2B5EF4-FFF2-40B4-BE49-F238E27FC236}">
-                <a16:creationId xmlns:a16="http://schemas.microsoft.com/office/drawing/2014/main" id="{13C156C6-AABA-2F13-2CF4-263129DD4E3E}"/>
-              </a:ext>
-            </a:extLst>
-          </p:cNvPr>
-          <p:cNvSpPr txBox="1"/>
-          <p:nvPr/>
-        </p:nvSpPr>
-        <p:spPr>
-          <a:xfrm>
-            <a:off x="814415" y="5467888"/>
-            <a:ext cx="7502925" cy="338554"/>
-          </a:xfrm>
-          <a:prstGeom prst="rect">
-            <a:avLst/>
-          </a:prstGeom>
-          <a:noFill/>
-        </p:spPr>
-        <p:txBody>
-          <a:bodyPr wrap="square" rtlCol="0">
-            <a:spAutoFit/>
-          </a:bodyPr>
-          <a:lstStyle/>
-          <a:p>
-            <a:pPr algn="ctr"/>
-            <a:r>
-              <a:rPr lang="en-US" sz="1600" dirty="0">
-                <a:solidFill>
-                  <a:schemeClr val="tx1">
-                    <a:lumMod val="75000"/>
-                    <a:lumOff val="25000"/>
-                  </a:schemeClr>
-                </a:solidFill>
-              </a:rPr>
-              <a:t>US Core 6.1.0 Resources are defined in a separate implementation guide</a:t>
-            </a:r>
-          </a:p>
-        </p:txBody>
-      </p:sp>
-      <p:sp>
-        <p:nvSpPr>
           <p:cNvPr id="36" name="Rectangle: Rounded Corners 35">
             <a:extLst>
               <a:ext uri="{FF2B5EF4-FFF2-40B4-BE49-F238E27FC236}">
@@ -14392,7 +14319,7 @@
         </p:nvSpPr>
         <p:spPr bwMode="auto">
           <a:xfrm>
-            <a:off x="6471073" y="4513208"/>
+            <a:off x="6471073" y="4645701"/>
             <a:ext cx="910712" cy="929216"/>
           </a:xfrm>
           <a:prstGeom prst="roundRect">
@@ -14463,7 +14390,7 @@
         </p:nvSpPr>
         <p:spPr>
           <a:xfrm>
-            <a:off x="6628203" y="5182427"/>
+            <a:off x="6628203" y="5314920"/>
             <a:ext cx="640080" cy="274320"/>
           </a:xfrm>
           <a:prstGeom prst="rect">
@@ -14504,7 +14431,7 @@
           <p:nvPr/>
         </p:nvPicPr>
         <p:blipFill>
-          <a:blip r:embed="rId11">
+          <a:blip r:embed="rId10">
             <a:extLst>
               <a:ext uri="{28A0092B-C50C-407E-A947-70E740481C1C}">
                 <a14:useLocalDpi xmlns:a14="http://schemas.microsoft.com/office/drawing/2010/main" val="0"/>
@@ -14517,8 +14444,38 @@
         </p:blipFill>
         <p:spPr>
           <a:xfrm>
-            <a:off x="6624977" y="4605261"/>
+            <a:off x="6624977" y="4737754"/>
             <a:ext cx="609631" cy="609631"/>
+          </a:xfrm>
+          <a:prstGeom prst="rect">
+            <a:avLst/>
+          </a:prstGeom>
+        </p:spPr>
+      </p:pic>
+      <p:pic>
+        <p:nvPicPr>
+          <p:cNvPr id="3" name="Picture 2">
+            <a:extLst>
+              <a:ext uri="{FF2B5EF4-FFF2-40B4-BE49-F238E27FC236}">
+                <a16:creationId xmlns:a16="http://schemas.microsoft.com/office/drawing/2014/main" id="{955A099E-3DCC-C6C0-3BC3-E86AE8B7E53D}"/>
+              </a:ext>
+            </a:extLst>
+          </p:cNvPr>
+          <p:cNvPicPr>
+            <a:picLocks noChangeAspect="1"/>
+          </p:cNvPicPr>
+          <p:nvPr/>
+        </p:nvPicPr>
+        <p:blipFill>
+          <a:blip r:embed="rId11"/>
+          <a:stretch>
+            <a:fillRect/>
+          </a:stretch>
+        </p:blipFill>
+        <p:spPr>
+          <a:xfrm>
+            <a:off x="4088173" y="384384"/>
+            <a:ext cx="3291863" cy="2836953"/>
           </a:xfrm>
           <a:prstGeom prst="rect">
             <a:avLst/>

</xml_diff>

<commit_message>
FHIR-57959 and FHIR-57087 Links to US Core
</commit_message>
<xml_diff>
--- a/US-PCS ballot images 2026.pptx
+++ b/US-PCS ballot images 2026.pptx
@@ -861,7 +861,7 @@
           <a:p>
             <a:fld id="{10B9A41D-2C14-4FD9-A8FE-469DBFAB3809}" type="datetimeFigureOut">
               <a:rPr lang="en-CA" smtClean="0"/>
-              <a:t>2026-08-04</a:t>
+              <a:t>2026-08-13</a:t>
             </a:fld>
             <a:endParaRPr lang="en-CA" dirty="0"/>
           </a:p>
@@ -1713,7 +1713,7 @@
           <a:p>
             <a:fld id="{0D2F0FE0-C0B2-431B-95AF-3256C55C95DF}" type="datetimeFigureOut">
               <a:rPr lang="en-US" smtClean="0"/>
-              <a:t>8/4/2026</a:t>
+              <a:t>8/13/2026</a:t>
             </a:fld>
             <a:endParaRPr lang="en-US"/>
           </a:p>
@@ -1911,7 +1911,7 @@
           <a:p>
             <a:fld id="{0D2F0FE0-C0B2-431B-95AF-3256C55C95DF}" type="datetimeFigureOut">
               <a:rPr lang="en-US" smtClean="0"/>
-              <a:t>8/4/2026</a:t>
+              <a:t>8/13/2026</a:t>
             </a:fld>
             <a:endParaRPr lang="en-US"/>
           </a:p>
@@ -2186,7 +2186,7 @@
           <a:p>
             <a:fld id="{0D2F0FE0-C0B2-431B-95AF-3256C55C95DF}" type="datetimeFigureOut">
               <a:rPr lang="en-US" smtClean="0"/>
-              <a:t>8/4/2026</a:t>
+              <a:t>8/13/2026</a:t>
             </a:fld>
             <a:endParaRPr lang="en-US"/>
           </a:p>
@@ -2451,7 +2451,7 @@
           <a:p>
             <a:fld id="{0D2F0FE0-C0B2-431B-95AF-3256C55C95DF}" type="datetimeFigureOut">
               <a:rPr lang="en-US" smtClean="0"/>
-              <a:t>8/4/2026</a:t>
+              <a:t>8/13/2026</a:t>
             </a:fld>
             <a:endParaRPr lang="en-US"/>
           </a:p>
@@ -2863,7 +2863,7 @@
           <a:p>
             <a:fld id="{0D2F0FE0-C0B2-431B-95AF-3256C55C95DF}" type="datetimeFigureOut">
               <a:rPr lang="en-US" smtClean="0"/>
-              <a:t>8/4/2026</a:t>
+              <a:t>8/13/2026</a:t>
             </a:fld>
             <a:endParaRPr lang="en-US"/>
           </a:p>
@@ -3004,7 +3004,7 @@
           <a:p>
             <a:fld id="{0D2F0FE0-C0B2-431B-95AF-3256C55C95DF}" type="datetimeFigureOut">
               <a:rPr lang="en-US" smtClean="0"/>
-              <a:t>8/4/2026</a:t>
+              <a:t>8/13/2026</a:t>
             </a:fld>
             <a:endParaRPr lang="en-US"/>
           </a:p>
@@ -3117,7 +3117,7 @@
           <a:p>
             <a:fld id="{0D2F0FE0-C0B2-431B-95AF-3256C55C95DF}" type="datetimeFigureOut">
               <a:rPr lang="en-US" smtClean="0"/>
-              <a:t>8/4/2026</a:t>
+              <a:t>8/13/2026</a:t>
             </a:fld>
             <a:endParaRPr lang="en-US"/>
           </a:p>
@@ -3428,7 +3428,7 @@
           <a:p>
             <a:fld id="{0D2F0FE0-C0B2-431B-95AF-3256C55C95DF}" type="datetimeFigureOut">
               <a:rPr lang="en-US" smtClean="0"/>
-              <a:t>8/4/2026</a:t>
+              <a:t>8/13/2026</a:t>
             </a:fld>
             <a:endParaRPr lang="en-US"/>
           </a:p>
@@ -3716,7 +3716,7 @@
           <a:p>
             <a:fld id="{0D2F0FE0-C0B2-431B-95AF-3256C55C95DF}" type="datetimeFigureOut">
               <a:rPr lang="en-US" smtClean="0"/>
-              <a:t>8/4/2026</a:t>
+              <a:t>8/13/2026</a:t>
             </a:fld>
             <a:endParaRPr lang="en-US"/>
           </a:p>
@@ -3914,7 +3914,7 @@
           <a:p>
             <a:fld id="{0D2F0FE0-C0B2-431B-95AF-3256C55C95DF}" type="datetimeFigureOut">
               <a:rPr lang="en-US" smtClean="0"/>
-              <a:t>8/4/2026</a:t>
+              <a:t>8/13/2026</a:t>
             </a:fld>
             <a:endParaRPr lang="en-US"/>
           </a:p>
@@ -4365,7 +4365,7 @@
           <a:p>
             <a:fld id="{0D2F0FE0-C0B2-431B-95AF-3256C55C95DF}" type="datetimeFigureOut">
               <a:rPr lang="en-US" smtClean="0"/>
-              <a:t>8/4/2026</a:t>
+              <a:t>8/13/2026</a:t>
             </a:fld>
             <a:endParaRPr lang="en-US"/>
           </a:p>
@@ -7947,7 +7947,7 @@
           <a:p>
             <a:fld id="{0D2F0FE0-C0B2-431B-95AF-3256C55C95DF}" type="datetimeFigureOut">
               <a:rPr lang="en-US" smtClean="0"/>
-              <a:t>8/4/2026</a:t>
+              <a:t>8/13/2026</a:t>
             </a:fld>
             <a:endParaRPr lang="en-US"/>
           </a:p>
@@ -11662,7 +11662,7 @@
                 </a:solidFill>
                 <a:latin typeface="Aptos" panose="02110004020202020204"/>
               </a:rPr>
-              <a:t>US Core 6.1.0</a:t>
+              <a:t>US Core</a:t>
             </a:r>
           </a:p>
         </p:txBody>

</xml_diff>